<commit_message>
Overview figure: explicit parallel vs sequential tags and legend
Co-Authored-By: Claude Sonnet 5.5 <noreply@anthropic.com>
Claude-Session: https://claude.ai/code/session_01T6gEewJ8YaCdmnsfS34RJd
</commit_message>
<xml_diff>
--- a/results/seminar/figs/Seminar_Ibtihal_FINAL.pptx
+++ b/results/seminar/figs/Seminar_Ibtihal_FINAL.pptx
@@ -3992,7 +3992,7 @@
         <p:spPr>
           <a:xfrm>
             <a:off x="365760" y="228600"/>
-            <a:ext cx="2240280" cy="1325880"/>
+            <a:ext cx="2240280" cy="1005840"/>
           </a:xfrm>
           <a:prstGeom prst="rect">
             <a:avLst/>
@@ -4064,6 +4064,72 @@
         </p:nvSpPr>
         <p:spPr>
           <a:xfrm>
+            <a:off x="475488" y="1188720"/>
+            <a:ext cx="2020824" cy="292608"/>
+          </a:xfrm>
+          <a:prstGeom prst="roundRect">
+            <a:avLst>
+              <a:gd name="adj" fmla="val 50000"/>
+            </a:avLst>
+          </a:prstGeom>
+          <a:solidFill>
+            <a:srgbClr val="FFFFFF"/>
+          </a:solidFill>
+          <a:ln w="12700">
+            <a:solidFill>
+              <a:srgbClr val="FFFFFF"/>
+            </a:solidFill>
+            <a:prstDash val="solid"/>
+          </a:ln>
+        </p:spPr>
+      </p:sp>
+      <p:sp>
+        <p:nvSpPr>
+          <p:cNvPr id="6" name="Text 4"/>
+          <p:cNvSpPr/>
+          <p:nvPr/>
+        </p:nvSpPr>
+        <p:spPr>
+          <a:xfrm>
+            <a:off x="475488" y="1188720"/>
+            <a:ext cx="2020824" cy="292608"/>
+          </a:xfrm>
+          <a:prstGeom prst="rect">
+            <a:avLst/>
+          </a:prstGeom>
+          <a:noFill/>
+          <a:ln/>
+        </p:spPr>
+        <p:txBody>
+          <a:bodyPr wrap="square" lIns="0" tIns="0" rIns="0" bIns="0" rtlCol="0" anchor="ctr"/>
+          <a:lstStyle/>
+          <a:p>
+            <a:pPr algn="ctr" indent="0" marL="0">
+              <a:buNone/>
+            </a:pPr>
+            <a:r>
+              <a:rPr lang="en-US" sz="1200" b="1" dirty="0">
+                <a:solidFill>
+                  <a:srgbClr val="5B6770"/>
+                </a:solidFill>
+                <a:latin typeface="Calibri" pitchFamily="34" charset="0"/>
+                <a:ea typeface="Calibri" pitchFamily="34" charset="-122"/>
+                <a:cs typeface="Calibri" pitchFamily="34" charset="-120"/>
+              </a:rPr>
+              <a:t>SEQUENTIAL: Rank 0</a:t>
+            </a:r>
+            <a:endParaRPr lang="en-US" sz="1200" dirty="0"/>
+          </a:p>
+        </p:txBody>
+      </p:sp>
+      <p:sp>
+        <p:nvSpPr>
+          <p:cNvPr id="7" name="Shape 5"/>
+          <p:cNvSpPr/>
+          <p:nvPr/>
+        </p:nvSpPr>
+        <p:spPr>
+          <a:xfrm>
             <a:off x="2788920" y="320040"/>
             <a:ext cx="2011680" cy="1143000"/>
           </a:xfrm>
@@ -4085,7 +4151,7 @@
       </p:sp>
       <p:sp>
         <p:nvSpPr>
-          <p:cNvPr id="6" name="Text 4"/>
+          <p:cNvPr id="8" name="Text 6"/>
           <p:cNvSpPr/>
           <p:nvPr/>
         </p:nvSpPr>
@@ -4158,7 +4224,7 @@
       </p:sp>
       <p:sp>
         <p:nvSpPr>
-          <p:cNvPr id="7" name="Shape 5"/>
+          <p:cNvPr id="9" name="Shape 7"/>
           <p:cNvSpPr/>
           <p:nvPr/>
         </p:nvSpPr>
@@ -4183,7 +4249,7 @@
       </p:sp>
       <p:sp>
         <p:nvSpPr>
-          <p:cNvPr id="8" name="Shape 6"/>
+          <p:cNvPr id="10" name="Shape 8"/>
           <p:cNvSpPr/>
           <p:nvPr/>
         </p:nvSpPr>
@@ -4210,7 +4276,7 @@
       </p:sp>
       <p:sp>
         <p:nvSpPr>
-          <p:cNvPr id="9" name="Text 7"/>
+          <p:cNvPr id="11" name="Text 9"/>
           <p:cNvSpPr/>
           <p:nvPr/>
         </p:nvSpPr>
@@ -4266,7 +4332,7 @@
       </p:sp>
       <p:sp>
         <p:nvSpPr>
-          <p:cNvPr id="10" name="Shape 8"/>
+          <p:cNvPr id="12" name="Shape 10"/>
           <p:cNvSpPr/>
           <p:nvPr/>
         </p:nvSpPr>
@@ -4291,7 +4357,7 @@
       </p:sp>
       <p:sp>
         <p:nvSpPr>
-          <p:cNvPr id="11" name="Shape 9"/>
+          <p:cNvPr id="13" name="Shape 11"/>
           <p:cNvSpPr/>
           <p:nvPr/>
         </p:nvSpPr>
@@ -4318,7 +4384,7 @@
       </p:sp>
       <p:sp>
         <p:nvSpPr>
-          <p:cNvPr id="12" name="Text 10"/>
+          <p:cNvPr id="14" name="Text 12"/>
           <p:cNvSpPr/>
           <p:nvPr/>
         </p:nvSpPr>
@@ -4391,7 +4457,7 @@
       </p:sp>
       <p:sp>
         <p:nvSpPr>
-          <p:cNvPr id="13" name="Text 11"/>
+          <p:cNvPr id="15" name="Text 13"/>
           <p:cNvSpPr/>
           <p:nvPr/>
         </p:nvSpPr>
@@ -4430,7 +4496,7 @@
       </p:sp>
       <p:sp>
         <p:nvSpPr>
-          <p:cNvPr id="14" name="Shape 12"/>
+          <p:cNvPr id="16" name="Shape 14"/>
           <p:cNvSpPr/>
           <p:nvPr/>
         </p:nvSpPr>
@@ -4455,7 +4521,7 @@
       </p:sp>
       <p:sp>
         <p:nvSpPr>
-          <p:cNvPr id="15" name="Shape 13"/>
+          <p:cNvPr id="17" name="Shape 15"/>
           <p:cNvSpPr/>
           <p:nvPr/>
         </p:nvSpPr>
@@ -4482,7 +4548,7 @@
       </p:sp>
       <p:sp>
         <p:nvSpPr>
-          <p:cNvPr id="16" name="Shape 14"/>
+          <p:cNvPr id="18" name="Shape 16"/>
           <p:cNvSpPr/>
           <p:nvPr/>
         </p:nvSpPr>
@@ -4509,14 +4575,14 @@
       </p:sp>
       <p:sp>
         <p:nvSpPr>
-          <p:cNvPr id="17" name="Text 15"/>
+          <p:cNvPr id="19" name="Text 17"/>
           <p:cNvSpPr/>
           <p:nvPr/>
         </p:nvSpPr>
         <p:spPr>
           <a:xfrm>
             <a:off x="365760" y="1856232"/>
-            <a:ext cx="2240280" cy="1325880"/>
+            <a:ext cx="2240280" cy="1005840"/>
           </a:xfrm>
           <a:prstGeom prst="rect">
             <a:avLst/>
@@ -4582,7 +4648,73 @@
       </p:sp>
       <p:sp>
         <p:nvSpPr>
-          <p:cNvPr id="18" name="Shape 16"/>
+          <p:cNvPr id="20" name="Shape 18"/>
+          <p:cNvSpPr/>
+          <p:nvPr/>
+        </p:nvSpPr>
+        <p:spPr>
+          <a:xfrm>
+            <a:off x="475488" y="2816352"/>
+            <a:ext cx="2020824" cy="292608"/>
+          </a:xfrm>
+          <a:prstGeom prst="roundRect">
+            <a:avLst>
+              <a:gd name="adj" fmla="val 50000"/>
+            </a:avLst>
+          </a:prstGeom>
+          <a:solidFill>
+            <a:srgbClr val="FFFFFF"/>
+          </a:solidFill>
+          <a:ln w="12700">
+            <a:solidFill>
+              <a:srgbClr val="FFFFFF"/>
+            </a:solidFill>
+            <a:prstDash val="solid"/>
+          </a:ln>
+        </p:spPr>
+      </p:sp>
+      <p:sp>
+        <p:nvSpPr>
+          <p:cNvPr id="21" name="Text 19"/>
+          <p:cNvSpPr/>
+          <p:nvPr/>
+        </p:nvSpPr>
+        <p:spPr>
+          <a:xfrm>
+            <a:off x="475488" y="2816352"/>
+            <a:ext cx="2020824" cy="292608"/>
+          </a:xfrm>
+          <a:prstGeom prst="rect">
+            <a:avLst/>
+          </a:prstGeom>
+          <a:noFill/>
+          <a:ln/>
+        </p:spPr>
+        <p:txBody>
+          <a:bodyPr wrap="square" lIns="0" tIns="0" rIns="0" bIns="0" rtlCol="0" anchor="ctr"/>
+          <a:lstStyle/>
+          <a:p>
+            <a:pPr algn="ctr" indent="0" marL="0">
+              <a:buNone/>
+            </a:pPr>
+            <a:r>
+              <a:rPr lang="en-US" sz="1200" b="1" dirty="0">
+                <a:solidFill>
+                  <a:srgbClr val="E07B22"/>
+                </a:solidFill>
+                <a:latin typeface="Calibri" pitchFamily="34" charset="0"/>
+                <a:ea typeface="Calibri" pitchFamily="34" charset="-122"/>
+                <a:cs typeface="Calibri" pitchFamily="34" charset="-120"/>
+              </a:rPr>
+              <a:t>PARALLEL: all ranks</a:t>
+            </a:r>
+            <a:endParaRPr lang="en-US" sz="1200" dirty="0"/>
+          </a:p>
+        </p:txBody>
+      </p:sp>
+      <p:sp>
+        <p:nvSpPr>
+          <p:cNvPr id="22" name="Shape 20"/>
           <p:cNvSpPr/>
           <p:nvPr/>
         </p:nvSpPr>
@@ -4609,7 +4741,7 @@
       </p:sp>
       <p:sp>
         <p:nvSpPr>
-          <p:cNvPr id="19" name="Text 17"/>
+          <p:cNvPr id="23" name="Text 21"/>
           <p:cNvSpPr/>
           <p:nvPr/>
         </p:nvSpPr>
@@ -4682,7 +4814,7 @@
       </p:sp>
       <p:sp>
         <p:nvSpPr>
-          <p:cNvPr id="20" name="Shape 18"/>
+          <p:cNvPr id="24" name="Shape 22"/>
           <p:cNvSpPr/>
           <p:nvPr/>
         </p:nvSpPr>
@@ -4707,7 +4839,7 @@
       </p:sp>
       <p:sp>
         <p:nvSpPr>
-          <p:cNvPr id="21" name="Shape 19"/>
+          <p:cNvPr id="25" name="Shape 23"/>
           <p:cNvSpPr/>
           <p:nvPr/>
         </p:nvSpPr>
@@ -4734,7 +4866,7 @@
       </p:sp>
       <p:sp>
         <p:nvSpPr>
-          <p:cNvPr id="22" name="Text 20"/>
+          <p:cNvPr id="26" name="Text 24"/>
           <p:cNvSpPr/>
           <p:nvPr/>
         </p:nvSpPr>
@@ -4807,7 +4939,7 @@
       </p:sp>
       <p:sp>
         <p:nvSpPr>
-          <p:cNvPr id="23" name="Shape 21"/>
+          <p:cNvPr id="27" name="Shape 25"/>
           <p:cNvSpPr/>
           <p:nvPr/>
         </p:nvSpPr>
@@ -4832,7 +4964,7 @@
       </p:sp>
       <p:sp>
         <p:nvSpPr>
-          <p:cNvPr id="24" name="Shape 22"/>
+          <p:cNvPr id="28" name="Shape 26"/>
           <p:cNvSpPr/>
           <p:nvPr/>
         </p:nvSpPr>
@@ -4859,7 +4991,7 @@
       </p:sp>
       <p:sp>
         <p:nvSpPr>
-          <p:cNvPr id="25" name="Text 23"/>
+          <p:cNvPr id="29" name="Text 27"/>
           <p:cNvSpPr/>
           <p:nvPr/>
         </p:nvSpPr>
@@ -4932,7 +5064,7 @@
       </p:sp>
       <p:sp>
         <p:nvSpPr>
-          <p:cNvPr id="26" name="Shape 24"/>
+          <p:cNvPr id="30" name="Shape 28"/>
           <p:cNvSpPr/>
           <p:nvPr/>
         </p:nvSpPr>
@@ -4957,7 +5089,7 @@
       </p:sp>
       <p:sp>
         <p:nvSpPr>
-          <p:cNvPr id="27" name="Shape 25"/>
+          <p:cNvPr id="31" name="Shape 29"/>
           <p:cNvSpPr/>
           <p:nvPr/>
         </p:nvSpPr>
@@ -4984,7 +5116,7 @@
       </p:sp>
       <p:sp>
         <p:nvSpPr>
-          <p:cNvPr id="28" name="Text 26"/>
+          <p:cNvPr id="32" name="Text 30"/>
           <p:cNvSpPr/>
           <p:nvPr/>
         </p:nvSpPr>
@@ -5057,7 +5189,7 @@
       </p:sp>
       <p:sp>
         <p:nvSpPr>
-          <p:cNvPr id="29" name="Text 27"/>
+          <p:cNvPr id="33" name="Text 31"/>
           <p:cNvSpPr/>
           <p:nvPr/>
         </p:nvSpPr>
@@ -5096,7 +5228,7 @@
       </p:sp>
       <p:sp>
         <p:nvSpPr>
-          <p:cNvPr id="30" name="Shape 28"/>
+          <p:cNvPr id="34" name="Shape 32"/>
           <p:cNvSpPr/>
           <p:nvPr/>
         </p:nvSpPr>
@@ -5121,7 +5253,7 @@
       </p:sp>
       <p:sp>
         <p:nvSpPr>
-          <p:cNvPr id="31" name="Shape 29"/>
+          <p:cNvPr id="35" name="Shape 33"/>
           <p:cNvSpPr/>
           <p:nvPr/>
         </p:nvSpPr>
@@ -5148,7 +5280,7 @@
       </p:sp>
       <p:sp>
         <p:nvSpPr>
-          <p:cNvPr id="32" name="Shape 30"/>
+          <p:cNvPr id="36" name="Shape 34"/>
           <p:cNvSpPr/>
           <p:nvPr/>
         </p:nvSpPr>
@@ -5175,14 +5307,14 @@
       </p:sp>
       <p:sp>
         <p:nvSpPr>
-          <p:cNvPr id="33" name="Text 31"/>
+          <p:cNvPr id="37" name="Text 35"/>
           <p:cNvSpPr/>
           <p:nvPr/>
         </p:nvSpPr>
         <p:spPr>
           <a:xfrm>
             <a:off x="365760" y="3483864"/>
-            <a:ext cx="2240280" cy="1325880"/>
+            <a:ext cx="2240280" cy="1005840"/>
           </a:xfrm>
           <a:prstGeom prst="rect">
             <a:avLst/>
@@ -5240,7 +5372,7 @@
                 <a:ea typeface="Calibri" pitchFamily="34" charset="-122"/>
                 <a:cs typeface="Calibri" pitchFamily="34" charset="-120"/>
               </a:rPr>
-              <a:t>Coding (Rank 0)</a:t>
+              <a:t>Coding</a:t>
             </a:r>
             <a:endParaRPr lang="en-US" sz="2200" dirty="0"/>
           </a:p>
@@ -5248,7 +5380,73 @@
       </p:sp>
       <p:sp>
         <p:nvSpPr>
-          <p:cNvPr id="34" name="Shape 32"/>
+          <p:cNvPr id="38" name="Shape 36"/>
+          <p:cNvSpPr/>
+          <p:nvPr/>
+        </p:nvSpPr>
+        <p:spPr>
+          <a:xfrm>
+            <a:off x="475488" y="4443984"/>
+            <a:ext cx="2020824" cy="292608"/>
+          </a:xfrm>
+          <a:prstGeom prst="roundRect">
+            <a:avLst>
+              <a:gd name="adj" fmla="val 50000"/>
+            </a:avLst>
+          </a:prstGeom>
+          <a:solidFill>
+            <a:srgbClr val="FFFFFF"/>
+          </a:solidFill>
+          <a:ln w="12700">
+            <a:solidFill>
+              <a:srgbClr val="FFFFFF"/>
+            </a:solidFill>
+            <a:prstDash val="solid"/>
+          </a:ln>
+        </p:spPr>
+      </p:sp>
+      <p:sp>
+        <p:nvSpPr>
+          <p:cNvPr id="39" name="Text 37"/>
+          <p:cNvSpPr/>
+          <p:nvPr/>
+        </p:nvSpPr>
+        <p:spPr>
+          <a:xfrm>
+            <a:off x="475488" y="4443984"/>
+            <a:ext cx="2020824" cy="292608"/>
+          </a:xfrm>
+          <a:prstGeom prst="rect">
+            <a:avLst/>
+          </a:prstGeom>
+          <a:noFill/>
+          <a:ln/>
+        </p:spPr>
+        <p:txBody>
+          <a:bodyPr wrap="square" lIns="0" tIns="0" rIns="0" bIns="0" rtlCol="0" anchor="ctr"/>
+          <a:lstStyle/>
+          <a:p>
+            <a:pPr algn="ctr" indent="0" marL="0">
+              <a:buNone/>
+            </a:pPr>
+            <a:r>
+              <a:rPr lang="en-US" sz="1200" b="1" dirty="0">
+                <a:solidFill>
+                  <a:srgbClr val="5B6770"/>
+                </a:solidFill>
+                <a:latin typeface="Calibri" pitchFamily="34" charset="0"/>
+                <a:ea typeface="Calibri" pitchFamily="34" charset="-122"/>
+                <a:cs typeface="Calibri" pitchFamily="34" charset="-120"/>
+              </a:rPr>
+              <a:t>SEQUENTIAL: Rank 0</a:t>
+            </a:r>
+            <a:endParaRPr lang="en-US" sz="1200" dirty="0"/>
+          </a:p>
+        </p:txBody>
+      </p:sp>
+      <p:sp>
+        <p:nvSpPr>
+          <p:cNvPr id="40" name="Shape 38"/>
           <p:cNvSpPr/>
           <p:nvPr/>
         </p:nvSpPr>
@@ -5275,7 +5473,7 @@
       </p:sp>
       <p:sp>
         <p:nvSpPr>
-          <p:cNvPr id="35" name="Text 33"/>
+          <p:cNvPr id="41" name="Text 39"/>
           <p:cNvSpPr/>
           <p:nvPr/>
         </p:nvSpPr>
@@ -5348,7 +5546,7 @@
       </p:sp>
       <p:sp>
         <p:nvSpPr>
-          <p:cNvPr id="36" name="Shape 34"/>
+          <p:cNvPr id="42" name="Shape 40"/>
           <p:cNvSpPr/>
           <p:nvPr/>
         </p:nvSpPr>
@@ -5373,7 +5571,7 @@
       </p:sp>
       <p:sp>
         <p:nvSpPr>
-          <p:cNvPr id="37" name="Shape 35"/>
+          <p:cNvPr id="43" name="Shape 41"/>
           <p:cNvSpPr/>
           <p:nvPr/>
         </p:nvSpPr>
@@ -5400,7 +5598,7 @@
       </p:sp>
       <p:sp>
         <p:nvSpPr>
-          <p:cNvPr id="38" name="Text 36"/>
+          <p:cNvPr id="44" name="Text 42"/>
           <p:cNvSpPr/>
           <p:nvPr/>
         </p:nvSpPr>
@@ -5473,7 +5671,7 @@
       </p:sp>
       <p:sp>
         <p:nvSpPr>
-          <p:cNvPr id="39" name="Shape 37"/>
+          <p:cNvPr id="45" name="Shape 43"/>
           <p:cNvSpPr/>
           <p:nvPr/>
         </p:nvSpPr>
@@ -5498,7 +5696,7 @@
       </p:sp>
       <p:sp>
         <p:nvSpPr>
-          <p:cNvPr id="40" name="Shape 38"/>
+          <p:cNvPr id="46" name="Shape 44"/>
           <p:cNvSpPr/>
           <p:nvPr/>
         </p:nvSpPr>
@@ -5525,7 +5723,7 @@
       </p:sp>
       <p:sp>
         <p:nvSpPr>
-          <p:cNvPr id="41" name="Text 39"/>
+          <p:cNvPr id="47" name="Text 45"/>
           <p:cNvSpPr/>
           <p:nvPr/>
         </p:nvSpPr>
@@ -5598,7 +5796,7 @@
       </p:sp>
       <p:sp>
         <p:nvSpPr>
-          <p:cNvPr id="42" name="Text 40"/>
+          <p:cNvPr id="48" name="Text 46"/>
           <p:cNvSpPr/>
           <p:nvPr/>
         </p:nvSpPr>
@@ -5637,7 +5835,7 @@
       </p:sp>
       <p:sp>
         <p:nvSpPr>
-          <p:cNvPr id="43" name="Shape 41"/>
+          <p:cNvPr id="49" name="Shape 47"/>
           <p:cNvSpPr/>
           <p:nvPr/>
         </p:nvSpPr>
@@ -5662,7 +5860,7 @@
       </p:sp>
       <p:sp>
         <p:nvSpPr>
-          <p:cNvPr id="44" name="Shape 42"/>
+          <p:cNvPr id="50" name="Shape 48"/>
           <p:cNvSpPr/>
           <p:nvPr/>
         </p:nvSpPr>
@@ -5689,7 +5887,7 @@
       </p:sp>
       <p:sp>
         <p:nvSpPr>
-          <p:cNvPr id="45" name="Shape 43"/>
+          <p:cNvPr id="51" name="Shape 49"/>
           <p:cNvSpPr/>
           <p:nvPr/>
         </p:nvSpPr>
@@ -5716,14 +5914,14 @@
       </p:sp>
       <p:sp>
         <p:nvSpPr>
-          <p:cNvPr id="46" name="Text 44"/>
+          <p:cNvPr id="52" name="Text 50"/>
           <p:cNvSpPr/>
           <p:nvPr/>
         </p:nvSpPr>
         <p:spPr>
           <a:xfrm>
             <a:off x="365760" y="5111496"/>
-            <a:ext cx="2240280" cy="1325880"/>
+            <a:ext cx="2240280" cy="1005840"/>
           </a:xfrm>
           <a:prstGeom prst="rect">
             <a:avLst/>
@@ -5789,7 +5987,73 @@
       </p:sp>
       <p:sp>
         <p:nvSpPr>
-          <p:cNvPr id="47" name="Shape 45"/>
+          <p:cNvPr id="53" name="Shape 51"/>
+          <p:cNvSpPr/>
+          <p:nvPr/>
+        </p:nvSpPr>
+        <p:spPr>
+          <a:xfrm>
+            <a:off x="475488" y="6071616"/>
+            <a:ext cx="2020824" cy="292608"/>
+          </a:xfrm>
+          <a:prstGeom prst="roundRect">
+            <a:avLst>
+              <a:gd name="adj" fmla="val 50000"/>
+            </a:avLst>
+          </a:prstGeom>
+          <a:solidFill>
+            <a:srgbClr val="FFFFFF"/>
+          </a:solidFill>
+          <a:ln w="12700">
+            <a:solidFill>
+              <a:srgbClr val="FFFFFF"/>
+            </a:solidFill>
+            <a:prstDash val="solid"/>
+          </a:ln>
+        </p:spPr>
+      </p:sp>
+      <p:sp>
+        <p:nvSpPr>
+          <p:cNvPr id="54" name="Text 52"/>
+          <p:cNvSpPr/>
+          <p:nvPr/>
+        </p:nvSpPr>
+        <p:spPr>
+          <a:xfrm>
+            <a:off x="475488" y="6071616"/>
+            <a:ext cx="2020824" cy="292608"/>
+          </a:xfrm>
+          <a:prstGeom prst="rect">
+            <a:avLst/>
+          </a:prstGeom>
+          <a:noFill/>
+          <a:ln/>
+        </p:spPr>
+        <p:txBody>
+          <a:bodyPr wrap="square" lIns="0" tIns="0" rIns="0" bIns="0" rtlCol="0" anchor="ctr"/>
+          <a:lstStyle/>
+          <a:p>
+            <a:pPr algn="ctr" indent="0" marL="0">
+              <a:buNone/>
+            </a:pPr>
+            <a:r>
+              <a:rPr lang="en-US" sz="1200" b="1" dirty="0">
+                <a:solidFill>
+                  <a:srgbClr val="5B6770"/>
+                </a:solidFill>
+                <a:latin typeface="Calibri" pitchFamily="34" charset="0"/>
+                <a:ea typeface="Calibri" pitchFamily="34" charset="-122"/>
+                <a:cs typeface="Calibri" pitchFamily="34" charset="-120"/>
+              </a:rPr>
+              <a:t>SEQUENTIAL: Rank 0</a:t>
+            </a:r>
+            <a:endParaRPr lang="en-US" sz="1200" dirty="0"/>
+          </a:p>
+        </p:txBody>
+      </p:sp>
+      <p:sp>
+        <p:nvSpPr>
+          <p:cNvPr id="55" name="Shape 53"/>
           <p:cNvSpPr/>
           <p:nvPr/>
         </p:nvSpPr>
@@ -5816,7 +6080,7 @@
       </p:sp>
       <p:sp>
         <p:nvSpPr>
-          <p:cNvPr id="48" name="Text 46"/>
+          <p:cNvPr id="56" name="Text 54"/>
           <p:cNvSpPr/>
           <p:nvPr/>
         </p:nvSpPr>
@@ -5864,15 +6128,32 @@
                 <a:ea typeface="Calibri" pitchFamily="34" charset="-122"/>
                 <a:cs typeface="Calibri" pitchFamily="34" charset="-120"/>
               </a:rPr>
-              <a:t>Rank 0</a:t>
+              <a:t>bit stream to</a:t>
             </a:r>
             <a:endParaRPr lang="en-US" sz="1600" dirty="0"/>
           </a:p>
+          <a:p>
+            <a:pPr algn="ctr" indent="0" marL="0">
+              <a:buNone/>
+            </a:pPr>
+            <a:r>
+              <a:rPr lang="en-US" sz="1300" dirty="0">
+                <a:solidFill>
+                  <a:srgbClr val="1F1A33"/>
+                </a:solidFill>
+                <a:latin typeface="Calibri" pitchFamily="34" charset="0"/>
+                <a:ea typeface="Calibri" pitchFamily="34" charset="-122"/>
+                <a:cs typeface="Calibri" pitchFamily="34" charset="-120"/>
+              </a:rPr>
+              <a:t>delta values</a:t>
+            </a:r>
+            <a:endParaRPr lang="en-US" sz="1600" dirty="0"/>
+          </a:p>
         </p:txBody>
       </p:sp>
       <p:sp>
         <p:nvSpPr>
-          <p:cNvPr id="49" name="Shape 47"/>
+          <p:cNvPr id="57" name="Shape 55"/>
           <p:cNvSpPr/>
           <p:nvPr/>
         </p:nvSpPr>
@@ -5897,7 +6178,7 @@
       </p:sp>
       <p:sp>
         <p:nvSpPr>
-          <p:cNvPr id="50" name="Shape 48"/>
+          <p:cNvPr id="58" name="Shape 56"/>
           <p:cNvSpPr/>
           <p:nvPr/>
         </p:nvSpPr>
@@ -5924,7 +6205,7 @@
       </p:sp>
       <p:sp>
         <p:nvSpPr>
-          <p:cNvPr id="51" name="Text 49"/>
+          <p:cNvPr id="59" name="Text 57"/>
           <p:cNvSpPr/>
           <p:nvPr/>
         </p:nvSpPr>
@@ -5997,7 +6278,7 @@
       </p:sp>
       <p:sp>
         <p:nvSpPr>
-          <p:cNvPr id="52" name="Shape 50"/>
+          <p:cNvPr id="60" name="Shape 58"/>
           <p:cNvSpPr/>
           <p:nvPr/>
         </p:nvSpPr>
@@ -6022,7 +6303,7 @@
       </p:sp>
       <p:sp>
         <p:nvSpPr>
-          <p:cNvPr id="53" name="Shape 51"/>
+          <p:cNvPr id="61" name="Shape 59"/>
           <p:cNvSpPr/>
           <p:nvPr/>
         </p:nvSpPr>
@@ -6049,7 +6330,7 @@
       </p:sp>
       <p:sp>
         <p:nvSpPr>
-          <p:cNvPr id="54" name="Text 52"/>
+          <p:cNvPr id="62" name="Text 60"/>
           <p:cNvSpPr/>
           <p:nvPr/>
         </p:nvSpPr>
@@ -6122,7 +6403,7 @@
       </p:sp>
       <p:sp>
         <p:nvSpPr>
-          <p:cNvPr id="55" name="Shape 53"/>
+          <p:cNvPr id="63" name="Shape 61"/>
           <p:cNvSpPr/>
           <p:nvPr/>
         </p:nvSpPr>
@@ -6147,7 +6428,7 @@
       </p:sp>
       <p:sp>
         <p:nvSpPr>
-          <p:cNvPr id="56" name="Shape 54"/>
+          <p:cNvPr id="64" name="Shape 62"/>
           <p:cNvSpPr/>
           <p:nvPr/>
         </p:nvSpPr>
@@ -6162,19 +6443,19 @@
             </a:avLst>
           </a:prstGeom>
           <a:solidFill>
-            <a:srgbClr val="FFFFFF"/>
+            <a:srgbClr val="FDEBD9"/>
           </a:solidFill>
-          <a:ln w="19050">
+          <a:ln w="31750">
             <a:solidFill>
-              <a:srgbClr val="6B4FA3"/>
+              <a:srgbClr val="E07B22"/>
             </a:solidFill>
-            <a:prstDash val="solid"/>
+            <a:prstDash val="dash"/>
           </a:ln>
         </p:spPr>
       </p:sp>
       <p:sp>
         <p:nvSpPr>
-          <p:cNvPr id="57" name="Text 55"/>
+          <p:cNvPr id="65" name="Text 63"/>
           <p:cNvSpPr/>
           <p:nvPr/>
         </p:nvSpPr>
@@ -6222,7 +6503,7 @@
                 <a:ea typeface="Calibri" pitchFamily="34" charset="-122"/>
                 <a:cs typeface="Calibri" pitchFamily="34" charset="-120"/>
               </a:rPr>
-              <a:t>CR, BPP, MSE,</a:t>
+              <a:t>CR, BPP, MSE, PSNR</a:t>
             </a:r>
             <a:endParaRPr lang="en-US" sz="1600" dirty="0"/>
           </a:p>
@@ -6239,46 +6520,156 @@
                 <a:ea typeface="Calibri" pitchFamily="34" charset="-122"/>
                 <a:cs typeface="Calibri" pitchFamily="34" charset="-120"/>
               </a:rPr>
-              <a:t>PSNR; parallel SSIM</a:t>
+              <a:t>(Rank 0)</a:t>
             </a:r>
             <a:endParaRPr lang="en-US" sz="1600" dirty="0"/>
           </a:p>
-        </p:txBody>
-      </p:sp>
-      <p:sp>
-        <p:nvSpPr>
-          <p:cNvPr id="58" name="Text 56"/>
-          <p:cNvSpPr/>
-          <p:nvPr/>
-        </p:nvSpPr>
-        <p:spPr>
-          <a:xfrm>
-            <a:off x="365760" y="6492240"/>
-            <a:ext cx="11430000" cy="274320"/>
-          </a:xfrm>
-          <a:prstGeom prst="rect">
-            <a:avLst/>
-          </a:prstGeom>
-          <a:noFill/>
-          <a:ln/>
-        </p:spPr>
-        <p:txBody>
-          <a:bodyPr wrap="square" lIns="0" tIns="0" rIns="0" bIns="0" rtlCol="0" anchor="ctr"/>
-          <a:lstStyle/>
           <a:p>
             <a:pPr algn="ctr" indent="0" marL="0">
               <a:buNone/>
             </a:pPr>
             <a:r>
-              <a:rPr lang="en-US" sz="1300" i="1" dirty="0">
+              <a:rPr lang="en-US" sz="1300" dirty="0">
                 <a:solidFill>
-                  <a:srgbClr val="6B4FA3"/>
+                  <a:srgbClr val="1F1A33"/>
                 </a:solidFill>
                 <a:latin typeface="Calibri" pitchFamily="34" charset="0"/>
                 <a:ea typeface="Calibri" pitchFamily="34" charset="-122"/>
                 <a:cs typeface="Calibri" pitchFamily="34" charset="-120"/>
               </a:rPr>
-              <a:t>Parallel: LBG training and SSIM   |   Rank 0: index coding, decoding, reconstruction, and remaining metrics</a:t>
+              <a:t>SSIM (parallel)</a:t>
+            </a:r>
+            <a:endParaRPr lang="en-US" sz="1600" dirty="0"/>
+          </a:p>
+        </p:txBody>
+      </p:sp>
+      <p:sp>
+        <p:nvSpPr>
+          <p:cNvPr id="66" name="Shape 64"/>
+          <p:cNvSpPr/>
+          <p:nvPr/>
+        </p:nvSpPr>
+        <p:spPr>
+          <a:xfrm>
+            <a:off x="2377440" y="6473952"/>
+            <a:ext cx="457200" cy="219456"/>
+          </a:xfrm>
+          <a:prstGeom prst="roundRect">
+            <a:avLst>
+              <a:gd name="adj" fmla="val 50000"/>
+            </a:avLst>
+          </a:prstGeom>
+          <a:solidFill>
+            <a:srgbClr val="E07B22"/>
+          </a:solidFill>
+          <a:ln w="12700">
+            <a:solidFill>
+              <a:srgbClr val="FFFFFF"/>
+            </a:solidFill>
+            <a:prstDash val="solid"/>
+          </a:ln>
+        </p:spPr>
+      </p:sp>
+      <p:sp>
+        <p:nvSpPr>
+          <p:cNvPr id="67" name="Text 65"/>
+          <p:cNvSpPr/>
+          <p:nvPr/>
+        </p:nvSpPr>
+        <p:spPr>
+          <a:xfrm>
+            <a:off x="2926080" y="6455664"/>
+            <a:ext cx="3840480" cy="256032"/>
+          </a:xfrm>
+          <a:prstGeom prst="rect">
+            <a:avLst/>
+          </a:prstGeom>
+          <a:noFill/>
+          <a:ln/>
+        </p:spPr>
+        <p:txBody>
+          <a:bodyPr wrap="square" lIns="0" tIns="0" rIns="0" bIns="0" rtlCol="0" anchor="ctr"/>
+          <a:lstStyle/>
+          <a:p>
+            <a:pPr indent="0" marL="0">
+              <a:buNone/>
+            </a:pPr>
+            <a:r>
+              <a:rPr lang="en-US" sz="1300" b="1" dirty="0">
+                <a:solidFill>
+                  <a:srgbClr val="1F1A33"/>
+                </a:solidFill>
+                <a:latin typeface="Calibri" pitchFamily="34" charset="0"/>
+                <a:ea typeface="Calibri" pitchFamily="34" charset="-122"/>
+                <a:cs typeface="Calibri" pitchFamily="34" charset="-120"/>
+              </a:rPr>
+              <a:t>Parallel: all MPI ranks work together</a:t>
+            </a:r>
+            <a:endParaRPr lang="en-US" sz="1300" dirty="0"/>
+          </a:p>
+        </p:txBody>
+      </p:sp>
+      <p:sp>
+        <p:nvSpPr>
+          <p:cNvPr id="68" name="Shape 66"/>
+          <p:cNvSpPr/>
+          <p:nvPr/>
+        </p:nvSpPr>
+        <p:spPr>
+          <a:xfrm>
+            <a:off x="6766560" y="6473952"/>
+            <a:ext cx="457200" cy="219456"/>
+          </a:xfrm>
+          <a:prstGeom prst="roundRect">
+            <a:avLst>
+              <a:gd name="adj" fmla="val 50000"/>
+            </a:avLst>
+          </a:prstGeom>
+          <a:solidFill>
+            <a:srgbClr val="5B6770"/>
+          </a:solidFill>
+          <a:ln w="12700">
+            <a:solidFill>
+              <a:srgbClr val="FFFFFF"/>
+            </a:solidFill>
+            <a:prstDash val="solid"/>
+          </a:ln>
+        </p:spPr>
+      </p:sp>
+      <p:sp>
+        <p:nvSpPr>
+          <p:cNvPr id="69" name="Text 67"/>
+          <p:cNvSpPr/>
+          <p:nvPr/>
+        </p:nvSpPr>
+        <p:spPr>
+          <a:xfrm>
+            <a:off x="7315200" y="6455664"/>
+            <a:ext cx="3840480" cy="256032"/>
+          </a:xfrm>
+          <a:prstGeom prst="rect">
+            <a:avLst/>
+          </a:prstGeom>
+          <a:noFill/>
+          <a:ln/>
+        </p:spPr>
+        <p:txBody>
+          <a:bodyPr wrap="square" lIns="0" tIns="0" rIns="0" bIns="0" rtlCol="0" anchor="ctr"/>
+          <a:lstStyle/>
+          <a:p>
+            <a:pPr indent="0" marL="0">
+              <a:buNone/>
+            </a:pPr>
+            <a:r>
+              <a:rPr lang="en-US" sz="1300" b="1" dirty="0">
+                <a:solidFill>
+                  <a:srgbClr val="1F1A33"/>
+                </a:solidFill>
+                <a:latin typeface="Calibri" pitchFamily="34" charset="0"/>
+                <a:ea typeface="Calibri" pitchFamily="34" charset="-122"/>
+                <a:cs typeface="Calibri" pitchFamily="34" charset="-120"/>
+              </a:rPr>
+              <a:t>Sequential: executed on Rank 0 only</a:t>
             </a:r>
             <a:endParaRPr lang="en-US" sz="1300" dirty="0"/>
           </a:p>

</xml_diff>

<commit_message>
Overview: Stage 4 tag reads Rank 0 | Parallel: SSIM
Co-Authored-By: Claude Sonnet 5.5 <noreply@anthropic.com>
Claude-Session: https://claude.ai/code/session_01T6gEewJ8YaCdmnsfS34RJd
</commit_message>
<xml_diff>
--- a/results/seminar/figs/Seminar_Ibtihal_FINAL.pptx
+++ b/results/seminar/figs/Seminar_Ibtihal_FINAL.pptx
@@ -6037,7 +6037,7 @@
               <a:buNone/>
             </a:pPr>
             <a:r>
-              <a:rPr lang="en-US" sz="1200" b="1" dirty="0">
+              <a:rPr lang="en-US" sz="1100" b="1" dirty="0">
                 <a:solidFill>
                   <a:srgbClr val="5B6770"/>
                 </a:solidFill>
@@ -6045,9 +6045,9 @@
                 <a:ea typeface="Calibri" pitchFamily="34" charset="-122"/>
                 <a:cs typeface="Calibri" pitchFamily="34" charset="-120"/>
               </a:rPr>
-              <a:t>SEQUENTIAL: Rank 0</a:t>
-            </a:r>
-            <a:endParaRPr lang="en-US" sz="1200" dirty="0"/>
+              <a:t>Rank 0 | Parallel: SSIM</a:t>
+            </a:r>
+            <a:endParaRPr lang="en-US" sz="1100" dirty="0"/>
           </a:p>
         </p:txBody>
       </p:sp>

</xml_diff>

<commit_message>
Overview: training vectors per channel
Co-Authored-By: Claude Sonnet 5.5 <noreply@anthropic.com>
Claude-Session: https://claude.ai/code/session_01T6gEewJ8YaCdmnsfS34RJd
</commit_message>
<xml_diff>
--- a/results/seminar/figs/Seminar_Ibtihal_FINAL.pptx
+++ b/results/seminar/figs/Seminar_Ibtihal_FINAL.pptx
@@ -4432,7 +4432,7 @@
                 <a:ea typeface="Calibri" pitchFamily="34" charset="-122"/>
                 <a:cs typeface="Calibri" pitchFamily="34" charset="-120"/>
               </a:rPr>
-              <a:t>16-D,</a:t>
+              <a:t>16-D, N = 16,384</a:t>
             </a:r>
             <a:endParaRPr lang="en-US" sz="1600" dirty="0"/>
           </a:p>
@@ -4449,7 +4449,7 @@
                 <a:ea typeface="Calibri" pitchFamily="34" charset="-122"/>
                 <a:cs typeface="Calibri" pitchFamily="34" charset="-120"/>
               </a:rPr>
-              <a:t>N = 16,384</a:t>
+              <a:t>per channel</a:t>
             </a:r>
             <a:endParaRPr lang="en-US" sz="1600" dirty="0"/>
           </a:p>
@@ -4488,7 +4488,7 @@
                 <a:ea typeface="Calibri" pitchFamily="34" charset="-122"/>
                 <a:cs typeface="Calibri" pitchFamily="34" charset="-120"/>
               </a:rPr>
-              <a:t>16,384 training vectors (16-D)</a:t>
+              <a:t>16,384 training vectors per channel (16-D)</a:t>
             </a:r>
             <a:endParaRPr lang="en-US" sz="1300" dirty="0"/>
           </a:p>

</xml_diff>

<commit_message>
Metrics slide: new title, larger font, short S_comp note
Co-Authored-By: Claude Sonnet 5.5 <noreply@anthropic.com>
Claude-Session: https://claude.ai/code/session_01T6gEewJ8YaCdmnsfS34RJd
</commit_message>
<xml_diff>
--- a/results/seminar/figs/Seminar_Ibtihal_FINAL.pptx
+++ b/results/seminar/figs/Seminar_Ibtihal_FINAL.pptx
@@ -10504,7 +10504,7 @@
         <p:spPr>
           <a:xfrm>
             <a:off x="457200" y="320040"/>
-            <a:ext cx="3017520" cy="502920"/>
+            <a:ext cx="1463040" cy="502920"/>
           </a:xfrm>
           <a:prstGeom prst="roundRect">
             <a:avLst>
@@ -10531,7 +10531,7 @@
         <p:spPr>
           <a:xfrm>
             <a:off x="457200" y="320040"/>
-            <a:ext cx="3017520" cy="502920"/>
+            <a:ext cx="1463040" cy="502920"/>
           </a:xfrm>
           <a:prstGeom prst="rect">
             <a:avLst/>
@@ -10555,7 +10555,7 @@
                 <a:ea typeface="Calibri" pitchFamily="34" charset="-122"/>
                 <a:cs typeface="Calibri" pitchFamily="34" charset="-120"/>
               </a:rPr>
-              <a:t>Experimental Results</a:t>
+              <a:t>Results</a:t>
             </a:r>
             <a:endParaRPr lang="en-US" sz="1600" dirty="0"/>
           </a:p>
@@ -10569,8 +10569,8 @@
         </p:nvSpPr>
         <p:spPr>
           <a:xfrm>
-            <a:off x="3657600" y="274320"/>
-            <a:ext cx="8503920" cy="594360"/>
+            <a:off x="2103120" y="274320"/>
+            <a:ext cx="10058400" cy="594360"/>
           </a:xfrm>
           <a:prstGeom prst="rect">
             <a:avLst/>
@@ -10594,7 +10594,7 @@
                 <a:ea typeface="Cambria" pitchFamily="34" charset="-122"/>
                 <a:cs typeface="Cambria" pitchFamily="34" charset="-120"/>
               </a:rPr>
-              <a:t>Evaluation Metrics</a:t>
+              <a:t>Performance and Quality Evaluation Metrics</a:t>
             </a:r>
             <a:endParaRPr lang="en-US" sz="2800" dirty="0"/>
           </a:p>
@@ -10653,7 +10653,7 @@
                 <a:gridCol w="1920240"/>
                 <a:gridCol w="3520440"/>
               </a:tblGrid>
-              <a:tr h="566928">
+              <a:tr h="640080">
                 <a:tc>
                   <a:txBody>
                     <a:bodyPr/>
@@ -10927,7 +10927,7 @@
                   </a:tcPr>
                 </a:tc>
               </a:tr>
-              <a:tr h="566928">
+              <a:tr h="640080">
                 <a:tc>
                   <a:txBody>
                     <a:bodyPr/>
@@ -10937,7 +10937,7 @@
                         <a:buNone/>
                       </a:pPr>
                       <a:r>
-                        <a:rPr lang="en-US" sz="1500" b="1" dirty="0">
+                        <a:rPr lang="en-US" sz="1700" b="1" dirty="0">
                           <a:solidFill>
                             <a:srgbClr val="2A9D8F"/>
                           </a:solidFill>
@@ -10947,7 +10947,7 @@
                         </a:rPr>
                         <a:t>CR</a:t>
                       </a:r>
-                      <a:endParaRPr lang="en-US" sz="1500" dirty="0">
+                      <a:endParaRPr lang="en-US" sz="1700" dirty="0">
                         <a:latin typeface="Calibri" charset="0"/>
                         <a:ea typeface="Calibri" charset="0"/>
                         <a:cs typeface="Calibri" charset="0"/>
@@ -11005,7 +11005,7 @@
                         <a:buNone/>
                       </a:pPr>
                       <a:r>
-                        <a:rPr lang="en-US" sz="1400" dirty="0">
+                        <a:rPr lang="en-US" sz="1600" dirty="0">
                           <a:solidFill>
                             <a:srgbClr val="1F1A33"/>
                           </a:solidFill>
@@ -11015,7 +11015,7 @@
                         </a:rPr>
                         <a:t>S_orig / S_comp</a:t>
                       </a:r>
-                      <a:endParaRPr lang="en-US" sz="1400" dirty="0">
+                      <a:endParaRPr lang="en-US" sz="1600" dirty="0">
                         <a:latin typeface="Calibri" charset="0"/>
                         <a:ea typeface="Calibri" charset="0"/>
                         <a:cs typeface="Calibri" charset="0"/>
@@ -11073,7 +11073,7 @@
                         <a:buNone/>
                       </a:pPr>
                       <a:r>
-                        <a:rPr lang="en-US" sz="1500" b="1" dirty="0">
+                        <a:rPr lang="en-US" sz="1700" b="1" dirty="0">
                           <a:solidFill>
                             <a:srgbClr val="E07B22"/>
                           </a:solidFill>
@@ -11083,7 +11083,7 @@
                         </a:rPr>
                         <a:t>Execution time</a:t>
                       </a:r>
-                      <a:endParaRPr lang="en-US" sz="1500" dirty="0">
+                      <a:endParaRPr lang="en-US" sz="1700" dirty="0">
                         <a:latin typeface="Calibri" charset="0"/>
                         <a:ea typeface="Calibri" charset="0"/>
                         <a:cs typeface="Calibri" charset="0"/>
@@ -11141,7 +11141,7 @@
                         <a:buNone/>
                       </a:pPr>
                       <a:r>
-                        <a:rPr lang="en-US" sz="1400" dirty="0">
+                        <a:rPr lang="en-US" sz="1600" dirty="0">
                           <a:solidFill>
                             <a:srgbClr val="1F1A33"/>
                           </a:solidFill>
@@ -11151,7 +11151,7 @@
                         </a:rPr>
                         <a:t>T (median of 5 runs)</a:t>
                       </a:r>
-                      <a:endParaRPr lang="en-US" sz="1400" dirty="0">
+                      <a:endParaRPr lang="en-US" sz="1600" dirty="0">
                         <a:latin typeface="Calibri" charset="0"/>
                         <a:ea typeface="Calibri" charset="0"/>
                         <a:cs typeface="Calibri" charset="0"/>
@@ -11201,7 +11201,7 @@
                   </a:tcPr>
                 </a:tc>
               </a:tr>
-              <a:tr h="566928">
+              <a:tr h="640080">
                 <a:tc>
                   <a:txBody>
                     <a:bodyPr/>
@@ -11211,7 +11211,7 @@
                         <a:buNone/>
                       </a:pPr>
                       <a:r>
-                        <a:rPr lang="en-US" sz="1500" b="1" dirty="0">
+                        <a:rPr lang="en-US" sz="1700" b="1" dirty="0">
                           <a:solidFill>
                             <a:srgbClr val="2A9D8F"/>
                           </a:solidFill>
@@ -11221,7 +11221,7 @@
                         </a:rPr>
                         <a:t>BPP</a:t>
                       </a:r>
-                      <a:endParaRPr lang="en-US" sz="1500" dirty="0">
+                      <a:endParaRPr lang="en-US" sz="1700" dirty="0">
                         <a:latin typeface="Calibri" charset="0"/>
                         <a:ea typeface="Calibri" charset="0"/>
                         <a:cs typeface="Calibri" charset="0"/>
@@ -11279,7 +11279,7 @@
                         <a:buNone/>
                       </a:pPr>
                       <a:r>
-                        <a:rPr lang="en-US" sz="1400" dirty="0">
+                        <a:rPr lang="en-US" sz="1600" dirty="0">
                           <a:solidFill>
                             <a:srgbClr val="1F1A33"/>
                           </a:solidFill>
@@ -11289,7 +11289,7 @@
                         </a:rPr>
                         <a:t>compressed bits / pixels</a:t>
                       </a:r>
-                      <a:endParaRPr lang="en-US" sz="1400" dirty="0">
+                      <a:endParaRPr lang="en-US" sz="1600" dirty="0">
                         <a:latin typeface="Calibri" charset="0"/>
                         <a:ea typeface="Calibri" charset="0"/>
                         <a:cs typeface="Calibri" charset="0"/>
@@ -11347,7 +11347,7 @@
                         <a:buNone/>
                       </a:pPr>
                       <a:r>
-                        <a:rPr lang="en-US" sz="1500" b="1" dirty="0">
+                        <a:rPr lang="en-US" sz="1700" b="1" dirty="0">
                           <a:solidFill>
                             <a:srgbClr val="E07B22"/>
                           </a:solidFill>
@@ -11357,7 +11357,7 @@
                         </a:rPr>
                         <a:t>Speedup</a:t>
                       </a:r>
-                      <a:endParaRPr lang="en-US" sz="1500" dirty="0">
+                      <a:endParaRPr lang="en-US" sz="1700" dirty="0">
                         <a:latin typeface="Calibri" charset="0"/>
                         <a:ea typeface="Calibri" charset="0"/>
                         <a:cs typeface="Calibri" charset="0"/>
@@ -11415,7 +11415,7 @@
                         <a:buNone/>
                       </a:pPr>
                       <a:r>
-                        <a:rPr lang="en-US" sz="1400" dirty="0">
+                        <a:rPr lang="en-US" sz="1600" dirty="0">
                           <a:solidFill>
                             <a:srgbClr val="1F1A33"/>
                           </a:solidFill>
@@ -11425,7 +11425,7 @@
                         </a:rPr>
                         <a:t>S = T_seq / T_P</a:t>
                       </a:r>
-                      <a:endParaRPr lang="en-US" sz="1400" dirty="0">
+                      <a:endParaRPr lang="en-US" sz="1600" dirty="0">
                         <a:latin typeface="Calibri" charset="0"/>
                         <a:ea typeface="Calibri" charset="0"/>
                         <a:cs typeface="Calibri" charset="0"/>
@@ -11475,7 +11475,7 @@
                   </a:tcPr>
                 </a:tc>
               </a:tr>
-              <a:tr h="566928">
+              <a:tr h="640080">
                 <a:tc>
                   <a:txBody>
                     <a:bodyPr/>
@@ -11485,7 +11485,7 @@
                         <a:buNone/>
                       </a:pPr>
                       <a:r>
-                        <a:rPr lang="en-US" sz="1500" b="1" dirty="0">
+                        <a:rPr lang="en-US" sz="1700" b="1" dirty="0">
                           <a:solidFill>
                             <a:srgbClr val="2A9D8F"/>
                           </a:solidFill>
@@ -11495,7 +11495,7 @@
                         </a:rPr>
                         <a:t>MSE</a:t>
                       </a:r>
-                      <a:endParaRPr lang="en-US" sz="1500" dirty="0">
+                      <a:endParaRPr lang="en-US" sz="1700" dirty="0">
                         <a:latin typeface="Calibri" charset="0"/>
                         <a:ea typeface="Calibri" charset="0"/>
                         <a:cs typeface="Calibri" charset="0"/>
@@ -11553,7 +11553,7 @@
                         <a:buNone/>
                       </a:pPr>
                       <a:r>
-                        <a:rPr lang="en-US" sz="1400" dirty="0">
+                        <a:rPr lang="en-US" sz="1600" dirty="0">
                           <a:solidFill>
                             <a:srgbClr val="1F1A33"/>
                           </a:solidFill>
@@ -11563,7 +11563,7 @@
                         </a:rPr>
                         <a:t>mean (I − Î)²</a:t>
                       </a:r>
-                      <a:endParaRPr lang="en-US" sz="1400" dirty="0">
+                      <a:endParaRPr lang="en-US" sz="1600" dirty="0">
                         <a:latin typeface="Calibri" charset="0"/>
                         <a:ea typeface="Calibri" charset="0"/>
                         <a:cs typeface="Calibri" charset="0"/>
@@ -11621,7 +11621,7 @@
                         <a:buNone/>
                       </a:pPr>
                       <a:r>
-                        <a:rPr lang="en-US" sz="1500" b="1" dirty="0">
+                        <a:rPr lang="en-US" sz="1700" b="1" dirty="0">
                           <a:solidFill>
                             <a:srgbClr val="E07B22"/>
                           </a:solidFill>
@@ -11631,7 +11631,7 @@
                         </a:rPr>
                         <a:t>Efficiency</a:t>
                       </a:r>
-                      <a:endParaRPr lang="en-US" sz="1500" dirty="0">
+                      <a:endParaRPr lang="en-US" sz="1700" dirty="0">
                         <a:latin typeface="Calibri" charset="0"/>
                         <a:ea typeface="Calibri" charset="0"/>
                         <a:cs typeface="Calibri" charset="0"/>
@@ -11689,7 +11689,7 @@
                         <a:buNone/>
                       </a:pPr>
                       <a:r>
-                        <a:rPr lang="en-US" sz="1400" dirty="0">
+                        <a:rPr lang="en-US" sz="1600" dirty="0">
                           <a:solidFill>
                             <a:srgbClr val="1F1A33"/>
                           </a:solidFill>
@@ -11699,7 +11699,7 @@
                         </a:rPr>
                         <a:t>E = S / P</a:t>
                       </a:r>
-                      <a:endParaRPr lang="en-US" sz="1400" dirty="0">
+                      <a:endParaRPr lang="en-US" sz="1600" dirty="0">
                         <a:latin typeface="Calibri" charset="0"/>
                         <a:ea typeface="Calibri" charset="0"/>
                         <a:cs typeface="Calibri" charset="0"/>
@@ -11749,7 +11749,7 @@
                   </a:tcPr>
                 </a:tc>
               </a:tr>
-              <a:tr h="566928">
+              <a:tr h="640080">
                 <a:tc>
                   <a:txBody>
                     <a:bodyPr/>
@@ -11759,7 +11759,7 @@
                         <a:buNone/>
                       </a:pPr>
                       <a:r>
-                        <a:rPr lang="en-US" sz="1500" b="1" dirty="0">
+                        <a:rPr lang="en-US" sz="1700" b="1" dirty="0">
                           <a:solidFill>
                             <a:srgbClr val="2A9D8F"/>
                           </a:solidFill>
@@ -11769,7 +11769,7 @@
                         </a:rPr>
                         <a:t>PSNR</a:t>
                       </a:r>
-                      <a:endParaRPr lang="en-US" sz="1500" dirty="0">
+                      <a:endParaRPr lang="en-US" sz="1700" dirty="0">
                         <a:latin typeface="Calibri" charset="0"/>
                         <a:ea typeface="Calibri" charset="0"/>
                         <a:cs typeface="Calibri" charset="0"/>
@@ -11827,7 +11827,7 @@
                         <a:buNone/>
                       </a:pPr>
                       <a:r>
-                        <a:rPr lang="en-US" sz="1400" dirty="0">
+                        <a:rPr lang="en-US" sz="1600" dirty="0">
                           <a:solidFill>
                             <a:srgbClr val="1F1A33"/>
                           </a:solidFill>
@@ -11837,7 +11837,7 @@
                         </a:rPr>
                         <a:t>10·log10(255² / MSE)  dB</a:t>
                       </a:r>
-                      <a:endParaRPr lang="en-US" sz="1400" dirty="0">
+                      <a:endParaRPr lang="en-US" sz="1600" dirty="0">
                         <a:latin typeface="Calibri" charset="0"/>
                         <a:ea typeface="Calibri" charset="0"/>
                         <a:cs typeface="Calibri" charset="0"/>
@@ -11895,7 +11895,7 @@
                         <a:buNone/>
                       </a:pPr>
                       <a:r>
-                        <a:rPr lang="en-US" sz="1500" b="1" dirty="0">
+                        <a:rPr lang="en-US" sz="1700" b="1" dirty="0">
                           <a:solidFill>
                             <a:srgbClr val="E07B22"/>
                           </a:solidFill>
@@ -11905,7 +11905,7 @@
                         </a:rPr>
                         <a:t>Throughput</a:t>
                       </a:r>
-                      <a:endParaRPr lang="en-US" sz="1500" dirty="0">
+                      <a:endParaRPr lang="en-US" sz="1700" dirty="0">
                         <a:latin typeface="Calibri" charset="0"/>
                         <a:ea typeface="Calibri" charset="0"/>
                         <a:cs typeface="Calibri" charset="0"/>
@@ -11963,7 +11963,7 @@
                         <a:buNone/>
                       </a:pPr>
                       <a:r>
-                        <a:rPr lang="en-US" sz="1400" dirty="0">
+                        <a:rPr lang="en-US" sz="1600" dirty="0">
                           <a:solidFill>
                             <a:srgbClr val="1F1A33"/>
                           </a:solidFill>
@@ -11973,7 +11973,7 @@
                         </a:rPr>
                         <a:t>I_size / T_total  (MiB/s)</a:t>
                       </a:r>
-                      <a:endParaRPr lang="en-US" sz="1400" dirty="0">
+                      <a:endParaRPr lang="en-US" sz="1600" dirty="0">
                         <a:latin typeface="Calibri" charset="0"/>
                         <a:ea typeface="Calibri" charset="0"/>
                         <a:cs typeface="Calibri" charset="0"/>
@@ -12023,7 +12023,7 @@
                   </a:tcPr>
                 </a:tc>
               </a:tr>
-              <a:tr h="566928">
+              <a:tr h="640080">
                 <a:tc>
                   <a:txBody>
                     <a:bodyPr/>
@@ -12033,7 +12033,7 @@
                         <a:buNone/>
                       </a:pPr>
                       <a:r>
-                        <a:rPr lang="en-US" sz="1500" b="1" dirty="0">
+                        <a:rPr lang="en-US" sz="1700" b="1" dirty="0">
                           <a:solidFill>
                             <a:srgbClr val="2A9D8F"/>
                           </a:solidFill>
@@ -12043,7 +12043,7 @@
                         </a:rPr>
                         <a:t>SSIM</a:t>
                       </a:r>
-                      <a:endParaRPr lang="en-US" sz="1500" dirty="0">
+                      <a:endParaRPr lang="en-US" sz="1700" dirty="0">
                         <a:latin typeface="Calibri" charset="0"/>
                         <a:ea typeface="Calibri" charset="0"/>
                         <a:cs typeface="Calibri" charset="0"/>
@@ -12101,7 +12101,7 @@
                         <a:buNone/>
                       </a:pPr>
                       <a:r>
-                        <a:rPr lang="en-US" sz="1400" dirty="0">
+                        <a:rPr lang="en-US" sz="1600" dirty="0">
                           <a:solidFill>
                             <a:srgbClr val="1F1A33"/>
                           </a:solidFill>
@@ -12111,7 +12111,7 @@
                         </a:rPr>
                         <a:t>11 × 11 Gaussian window, σ = 1.5</a:t>
                       </a:r>
-                      <a:endParaRPr lang="en-US" sz="1400" dirty="0">
+                      <a:endParaRPr lang="en-US" sz="1600" dirty="0">
                         <a:latin typeface="Calibri" charset="0"/>
                         <a:ea typeface="Calibri" charset="0"/>
                         <a:cs typeface="Calibri" charset="0"/>
@@ -12169,7 +12169,7 @@
                         <a:buNone/>
                       </a:pPr>
                       <a:r>
-                        <a:rPr lang="en-US" sz="1500" b="1" dirty="0">
+                        <a:rPr lang="en-US" sz="1700" b="1" dirty="0">
                           <a:solidFill>
                             <a:srgbClr val="E07B22"/>
                           </a:solidFill>
@@ -12179,7 +12179,7 @@
                         </a:rPr>
                         <a:t>Karp–Flatt</a:t>
                       </a:r>
-                      <a:endParaRPr lang="en-US" sz="1500" dirty="0">
+                      <a:endParaRPr lang="en-US" sz="1700" dirty="0">
                         <a:latin typeface="Calibri" charset="0"/>
                         <a:ea typeface="Calibri" charset="0"/>
                         <a:cs typeface="Calibri" charset="0"/>
@@ -12237,7 +12237,7 @@
                         <a:buNone/>
                       </a:pPr>
                       <a:r>
-                        <a:rPr lang="en-US" sz="1400" dirty="0">
+                        <a:rPr lang="en-US" sz="1600" dirty="0">
                           <a:solidFill>
                             <a:srgbClr val="1F1A33"/>
                           </a:solidFill>
@@ -12247,7 +12247,7 @@
                         </a:rPr>
                         <a:t>e = (1/S − 1/P) / (1 − 1/P)</a:t>
                       </a:r>
-                      <a:endParaRPr lang="en-US" sz="1400" dirty="0">
+                      <a:endParaRPr lang="en-US" sz="1600" dirty="0">
                         <a:latin typeface="Calibri" charset="0"/>
                         <a:ea typeface="Calibri" charset="0"/>
                         <a:cs typeface="Calibri" charset="0"/>
@@ -12309,8 +12309,8 @@
         </p:nvSpPr>
         <p:spPr>
           <a:xfrm>
-            <a:off x="640080" y="5120640"/>
-            <a:ext cx="10927080" cy="914400"/>
+            <a:off x="640080" y="5257800"/>
+            <a:ext cx="10927080" cy="365760"/>
           </a:xfrm>
           <a:prstGeom prst="rect">
             <a:avLst/>
@@ -12326,7 +12326,7 @@
               <a:buNone/>
             </a:pPr>
             <a:r>
-              <a:rPr lang="en-US" sz="1300" i="1" dirty="0">
+              <a:rPr lang="en-US" sz="1500" i="1" dirty="0">
                 <a:solidFill>
                   <a:srgbClr val="6B4FA3"/>
                 </a:solidFill>
@@ -12334,9 +12334,9 @@
                 <a:ea typeface="Calibri" pitchFamily="34" charset="-122"/>
                 <a:cs typeface="Calibri" pitchFamily="34" charset="-120"/>
               </a:rPr>
-              <a:t>S_comp = accounted compressed size = codebook (K × 16 bytes, one byte per element) + Huffman table + Huffman-coded data. The table is accounted as 5 bytes per used symbol (1 byte symbol + 4 bytes frequency) plus 10 bytes of fixed metadata. For color images, MSE and PSNR are computed over RGB and SSIM is the mean of the channels.</a:t>
-            </a:r>
-            <a:endParaRPr lang="en-US" sz="1300" dirty="0"/>
+              <a:t>S_comp = codebook + Huffman table + Huffman-coded data (accounted size).</a:t>
+            </a:r>
+            <a:endParaRPr lang="en-US" sz="1500" dirty="0"/>
           </a:p>
         </p:txBody>
       </p:sp>
@@ -34061,7 +34061,7 @@
                 <a:gridCol w="1280160"/>
                 <a:gridCol w="2103120"/>
               </a:tblGrid>
-              <a:tr h="566928">
+              <a:tr h="640080">
                 <a:tc>
                   <a:txBody>
                     <a:bodyPr/>
@@ -34403,7 +34403,7 @@
                   </a:tcPr>
                 </a:tc>
               </a:tr>
-              <a:tr h="566928">
+              <a:tr h="640080">
                 <a:tc>
                   <a:txBody>
                     <a:bodyPr/>
@@ -34745,7 +34745,7 @@
                   </a:tcPr>
                 </a:tc>
               </a:tr>
-              <a:tr h="566928">
+              <a:tr h="640080">
                 <a:tc>
                   <a:txBody>
                     <a:bodyPr/>
@@ -35087,7 +35087,7 @@
                   </a:tcPr>
                 </a:tc>
               </a:tr>
-              <a:tr h="566928">
+              <a:tr h="640080">
                 <a:tc>
                   <a:txBody>
                     <a:bodyPr/>
@@ -35429,7 +35429,7 @@
                   </a:tcPr>
                 </a:tc>
               </a:tr>
-              <a:tr h="566928">
+              <a:tr h="640080">
                 <a:tc>
                   <a:txBody>
                     <a:bodyPr/>

</xml_diff>

<commit_message>
Seminar: formulas moved next to each result; metrics slide lists names only
Co-Authored-By: Claude Sonnet 5.5 <noreply@anthropic.com>
Claude-Session: https://claude.ai/code/session_01T6gEewJ8YaCdmnsfS34RJd
</commit_message>
<xml_diff>
--- a/results/seminar/figs/Seminar_Ibtihal_FINAL.pptx
+++ b/results/seminar/figs/Seminar_Ibtihal_FINAL.pptx
@@ -10625,1692 +10625,43 @@
           </a:ln>
         </p:spPr>
       </p:sp>
-      <p:graphicFrame>
-        <p:nvGraphicFramePr>
-          <p:cNvPr id="20" name="Table 0"/>
-          <p:cNvGraphicFramePr>
-            <a:graphicFrameLocks noGrp="1"/>
-          </p:cNvGraphicFramePr>
-          <p:nvPr>
-            <p:extLst>
-              <p:ext uri="{D42A27DB-BD31-4B8C-83A1-F6EECF244321}">
-                <p14:modId xmlns:p14="http://schemas.microsoft.com/office/powerpoint/2010/main" val="1579011935"/>
-              </p:ext>
-            </p:extLst>
-          </p:nvPr>
-        </p:nvGraphicFramePr>
-        <p:xfrm>
-          <a:off x="640080" y="1325880"/>
-          <a:ext cx="10927080" cy="914400"/>
-        </p:xfrm>
-        <a:graphic>
-          <a:graphicData uri="http://schemas.openxmlformats.org/drawingml/2006/table">
-            <a:tbl>
-              <a:tblPr/>
-              <a:tblGrid>
-                <a:gridCol w="1463040"/>
-                <a:gridCol w="4023360"/>
-                <a:gridCol w="1920240"/>
-                <a:gridCol w="3520440"/>
-              </a:tblGrid>
-              <a:tr h="640080">
-                <a:tc>
-                  <a:txBody>
-                    <a:bodyPr/>
-                    <a:lstStyle/>
-                    <a:p>
-                      <a:pPr algn="ctr" indent="0" marL="0">
-                        <a:buNone/>
-                      </a:pPr>
-                      <a:r>
-                        <a:rPr lang="en-US" sz="1400" b="1" dirty="0">
-                          <a:solidFill>
-                            <a:srgbClr val="FFFFFF"/>
-                          </a:solidFill>
-                          <a:latin typeface="Calibri" pitchFamily="34" charset="0"/>
-                          <a:ea typeface="Calibri" pitchFamily="34" charset="-122"/>
-                          <a:cs typeface="Calibri" pitchFamily="34" charset="-120"/>
-                        </a:rPr>
-                        <a:t>Quality</a:t>
-                      </a:r>
-                      <a:endParaRPr lang="en-US" sz="1400" dirty="0">
-                        <a:latin typeface="Calibri" charset="0"/>
-                        <a:ea typeface="Calibri" charset="0"/>
-                        <a:cs typeface="Calibri" charset="0"/>
-                      </a:endParaRPr>
-                    </a:p>
-                  </a:txBody>
-                  <a:tcPr marL="91440" marR="91440" marT="45720" marB="45720" anchor="ctr">
-                    <a:lnL w="19050" cap="flat" cmpd="sng" algn="ctr">
-                      <a:solidFill>
-                        <a:srgbClr val="FFFFFF"/>
-                      </a:solidFill>
-                      <a:prstDash val="solid"/>
-                      <a:round/>
-                      <a:headEnd type="none" w="med" len="med"/>
-                      <a:tailEnd type="none" w="med" len="med"/>
-                    </a:lnL>
-                    <a:lnR w="19050" cap="flat" cmpd="sng" algn="ctr">
-                      <a:solidFill>
-                        <a:srgbClr val="FFFFFF"/>
-                      </a:solidFill>
-                      <a:prstDash val="solid"/>
-                      <a:round/>
-                      <a:headEnd type="none" w="med" len="med"/>
-                      <a:tailEnd type="none" w="med" len="med"/>
-                    </a:lnR>
-                    <a:lnT w="19050" cap="flat" cmpd="sng" algn="ctr">
-                      <a:solidFill>
-                        <a:srgbClr val="FFFFFF"/>
-                      </a:solidFill>
-                      <a:prstDash val="solid"/>
-                      <a:round/>
-                      <a:headEnd type="none" w="med" len="med"/>
-                      <a:tailEnd type="none" w="med" len="med"/>
-                    </a:lnT>
-                    <a:lnB w="19050" cap="flat" cmpd="sng" algn="ctr">
-                      <a:solidFill>
-                        <a:srgbClr val="FFFFFF"/>
-                      </a:solidFill>
-                      <a:prstDash val="solid"/>
-                      <a:round/>
-                      <a:headEnd type="none" w="med" len="med"/>
-                      <a:tailEnd type="none" w="med" len="med"/>
-                    </a:lnB>
-                    <a:solidFill>
-                      <a:srgbClr val="2A9D8F"/>
-                    </a:solidFill>
-                  </a:tcPr>
-                </a:tc>
-                <a:tc>
-                  <a:txBody>
-                    <a:bodyPr/>
-                    <a:lstStyle/>
-                    <a:p>
-                      <a:pPr algn="ctr" indent="0" marL="0">
-                        <a:buNone/>
-                      </a:pPr>
-                      <a:r>
-                        <a:rPr lang="en-US" sz="1400" b="1" dirty="0">
-                          <a:solidFill>
-                            <a:srgbClr val="FFFFFF"/>
-                          </a:solidFill>
-                          <a:latin typeface="Calibri" pitchFamily="34" charset="0"/>
-                          <a:ea typeface="Calibri" pitchFamily="34" charset="-122"/>
-                          <a:cs typeface="Calibri" pitchFamily="34" charset="-120"/>
-                        </a:rPr>
-                        <a:t>Formula</a:t>
-                      </a:r>
-                      <a:endParaRPr lang="en-US" sz="1400" dirty="0">
-                        <a:latin typeface="Calibri" charset="0"/>
-                        <a:ea typeface="Calibri" charset="0"/>
-                        <a:cs typeface="Calibri" charset="0"/>
-                      </a:endParaRPr>
-                    </a:p>
-                  </a:txBody>
-                  <a:tcPr marL="91440" marR="91440" marT="45720" marB="45720" anchor="ctr">
-                    <a:lnL w="19050" cap="flat" cmpd="sng" algn="ctr">
-                      <a:solidFill>
-                        <a:srgbClr val="FFFFFF"/>
-                      </a:solidFill>
-                      <a:prstDash val="solid"/>
-                      <a:round/>
-                      <a:headEnd type="none" w="med" len="med"/>
-                      <a:tailEnd type="none" w="med" len="med"/>
-                    </a:lnL>
-                    <a:lnR w="19050" cap="flat" cmpd="sng" algn="ctr">
-                      <a:solidFill>
-                        <a:srgbClr val="FFFFFF"/>
-                      </a:solidFill>
-                      <a:prstDash val="solid"/>
-                      <a:round/>
-                      <a:headEnd type="none" w="med" len="med"/>
-                      <a:tailEnd type="none" w="med" len="med"/>
-                    </a:lnR>
-                    <a:lnT w="19050" cap="flat" cmpd="sng" algn="ctr">
-                      <a:solidFill>
-                        <a:srgbClr val="FFFFFF"/>
-                      </a:solidFill>
-                      <a:prstDash val="solid"/>
-                      <a:round/>
-                      <a:headEnd type="none" w="med" len="med"/>
-                      <a:tailEnd type="none" w="med" len="med"/>
-                    </a:lnT>
-                    <a:lnB w="19050" cap="flat" cmpd="sng" algn="ctr">
-                      <a:solidFill>
-                        <a:srgbClr val="FFFFFF"/>
-                      </a:solidFill>
-                      <a:prstDash val="solid"/>
-                      <a:round/>
-                      <a:headEnd type="none" w="med" len="med"/>
-                      <a:tailEnd type="none" w="med" len="med"/>
-                    </a:lnB>
-                    <a:solidFill>
-                      <a:srgbClr val="2A9D8F"/>
-                    </a:solidFill>
-                  </a:tcPr>
-                </a:tc>
-                <a:tc>
-                  <a:txBody>
-                    <a:bodyPr/>
-                    <a:lstStyle/>
-                    <a:p>
-                      <a:pPr algn="ctr" indent="0" marL="0">
-                        <a:buNone/>
-                      </a:pPr>
-                      <a:r>
-                        <a:rPr lang="en-US" sz="1400" b="1" dirty="0">
-                          <a:solidFill>
-                            <a:srgbClr val="FFFFFF"/>
-                          </a:solidFill>
-                          <a:latin typeface="Calibri" pitchFamily="34" charset="0"/>
-                          <a:ea typeface="Calibri" pitchFamily="34" charset="-122"/>
-                          <a:cs typeface="Calibri" pitchFamily="34" charset="-120"/>
-                        </a:rPr>
-                        <a:t>Performance</a:t>
-                      </a:r>
-                      <a:endParaRPr lang="en-US" sz="1400" dirty="0">
-                        <a:latin typeface="Calibri" charset="0"/>
-                        <a:ea typeface="Calibri" charset="0"/>
-                        <a:cs typeface="Calibri" charset="0"/>
-                      </a:endParaRPr>
-                    </a:p>
-                  </a:txBody>
-                  <a:tcPr marL="91440" marR="91440" marT="45720" marB="45720" anchor="ctr">
-                    <a:lnL w="19050" cap="flat" cmpd="sng" algn="ctr">
-                      <a:solidFill>
-                        <a:srgbClr val="FFFFFF"/>
-                      </a:solidFill>
-                      <a:prstDash val="solid"/>
-                      <a:round/>
-                      <a:headEnd type="none" w="med" len="med"/>
-                      <a:tailEnd type="none" w="med" len="med"/>
-                    </a:lnL>
-                    <a:lnR w="19050" cap="flat" cmpd="sng" algn="ctr">
-                      <a:solidFill>
-                        <a:srgbClr val="FFFFFF"/>
-                      </a:solidFill>
-                      <a:prstDash val="solid"/>
-                      <a:round/>
-                      <a:headEnd type="none" w="med" len="med"/>
-                      <a:tailEnd type="none" w="med" len="med"/>
-                    </a:lnR>
-                    <a:lnT w="19050" cap="flat" cmpd="sng" algn="ctr">
-                      <a:solidFill>
-                        <a:srgbClr val="FFFFFF"/>
-                      </a:solidFill>
-                      <a:prstDash val="solid"/>
-                      <a:round/>
-                      <a:headEnd type="none" w="med" len="med"/>
-                      <a:tailEnd type="none" w="med" len="med"/>
-                    </a:lnT>
-                    <a:lnB w="19050" cap="flat" cmpd="sng" algn="ctr">
-                      <a:solidFill>
-                        <a:srgbClr val="FFFFFF"/>
-                      </a:solidFill>
-                      <a:prstDash val="solid"/>
-                      <a:round/>
-                      <a:headEnd type="none" w="med" len="med"/>
-                      <a:tailEnd type="none" w="med" len="med"/>
-                    </a:lnB>
-                    <a:solidFill>
-                      <a:srgbClr val="E07B22"/>
-                    </a:solidFill>
-                  </a:tcPr>
-                </a:tc>
-                <a:tc>
-                  <a:txBody>
-                    <a:bodyPr/>
-                    <a:lstStyle/>
-                    <a:p>
-                      <a:pPr algn="ctr" indent="0" marL="0">
-                        <a:buNone/>
-                      </a:pPr>
-                      <a:r>
-                        <a:rPr lang="en-US" sz="1400" b="1" dirty="0">
-                          <a:solidFill>
-                            <a:srgbClr val="FFFFFF"/>
-                          </a:solidFill>
-                          <a:latin typeface="Calibri" pitchFamily="34" charset="0"/>
-                          <a:ea typeface="Calibri" pitchFamily="34" charset="-122"/>
-                          <a:cs typeface="Calibri" pitchFamily="34" charset="-120"/>
-                        </a:rPr>
-                        <a:t>Formula</a:t>
-                      </a:r>
-                      <a:endParaRPr lang="en-US" sz="1400" dirty="0">
-                        <a:latin typeface="Calibri" charset="0"/>
-                        <a:ea typeface="Calibri" charset="0"/>
-                        <a:cs typeface="Calibri" charset="0"/>
-                      </a:endParaRPr>
-                    </a:p>
-                  </a:txBody>
-                  <a:tcPr marL="91440" marR="91440" marT="45720" marB="45720" anchor="ctr">
-                    <a:lnL w="19050" cap="flat" cmpd="sng" algn="ctr">
-                      <a:solidFill>
-                        <a:srgbClr val="FFFFFF"/>
-                      </a:solidFill>
-                      <a:prstDash val="solid"/>
-                      <a:round/>
-                      <a:headEnd type="none" w="med" len="med"/>
-                      <a:tailEnd type="none" w="med" len="med"/>
-                    </a:lnL>
-                    <a:lnR w="19050" cap="flat" cmpd="sng" algn="ctr">
-                      <a:solidFill>
-                        <a:srgbClr val="FFFFFF"/>
-                      </a:solidFill>
-                      <a:prstDash val="solid"/>
-                      <a:round/>
-                      <a:headEnd type="none" w="med" len="med"/>
-                      <a:tailEnd type="none" w="med" len="med"/>
-                    </a:lnR>
-                    <a:lnT w="19050" cap="flat" cmpd="sng" algn="ctr">
-                      <a:solidFill>
-                        <a:srgbClr val="FFFFFF"/>
-                      </a:solidFill>
-                      <a:prstDash val="solid"/>
-                      <a:round/>
-                      <a:headEnd type="none" w="med" len="med"/>
-                      <a:tailEnd type="none" w="med" len="med"/>
-                    </a:lnT>
-                    <a:lnB w="19050" cap="flat" cmpd="sng" algn="ctr">
-                      <a:solidFill>
-                        <a:srgbClr val="FFFFFF"/>
-                      </a:solidFill>
-                      <a:prstDash val="solid"/>
-                      <a:round/>
-                      <a:headEnd type="none" w="med" len="med"/>
-                      <a:tailEnd type="none" w="med" len="med"/>
-                    </a:lnB>
-                    <a:solidFill>
-                      <a:srgbClr val="E07B22"/>
-                    </a:solidFill>
-                  </a:tcPr>
-                </a:tc>
-              </a:tr>
-              <a:tr h="640080">
-                <a:tc>
-                  <a:txBody>
-                    <a:bodyPr/>
-                    <a:lstStyle/>
-                    <a:p>
-                      <a:pPr algn="ctr" indent="0" marL="0">
-                        <a:buNone/>
-                      </a:pPr>
-                      <a:r>
-                        <a:rPr lang="en-US" sz="1700" b="1" dirty="0">
-                          <a:solidFill>
-                            <a:srgbClr val="2A9D8F"/>
-                          </a:solidFill>
-                          <a:latin typeface="Calibri" pitchFamily="34" charset="0"/>
-                          <a:ea typeface="Calibri" pitchFamily="34" charset="-122"/>
-                          <a:cs typeface="Calibri" pitchFamily="34" charset="-120"/>
-                        </a:rPr>
-                        <a:t>CR</a:t>
-                      </a:r>
-                      <a:endParaRPr lang="en-US" sz="1700" dirty="0">
-                        <a:latin typeface="Calibri" charset="0"/>
-                        <a:ea typeface="Calibri" charset="0"/>
-                        <a:cs typeface="Calibri" charset="0"/>
-                      </a:endParaRPr>
-                    </a:p>
-                  </a:txBody>
-                  <a:tcPr marL="91440" marR="91440" marT="45720" marB="45720" anchor="ctr">
-                    <a:lnL w="19050" cap="flat" cmpd="sng" algn="ctr">
-                      <a:solidFill>
-                        <a:srgbClr val="FFFFFF"/>
-                      </a:solidFill>
-                      <a:prstDash val="solid"/>
-                      <a:round/>
-                      <a:headEnd type="none" w="med" len="med"/>
-                      <a:tailEnd type="none" w="med" len="med"/>
-                    </a:lnL>
-                    <a:lnR w="19050" cap="flat" cmpd="sng" algn="ctr">
-                      <a:solidFill>
-                        <a:srgbClr val="FFFFFF"/>
-                      </a:solidFill>
-                      <a:prstDash val="solid"/>
-                      <a:round/>
-                      <a:headEnd type="none" w="med" len="med"/>
-                      <a:tailEnd type="none" w="med" len="med"/>
-                    </a:lnR>
-                    <a:lnT w="19050" cap="flat" cmpd="sng" algn="ctr">
-                      <a:solidFill>
-                        <a:srgbClr val="FFFFFF"/>
-                      </a:solidFill>
-                      <a:prstDash val="solid"/>
-                      <a:round/>
-                      <a:headEnd type="none" w="med" len="med"/>
-                      <a:tailEnd type="none" w="med" len="med"/>
-                    </a:lnT>
-                    <a:lnB w="19050" cap="flat" cmpd="sng" algn="ctr">
-                      <a:solidFill>
-                        <a:srgbClr val="FFFFFF"/>
-                      </a:solidFill>
-                      <a:prstDash val="solid"/>
-                      <a:round/>
-                      <a:headEnd type="none" w="med" len="med"/>
-                      <a:tailEnd type="none" w="med" len="med"/>
-                    </a:lnB>
-                    <a:solidFill>
-                      <a:srgbClr val="EEF8F6"/>
-                    </a:solidFill>
-                  </a:tcPr>
-                </a:tc>
-                <a:tc>
-                  <a:txBody>
-                    <a:bodyPr/>
-                    <a:lstStyle/>
-                    <a:p>
-                      <a:pPr algn="ctr" indent="0" marL="0">
-                        <a:buNone/>
-                      </a:pPr>
-                      <a:r>
-                        <a:rPr lang="en-US" sz="1600" dirty="0">
-                          <a:solidFill>
-                            <a:srgbClr val="1F1A33"/>
-                          </a:solidFill>
-                          <a:latin typeface="Calibri" pitchFamily="34" charset="0"/>
-                          <a:ea typeface="Calibri" pitchFamily="34" charset="-122"/>
-                          <a:cs typeface="Calibri" pitchFamily="34" charset="-120"/>
-                        </a:rPr>
-                        <a:t>S_orig / S_comp</a:t>
-                      </a:r>
-                      <a:endParaRPr lang="en-US" sz="1600" dirty="0">
-                        <a:latin typeface="Calibri" charset="0"/>
-                        <a:ea typeface="Calibri" charset="0"/>
-                        <a:cs typeface="Calibri" charset="0"/>
-                      </a:endParaRPr>
-                    </a:p>
-                  </a:txBody>
-                  <a:tcPr marL="91440" marR="91440" marT="45720" marB="45720" anchor="ctr">
-                    <a:lnL w="19050" cap="flat" cmpd="sng" algn="ctr">
-                      <a:solidFill>
-                        <a:srgbClr val="FFFFFF"/>
-                      </a:solidFill>
-                      <a:prstDash val="solid"/>
-                      <a:round/>
-                      <a:headEnd type="none" w="med" len="med"/>
-                      <a:tailEnd type="none" w="med" len="med"/>
-                    </a:lnL>
-                    <a:lnR w="19050" cap="flat" cmpd="sng" algn="ctr">
-                      <a:solidFill>
-                        <a:srgbClr val="FFFFFF"/>
-                      </a:solidFill>
-                      <a:prstDash val="solid"/>
-                      <a:round/>
-                      <a:headEnd type="none" w="med" len="med"/>
-                      <a:tailEnd type="none" w="med" len="med"/>
-                    </a:lnR>
-                    <a:lnT w="19050" cap="flat" cmpd="sng" algn="ctr">
-                      <a:solidFill>
-                        <a:srgbClr val="FFFFFF"/>
-                      </a:solidFill>
-                      <a:prstDash val="solid"/>
-                      <a:round/>
-                      <a:headEnd type="none" w="med" len="med"/>
-                      <a:tailEnd type="none" w="med" len="med"/>
-                    </a:lnT>
-                    <a:lnB w="19050" cap="flat" cmpd="sng" algn="ctr">
-                      <a:solidFill>
-                        <a:srgbClr val="FFFFFF"/>
-                      </a:solidFill>
-                      <a:prstDash val="solid"/>
-                      <a:round/>
-                      <a:headEnd type="none" w="med" len="med"/>
-                      <a:tailEnd type="none" w="med" len="med"/>
-                    </a:lnB>
-                    <a:solidFill>
-                      <a:srgbClr val="EEF8F6"/>
-                    </a:solidFill>
-                  </a:tcPr>
-                </a:tc>
-                <a:tc>
-                  <a:txBody>
-                    <a:bodyPr/>
-                    <a:lstStyle/>
-                    <a:p>
-                      <a:pPr algn="ctr" indent="0" marL="0">
-                        <a:buNone/>
-                      </a:pPr>
-                      <a:r>
-                        <a:rPr lang="en-US" sz="1700" b="1" dirty="0">
-                          <a:solidFill>
-                            <a:srgbClr val="E07B22"/>
-                          </a:solidFill>
-                          <a:latin typeface="Calibri" pitchFamily="34" charset="0"/>
-                          <a:ea typeface="Calibri" pitchFamily="34" charset="-122"/>
-                          <a:cs typeface="Calibri" pitchFamily="34" charset="-120"/>
-                        </a:rPr>
-                        <a:t>Execution time</a:t>
-                      </a:r>
-                      <a:endParaRPr lang="en-US" sz="1700" dirty="0">
-                        <a:latin typeface="Calibri" charset="0"/>
-                        <a:ea typeface="Calibri" charset="0"/>
-                        <a:cs typeface="Calibri" charset="0"/>
-                      </a:endParaRPr>
-                    </a:p>
-                  </a:txBody>
-                  <a:tcPr marL="91440" marR="91440" marT="45720" marB="45720" anchor="ctr">
-                    <a:lnL w="19050" cap="flat" cmpd="sng" algn="ctr">
-                      <a:solidFill>
-                        <a:srgbClr val="FFFFFF"/>
-                      </a:solidFill>
-                      <a:prstDash val="solid"/>
-                      <a:round/>
-                      <a:headEnd type="none" w="med" len="med"/>
-                      <a:tailEnd type="none" w="med" len="med"/>
-                    </a:lnL>
-                    <a:lnR w="19050" cap="flat" cmpd="sng" algn="ctr">
-                      <a:solidFill>
-                        <a:srgbClr val="FFFFFF"/>
-                      </a:solidFill>
-                      <a:prstDash val="solid"/>
-                      <a:round/>
-                      <a:headEnd type="none" w="med" len="med"/>
-                      <a:tailEnd type="none" w="med" len="med"/>
-                    </a:lnR>
-                    <a:lnT w="19050" cap="flat" cmpd="sng" algn="ctr">
-                      <a:solidFill>
-                        <a:srgbClr val="FFFFFF"/>
-                      </a:solidFill>
-                      <a:prstDash val="solid"/>
-                      <a:round/>
-                      <a:headEnd type="none" w="med" len="med"/>
-                      <a:tailEnd type="none" w="med" len="med"/>
-                    </a:lnT>
-                    <a:lnB w="19050" cap="flat" cmpd="sng" algn="ctr">
-                      <a:solidFill>
-                        <a:srgbClr val="FFFFFF"/>
-                      </a:solidFill>
-                      <a:prstDash val="solid"/>
-                      <a:round/>
-                      <a:headEnd type="none" w="med" len="med"/>
-                      <a:tailEnd type="none" w="med" len="med"/>
-                    </a:lnB>
-                    <a:solidFill>
-                      <a:srgbClr val="FDF1E6"/>
-                    </a:solidFill>
-                  </a:tcPr>
-                </a:tc>
-                <a:tc>
-                  <a:txBody>
-                    <a:bodyPr/>
-                    <a:lstStyle/>
-                    <a:p>
-                      <a:pPr algn="ctr" indent="0" marL="0">
-                        <a:buNone/>
-                      </a:pPr>
-                      <a:r>
-                        <a:rPr lang="en-US" sz="1600" dirty="0">
-                          <a:solidFill>
-                            <a:srgbClr val="1F1A33"/>
-                          </a:solidFill>
-                          <a:latin typeface="Calibri" pitchFamily="34" charset="0"/>
-                          <a:ea typeface="Calibri" pitchFamily="34" charset="-122"/>
-                          <a:cs typeface="Calibri" pitchFamily="34" charset="-120"/>
-                        </a:rPr>
-                        <a:t>T (median of 5 runs)</a:t>
-                      </a:r>
-                      <a:endParaRPr lang="en-US" sz="1600" dirty="0">
-                        <a:latin typeface="Calibri" charset="0"/>
-                        <a:ea typeface="Calibri" charset="0"/>
-                        <a:cs typeface="Calibri" charset="0"/>
-                      </a:endParaRPr>
-                    </a:p>
-                  </a:txBody>
-                  <a:tcPr marL="91440" marR="91440" marT="45720" marB="45720" anchor="ctr">
-                    <a:lnL w="19050" cap="flat" cmpd="sng" algn="ctr">
-                      <a:solidFill>
-                        <a:srgbClr val="FFFFFF"/>
-                      </a:solidFill>
-                      <a:prstDash val="solid"/>
-                      <a:round/>
-                      <a:headEnd type="none" w="med" len="med"/>
-                      <a:tailEnd type="none" w="med" len="med"/>
-                    </a:lnL>
-                    <a:lnR w="19050" cap="flat" cmpd="sng" algn="ctr">
-                      <a:solidFill>
-                        <a:srgbClr val="FFFFFF"/>
-                      </a:solidFill>
-                      <a:prstDash val="solid"/>
-                      <a:round/>
-                      <a:headEnd type="none" w="med" len="med"/>
-                      <a:tailEnd type="none" w="med" len="med"/>
-                    </a:lnR>
-                    <a:lnT w="19050" cap="flat" cmpd="sng" algn="ctr">
-                      <a:solidFill>
-                        <a:srgbClr val="FFFFFF"/>
-                      </a:solidFill>
-                      <a:prstDash val="solid"/>
-                      <a:round/>
-                      <a:headEnd type="none" w="med" len="med"/>
-                      <a:tailEnd type="none" w="med" len="med"/>
-                    </a:lnT>
-                    <a:lnB w="19050" cap="flat" cmpd="sng" algn="ctr">
-                      <a:solidFill>
-                        <a:srgbClr val="FFFFFF"/>
-                      </a:solidFill>
-                      <a:prstDash val="solid"/>
-                      <a:round/>
-                      <a:headEnd type="none" w="med" len="med"/>
-                      <a:tailEnd type="none" w="med" len="med"/>
-                    </a:lnB>
-                    <a:solidFill>
-                      <a:srgbClr val="FDF1E6"/>
-                    </a:solidFill>
-                  </a:tcPr>
-                </a:tc>
-              </a:tr>
-              <a:tr h="640080">
-                <a:tc>
-                  <a:txBody>
-                    <a:bodyPr/>
-                    <a:lstStyle/>
-                    <a:p>
-                      <a:pPr algn="ctr" indent="0" marL="0">
-                        <a:buNone/>
-                      </a:pPr>
-                      <a:r>
-                        <a:rPr lang="en-US" sz="1700" b="1" dirty="0">
-                          <a:solidFill>
-                            <a:srgbClr val="2A9D8F"/>
-                          </a:solidFill>
-                          <a:latin typeface="Calibri" pitchFamily="34" charset="0"/>
-                          <a:ea typeface="Calibri" pitchFamily="34" charset="-122"/>
-                          <a:cs typeface="Calibri" pitchFamily="34" charset="-120"/>
-                        </a:rPr>
-                        <a:t>BPP</a:t>
-                      </a:r>
-                      <a:endParaRPr lang="en-US" sz="1700" dirty="0">
-                        <a:latin typeface="Calibri" charset="0"/>
-                        <a:ea typeface="Calibri" charset="0"/>
-                        <a:cs typeface="Calibri" charset="0"/>
-                      </a:endParaRPr>
-                    </a:p>
-                  </a:txBody>
-                  <a:tcPr marL="91440" marR="91440" marT="45720" marB="45720" anchor="ctr">
-                    <a:lnL w="19050" cap="flat" cmpd="sng" algn="ctr">
-                      <a:solidFill>
-                        <a:srgbClr val="FFFFFF"/>
-                      </a:solidFill>
-                      <a:prstDash val="solid"/>
-                      <a:round/>
-                      <a:headEnd type="none" w="med" len="med"/>
-                      <a:tailEnd type="none" w="med" len="med"/>
-                    </a:lnL>
-                    <a:lnR w="19050" cap="flat" cmpd="sng" algn="ctr">
-                      <a:solidFill>
-                        <a:srgbClr val="FFFFFF"/>
-                      </a:solidFill>
-                      <a:prstDash val="solid"/>
-                      <a:round/>
-                      <a:headEnd type="none" w="med" len="med"/>
-                      <a:tailEnd type="none" w="med" len="med"/>
-                    </a:lnR>
-                    <a:lnT w="19050" cap="flat" cmpd="sng" algn="ctr">
-                      <a:solidFill>
-                        <a:srgbClr val="FFFFFF"/>
-                      </a:solidFill>
-                      <a:prstDash val="solid"/>
-                      <a:round/>
-                      <a:headEnd type="none" w="med" len="med"/>
-                      <a:tailEnd type="none" w="med" len="med"/>
-                    </a:lnT>
-                    <a:lnB w="19050" cap="flat" cmpd="sng" algn="ctr">
-                      <a:solidFill>
-                        <a:srgbClr val="FFFFFF"/>
-                      </a:solidFill>
-                      <a:prstDash val="solid"/>
-                      <a:round/>
-                      <a:headEnd type="none" w="med" len="med"/>
-                      <a:tailEnd type="none" w="med" len="med"/>
-                    </a:lnB>
-                    <a:solidFill>
-                      <a:srgbClr val="FFFFFF"/>
-                    </a:solidFill>
-                  </a:tcPr>
-                </a:tc>
-                <a:tc>
-                  <a:txBody>
-                    <a:bodyPr/>
-                    <a:lstStyle/>
-                    <a:p>
-                      <a:pPr algn="ctr" indent="0" marL="0">
-                        <a:buNone/>
-                      </a:pPr>
-                      <a:r>
-                        <a:rPr lang="en-US" sz="1600" dirty="0">
-                          <a:solidFill>
-                            <a:srgbClr val="1F1A33"/>
-                          </a:solidFill>
-                          <a:latin typeface="Calibri" pitchFamily="34" charset="0"/>
-                          <a:ea typeface="Calibri" pitchFamily="34" charset="-122"/>
-                          <a:cs typeface="Calibri" pitchFamily="34" charset="-120"/>
-                        </a:rPr>
-                        <a:t>compressed bits / pixels</a:t>
-                      </a:r>
-                      <a:endParaRPr lang="en-US" sz="1600" dirty="0">
-                        <a:latin typeface="Calibri" charset="0"/>
-                        <a:ea typeface="Calibri" charset="0"/>
-                        <a:cs typeface="Calibri" charset="0"/>
-                      </a:endParaRPr>
-                    </a:p>
-                  </a:txBody>
-                  <a:tcPr marL="91440" marR="91440" marT="45720" marB="45720" anchor="ctr">
-                    <a:lnL w="19050" cap="flat" cmpd="sng" algn="ctr">
-                      <a:solidFill>
-                        <a:srgbClr val="FFFFFF"/>
-                      </a:solidFill>
-                      <a:prstDash val="solid"/>
-                      <a:round/>
-                      <a:headEnd type="none" w="med" len="med"/>
-                      <a:tailEnd type="none" w="med" len="med"/>
-                    </a:lnL>
-                    <a:lnR w="19050" cap="flat" cmpd="sng" algn="ctr">
-                      <a:solidFill>
-                        <a:srgbClr val="FFFFFF"/>
-                      </a:solidFill>
-                      <a:prstDash val="solid"/>
-                      <a:round/>
-                      <a:headEnd type="none" w="med" len="med"/>
-                      <a:tailEnd type="none" w="med" len="med"/>
-                    </a:lnR>
-                    <a:lnT w="19050" cap="flat" cmpd="sng" algn="ctr">
-                      <a:solidFill>
-                        <a:srgbClr val="FFFFFF"/>
-                      </a:solidFill>
-                      <a:prstDash val="solid"/>
-                      <a:round/>
-                      <a:headEnd type="none" w="med" len="med"/>
-                      <a:tailEnd type="none" w="med" len="med"/>
-                    </a:lnT>
-                    <a:lnB w="19050" cap="flat" cmpd="sng" algn="ctr">
-                      <a:solidFill>
-                        <a:srgbClr val="FFFFFF"/>
-                      </a:solidFill>
-                      <a:prstDash val="solid"/>
-                      <a:round/>
-                      <a:headEnd type="none" w="med" len="med"/>
-                      <a:tailEnd type="none" w="med" len="med"/>
-                    </a:lnB>
-                    <a:solidFill>
-                      <a:srgbClr val="FFFFFF"/>
-                    </a:solidFill>
-                  </a:tcPr>
-                </a:tc>
-                <a:tc>
-                  <a:txBody>
-                    <a:bodyPr/>
-                    <a:lstStyle/>
-                    <a:p>
-                      <a:pPr algn="ctr" indent="0" marL="0">
-                        <a:buNone/>
-                      </a:pPr>
-                      <a:r>
-                        <a:rPr lang="en-US" sz="1700" b="1" dirty="0">
-                          <a:solidFill>
-                            <a:srgbClr val="E07B22"/>
-                          </a:solidFill>
-                          <a:latin typeface="Calibri" pitchFamily="34" charset="0"/>
-                          <a:ea typeface="Calibri" pitchFamily="34" charset="-122"/>
-                          <a:cs typeface="Calibri" pitchFamily="34" charset="-120"/>
-                        </a:rPr>
-                        <a:t>Speedup</a:t>
-                      </a:r>
-                      <a:endParaRPr lang="en-US" sz="1700" dirty="0">
-                        <a:latin typeface="Calibri" charset="0"/>
-                        <a:ea typeface="Calibri" charset="0"/>
-                        <a:cs typeface="Calibri" charset="0"/>
-                      </a:endParaRPr>
-                    </a:p>
-                  </a:txBody>
-                  <a:tcPr marL="91440" marR="91440" marT="45720" marB="45720" anchor="ctr">
-                    <a:lnL w="19050" cap="flat" cmpd="sng" algn="ctr">
-                      <a:solidFill>
-                        <a:srgbClr val="FFFFFF"/>
-                      </a:solidFill>
-                      <a:prstDash val="solid"/>
-                      <a:round/>
-                      <a:headEnd type="none" w="med" len="med"/>
-                      <a:tailEnd type="none" w="med" len="med"/>
-                    </a:lnL>
-                    <a:lnR w="19050" cap="flat" cmpd="sng" algn="ctr">
-                      <a:solidFill>
-                        <a:srgbClr val="FFFFFF"/>
-                      </a:solidFill>
-                      <a:prstDash val="solid"/>
-                      <a:round/>
-                      <a:headEnd type="none" w="med" len="med"/>
-                      <a:tailEnd type="none" w="med" len="med"/>
-                    </a:lnR>
-                    <a:lnT w="19050" cap="flat" cmpd="sng" algn="ctr">
-                      <a:solidFill>
-                        <a:srgbClr val="FFFFFF"/>
-                      </a:solidFill>
-                      <a:prstDash val="solid"/>
-                      <a:round/>
-                      <a:headEnd type="none" w="med" len="med"/>
-                      <a:tailEnd type="none" w="med" len="med"/>
-                    </a:lnT>
-                    <a:lnB w="19050" cap="flat" cmpd="sng" algn="ctr">
-                      <a:solidFill>
-                        <a:srgbClr val="FFFFFF"/>
-                      </a:solidFill>
-                      <a:prstDash val="solid"/>
-                      <a:round/>
-                      <a:headEnd type="none" w="med" len="med"/>
-                      <a:tailEnd type="none" w="med" len="med"/>
-                    </a:lnB>
-                    <a:solidFill>
-                      <a:srgbClr val="FFFFFF"/>
-                    </a:solidFill>
-                  </a:tcPr>
-                </a:tc>
-                <a:tc>
-                  <a:txBody>
-                    <a:bodyPr/>
-                    <a:lstStyle/>
-                    <a:p>
-                      <a:pPr algn="ctr" indent="0" marL="0">
-                        <a:buNone/>
-                      </a:pPr>
-                      <a:r>
-                        <a:rPr lang="en-US" sz="1600" dirty="0">
-                          <a:solidFill>
-                            <a:srgbClr val="1F1A33"/>
-                          </a:solidFill>
-                          <a:latin typeface="Calibri" pitchFamily="34" charset="0"/>
-                          <a:ea typeface="Calibri" pitchFamily="34" charset="-122"/>
-                          <a:cs typeface="Calibri" pitchFamily="34" charset="-120"/>
-                        </a:rPr>
-                        <a:t>S = T_seq / T_P</a:t>
-                      </a:r>
-                      <a:endParaRPr lang="en-US" sz="1600" dirty="0">
-                        <a:latin typeface="Calibri" charset="0"/>
-                        <a:ea typeface="Calibri" charset="0"/>
-                        <a:cs typeface="Calibri" charset="0"/>
-                      </a:endParaRPr>
-                    </a:p>
-                  </a:txBody>
-                  <a:tcPr marL="91440" marR="91440" marT="45720" marB="45720" anchor="ctr">
-                    <a:lnL w="19050" cap="flat" cmpd="sng" algn="ctr">
-                      <a:solidFill>
-                        <a:srgbClr val="FFFFFF"/>
-                      </a:solidFill>
-                      <a:prstDash val="solid"/>
-                      <a:round/>
-                      <a:headEnd type="none" w="med" len="med"/>
-                      <a:tailEnd type="none" w="med" len="med"/>
-                    </a:lnL>
-                    <a:lnR w="19050" cap="flat" cmpd="sng" algn="ctr">
-                      <a:solidFill>
-                        <a:srgbClr val="FFFFFF"/>
-                      </a:solidFill>
-                      <a:prstDash val="solid"/>
-                      <a:round/>
-                      <a:headEnd type="none" w="med" len="med"/>
-                      <a:tailEnd type="none" w="med" len="med"/>
-                    </a:lnR>
-                    <a:lnT w="19050" cap="flat" cmpd="sng" algn="ctr">
-                      <a:solidFill>
-                        <a:srgbClr val="FFFFFF"/>
-                      </a:solidFill>
-                      <a:prstDash val="solid"/>
-                      <a:round/>
-                      <a:headEnd type="none" w="med" len="med"/>
-                      <a:tailEnd type="none" w="med" len="med"/>
-                    </a:lnT>
-                    <a:lnB w="19050" cap="flat" cmpd="sng" algn="ctr">
-                      <a:solidFill>
-                        <a:srgbClr val="FFFFFF"/>
-                      </a:solidFill>
-                      <a:prstDash val="solid"/>
-                      <a:round/>
-                      <a:headEnd type="none" w="med" len="med"/>
-                      <a:tailEnd type="none" w="med" len="med"/>
-                    </a:lnB>
-                    <a:solidFill>
-                      <a:srgbClr val="FFFFFF"/>
-                    </a:solidFill>
-                  </a:tcPr>
-                </a:tc>
-              </a:tr>
-              <a:tr h="640080">
-                <a:tc>
-                  <a:txBody>
-                    <a:bodyPr/>
-                    <a:lstStyle/>
-                    <a:p>
-                      <a:pPr algn="ctr" indent="0" marL="0">
-                        <a:buNone/>
-                      </a:pPr>
-                      <a:r>
-                        <a:rPr lang="en-US" sz="1700" b="1" dirty="0">
-                          <a:solidFill>
-                            <a:srgbClr val="2A9D8F"/>
-                          </a:solidFill>
-                          <a:latin typeface="Calibri" pitchFamily="34" charset="0"/>
-                          <a:ea typeface="Calibri" pitchFamily="34" charset="-122"/>
-                          <a:cs typeface="Calibri" pitchFamily="34" charset="-120"/>
-                        </a:rPr>
-                        <a:t>MSE</a:t>
-                      </a:r>
-                      <a:endParaRPr lang="en-US" sz="1700" dirty="0">
-                        <a:latin typeface="Calibri" charset="0"/>
-                        <a:ea typeface="Calibri" charset="0"/>
-                        <a:cs typeface="Calibri" charset="0"/>
-                      </a:endParaRPr>
-                    </a:p>
-                  </a:txBody>
-                  <a:tcPr marL="91440" marR="91440" marT="45720" marB="45720" anchor="ctr">
-                    <a:lnL w="19050" cap="flat" cmpd="sng" algn="ctr">
-                      <a:solidFill>
-                        <a:srgbClr val="FFFFFF"/>
-                      </a:solidFill>
-                      <a:prstDash val="solid"/>
-                      <a:round/>
-                      <a:headEnd type="none" w="med" len="med"/>
-                      <a:tailEnd type="none" w="med" len="med"/>
-                    </a:lnL>
-                    <a:lnR w="19050" cap="flat" cmpd="sng" algn="ctr">
-                      <a:solidFill>
-                        <a:srgbClr val="FFFFFF"/>
-                      </a:solidFill>
-                      <a:prstDash val="solid"/>
-                      <a:round/>
-                      <a:headEnd type="none" w="med" len="med"/>
-                      <a:tailEnd type="none" w="med" len="med"/>
-                    </a:lnR>
-                    <a:lnT w="19050" cap="flat" cmpd="sng" algn="ctr">
-                      <a:solidFill>
-                        <a:srgbClr val="FFFFFF"/>
-                      </a:solidFill>
-                      <a:prstDash val="solid"/>
-                      <a:round/>
-                      <a:headEnd type="none" w="med" len="med"/>
-                      <a:tailEnd type="none" w="med" len="med"/>
-                    </a:lnT>
-                    <a:lnB w="19050" cap="flat" cmpd="sng" algn="ctr">
-                      <a:solidFill>
-                        <a:srgbClr val="FFFFFF"/>
-                      </a:solidFill>
-                      <a:prstDash val="solid"/>
-                      <a:round/>
-                      <a:headEnd type="none" w="med" len="med"/>
-                      <a:tailEnd type="none" w="med" len="med"/>
-                    </a:lnB>
-                    <a:solidFill>
-                      <a:srgbClr val="EEF8F6"/>
-                    </a:solidFill>
-                  </a:tcPr>
-                </a:tc>
-                <a:tc>
-                  <a:txBody>
-                    <a:bodyPr/>
-                    <a:lstStyle/>
-                    <a:p>
-                      <a:pPr algn="ctr" indent="0" marL="0">
-                        <a:buNone/>
-                      </a:pPr>
-                      <a:r>
-                        <a:rPr lang="en-US" sz="1600" dirty="0">
-                          <a:solidFill>
-                            <a:srgbClr val="1F1A33"/>
-                          </a:solidFill>
-                          <a:latin typeface="Calibri" pitchFamily="34" charset="0"/>
-                          <a:ea typeface="Calibri" pitchFamily="34" charset="-122"/>
-                          <a:cs typeface="Calibri" pitchFamily="34" charset="-120"/>
-                        </a:rPr>
-                        <a:t>mean (I − Î)²</a:t>
-                      </a:r>
-                      <a:endParaRPr lang="en-US" sz="1600" dirty="0">
-                        <a:latin typeface="Calibri" charset="0"/>
-                        <a:ea typeface="Calibri" charset="0"/>
-                        <a:cs typeface="Calibri" charset="0"/>
-                      </a:endParaRPr>
-                    </a:p>
-                  </a:txBody>
-                  <a:tcPr marL="91440" marR="91440" marT="45720" marB="45720" anchor="ctr">
-                    <a:lnL w="19050" cap="flat" cmpd="sng" algn="ctr">
-                      <a:solidFill>
-                        <a:srgbClr val="FFFFFF"/>
-                      </a:solidFill>
-                      <a:prstDash val="solid"/>
-                      <a:round/>
-                      <a:headEnd type="none" w="med" len="med"/>
-                      <a:tailEnd type="none" w="med" len="med"/>
-                    </a:lnL>
-                    <a:lnR w="19050" cap="flat" cmpd="sng" algn="ctr">
-                      <a:solidFill>
-                        <a:srgbClr val="FFFFFF"/>
-                      </a:solidFill>
-                      <a:prstDash val="solid"/>
-                      <a:round/>
-                      <a:headEnd type="none" w="med" len="med"/>
-                      <a:tailEnd type="none" w="med" len="med"/>
-                    </a:lnR>
-                    <a:lnT w="19050" cap="flat" cmpd="sng" algn="ctr">
-                      <a:solidFill>
-                        <a:srgbClr val="FFFFFF"/>
-                      </a:solidFill>
-                      <a:prstDash val="solid"/>
-                      <a:round/>
-                      <a:headEnd type="none" w="med" len="med"/>
-                      <a:tailEnd type="none" w="med" len="med"/>
-                    </a:lnT>
-                    <a:lnB w="19050" cap="flat" cmpd="sng" algn="ctr">
-                      <a:solidFill>
-                        <a:srgbClr val="FFFFFF"/>
-                      </a:solidFill>
-                      <a:prstDash val="solid"/>
-                      <a:round/>
-                      <a:headEnd type="none" w="med" len="med"/>
-                      <a:tailEnd type="none" w="med" len="med"/>
-                    </a:lnB>
-                    <a:solidFill>
-                      <a:srgbClr val="EEF8F6"/>
-                    </a:solidFill>
-                  </a:tcPr>
-                </a:tc>
-                <a:tc>
-                  <a:txBody>
-                    <a:bodyPr/>
-                    <a:lstStyle/>
-                    <a:p>
-                      <a:pPr algn="ctr" indent="0" marL="0">
-                        <a:buNone/>
-                      </a:pPr>
-                      <a:r>
-                        <a:rPr lang="en-US" sz="1700" b="1" dirty="0">
-                          <a:solidFill>
-                            <a:srgbClr val="E07B22"/>
-                          </a:solidFill>
-                          <a:latin typeface="Calibri" pitchFamily="34" charset="0"/>
-                          <a:ea typeface="Calibri" pitchFamily="34" charset="-122"/>
-                          <a:cs typeface="Calibri" pitchFamily="34" charset="-120"/>
-                        </a:rPr>
-                        <a:t>Efficiency</a:t>
-                      </a:r>
-                      <a:endParaRPr lang="en-US" sz="1700" dirty="0">
-                        <a:latin typeface="Calibri" charset="0"/>
-                        <a:ea typeface="Calibri" charset="0"/>
-                        <a:cs typeface="Calibri" charset="0"/>
-                      </a:endParaRPr>
-                    </a:p>
-                  </a:txBody>
-                  <a:tcPr marL="91440" marR="91440" marT="45720" marB="45720" anchor="ctr">
-                    <a:lnL w="19050" cap="flat" cmpd="sng" algn="ctr">
-                      <a:solidFill>
-                        <a:srgbClr val="FFFFFF"/>
-                      </a:solidFill>
-                      <a:prstDash val="solid"/>
-                      <a:round/>
-                      <a:headEnd type="none" w="med" len="med"/>
-                      <a:tailEnd type="none" w="med" len="med"/>
-                    </a:lnL>
-                    <a:lnR w="19050" cap="flat" cmpd="sng" algn="ctr">
-                      <a:solidFill>
-                        <a:srgbClr val="FFFFFF"/>
-                      </a:solidFill>
-                      <a:prstDash val="solid"/>
-                      <a:round/>
-                      <a:headEnd type="none" w="med" len="med"/>
-                      <a:tailEnd type="none" w="med" len="med"/>
-                    </a:lnR>
-                    <a:lnT w="19050" cap="flat" cmpd="sng" algn="ctr">
-                      <a:solidFill>
-                        <a:srgbClr val="FFFFFF"/>
-                      </a:solidFill>
-                      <a:prstDash val="solid"/>
-                      <a:round/>
-                      <a:headEnd type="none" w="med" len="med"/>
-                      <a:tailEnd type="none" w="med" len="med"/>
-                    </a:lnT>
-                    <a:lnB w="19050" cap="flat" cmpd="sng" algn="ctr">
-                      <a:solidFill>
-                        <a:srgbClr val="FFFFFF"/>
-                      </a:solidFill>
-                      <a:prstDash val="solid"/>
-                      <a:round/>
-                      <a:headEnd type="none" w="med" len="med"/>
-                      <a:tailEnd type="none" w="med" len="med"/>
-                    </a:lnB>
-                    <a:solidFill>
-                      <a:srgbClr val="FDF1E6"/>
-                    </a:solidFill>
-                  </a:tcPr>
-                </a:tc>
-                <a:tc>
-                  <a:txBody>
-                    <a:bodyPr/>
-                    <a:lstStyle/>
-                    <a:p>
-                      <a:pPr algn="ctr" indent="0" marL="0">
-                        <a:buNone/>
-                      </a:pPr>
-                      <a:r>
-                        <a:rPr lang="en-US" sz="1600" dirty="0">
-                          <a:solidFill>
-                            <a:srgbClr val="1F1A33"/>
-                          </a:solidFill>
-                          <a:latin typeface="Calibri" pitchFamily="34" charset="0"/>
-                          <a:ea typeface="Calibri" pitchFamily="34" charset="-122"/>
-                          <a:cs typeface="Calibri" pitchFamily="34" charset="-120"/>
-                        </a:rPr>
-                        <a:t>E = S / P</a:t>
-                      </a:r>
-                      <a:endParaRPr lang="en-US" sz="1600" dirty="0">
-                        <a:latin typeface="Calibri" charset="0"/>
-                        <a:ea typeface="Calibri" charset="0"/>
-                        <a:cs typeface="Calibri" charset="0"/>
-                      </a:endParaRPr>
-                    </a:p>
-                  </a:txBody>
-                  <a:tcPr marL="91440" marR="91440" marT="45720" marB="45720" anchor="ctr">
-                    <a:lnL w="19050" cap="flat" cmpd="sng" algn="ctr">
-                      <a:solidFill>
-                        <a:srgbClr val="FFFFFF"/>
-                      </a:solidFill>
-                      <a:prstDash val="solid"/>
-                      <a:round/>
-                      <a:headEnd type="none" w="med" len="med"/>
-                      <a:tailEnd type="none" w="med" len="med"/>
-                    </a:lnL>
-                    <a:lnR w="19050" cap="flat" cmpd="sng" algn="ctr">
-                      <a:solidFill>
-                        <a:srgbClr val="FFFFFF"/>
-                      </a:solidFill>
-                      <a:prstDash val="solid"/>
-                      <a:round/>
-                      <a:headEnd type="none" w="med" len="med"/>
-                      <a:tailEnd type="none" w="med" len="med"/>
-                    </a:lnR>
-                    <a:lnT w="19050" cap="flat" cmpd="sng" algn="ctr">
-                      <a:solidFill>
-                        <a:srgbClr val="FFFFFF"/>
-                      </a:solidFill>
-                      <a:prstDash val="solid"/>
-                      <a:round/>
-                      <a:headEnd type="none" w="med" len="med"/>
-                      <a:tailEnd type="none" w="med" len="med"/>
-                    </a:lnT>
-                    <a:lnB w="19050" cap="flat" cmpd="sng" algn="ctr">
-                      <a:solidFill>
-                        <a:srgbClr val="FFFFFF"/>
-                      </a:solidFill>
-                      <a:prstDash val="solid"/>
-                      <a:round/>
-                      <a:headEnd type="none" w="med" len="med"/>
-                      <a:tailEnd type="none" w="med" len="med"/>
-                    </a:lnB>
-                    <a:solidFill>
-                      <a:srgbClr val="FDF1E6"/>
-                    </a:solidFill>
-                  </a:tcPr>
-                </a:tc>
-              </a:tr>
-              <a:tr h="640080">
-                <a:tc>
-                  <a:txBody>
-                    <a:bodyPr/>
-                    <a:lstStyle/>
-                    <a:p>
-                      <a:pPr algn="ctr" indent="0" marL="0">
-                        <a:buNone/>
-                      </a:pPr>
-                      <a:r>
-                        <a:rPr lang="en-US" sz="1700" b="1" dirty="0">
-                          <a:solidFill>
-                            <a:srgbClr val="2A9D8F"/>
-                          </a:solidFill>
-                          <a:latin typeface="Calibri" pitchFamily="34" charset="0"/>
-                          <a:ea typeface="Calibri" pitchFamily="34" charset="-122"/>
-                          <a:cs typeface="Calibri" pitchFamily="34" charset="-120"/>
-                        </a:rPr>
-                        <a:t>PSNR</a:t>
-                      </a:r>
-                      <a:endParaRPr lang="en-US" sz="1700" dirty="0">
-                        <a:latin typeface="Calibri" charset="0"/>
-                        <a:ea typeface="Calibri" charset="0"/>
-                        <a:cs typeface="Calibri" charset="0"/>
-                      </a:endParaRPr>
-                    </a:p>
-                  </a:txBody>
-                  <a:tcPr marL="91440" marR="91440" marT="45720" marB="45720" anchor="ctr">
-                    <a:lnL w="19050" cap="flat" cmpd="sng" algn="ctr">
-                      <a:solidFill>
-                        <a:srgbClr val="FFFFFF"/>
-                      </a:solidFill>
-                      <a:prstDash val="solid"/>
-                      <a:round/>
-                      <a:headEnd type="none" w="med" len="med"/>
-                      <a:tailEnd type="none" w="med" len="med"/>
-                    </a:lnL>
-                    <a:lnR w="19050" cap="flat" cmpd="sng" algn="ctr">
-                      <a:solidFill>
-                        <a:srgbClr val="FFFFFF"/>
-                      </a:solidFill>
-                      <a:prstDash val="solid"/>
-                      <a:round/>
-                      <a:headEnd type="none" w="med" len="med"/>
-                      <a:tailEnd type="none" w="med" len="med"/>
-                    </a:lnR>
-                    <a:lnT w="19050" cap="flat" cmpd="sng" algn="ctr">
-                      <a:solidFill>
-                        <a:srgbClr val="FFFFFF"/>
-                      </a:solidFill>
-                      <a:prstDash val="solid"/>
-                      <a:round/>
-                      <a:headEnd type="none" w="med" len="med"/>
-                      <a:tailEnd type="none" w="med" len="med"/>
-                    </a:lnT>
-                    <a:lnB w="19050" cap="flat" cmpd="sng" algn="ctr">
-                      <a:solidFill>
-                        <a:srgbClr val="FFFFFF"/>
-                      </a:solidFill>
-                      <a:prstDash val="solid"/>
-                      <a:round/>
-                      <a:headEnd type="none" w="med" len="med"/>
-                      <a:tailEnd type="none" w="med" len="med"/>
-                    </a:lnB>
-                    <a:solidFill>
-                      <a:srgbClr val="FFFFFF"/>
-                    </a:solidFill>
-                  </a:tcPr>
-                </a:tc>
-                <a:tc>
-                  <a:txBody>
-                    <a:bodyPr/>
-                    <a:lstStyle/>
-                    <a:p>
-                      <a:pPr algn="ctr" indent="0" marL="0">
-                        <a:buNone/>
-                      </a:pPr>
-                      <a:r>
-                        <a:rPr lang="en-US" sz="1600" dirty="0">
-                          <a:solidFill>
-                            <a:srgbClr val="1F1A33"/>
-                          </a:solidFill>
-                          <a:latin typeface="Calibri" pitchFamily="34" charset="0"/>
-                          <a:ea typeface="Calibri" pitchFamily="34" charset="-122"/>
-                          <a:cs typeface="Calibri" pitchFamily="34" charset="-120"/>
-                        </a:rPr>
-                        <a:t>10·log10(255² / MSE)  dB</a:t>
-                      </a:r>
-                      <a:endParaRPr lang="en-US" sz="1600" dirty="0">
-                        <a:latin typeface="Calibri" charset="0"/>
-                        <a:ea typeface="Calibri" charset="0"/>
-                        <a:cs typeface="Calibri" charset="0"/>
-                      </a:endParaRPr>
-                    </a:p>
-                  </a:txBody>
-                  <a:tcPr marL="91440" marR="91440" marT="45720" marB="45720" anchor="ctr">
-                    <a:lnL w="19050" cap="flat" cmpd="sng" algn="ctr">
-                      <a:solidFill>
-                        <a:srgbClr val="FFFFFF"/>
-                      </a:solidFill>
-                      <a:prstDash val="solid"/>
-                      <a:round/>
-                      <a:headEnd type="none" w="med" len="med"/>
-                      <a:tailEnd type="none" w="med" len="med"/>
-                    </a:lnL>
-                    <a:lnR w="19050" cap="flat" cmpd="sng" algn="ctr">
-                      <a:solidFill>
-                        <a:srgbClr val="FFFFFF"/>
-                      </a:solidFill>
-                      <a:prstDash val="solid"/>
-                      <a:round/>
-                      <a:headEnd type="none" w="med" len="med"/>
-                      <a:tailEnd type="none" w="med" len="med"/>
-                    </a:lnR>
-                    <a:lnT w="19050" cap="flat" cmpd="sng" algn="ctr">
-                      <a:solidFill>
-                        <a:srgbClr val="FFFFFF"/>
-                      </a:solidFill>
-                      <a:prstDash val="solid"/>
-                      <a:round/>
-                      <a:headEnd type="none" w="med" len="med"/>
-                      <a:tailEnd type="none" w="med" len="med"/>
-                    </a:lnT>
-                    <a:lnB w="19050" cap="flat" cmpd="sng" algn="ctr">
-                      <a:solidFill>
-                        <a:srgbClr val="FFFFFF"/>
-                      </a:solidFill>
-                      <a:prstDash val="solid"/>
-                      <a:round/>
-                      <a:headEnd type="none" w="med" len="med"/>
-                      <a:tailEnd type="none" w="med" len="med"/>
-                    </a:lnB>
-                    <a:solidFill>
-                      <a:srgbClr val="FFFFFF"/>
-                    </a:solidFill>
-                  </a:tcPr>
-                </a:tc>
-                <a:tc>
-                  <a:txBody>
-                    <a:bodyPr/>
-                    <a:lstStyle/>
-                    <a:p>
-                      <a:pPr algn="ctr" indent="0" marL="0">
-                        <a:buNone/>
-                      </a:pPr>
-                      <a:r>
-                        <a:rPr lang="en-US" sz="1700" b="1" dirty="0">
-                          <a:solidFill>
-                            <a:srgbClr val="E07B22"/>
-                          </a:solidFill>
-                          <a:latin typeface="Calibri" pitchFamily="34" charset="0"/>
-                          <a:ea typeface="Calibri" pitchFamily="34" charset="-122"/>
-                          <a:cs typeface="Calibri" pitchFamily="34" charset="-120"/>
-                        </a:rPr>
-                        <a:t>Throughput</a:t>
-                      </a:r>
-                      <a:endParaRPr lang="en-US" sz="1700" dirty="0">
-                        <a:latin typeface="Calibri" charset="0"/>
-                        <a:ea typeface="Calibri" charset="0"/>
-                        <a:cs typeface="Calibri" charset="0"/>
-                      </a:endParaRPr>
-                    </a:p>
-                  </a:txBody>
-                  <a:tcPr marL="91440" marR="91440" marT="45720" marB="45720" anchor="ctr">
-                    <a:lnL w="19050" cap="flat" cmpd="sng" algn="ctr">
-                      <a:solidFill>
-                        <a:srgbClr val="FFFFFF"/>
-                      </a:solidFill>
-                      <a:prstDash val="solid"/>
-                      <a:round/>
-                      <a:headEnd type="none" w="med" len="med"/>
-                      <a:tailEnd type="none" w="med" len="med"/>
-                    </a:lnL>
-                    <a:lnR w="19050" cap="flat" cmpd="sng" algn="ctr">
-                      <a:solidFill>
-                        <a:srgbClr val="FFFFFF"/>
-                      </a:solidFill>
-                      <a:prstDash val="solid"/>
-                      <a:round/>
-                      <a:headEnd type="none" w="med" len="med"/>
-                      <a:tailEnd type="none" w="med" len="med"/>
-                    </a:lnR>
-                    <a:lnT w="19050" cap="flat" cmpd="sng" algn="ctr">
-                      <a:solidFill>
-                        <a:srgbClr val="FFFFFF"/>
-                      </a:solidFill>
-                      <a:prstDash val="solid"/>
-                      <a:round/>
-                      <a:headEnd type="none" w="med" len="med"/>
-                      <a:tailEnd type="none" w="med" len="med"/>
-                    </a:lnT>
-                    <a:lnB w="19050" cap="flat" cmpd="sng" algn="ctr">
-                      <a:solidFill>
-                        <a:srgbClr val="FFFFFF"/>
-                      </a:solidFill>
-                      <a:prstDash val="solid"/>
-                      <a:round/>
-                      <a:headEnd type="none" w="med" len="med"/>
-                      <a:tailEnd type="none" w="med" len="med"/>
-                    </a:lnB>
-                    <a:solidFill>
-                      <a:srgbClr val="FFFFFF"/>
-                    </a:solidFill>
-                  </a:tcPr>
-                </a:tc>
-                <a:tc>
-                  <a:txBody>
-                    <a:bodyPr/>
-                    <a:lstStyle/>
-                    <a:p>
-                      <a:pPr algn="ctr" indent="0" marL="0">
-                        <a:buNone/>
-                      </a:pPr>
-                      <a:r>
-                        <a:rPr lang="en-US" sz="1600" dirty="0">
-                          <a:solidFill>
-                            <a:srgbClr val="1F1A33"/>
-                          </a:solidFill>
-                          <a:latin typeface="Calibri" pitchFamily="34" charset="0"/>
-                          <a:ea typeface="Calibri" pitchFamily="34" charset="-122"/>
-                          <a:cs typeface="Calibri" pitchFamily="34" charset="-120"/>
-                        </a:rPr>
-                        <a:t>I_size / T_total  (MiB/s)</a:t>
-                      </a:r>
-                      <a:endParaRPr lang="en-US" sz="1600" dirty="0">
-                        <a:latin typeface="Calibri" charset="0"/>
-                        <a:ea typeface="Calibri" charset="0"/>
-                        <a:cs typeface="Calibri" charset="0"/>
-                      </a:endParaRPr>
-                    </a:p>
-                  </a:txBody>
-                  <a:tcPr marL="91440" marR="91440" marT="45720" marB="45720" anchor="ctr">
-                    <a:lnL w="19050" cap="flat" cmpd="sng" algn="ctr">
-                      <a:solidFill>
-                        <a:srgbClr val="FFFFFF"/>
-                      </a:solidFill>
-                      <a:prstDash val="solid"/>
-                      <a:round/>
-                      <a:headEnd type="none" w="med" len="med"/>
-                      <a:tailEnd type="none" w="med" len="med"/>
-                    </a:lnL>
-                    <a:lnR w="19050" cap="flat" cmpd="sng" algn="ctr">
-                      <a:solidFill>
-                        <a:srgbClr val="FFFFFF"/>
-                      </a:solidFill>
-                      <a:prstDash val="solid"/>
-                      <a:round/>
-                      <a:headEnd type="none" w="med" len="med"/>
-                      <a:tailEnd type="none" w="med" len="med"/>
-                    </a:lnR>
-                    <a:lnT w="19050" cap="flat" cmpd="sng" algn="ctr">
-                      <a:solidFill>
-                        <a:srgbClr val="FFFFFF"/>
-                      </a:solidFill>
-                      <a:prstDash val="solid"/>
-                      <a:round/>
-                      <a:headEnd type="none" w="med" len="med"/>
-                      <a:tailEnd type="none" w="med" len="med"/>
-                    </a:lnT>
-                    <a:lnB w="19050" cap="flat" cmpd="sng" algn="ctr">
-                      <a:solidFill>
-                        <a:srgbClr val="FFFFFF"/>
-                      </a:solidFill>
-                      <a:prstDash val="solid"/>
-                      <a:round/>
-                      <a:headEnd type="none" w="med" len="med"/>
-                      <a:tailEnd type="none" w="med" len="med"/>
-                    </a:lnB>
-                    <a:solidFill>
-                      <a:srgbClr val="FFFFFF"/>
-                    </a:solidFill>
-                  </a:tcPr>
-                </a:tc>
-              </a:tr>
-              <a:tr h="640080">
-                <a:tc>
-                  <a:txBody>
-                    <a:bodyPr/>
-                    <a:lstStyle/>
-                    <a:p>
-                      <a:pPr algn="ctr" indent="0" marL="0">
-                        <a:buNone/>
-                      </a:pPr>
-                      <a:r>
-                        <a:rPr lang="en-US" sz="1700" b="1" dirty="0">
-                          <a:solidFill>
-                            <a:srgbClr val="2A9D8F"/>
-                          </a:solidFill>
-                          <a:latin typeface="Calibri" pitchFamily="34" charset="0"/>
-                          <a:ea typeface="Calibri" pitchFamily="34" charset="-122"/>
-                          <a:cs typeface="Calibri" pitchFamily="34" charset="-120"/>
-                        </a:rPr>
-                        <a:t>SSIM</a:t>
-                      </a:r>
-                      <a:endParaRPr lang="en-US" sz="1700" dirty="0">
-                        <a:latin typeface="Calibri" charset="0"/>
-                        <a:ea typeface="Calibri" charset="0"/>
-                        <a:cs typeface="Calibri" charset="0"/>
-                      </a:endParaRPr>
-                    </a:p>
-                  </a:txBody>
-                  <a:tcPr marL="91440" marR="91440" marT="45720" marB="45720" anchor="ctr">
-                    <a:lnL w="19050" cap="flat" cmpd="sng" algn="ctr">
-                      <a:solidFill>
-                        <a:srgbClr val="FFFFFF"/>
-                      </a:solidFill>
-                      <a:prstDash val="solid"/>
-                      <a:round/>
-                      <a:headEnd type="none" w="med" len="med"/>
-                      <a:tailEnd type="none" w="med" len="med"/>
-                    </a:lnL>
-                    <a:lnR w="19050" cap="flat" cmpd="sng" algn="ctr">
-                      <a:solidFill>
-                        <a:srgbClr val="FFFFFF"/>
-                      </a:solidFill>
-                      <a:prstDash val="solid"/>
-                      <a:round/>
-                      <a:headEnd type="none" w="med" len="med"/>
-                      <a:tailEnd type="none" w="med" len="med"/>
-                    </a:lnR>
-                    <a:lnT w="19050" cap="flat" cmpd="sng" algn="ctr">
-                      <a:solidFill>
-                        <a:srgbClr val="FFFFFF"/>
-                      </a:solidFill>
-                      <a:prstDash val="solid"/>
-                      <a:round/>
-                      <a:headEnd type="none" w="med" len="med"/>
-                      <a:tailEnd type="none" w="med" len="med"/>
-                    </a:lnT>
-                    <a:lnB w="19050" cap="flat" cmpd="sng" algn="ctr">
-                      <a:solidFill>
-                        <a:srgbClr val="FFFFFF"/>
-                      </a:solidFill>
-                      <a:prstDash val="solid"/>
-                      <a:round/>
-                      <a:headEnd type="none" w="med" len="med"/>
-                      <a:tailEnd type="none" w="med" len="med"/>
-                    </a:lnB>
-                    <a:solidFill>
-                      <a:srgbClr val="EEF8F6"/>
-                    </a:solidFill>
-                  </a:tcPr>
-                </a:tc>
-                <a:tc>
-                  <a:txBody>
-                    <a:bodyPr/>
-                    <a:lstStyle/>
-                    <a:p>
-                      <a:pPr algn="ctr" indent="0" marL="0">
-                        <a:buNone/>
-                      </a:pPr>
-                      <a:r>
-                        <a:rPr lang="en-US" sz="1600" dirty="0">
-                          <a:solidFill>
-                            <a:srgbClr val="1F1A33"/>
-                          </a:solidFill>
-                          <a:latin typeface="Calibri" pitchFamily="34" charset="0"/>
-                          <a:ea typeface="Calibri" pitchFamily="34" charset="-122"/>
-                          <a:cs typeface="Calibri" pitchFamily="34" charset="-120"/>
-                        </a:rPr>
-                        <a:t>11 × 11 Gaussian window, σ = 1.5</a:t>
-                      </a:r>
-                      <a:endParaRPr lang="en-US" sz="1600" dirty="0">
-                        <a:latin typeface="Calibri" charset="0"/>
-                        <a:ea typeface="Calibri" charset="0"/>
-                        <a:cs typeface="Calibri" charset="0"/>
-                      </a:endParaRPr>
-                    </a:p>
-                  </a:txBody>
-                  <a:tcPr marL="91440" marR="91440" marT="45720" marB="45720" anchor="ctr">
-                    <a:lnL w="19050" cap="flat" cmpd="sng" algn="ctr">
-                      <a:solidFill>
-                        <a:srgbClr val="FFFFFF"/>
-                      </a:solidFill>
-                      <a:prstDash val="solid"/>
-                      <a:round/>
-                      <a:headEnd type="none" w="med" len="med"/>
-                      <a:tailEnd type="none" w="med" len="med"/>
-                    </a:lnL>
-                    <a:lnR w="19050" cap="flat" cmpd="sng" algn="ctr">
-                      <a:solidFill>
-                        <a:srgbClr val="FFFFFF"/>
-                      </a:solidFill>
-                      <a:prstDash val="solid"/>
-                      <a:round/>
-                      <a:headEnd type="none" w="med" len="med"/>
-                      <a:tailEnd type="none" w="med" len="med"/>
-                    </a:lnR>
-                    <a:lnT w="19050" cap="flat" cmpd="sng" algn="ctr">
-                      <a:solidFill>
-                        <a:srgbClr val="FFFFFF"/>
-                      </a:solidFill>
-                      <a:prstDash val="solid"/>
-                      <a:round/>
-                      <a:headEnd type="none" w="med" len="med"/>
-                      <a:tailEnd type="none" w="med" len="med"/>
-                    </a:lnT>
-                    <a:lnB w="19050" cap="flat" cmpd="sng" algn="ctr">
-                      <a:solidFill>
-                        <a:srgbClr val="FFFFFF"/>
-                      </a:solidFill>
-                      <a:prstDash val="solid"/>
-                      <a:round/>
-                      <a:headEnd type="none" w="med" len="med"/>
-                      <a:tailEnd type="none" w="med" len="med"/>
-                    </a:lnB>
-                    <a:solidFill>
-                      <a:srgbClr val="EEF8F6"/>
-                    </a:solidFill>
-                  </a:tcPr>
-                </a:tc>
-                <a:tc>
-                  <a:txBody>
-                    <a:bodyPr/>
-                    <a:lstStyle/>
-                    <a:p>
-                      <a:pPr algn="ctr" indent="0" marL="0">
-                        <a:buNone/>
-                      </a:pPr>
-                      <a:r>
-                        <a:rPr lang="en-US" sz="1700" b="1" dirty="0">
-                          <a:solidFill>
-                            <a:srgbClr val="E07B22"/>
-                          </a:solidFill>
-                          <a:latin typeface="Calibri" pitchFamily="34" charset="0"/>
-                          <a:ea typeface="Calibri" pitchFamily="34" charset="-122"/>
-                          <a:cs typeface="Calibri" pitchFamily="34" charset="-120"/>
-                        </a:rPr>
-                        <a:t>Karp–Flatt</a:t>
-                      </a:r>
-                      <a:endParaRPr lang="en-US" sz="1700" dirty="0">
-                        <a:latin typeface="Calibri" charset="0"/>
-                        <a:ea typeface="Calibri" charset="0"/>
-                        <a:cs typeface="Calibri" charset="0"/>
-                      </a:endParaRPr>
-                    </a:p>
-                  </a:txBody>
-                  <a:tcPr marL="91440" marR="91440" marT="45720" marB="45720" anchor="ctr">
-                    <a:lnL w="19050" cap="flat" cmpd="sng" algn="ctr">
-                      <a:solidFill>
-                        <a:srgbClr val="FFFFFF"/>
-                      </a:solidFill>
-                      <a:prstDash val="solid"/>
-                      <a:round/>
-                      <a:headEnd type="none" w="med" len="med"/>
-                      <a:tailEnd type="none" w="med" len="med"/>
-                    </a:lnL>
-                    <a:lnR w="19050" cap="flat" cmpd="sng" algn="ctr">
-                      <a:solidFill>
-                        <a:srgbClr val="FFFFFF"/>
-                      </a:solidFill>
-                      <a:prstDash val="solid"/>
-                      <a:round/>
-                      <a:headEnd type="none" w="med" len="med"/>
-                      <a:tailEnd type="none" w="med" len="med"/>
-                    </a:lnR>
-                    <a:lnT w="19050" cap="flat" cmpd="sng" algn="ctr">
-                      <a:solidFill>
-                        <a:srgbClr val="FFFFFF"/>
-                      </a:solidFill>
-                      <a:prstDash val="solid"/>
-                      <a:round/>
-                      <a:headEnd type="none" w="med" len="med"/>
-                      <a:tailEnd type="none" w="med" len="med"/>
-                    </a:lnT>
-                    <a:lnB w="19050" cap="flat" cmpd="sng" algn="ctr">
-                      <a:solidFill>
-                        <a:srgbClr val="FFFFFF"/>
-                      </a:solidFill>
-                      <a:prstDash val="solid"/>
-                      <a:round/>
-                      <a:headEnd type="none" w="med" len="med"/>
-                      <a:tailEnd type="none" w="med" len="med"/>
-                    </a:lnB>
-                    <a:solidFill>
-                      <a:srgbClr val="FDF1E6"/>
-                    </a:solidFill>
-                  </a:tcPr>
-                </a:tc>
-                <a:tc>
-                  <a:txBody>
-                    <a:bodyPr/>
-                    <a:lstStyle/>
-                    <a:p>
-                      <a:pPr algn="ctr" indent="0" marL="0">
-                        <a:buNone/>
-                      </a:pPr>
-                      <a:r>
-                        <a:rPr lang="en-US" sz="1600" dirty="0">
-                          <a:solidFill>
-                            <a:srgbClr val="1F1A33"/>
-                          </a:solidFill>
-                          <a:latin typeface="Calibri" pitchFamily="34" charset="0"/>
-                          <a:ea typeface="Calibri" pitchFamily="34" charset="-122"/>
-                          <a:cs typeface="Calibri" pitchFamily="34" charset="-120"/>
-                        </a:rPr>
-                        <a:t>e = (1/S − 1/P) / (1 − 1/P)</a:t>
-                      </a:r>
-                      <a:endParaRPr lang="en-US" sz="1600" dirty="0">
-                        <a:latin typeface="Calibri" charset="0"/>
-                        <a:ea typeface="Calibri" charset="0"/>
-                        <a:cs typeface="Calibri" charset="0"/>
-                      </a:endParaRPr>
-                    </a:p>
-                  </a:txBody>
-                  <a:tcPr marL="91440" marR="91440" marT="45720" marB="45720" anchor="ctr">
-                    <a:lnL w="19050" cap="flat" cmpd="sng" algn="ctr">
-                      <a:solidFill>
-                        <a:srgbClr val="FFFFFF"/>
-                      </a:solidFill>
-                      <a:prstDash val="solid"/>
-                      <a:round/>
-                      <a:headEnd type="none" w="med" len="med"/>
-                      <a:tailEnd type="none" w="med" len="med"/>
-                    </a:lnL>
-                    <a:lnR w="19050" cap="flat" cmpd="sng" algn="ctr">
-                      <a:solidFill>
-                        <a:srgbClr val="FFFFFF"/>
-                      </a:solidFill>
-                      <a:prstDash val="solid"/>
-                      <a:round/>
-                      <a:headEnd type="none" w="med" len="med"/>
-                      <a:tailEnd type="none" w="med" len="med"/>
-                    </a:lnR>
-                    <a:lnT w="19050" cap="flat" cmpd="sng" algn="ctr">
-                      <a:solidFill>
-                        <a:srgbClr val="FFFFFF"/>
-                      </a:solidFill>
-                      <a:prstDash val="solid"/>
-                      <a:round/>
-                      <a:headEnd type="none" w="med" len="med"/>
-                      <a:tailEnd type="none" w="med" len="med"/>
-                    </a:lnT>
-                    <a:lnB w="19050" cap="flat" cmpd="sng" algn="ctr">
-                      <a:solidFill>
-                        <a:srgbClr val="FFFFFF"/>
-                      </a:solidFill>
-                      <a:prstDash val="solid"/>
-                      <a:round/>
-                      <a:headEnd type="none" w="med" len="med"/>
-                      <a:tailEnd type="none" w="med" len="med"/>
-                    </a:lnB>
-                    <a:solidFill>
-                      <a:srgbClr val="FDF1E6"/>
-                    </a:solidFill>
-                  </a:tcPr>
-                </a:tc>
-              </a:tr>
-            </a:tbl>
-          </a:graphicData>
-        </a:graphic>
-      </p:graphicFrame>
-      <p:sp>
-        <p:nvSpPr>
-          <p:cNvPr id="7" name="Text 4"/>
-          <p:cNvSpPr/>
-          <p:nvPr/>
-        </p:nvSpPr>
-        <p:spPr>
-          <a:xfrm>
-            <a:off x="640080" y="5257800"/>
-            <a:ext cx="10927080" cy="365760"/>
+      <p:sp>
+        <p:nvSpPr>
+          <p:cNvPr id="6" name="Shape 4"/>
+          <p:cNvSpPr/>
+          <p:nvPr/>
+        </p:nvSpPr>
+        <p:spPr>
+          <a:xfrm>
+            <a:off x="822960" y="1371600"/>
+            <a:ext cx="5029200" cy="640080"/>
+          </a:xfrm>
+          <a:prstGeom prst="roundRect">
+            <a:avLst>
+              <a:gd name="adj" fmla="val 11429"/>
+            </a:avLst>
+          </a:prstGeom>
+          <a:solidFill>
+            <a:srgbClr val="2A9D8F"/>
+          </a:solidFill>
+          <a:ln w="12700">
+            <a:solidFill>
+              <a:srgbClr val="2A9D8F"/>
+            </a:solidFill>
+            <a:prstDash val="solid"/>
+          </a:ln>
+        </p:spPr>
+      </p:sp>
+      <p:sp>
+        <p:nvSpPr>
+          <p:cNvPr id="7" name="Text 5"/>
+          <p:cNvSpPr/>
+          <p:nvPr/>
+        </p:nvSpPr>
+        <p:spPr>
+          <a:xfrm>
+            <a:off x="822960" y="1371600"/>
+            <a:ext cx="5029200" cy="640080"/>
           </a:xfrm>
           <a:prstGeom prst="rect">
             <a:avLst/>
@@ -12322,11 +10673,424 @@
           <a:bodyPr wrap="square" lIns="0" tIns="0" rIns="0" bIns="0" rtlCol="0" anchor="ctr"/>
           <a:lstStyle/>
           <a:p>
-            <a:pPr indent="0" marL="0">
+            <a:pPr algn="ctr" indent="0" marL="0">
               <a:buNone/>
             </a:pPr>
             <a:r>
-              <a:rPr lang="en-US" sz="1500" i="1" dirty="0">
+              <a:rPr lang="en-US" sz="2200" b="1" dirty="0">
+                <a:solidFill>
+                  <a:srgbClr val="FFFFFF"/>
+                </a:solidFill>
+                <a:latin typeface="Calibri" pitchFamily="34" charset="0"/>
+                <a:ea typeface="Calibri" pitchFamily="34" charset="-122"/>
+                <a:cs typeface="Calibri" pitchFamily="34" charset="-120"/>
+              </a:rPr>
+              <a:t>Compression Quality</a:t>
+            </a:r>
+            <a:endParaRPr lang="en-US" sz="2200" dirty="0"/>
+          </a:p>
+        </p:txBody>
+      </p:sp>
+      <p:sp>
+        <p:nvSpPr>
+          <p:cNvPr id="8" name="Shape 6"/>
+          <p:cNvSpPr/>
+          <p:nvPr/>
+        </p:nvSpPr>
+        <p:spPr>
+          <a:xfrm>
+            <a:off x="822960" y="2103120"/>
+            <a:ext cx="5029200" cy="3291840"/>
+          </a:xfrm>
+          <a:prstGeom prst="roundRect">
+            <a:avLst>
+              <a:gd name="adj" fmla="val 2222"/>
+            </a:avLst>
+          </a:prstGeom>
+          <a:solidFill>
+            <a:srgbClr val="EEF8F6"/>
+          </a:solidFill>
+          <a:ln w="15875">
+            <a:solidFill>
+              <a:srgbClr val="2A9D8F"/>
+            </a:solidFill>
+            <a:prstDash val="solid"/>
+          </a:ln>
+        </p:spPr>
+      </p:sp>
+      <p:sp>
+        <p:nvSpPr>
+          <p:cNvPr id="9" name="Text 7"/>
+          <p:cNvSpPr/>
+          <p:nvPr/>
+        </p:nvSpPr>
+        <p:spPr>
+          <a:xfrm>
+            <a:off x="1097280" y="2194560"/>
+            <a:ext cx="4480560" cy="3108960"/>
+          </a:xfrm>
+          <a:prstGeom prst="rect">
+            <a:avLst/>
+          </a:prstGeom>
+          <a:noFill/>
+          <a:ln/>
+        </p:spPr>
+        <p:txBody>
+          <a:bodyPr wrap="square" lIns="635" tIns="635" rIns="635" bIns="635" rtlCol="0" anchor="ctr"/>
+          <a:lstStyle/>
+          <a:p>
+            <a:pPr marL="342900" indent="-342900">
+              <a:spcAft>
+                <a:spcPts val="1000"/>
+              </a:spcAft>
+              <a:buSzPct val="100000"/>
+              <a:buChar char="■"/>
+            </a:pPr>
+            <a:r>
+              <a:rPr lang="en-US" sz="2200" dirty="0">
+                <a:solidFill>
+                  <a:srgbClr val="1F1A33"/>
+                </a:solidFill>
+                <a:latin typeface="Calibri" pitchFamily="34" charset="0"/>
+                <a:ea typeface="Calibri" pitchFamily="34" charset="-122"/>
+                <a:cs typeface="Calibri" pitchFamily="34" charset="-120"/>
+              </a:rPr>
+              <a:t>Compression Ratio (CR)</a:t>
+            </a:r>
+            <a:endParaRPr lang="en-US" sz="2200" dirty="0"/>
+          </a:p>
+          <a:p>
+            <a:pPr marL="342900" indent="-342900">
+              <a:spcAft>
+                <a:spcPts val="1000"/>
+              </a:spcAft>
+              <a:buSzPct val="100000"/>
+              <a:buChar char="■"/>
+            </a:pPr>
+            <a:r>
+              <a:rPr lang="en-US" sz="2200" dirty="0">
+                <a:solidFill>
+                  <a:srgbClr val="1F1A33"/>
+                </a:solidFill>
+                <a:latin typeface="Calibri" pitchFamily="34" charset="0"/>
+                <a:ea typeface="Calibri" pitchFamily="34" charset="-122"/>
+                <a:cs typeface="Calibri" pitchFamily="34" charset="-120"/>
+              </a:rPr>
+              <a:t>Bits Per Pixel (BPP)</a:t>
+            </a:r>
+            <a:endParaRPr lang="en-US" sz="2200" dirty="0"/>
+          </a:p>
+          <a:p>
+            <a:pPr marL="342900" indent="-342900">
+              <a:spcAft>
+                <a:spcPts val="1000"/>
+              </a:spcAft>
+              <a:buSzPct val="100000"/>
+              <a:buChar char="■"/>
+            </a:pPr>
+            <a:r>
+              <a:rPr lang="en-US" sz="2200" dirty="0">
+                <a:solidFill>
+                  <a:srgbClr val="1F1A33"/>
+                </a:solidFill>
+                <a:latin typeface="Calibri" pitchFamily="34" charset="0"/>
+                <a:ea typeface="Calibri" pitchFamily="34" charset="-122"/>
+                <a:cs typeface="Calibri" pitchFamily="34" charset="-120"/>
+              </a:rPr>
+              <a:t>MSE</a:t>
+            </a:r>
+            <a:endParaRPr lang="en-US" sz="2200" dirty="0"/>
+          </a:p>
+          <a:p>
+            <a:pPr marL="342900" indent="-342900">
+              <a:spcAft>
+                <a:spcPts val="1000"/>
+              </a:spcAft>
+              <a:buSzPct val="100000"/>
+              <a:buChar char="■"/>
+            </a:pPr>
+            <a:r>
+              <a:rPr lang="en-US" sz="2200" dirty="0">
+                <a:solidFill>
+                  <a:srgbClr val="1F1A33"/>
+                </a:solidFill>
+                <a:latin typeface="Calibri" pitchFamily="34" charset="0"/>
+                <a:ea typeface="Calibri" pitchFamily="34" charset="-122"/>
+                <a:cs typeface="Calibri" pitchFamily="34" charset="-120"/>
+              </a:rPr>
+              <a:t>PSNR</a:t>
+            </a:r>
+            <a:endParaRPr lang="en-US" sz="2200" dirty="0"/>
+          </a:p>
+          <a:p>
+            <a:pPr marL="342900" indent="-342900">
+              <a:spcAft>
+                <a:spcPts val="1000"/>
+              </a:spcAft>
+              <a:buSzPct val="100000"/>
+              <a:buChar char="■"/>
+            </a:pPr>
+            <a:r>
+              <a:rPr lang="en-US" sz="2200" dirty="0">
+                <a:solidFill>
+                  <a:srgbClr val="1F1A33"/>
+                </a:solidFill>
+                <a:latin typeface="Calibri" pitchFamily="34" charset="0"/>
+                <a:ea typeface="Calibri" pitchFamily="34" charset="-122"/>
+                <a:cs typeface="Calibri" pitchFamily="34" charset="-120"/>
+              </a:rPr>
+              <a:t>SSIM</a:t>
+            </a:r>
+            <a:endParaRPr lang="en-US" sz="2200" dirty="0"/>
+          </a:p>
+        </p:txBody>
+      </p:sp>
+      <p:sp>
+        <p:nvSpPr>
+          <p:cNvPr id="10" name="Shape 8"/>
+          <p:cNvSpPr/>
+          <p:nvPr/>
+        </p:nvSpPr>
+        <p:spPr>
+          <a:xfrm>
+            <a:off x="6309360" y="1371600"/>
+            <a:ext cx="5029200" cy="640080"/>
+          </a:xfrm>
+          <a:prstGeom prst="roundRect">
+            <a:avLst>
+              <a:gd name="adj" fmla="val 11429"/>
+            </a:avLst>
+          </a:prstGeom>
+          <a:solidFill>
+            <a:srgbClr val="E07B22"/>
+          </a:solidFill>
+          <a:ln w="12700">
+            <a:solidFill>
+              <a:srgbClr val="E07B22"/>
+            </a:solidFill>
+            <a:prstDash val="solid"/>
+          </a:ln>
+        </p:spPr>
+      </p:sp>
+      <p:sp>
+        <p:nvSpPr>
+          <p:cNvPr id="11" name="Text 9"/>
+          <p:cNvSpPr/>
+          <p:nvPr/>
+        </p:nvSpPr>
+        <p:spPr>
+          <a:xfrm>
+            <a:off x="6309360" y="1371600"/>
+            <a:ext cx="5029200" cy="640080"/>
+          </a:xfrm>
+          <a:prstGeom prst="rect">
+            <a:avLst/>
+          </a:prstGeom>
+          <a:noFill/>
+          <a:ln/>
+        </p:spPr>
+        <p:txBody>
+          <a:bodyPr wrap="square" lIns="0" tIns="0" rIns="0" bIns="0" rtlCol="0" anchor="ctr"/>
+          <a:lstStyle/>
+          <a:p>
+            <a:pPr algn="ctr" indent="0" marL="0">
+              <a:buNone/>
+            </a:pPr>
+            <a:r>
+              <a:rPr lang="en-US" sz="2200" b="1" dirty="0">
+                <a:solidFill>
+                  <a:srgbClr val="FFFFFF"/>
+                </a:solidFill>
+                <a:latin typeface="Calibri" pitchFamily="34" charset="0"/>
+                <a:ea typeface="Calibri" pitchFamily="34" charset="-122"/>
+                <a:cs typeface="Calibri" pitchFamily="34" charset="-120"/>
+              </a:rPr>
+              <a:t>Parallel Performance</a:t>
+            </a:r>
+            <a:endParaRPr lang="en-US" sz="2200" dirty="0"/>
+          </a:p>
+        </p:txBody>
+      </p:sp>
+      <p:sp>
+        <p:nvSpPr>
+          <p:cNvPr id="12" name="Shape 10"/>
+          <p:cNvSpPr/>
+          <p:nvPr/>
+        </p:nvSpPr>
+        <p:spPr>
+          <a:xfrm>
+            <a:off x="6309360" y="2103120"/>
+            <a:ext cx="5029200" cy="3291840"/>
+          </a:xfrm>
+          <a:prstGeom prst="roundRect">
+            <a:avLst>
+              <a:gd name="adj" fmla="val 2222"/>
+            </a:avLst>
+          </a:prstGeom>
+          <a:solidFill>
+            <a:srgbClr val="FDF1E6"/>
+          </a:solidFill>
+          <a:ln w="15875">
+            <a:solidFill>
+              <a:srgbClr val="E07B22"/>
+            </a:solidFill>
+            <a:prstDash val="solid"/>
+          </a:ln>
+        </p:spPr>
+      </p:sp>
+      <p:sp>
+        <p:nvSpPr>
+          <p:cNvPr id="13" name="Text 11"/>
+          <p:cNvSpPr/>
+          <p:nvPr/>
+        </p:nvSpPr>
+        <p:spPr>
+          <a:xfrm>
+            <a:off x="6583680" y="2194560"/>
+            <a:ext cx="4480560" cy="3108960"/>
+          </a:xfrm>
+          <a:prstGeom prst="rect">
+            <a:avLst/>
+          </a:prstGeom>
+          <a:noFill/>
+          <a:ln/>
+        </p:spPr>
+        <p:txBody>
+          <a:bodyPr wrap="square" lIns="635" tIns="635" rIns="635" bIns="635" rtlCol="0" anchor="ctr"/>
+          <a:lstStyle/>
+          <a:p>
+            <a:pPr marL="342900" indent="-342900">
+              <a:spcAft>
+                <a:spcPts val="1000"/>
+              </a:spcAft>
+              <a:buSzPct val="100000"/>
+              <a:buChar char="■"/>
+            </a:pPr>
+            <a:r>
+              <a:rPr lang="en-US" sz="2200" dirty="0">
+                <a:solidFill>
+                  <a:srgbClr val="1F1A33"/>
+                </a:solidFill>
+                <a:latin typeface="Calibri" pitchFamily="34" charset="0"/>
+                <a:ea typeface="Calibri" pitchFamily="34" charset="-122"/>
+                <a:cs typeface="Calibri" pitchFamily="34" charset="-120"/>
+              </a:rPr>
+              <a:t>Execution Time</a:t>
+            </a:r>
+            <a:endParaRPr lang="en-US" sz="2200" dirty="0"/>
+          </a:p>
+          <a:p>
+            <a:pPr marL="342900" indent="-342900">
+              <a:spcAft>
+                <a:spcPts val="1000"/>
+              </a:spcAft>
+              <a:buSzPct val="100000"/>
+              <a:buChar char="■"/>
+            </a:pPr>
+            <a:r>
+              <a:rPr lang="en-US" sz="2200" dirty="0">
+                <a:solidFill>
+                  <a:srgbClr val="1F1A33"/>
+                </a:solidFill>
+                <a:latin typeface="Calibri" pitchFamily="34" charset="0"/>
+                <a:ea typeface="Calibri" pitchFamily="34" charset="-122"/>
+                <a:cs typeface="Calibri" pitchFamily="34" charset="-120"/>
+              </a:rPr>
+              <a:t>Speedup</a:t>
+            </a:r>
+            <a:endParaRPr lang="en-US" sz="2200" dirty="0"/>
+          </a:p>
+          <a:p>
+            <a:pPr marL="342900" indent="-342900">
+              <a:spcAft>
+                <a:spcPts val="1000"/>
+              </a:spcAft>
+              <a:buSzPct val="100000"/>
+              <a:buChar char="■"/>
+            </a:pPr>
+            <a:r>
+              <a:rPr lang="en-US" sz="2200" dirty="0">
+                <a:solidFill>
+                  <a:srgbClr val="1F1A33"/>
+                </a:solidFill>
+                <a:latin typeface="Calibri" pitchFamily="34" charset="0"/>
+                <a:ea typeface="Calibri" pitchFamily="34" charset="-122"/>
+                <a:cs typeface="Calibri" pitchFamily="34" charset="-120"/>
+              </a:rPr>
+              <a:t>Parallel Efficiency</a:t>
+            </a:r>
+            <a:endParaRPr lang="en-US" sz="2200" dirty="0"/>
+          </a:p>
+          <a:p>
+            <a:pPr marL="342900" indent="-342900">
+              <a:spcAft>
+                <a:spcPts val="1000"/>
+              </a:spcAft>
+              <a:buSzPct val="100000"/>
+              <a:buChar char="■"/>
+            </a:pPr>
+            <a:r>
+              <a:rPr lang="en-US" sz="2200" dirty="0">
+                <a:solidFill>
+                  <a:srgbClr val="1F1A33"/>
+                </a:solidFill>
+                <a:latin typeface="Calibri" pitchFamily="34" charset="0"/>
+                <a:ea typeface="Calibri" pitchFamily="34" charset="-122"/>
+                <a:cs typeface="Calibri" pitchFamily="34" charset="-120"/>
+              </a:rPr>
+              <a:t>Throughput</a:t>
+            </a:r>
+            <a:endParaRPr lang="en-US" sz="2200" dirty="0"/>
+          </a:p>
+          <a:p>
+            <a:pPr marL="342900" indent="-342900">
+              <a:spcAft>
+                <a:spcPts val="1000"/>
+              </a:spcAft>
+              <a:buSzPct val="100000"/>
+              <a:buChar char="■"/>
+            </a:pPr>
+            <a:r>
+              <a:rPr lang="en-US" sz="2200" dirty="0">
+                <a:solidFill>
+                  <a:srgbClr val="1F1A33"/>
+                </a:solidFill>
+                <a:latin typeface="Calibri" pitchFamily="34" charset="0"/>
+                <a:ea typeface="Calibri" pitchFamily="34" charset="-122"/>
+                <a:cs typeface="Calibri" pitchFamily="34" charset="-120"/>
+              </a:rPr>
+              <a:t>Karp–Flatt Metric</a:t>
+            </a:r>
+            <a:endParaRPr lang="en-US" sz="2200" dirty="0"/>
+          </a:p>
+        </p:txBody>
+      </p:sp>
+      <p:sp>
+        <p:nvSpPr>
+          <p:cNvPr id="14" name="Text 12"/>
+          <p:cNvSpPr/>
+          <p:nvPr/>
+        </p:nvSpPr>
+        <p:spPr>
+          <a:xfrm>
+            <a:off x="822960" y="5669280"/>
+            <a:ext cx="10515600" cy="365760"/>
+          </a:xfrm>
+          <a:prstGeom prst="rect">
+            <a:avLst/>
+          </a:prstGeom>
+          <a:noFill/>
+          <a:ln/>
+        </p:spPr>
+        <p:txBody>
+          <a:bodyPr wrap="square" lIns="0" tIns="0" rIns="0" bIns="0" rtlCol="0" anchor="ctr"/>
+          <a:lstStyle/>
+          <a:p>
+            <a:pPr algn="ctr" indent="0" marL="0">
+              <a:buNone/>
+            </a:pPr>
+            <a:r>
+              <a:rPr lang="en-US" sz="1600" i="1" dirty="0">
                 <a:solidFill>
                   <a:srgbClr val="6B4FA3"/>
                 </a:solidFill>
@@ -12334,9 +11098,9 @@
                 <a:ea typeface="Calibri" pitchFamily="34" charset="-122"/>
                 <a:cs typeface="Calibri" pitchFamily="34" charset="-120"/>
               </a:rPr>
-              <a:t>S_comp = codebook + Huffman table + Huffman-coded data (accounted size).</a:t>
-            </a:r>
-            <a:endParaRPr lang="en-US" sz="1500" dirty="0"/>
+              <a:t>Each formula is shown next to the result it measures.</a:t>
+            </a:r>
+            <a:endParaRPr lang="en-US" sz="1600" dirty="0"/>
           </a:p>
         </p:txBody>
       </p:sp>
@@ -17032,6 +15796,89 @@
           </a:ln>
         </p:spPr>
       </p:sp>
+      <p:sp>
+        <p:nvSpPr>
+          <p:cNvPr id="6" name="Shape 4"/>
+          <p:cNvSpPr/>
+          <p:nvPr/>
+        </p:nvSpPr>
+        <p:spPr>
+          <a:xfrm>
+            <a:off x="822960" y="1097280"/>
+            <a:ext cx="10515600" cy="822960"/>
+          </a:xfrm>
+          <a:prstGeom prst="roundRect">
+            <a:avLst>
+              <a:gd name="adj" fmla="val 8889"/>
+            </a:avLst>
+          </a:prstGeom>
+          <a:solidFill>
+            <a:srgbClr val="FDF1E6"/>
+          </a:solidFill>
+          <a:ln w="15875">
+            <a:solidFill>
+              <a:srgbClr val="E07B22"/>
+            </a:solidFill>
+            <a:prstDash val="solid"/>
+          </a:ln>
+        </p:spPr>
+      </p:sp>
+      <p:sp>
+        <p:nvSpPr>
+          <p:cNvPr id="7" name="Text 5"/>
+          <p:cNvSpPr/>
+          <p:nvPr/>
+        </p:nvSpPr>
+        <p:spPr>
+          <a:xfrm>
+            <a:off x="822960" y="1097280"/>
+            <a:ext cx="10515600" cy="822960"/>
+          </a:xfrm>
+          <a:prstGeom prst="rect">
+            <a:avLst/>
+          </a:prstGeom>
+          <a:noFill/>
+          <a:ln/>
+        </p:spPr>
+        <p:txBody>
+          <a:bodyPr wrap="square" lIns="508" tIns="508" rIns="508" bIns="508" rtlCol="0" anchor="ctr"/>
+          <a:lstStyle/>
+          <a:p>
+            <a:pPr algn="ctr" indent="0" marL="0">
+              <a:buNone/>
+            </a:pPr>
+            <a:r>
+              <a:rPr lang="en-US" sz="1700" b="1" dirty="0">
+                <a:solidFill>
+                  <a:srgbClr val="2E2055"/>
+                </a:solidFill>
+                <a:latin typeface="Cambria" pitchFamily="34" charset="0"/>
+                <a:ea typeface="Cambria" pitchFamily="34" charset="-122"/>
+                <a:cs typeface="Cambria" pitchFamily="34" charset="-120"/>
+              </a:rPr>
+              <a:t>CR = S_orig / S_comp        BPP = compressed bits / number of pixels</a:t>
+            </a:r>
+            <a:endParaRPr lang="en-US" sz="1700" dirty="0"/>
+          </a:p>
+          <a:p>
+            <a:pPr algn="ctr" indent="0" marL="0">
+              <a:buNone/>
+            </a:pPr>
+            <a:r>
+              <a:rPr lang="en-US" sz="1700" b="1" dirty="0">
+                <a:solidFill>
+                  <a:srgbClr val="2E2055"/>
+                </a:solidFill>
+                <a:latin typeface="Cambria" pitchFamily="34" charset="0"/>
+                <a:ea typeface="Cambria" pitchFamily="34" charset="-122"/>
+                <a:cs typeface="Cambria" pitchFamily="34" charset="-120"/>
+              </a:rPr>
+              <a:t>MSE = mean (I − Î)²        PSNR = 10·log₁₀(255² / MSE)  dB        SSIM: 11 × 11 Gaussian window, σ = 1.5</a:t>
+            </a:r>
+            <a:endParaRPr lang="en-US" sz="1700" dirty="0"/>
+          </a:p>
+        </p:txBody>
+      </p:sp>
       <p:graphicFrame>
         <p:nvGraphicFramePr>
           <p:cNvPr id="24" name="Table 0"/>
@@ -17047,7 +15894,7 @@
           </p:nvPr>
         </p:nvGraphicFramePr>
         <p:xfrm>
-          <a:off x="822960" y="1188720"/>
+          <a:off x="822960" y="2011680"/>
           <a:ext cx="10515600" cy="914400"/>
         </p:xfrm>
         <a:graphic>
@@ -17063,7 +15910,7 @@
                 <a:gridCol w="1554480"/>
                 <a:gridCol w="1371600"/>
               </a:tblGrid>
-              <a:tr h="393192">
+              <a:tr h="374904">
                 <a:tc>
                   <a:txBody>
                     <a:bodyPr/>
@@ -17541,7 +16388,7 @@
                   </a:tcPr>
                 </a:tc>
               </a:tr>
-              <a:tr h="393192">
+              <a:tr h="374904">
                 <a:tc>
                   <a:txBody>
                     <a:bodyPr/>
@@ -18019,7 +16866,7 @@
                   </a:tcPr>
                 </a:tc>
               </a:tr>
-              <a:tr h="393192">
+              <a:tr h="374904">
                 <a:tc>
                   <a:txBody>
                     <a:bodyPr/>
@@ -18497,7 +17344,7 @@
                   </a:tcPr>
                 </a:tc>
               </a:tr>
-              <a:tr h="393192">
+              <a:tr h="374904">
                 <a:tc>
                   <a:txBody>
                     <a:bodyPr/>
@@ -18975,7 +17822,7 @@
                   </a:tcPr>
                 </a:tc>
               </a:tr>
-              <a:tr h="393192">
+              <a:tr h="374904">
                 <a:tc>
                   <a:txBody>
                     <a:bodyPr/>
@@ -19453,7 +18300,7 @@
                   </a:tcPr>
                 </a:tc>
               </a:tr>
-              <a:tr h="393192">
+              <a:tr h="374904">
                 <a:tc>
                   <a:txBody>
                     <a:bodyPr/>
@@ -19931,7 +18778,7 @@
                   </a:tcPr>
                 </a:tc>
               </a:tr>
-              <a:tr h="393192">
+              <a:tr h="374904">
                 <a:tc>
                   <a:txBody>
                     <a:bodyPr/>
@@ -20409,7 +19256,7 @@
                   </a:tcPr>
                 </a:tc>
               </a:tr>
-              <a:tr h="393192">
+              <a:tr h="374904">
                 <a:tc>
                   <a:txBody>
                     <a:bodyPr/>
@@ -20887,7 +19734,7 @@
                   </a:tcPr>
                 </a:tc>
               </a:tr>
-              <a:tr h="393192">
+              <a:tr h="374904">
                 <a:tc>
                   <a:txBody>
                     <a:bodyPr/>
@@ -21365,7 +20212,7 @@
                   </a:tcPr>
                 </a:tc>
               </a:tr>
-              <a:tr h="393192">
+              <a:tr h="374904">
                 <a:tc>
                   <a:txBody>
                     <a:bodyPr/>
@@ -21843,7 +20690,7 @@
                   </a:tcPr>
                 </a:tc>
               </a:tr>
-              <a:tr h="393192">
+              <a:tr h="374904">
                 <a:tc>
                   <a:txBody>
                     <a:bodyPr/>
@@ -22327,14 +21174,14 @@
       </p:graphicFrame>
       <p:sp>
         <p:nvSpPr>
-          <p:cNvPr id="7" name="Text 4"/>
-          <p:cNvSpPr/>
-          <p:nvPr/>
-        </p:nvSpPr>
-        <p:spPr>
-          <a:xfrm>
-            <a:off x="822960" y="5989320"/>
-            <a:ext cx="10515600" cy="548640"/>
+          <p:cNvPr id="9" name="Text 6"/>
+          <p:cNvSpPr/>
+          <p:nvPr/>
+        </p:nvSpPr>
+        <p:spPr>
+          <a:xfrm>
+            <a:off x="822960" y="6217920"/>
+            <a:ext cx="10515600" cy="502920"/>
           </a:xfrm>
           <a:prstGeom prst="rect">
             <a:avLst/>
@@ -22534,12 +21381,78 @@
         </p:nvSpPr>
         <p:spPr>
           <a:xfrm>
-            <a:off x="457200" y="1234440"/>
-            <a:ext cx="7498080" cy="5029200"/>
+            <a:off x="457200" y="1097280"/>
+            <a:ext cx="7498080" cy="457200"/>
           </a:xfrm>
           <a:prstGeom prst="roundRect">
             <a:avLst>
-              <a:gd name="adj" fmla="val 1455"/>
+              <a:gd name="adj" fmla="val 16000"/>
+            </a:avLst>
+          </a:prstGeom>
+          <a:solidFill>
+            <a:srgbClr val="FDF1E6"/>
+          </a:solidFill>
+          <a:ln w="15875">
+            <a:solidFill>
+              <a:srgbClr val="E07B22"/>
+            </a:solidFill>
+            <a:prstDash val="solid"/>
+          </a:ln>
+        </p:spPr>
+      </p:sp>
+      <p:sp>
+        <p:nvSpPr>
+          <p:cNvPr id="7" name="Text 5"/>
+          <p:cNvSpPr/>
+          <p:nvPr/>
+        </p:nvSpPr>
+        <p:spPr>
+          <a:xfrm>
+            <a:off x="457200" y="1097280"/>
+            <a:ext cx="7498080" cy="457200"/>
+          </a:xfrm>
+          <a:prstGeom prst="rect">
+            <a:avLst/>
+          </a:prstGeom>
+          <a:noFill/>
+          <a:ln/>
+        </p:spPr>
+        <p:txBody>
+          <a:bodyPr wrap="square" lIns="508" tIns="508" rIns="508" bIns="508" rtlCol="0" anchor="ctr"/>
+          <a:lstStyle/>
+          <a:p>
+            <a:pPr algn="ctr" indent="0" marL="0">
+              <a:buNone/>
+            </a:pPr>
+            <a:r>
+              <a:rPr lang="en-US" sz="1900" b="1" dirty="0">
+                <a:solidFill>
+                  <a:srgbClr val="2E2055"/>
+                </a:solidFill>
+                <a:latin typeface="Cambria" pitchFamily="34" charset="0"/>
+                <a:ea typeface="Cambria" pitchFamily="34" charset="-122"/>
+                <a:cs typeface="Cambria" pitchFamily="34" charset="-120"/>
+              </a:rPr>
+              <a:t>H = −Σ p(s) · log₂ p(s)   (bits / symbol)</a:t>
+            </a:r>
+            <a:endParaRPr lang="en-US" sz="1900" dirty="0"/>
+          </a:p>
+        </p:txBody>
+      </p:sp>
+      <p:sp>
+        <p:nvSpPr>
+          <p:cNvPr id="8" name="Shape 6"/>
+          <p:cNvSpPr/>
+          <p:nvPr/>
+        </p:nvSpPr>
+        <p:spPr>
+          <a:xfrm>
+            <a:off x="457200" y="1645920"/>
+            <a:ext cx="7498080" cy="4617720"/>
+          </a:xfrm>
+          <a:prstGeom prst="roundRect">
+            <a:avLst>
+              <a:gd name="adj" fmla="val 1584"/>
             </a:avLst>
           </a:prstGeom>
           <a:solidFill>
@@ -22555,7 +21468,7 @@
       </p:sp>
       <p:pic>
         <p:nvPicPr>
-          <p:cNvPr id="7" name="Image 0" descr="assets/entropy_chart.png">    </p:cNvPr>
+          <p:cNvPr id="9" name="Image 0" descr="assets/entropy_chart.png">    </p:cNvPr>
           <p:cNvPicPr>
             <a:picLocks noChangeAspect="1"/>
           </p:cNvPicPr>
@@ -22569,7 +21482,7 @@
         </p:blipFill>
         <p:spPr>
           <a:xfrm>
-            <a:off x="457200" y="1467016"/>
+            <a:off x="457200" y="1672756"/>
             <a:ext cx="7498080" cy="4564049"/>
           </a:xfrm>
           <a:prstGeom prst="rect">
@@ -22579,7 +21492,7 @@
       </p:pic>
       <p:sp>
         <p:nvSpPr>
-          <p:cNvPr id="8" name="Shape 5"/>
+          <p:cNvPr id="10" name="Shape 7"/>
           <p:cNvSpPr/>
           <p:nvPr/>
         </p:nvSpPr>
@@ -22606,7 +21519,7 @@
       </p:sp>
       <p:sp>
         <p:nvSpPr>
-          <p:cNvPr id="9" name="Text 6"/>
+          <p:cNvPr id="11" name="Text 8"/>
           <p:cNvSpPr/>
           <p:nvPr/>
         </p:nvSpPr>
@@ -22901,12 +21814,78 @@
         </p:nvSpPr>
         <p:spPr>
           <a:xfrm>
-            <a:off x="457200" y="1234440"/>
-            <a:ext cx="7498080" cy="5029200"/>
+            <a:off x="457200" y="1097280"/>
+            <a:ext cx="7498080" cy="457200"/>
           </a:xfrm>
           <a:prstGeom prst="roundRect">
             <a:avLst>
-              <a:gd name="adj" fmla="val 1455"/>
+              <a:gd name="adj" fmla="val 16000"/>
+            </a:avLst>
+          </a:prstGeom>
+          <a:solidFill>
+            <a:srgbClr val="FDF1E6"/>
+          </a:solidFill>
+          <a:ln w="15875">
+            <a:solidFill>
+              <a:srgbClr val="E07B22"/>
+            </a:solidFill>
+            <a:prstDash val="solid"/>
+          </a:ln>
+        </p:spPr>
+      </p:sp>
+      <p:sp>
+        <p:nvSpPr>
+          <p:cNvPr id="7" name="Text 5"/>
+          <p:cNvSpPr/>
+          <p:nvPr/>
+        </p:nvSpPr>
+        <p:spPr>
+          <a:xfrm>
+            <a:off x="457200" y="1097280"/>
+            <a:ext cx="7498080" cy="457200"/>
+          </a:xfrm>
+          <a:prstGeom prst="rect">
+            <a:avLst/>
+          </a:prstGeom>
+          <a:noFill/>
+          <a:ln/>
+        </p:spPr>
+        <p:txBody>
+          <a:bodyPr wrap="square" lIns="508" tIns="508" rIns="508" bIns="508" rtlCol="0" anchor="ctr"/>
+          <a:lstStyle/>
+          <a:p>
+            <a:pPr algn="ctr" indent="0" marL="0">
+              <a:buNone/>
+            </a:pPr>
+            <a:r>
+              <a:rPr lang="en-US" sz="2000" b="1" dirty="0">
+                <a:solidFill>
+                  <a:srgbClr val="2E2055"/>
+                </a:solidFill>
+                <a:latin typeface="Cambria" pitchFamily="34" charset="0"/>
+                <a:ea typeface="Cambria" pitchFamily="34" charset="-122"/>
+                <a:cs typeface="Cambria" pitchFamily="34" charset="-120"/>
+              </a:rPr>
+              <a:t>S = T_seq / T_P          E = S / P</a:t>
+            </a:r>
+            <a:endParaRPr lang="en-US" sz="2000" dirty="0"/>
+          </a:p>
+        </p:txBody>
+      </p:sp>
+      <p:sp>
+        <p:nvSpPr>
+          <p:cNvPr id="8" name="Shape 6"/>
+          <p:cNvSpPr/>
+          <p:nvPr/>
+        </p:nvSpPr>
+        <p:spPr>
+          <a:xfrm>
+            <a:off x="457200" y="1645920"/>
+            <a:ext cx="7498080" cy="4617720"/>
+          </a:xfrm>
+          <a:prstGeom prst="roundRect">
+            <a:avLst>
+              <a:gd name="adj" fmla="val 1584"/>
             </a:avLst>
           </a:prstGeom>
           <a:solidFill>
@@ -22922,7 +21901,7 @@
       </p:sp>
       <p:pic>
         <p:nvPicPr>
-          <p:cNvPr id="7" name="Image 0" descr="assets/speedup_chart.png">    </p:cNvPr>
+          <p:cNvPr id="9" name="Image 0" descr="assets/speedup_chart.png">    </p:cNvPr>
           <p:cNvPicPr>
             <a:picLocks noChangeAspect="1"/>
           </p:cNvPicPr>
@@ -22936,7 +21915,7 @@
         </p:blipFill>
         <p:spPr>
           <a:xfrm>
-            <a:off x="457200" y="1467016"/>
+            <a:off x="457200" y="1672756"/>
             <a:ext cx="7498080" cy="4564049"/>
           </a:xfrm>
           <a:prstGeom prst="rect">
@@ -22946,7 +21925,7 @@
       </p:pic>
       <p:sp>
         <p:nvSpPr>
-          <p:cNvPr id="8" name="Shape 5"/>
+          <p:cNvPr id="10" name="Shape 7"/>
           <p:cNvSpPr/>
           <p:nvPr/>
         </p:nvSpPr>
@@ -22973,7 +21952,7 @@
       </p:sp>
       <p:sp>
         <p:nvSpPr>
-          <p:cNvPr id="9" name="Text 6"/>
+          <p:cNvPr id="11" name="Text 8"/>
           <p:cNvSpPr/>
           <p:nvPr/>
         </p:nvSpPr>
@@ -23268,12 +22247,78 @@
         </p:nvSpPr>
         <p:spPr>
           <a:xfrm>
-            <a:off x="457200" y="1234440"/>
-            <a:ext cx="7498080" cy="5029200"/>
+            <a:off x="457200" y="1097280"/>
+            <a:ext cx="7498080" cy="457200"/>
           </a:xfrm>
           <a:prstGeom prst="roundRect">
             <a:avLst>
-              <a:gd name="adj" fmla="val 1455"/>
+              <a:gd name="adj" fmla="val 16000"/>
+            </a:avLst>
+          </a:prstGeom>
+          <a:solidFill>
+            <a:srgbClr val="FDF1E6"/>
+          </a:solidFill>
+          <a:ln w="15875">
+            <a:solidFill>
+              <a:srgbClr val="E07B22"/>
+            </a:solidFill>
+            <a:prstDash val="solid"/>
+          </a:ln>
+        </p:spPr>
+      </p:sp>
+      <p:sp>
+        <p:nvSpPr>
+          <p:cNvPr id="7" name="Text 5"/>
+          <p:cNvSpPr/>
+          <p:nvPr/>
+        </p:nvSpPr>
+        <p:spPr>
+          <a:xfrm>
+            <a:off x="457200" y="1097280"/>
+            <a:ext cx="7498080" cy="457200"/>
+          </a:xfrm>
+          <a:prstGeom prst="rect">
+            <a:avLst/>
+          </a:prstGeom>
+          <a:noFill/>
+          <a:ln/>
+        </p:spPr>
+        <p:txBody>
+          <a:bodyPr wrap="square" lIns="508" tIns="508" rIns="508" bIns="508" rtlCol="0" anchor="ctr"/>
+          <a:lstStyle/>
+          <a:p>
+            <a:pPr algn="ctr" indent="0" marL="0">
+              <a:buNone/>
+            </a:pPr>
+            <a:r>
+              <a:rPr lang="en-US" sz="2000" b="1" dirty="0">
+                <a:solidFill>
+                  <a:srgbClr val="2E2055"/>
+                </a:solidFill>
+                <a:latin typeface="Cambria" pitchFamily="34" charset="0"/>
+                <a:ea typeface="Cambria" pitchFamily="34" charset="-122"/>
+                <a:cs typeface="Cambria" pitchFamily="34" charset="-120"/>
+              </a:rPr>
+              <a:t>S = T_seq / T_P          E = S / P</a:t>
+            </a:r>
+            <a:endParaRPr lang="en-US" sz="2000" dirty="0"/>
+          </a:p>
+        </p:txBody>
+      </p:sp>
+      <p:sp>
+        <p:nvSpPr>
+          <p:cNvPr id="8" name="Shape 6"/>
+          <p:cNvSpPr/>
+          <p:nvPr/>
+        </p:nvSpPr>
+        <p:spPr>
+          <a:xfrm>
+            <a:off x="457200" y="1645920"/>
+            <a:ext cx="7498080" cy="4617720"/>
+          </a:xfrm>
+          <a:prstGeom prst="roundRect">
+            <a:avLst>
+              <a:gd name="adj" fmla="val 1584"/>
             </a:avLst>
           </a:prstGeom>
           <a:solidFill>
@@ -23289,7 +22334,7 @@
       </p:sp>
       <p:pic>
         <p:nvPicPr>
-          <p:cNvPr id="7" name="Image 0" descr="assets/total_speedup_chart.png">    </p:cNvPr>
+          <p:cNvPr id="9" name="Image 0" descr="assets/total_speedup_chart.png">    </p:cNvPr>
           <p:cNvPicPr>
             <a:picLocks noChangeAspect="1"/>
           </p:cNvPicPr>
@@ -23303,7 +22348,7 @@
         </p:blipFill>
         <p:spPr>
           <a:xfrm>
-            <a:off x="457200" y="1467016"/>
+            <a:off x="457200" y="1672756"/>
             <a:ext cx="7498080" cy="4564049"/>
           </a:xfrm>
           <a:prstGeom prst="rect">
@@ -23313,7 +22358,7 @@
       </p:pic>
       <p:sp>
         <p:nvSpPr>
-          <p:cNvPr id="8" name="Shape 5"/>
+          <p:cNvPr id="10" name="Shape 7"/>
           <p:cNvSpPr/>
           <p:nvPr/>
         </p:nvSpPr>
@@ -23340,7 +22385,7 @@
       </p:sp>
       <p:sp>
         <p:nvSpPr>
-          <p:cNvPr id="9" name="Text 6"/>
+          <p:cNvPr id="11" name="Text 8"/>
           <p:cNvSpPr/>
           <p:nvPr/>
         </p:nvSpPr>
@@ -24023,12 +23068,78 @@
         </p:nvSpPr>
         <p:spPr>
           <a:xfrm>
-            <a:off x="457200" y="1234440"/>
-            <a:ext cx="7498080" cy="5029200"/>
+            <a:off x="457200" y="1097280"/>
+            <a:ext cx="7498080" cy="457200"/>
           </a:xfrm>
           <a:prstGeom prst="roundRect">
             <a:avLst>
-              <a:gd name="adj" fmla="val 1455"/>
+              <a:gd name="adj" fmla="val 16000"/>
+            </a:avLst>
+          </a:prstGeom>
+          <a:solidFill>
+            <a:srgbClr val="FDF1E6"/>
+          </a:solidFill>
+          <a:ln w="15875">
+            <a:solidFill>
+              <a:srgbClr val="E07B22"/>
+            </a:solidFill>
+            <a:prstDash val="solid"/>
+          </a:ln>
+        </p:spPr>
+      </p:sp>
+      <p:sp>
+        <p:nvSpPr>
+          <p:cNvPr id="7" name="Text 5"/>
+          <p:cNvSpPr/>
+          <p:nvPr/>
+        </p:nvSpPr>
+        <p:spPr>
+          <a:xfrm>
+            <a:off x="457200" y="1097280"/>
+            <a:ext cx="7498080" cy="457200"/>
+          </a:xfrm>
+          <a:prstGeom prst="rect">
+            <a:avLst/>
+          </a:prstGeom>
+          <a:noFill/>
+          <a:ln/>
+        </p:spPr>
+        <p:txBody>
+          <a:bodyPr wrap="square" lIns="508" tIns="508" rIns="508" bIns="508" rtlCol="0" anchor="ctr"/>
+          <a:lstStyle/>
+          <a:p>
+            <a:pPr algn="ctr" indent="0" marL="0">
+              <a:buNone/>
+            </a:pPr>
+            <a:r>
+              <a:rPr lang="en-US" sz="1900" b="1" dirty="0">
+                <a:solidFill>
+                  <a:srgbClr val="2E2055"/>
+                </a:solidFill>
+                <a:latin typeface="Cambria" pitchFamily="34" charset="0"/>
+                <a:ea typeface="Cambria" pitchFamily="34" charset="-122"/>
+                <a:cs typeface="Cambria" pitchFamily="34" charset="-120"/>
+              </a:rPr>
+              <a:t>Throughput = I_size / T_total   (MiB/s)</a:t>
+            </a:r>
+            <a:endParaRPr lang="en-US" sz="1900" dirty="0"/>
+          </a:p>
+        </p:txBody>
+      </p:sp>
+      <p:sp>
+        <p:nvSpPr>
+          <p:cNvPr id="8" name="Shape 6"/>
+          <p:cNvSpPr/>
+          <p:nvPr/>
+        </p:nvSpPr>
+        <p:spPr>
+          <a:xfrm>
+            <a:off x="457200" y="1645920"/>
+            <a:ext cx="7498080" cy="4617720"/>
+          </a:xfrm>
+          <a:prstGeom prst="roundRect">
+            <a:avLst>
+              <a:gd name="adj" fmla="val 1584"/>
             </a:avLst>
           </a:prstGeom>
           <a:solidFill>
@@ -24044,7 +23155,7 @@
       </p:sp>
       <p:pic>
         <p:nvPicPr>
-          <p:cNvPr id="7" name="Image 0" descr="assets/throughput_ch4.png">    </p:cNvPr>
+          <p:cNvPr id="9" name="Image 0" descr="assets/throughput_ch4.png">    </p:cNvPr>
           <p:cNvPicPr>
             <a:picLocks noChangeAspect="1"/>
           </p:cNvPicPr>
@@ -24058,8 +23169,8 @@
         </p:blipFill>
         <p:spPr>
           <a:xfrm>
-            <a:off x="457200" y="1269906"/>
-            <a:ext cx="7498080" cy="4958268"/>
+            <a:off x="714695" y="1645920"/>
+            <a:ext cx="6983091" cy="4617720"/>
           </a:xfrm>
           <a:prstGeom prst="rect">
             <a:avLst/>
@@ -24068,7 +23179,7 @@
       </p:pic>
       <p:sp>
         <p:nvSpPr>
-          <p:cNvPr id="8" name="Shape 5"/>
+          <p:cNvPr id="10" name="Shape 7"/>
           <p:cNvSpPr/>
           <p:nvPr/>
         </p:nvSpPr>
@@ -24095,7 +23206,7 @@
       </p:sp>
       <p:sp>
         <p:nvSpPr>
-          <p:cNvPr id="9" name="Text 6"/>
+          <p:cNvPr id="11" name="Text 8"/>
           <p:cNvSpPr/>
           <p:nvPr/>
         </p:nvSpPr>
@@ -24382,6 +23493,72 @@
           </a:ln>
         </p:spPr>
       </p:sp>
+      <p:sp>
+        <p:nvSpPr>
+          <p:cNvPr id="6" name="Shape 4"/>
+          <p:cNvSpPr/>
+          <p:nvPr/>
+        </p:nvSpPr>
+        <p:spPr>
+          <a:xfrm>
+            <a:off x="457200" y="1143000"/>
+            <a:ext cx="7772400" cy="457200"/>
+          </a:xfrm>
+          <a:prstGeom prst="roundRect">
+            <a:avLst>
+              <a:gd name="adj" fmla="val 16000"/>
+            </a:avLst>
+          </a:prstGeom>
+          <a:solidFill>
+            <a:srgbClr val="FDF1E6"/>
+          </a:solidFill>
+          <a:ln w="15875">
+            <a:solidFill>
+              <a:srgbClr val="E07B22"/>
+            </a:solidFill>
+            <a:prstDash val="solid"/>
+          </a:ln>
+        </p:spPr>
+      </p:sp>
+      <p:sp>
+        <p:nvSpPr>
+          <p:cNvPr id="7" name="Text 5"/>
+          <p:cNvSpPr/>
+          <p:nvPr/>
+        </p:nvSpPr>
+        <p:spPr>
+          <a:xfrm>
+            <a:off x="457200" y="1143000"/>
+            <a:ext cx="7772400" cy="457200"/>
+          </a:xfrm>
+          <a:prstGeom prst="rect">
+            <a:avLst/>
+          </a:prstGeom>
+          <a:noFill/>
+          <a:ln/>
+        </p:spPr>
+        <p:txBody>
+          <a:bodyPr wrap="square" lIns="508" tIns="508" rIns="508" bIns="508" rtlCol="0" anchor="ctr"/>
+          <a:lstStyle/>
+          <a:p>
+            <a:pPr algn="ctr" indent="0" marL="0">
+              <a:buNone/>
+            </a:pPr>
+            <a:r>
+              <a:rPr lang="en-US" sz="2000" b="1" dirty="0">
+                <a:solidFill>
+                  <a:srgbClr val="2E2055"/>
+                </a:solidFill>
+                <a:latin typeface="Cambria" pitchFamily="34" charset="0"/>
+                <a:ea typeface="Cambria" pitchFamily="34" charset="-122"/>
+                <a:cs typeface="Cambria" pitchFamily="34" charset="-120"/>
+              </a:rPr>
+              <a:t>e = (1/S − 1/P) / (1 − 1/P)</a:t>
+            </a:r>
+            <a:endParaRPr lang="en-US" sz="2000" dirty="0"/>
+          </a:p>
+        </p:txBody>
+      </p:sp>
       <p:graphicFrame>
         <p:nvGraphicFramePr>
           <p:cNvPr id="30" name="Table 0"/>
@@ -24397,7 +23574,7 @@
           </p:nvPr>
         </p:nvGraphicFramePr>
         <p:xfrm>
-          <a:off x="457200" y="1280160"/>
+          <a:off x="457200" y="1737360"/>
           <a:ext cx="7772400" cy="914400"/>
         </p:xfrm>
         <a:graphic>
@@ -24413,7 +23590,7 @@
                 <a:gridCol w="1188720"/>
                 <a:gridCol w="1280160"/>
               </a:tblGrid>
-              <a:tr h="530352">
+              <a:tr h="502920">
                 <a:tc>
                   <a:txBody>
                     <a:bodyPr/>
@@ -24891,7 +24068,7 @@
                   </a:tcPr>
                 </a:tc>
               </a:tr>
-              <a:tr h="530352">
+              <a:tr h="502920">
                 <a:tc>
                   <a:txBody>
                     <a:bodyPr/>
@@ -25369,7 +24546,7 @@
                   </a:tcPr>
                 </a:tc>
               </a:tr>
-              <a:tr h="530352">
+              <a:tr h="502920">
                 <a:tc>
                   <a:txBody>
                     <a:bodyPr/>
@@ -25847,7 +25024,7 @@
                   </a:tcPr>
                 </a:tc>
               </a:tr>
-              <a:tr h="530352">
+              <a:tr h="502920">
                 <a:tc>
                   <a:txBody>
                     <a:bodyPr/>
@@ -26325,7 +25502,7 @@
                   </a:tcPr>
                 </a:tc>
               </a:tr>
-              <a:tr h="530352">
+              <a:tr h="502920">
                 <a:tc>
                   <a:txBody>
                     <a:bodyPr/>
@@ -26803,7 +25980,7 @@
                   </a:tcPr>
                 </a:tc>
               </a:tr>
-              <a:tr h="530352">
+              <a:tr h="502920">
                 <a:tc>
                   <a:txBody>
                     <a:bodyPr/>
@@ -27281,7 +26458,7 @@
                   </a:tcPr>
                 </a:tc>
               </a:tr>
-              <a:tr h="530352">
+              <a:tr h="502920">
                 <a:tc>
                   <a:txBody>
                     <a:bodyPr/>
@@ -27759,7 +26936,7 @@
                   </a:tcPr>
                 </a:tc>
               </a:tr>
-              <a:tr h="530352">
+              <a:tr h="502920">
                 <a:tc>
                   <a:txBody>
                     <a:bodyPr/>
@@ -28243,13 +27420,13 @@
       </p:graphicFrame>
       <p:sp>
         <p:nvSpPr>
-          <p:cNvPr id="7" name="Text 4"/>
-          <p:cNvSpPr/>
-          <p:nvPr/>
-        </p:nvSpPr>
-        <p:spPr>
-          <a:xfrm>
-            <a:off x="457200" y="5577840"/>
+          <p:cNvPr id="9" name="Text 6"/>
+          <p:cNvSpPr/>
+          <p:nvPr/>
+        </p:nvSpPr>
+        <p:spPr>
+          <a:xfrm>
+            <a:off x="457200" y="5852160"/>
             <a:ext cx="7772400" cy="548640"/>
           </a:xfrm>
           <a:prstGeom prst="rect">
@@ -28282,7 +27459,7 @@
       </p:sp>
       <p:sp>
         <p:nvSpPr>
-          <p:cNvPr id="8" name="Shape 5"/>
+          <p:cNvPr id="10" name="Shape 7"/>
           <p:cNvSpPr/>
           <p:nvPr/>
         </p:nvSpPr>
@@ -28309,7 +27486,7 @@
       </p:sp>
       <p:sp>
         <p:nvSpPr>
-          <p:cNvPr id="9" name="Text 6"/>
+          <p:cNvPr id="11" name="Text 8"/>
           <p:cNvSpPr/>
           <p:nvPr/>
         </p:nvSpPr>

</xml_diff>

<commit_message>
Seminar: separate speedup and efficiency slides (33 slides)
Co-Authored-By: Claude Sonnet 5.5 <noreply@anthropic.com>
Claude-Session: https://claude.ai/code/session_01T6gEewJ8YaCdmnsfS34RJd
</commit_message>
<xml_diff>
--- a/results/seminar/figs/Seminar_Ibtihal_FINAL.pptx
+++ b/results/seminar/figs/Seminar_Ibtihal_FINAL.pptx
@@ -37,9 +37,10 @@
     <p:sldId id="285" r:id="rId31"/>
     <p:sldId id="286" r:id="rId32"/>
     <p:sldId id="287" r:id="rId33"/>
+    <p:sldId id="288" r:id="rId34"/>
   </p:sldIdLst>
   <p:notesMasterIdLst>
-    <p:notesMasterId r:id="rId34"/>
+    <p:notesMasterId r:id="rId35"/>
   </p:notesMasterIdLst>
   <p:sldSz cx="12192000" cy="6858000"/>
   <p:notesSz cx="6858000" cy="12192000"/>
@@ -2757,6 +2758,94 @@
             <a:fld id="{F7021451-1387-4CA6-816F-3879F97B5CBC}" type="slidenum">
               <a:rPr lang="en-US"/>
               <a:t>32</a:t>
+            </a:fld>
+            <a:endParaRPr lang="en-US"/>
+          </a:p>
+        </p:txBody>
+      </p:sp>
+    </p:spTree>
+    <p:extLst>
+      <p:ext uri="{BB962C8B-B14F-4D97-AF65-F5344CB8AC3E}">
+        <p14:creationId xmlns:p14="http://schemas.microsoft.com/office/powerpoint/2010/main" val="1024086991"/>
+      </p:ext>
+    </p:extLst>
+  </p:cSld>
+  <p:clrMapOvr>
+    <a:masterClrMapping/>
+  </p:clrMapOvr>
+</p:notes>
+</file>
+
+<file path=ppt/notesSlides/notesSlide33.xml><?xml version="1.0" encoding="utf-8"?>
+<p:notes xmlns:a="http://schemas.openxmlformats.org/drawingml/2006/main" xmlns:r="http://schemas.openxmlformats.org/officeDocument/2006/relationships" xmlns:p="http://schemas.openxmlformats.org/presentationml/2006/main">
+  <p:cSld>
+    <p:spTree>
+      <p:nvGrpSpPr>
+        <p:cNvPr id="1" name=""/>
+        <p:cNvGrpSpPr/>
+        <p:nvPr/>
+      </p:nvGrpSpPr>
+      <p:grpSpPr>
+        <a:xfrm>
+          <a:off x="0" y="0"/>
+          <a:ext cx="0" cy="0"/>
+          <a:chOff x="0" y="0"/>
+          <a:chExt cx="0" cy="0"/>
+        </a:xfrm>
+      </p:grpSpPr>
+      <p:sp>
+        <p:nvSpPr>
+          <p:cNvPr id="2" name="Slide Image Placeholder 1"/>
+          <p:cNvSpPr>
+            <a:spLocks noGrp="1" noRot="1" noChangeAspect="1"/>
+          </p:cNvSpPr>
+          <p:nvPr>
+            <p:ph type="sldImg"/>
+          </p:nvPr>
+        </p:nvSpPr>
+        <p:spPr/>
+      </p:sp>
+      <p:sp>
+        <p:nvSpPr>
+          <p:cNvPr id="3" name="Notes Placeholder 2"/>
+          <p:cNvSpPr>
+            <a:spLocks noGrp="1"/>
+          </p:cNvSpPr>
+          <p:nvPr>
+            <p:ph type="body" idx="1"/>
+          </p:nvPr>
+        </p:nvSpPr>
+        <p:spPr/>
+        <p:txBody>
+          <a:bodyPr/>
+          <a:lstStyle/>
+          <a:p>
+            <a:r>
+              <a:rPr lang="en-US" dirty="0"/>
+              <a:t/>
+            </a:r>
+            <a:endParaRPr lang="en-US" dirty="0"/>
+          </a:p>
+        </p:txBody>
+      </p:sp>
+      <p:sp>
+        <p:nvSpPr>
+          <p:cNvPr id="4" name="Slide Number Placeholder 3"/>
+          <p:cNvSpPr>
+            <a:spLocks noGrp="1"/>
+          </p:cNvSpPr>
+          <p:nvPr>
+            <p:ph type="sldNum" sz="quarter" idx="10"/>
+          </p:nvPr>
+        </p:nvSpPr>
+        <p:spPr/>
+        <p:txBody>
+          <a:bodyPr/>
+          <a:lstStyle/>
+          <a:p>
+            <a:fld id="{F7021451-1387-4CA6-816F-3879F97B5CBC}" type="slidenum">
+              <a:rPr lang="en-US"/>
+              <a:t>33</a:t>
             </a:fld>
             <a:endParaRPr lang="en-US"/>
           </a:p>
@@ -21775,7 +21864,7 @@
                 <a:ea typeface="Cambria" pitchFamily="34" charset="-122"/>
                 <a:cs typeface="Cambria" pitchFamily="34" charset="-120"/>
               </a:rPr>
-              <a:t>Speedup and Efficiency of LBG Training</a:t>
+              <a:t>Speedup of LBG Training</a:t>
             </a:r>
             <a:endParaRPr lang="en-US" sz="2800" dirty="0"/>
           </a:p>
@@ -21866,7 +21955,7 @@
                 <a:ea typeface="Cambria" pitchFamily="34" charset="-122"/>
                 <a:cs typeface="Cambria" pitchFamily="34" charset="-120"/>
               </a:rPr>
-              <a:t>S = T_seq / T_P          E = S / P</a:t>
+              <a:t>S = T_seq / T_P</a:t>
             </a:r>
             <a:endParaRPr lang="en-US" sz="2000" dirty="0"/>
           </a:p>
@@ -21987,7 +22076,7 @@
                 <a:ea typeface="Calibri" pitchFamily="34" charset="-122"/>
                 <a:cs typeface="Calibri" pitchFamily="34" charset="-120"/>
               </a:rPr>
-              <a:t>LBG speedup reaches 9.19× on 14 processes (efficiency ≈ 66%).</a:t>
+              <a:t>LBG speedup reaches 9.19× on 14 processes.</a:t>
             </a:r>
             <a:endParaRPr lang="en-US" sz="1600" dirty="0"/>
           </a:p>
@@ -22050,7 +22139,7 @@
                 <a:ea typeface="Calibri" pitchFamily="34" charset="-122"/>
                 <a:cs typeface="Calibri" pitchFamily="34" charset="-120"/>
               </a:rPr>
-              <a:t>Karp–Flatt ≈ 0.04 for P ≥ 8: the serial fraction of LBG stays small.</a:t>
+              <a:t>Mean of the 8 images; the bars show the minimum and maximum.</a:t>
             </a:r>
             <a:endParaRPr lang="en-US" sz="1600" dirty="0"/>
           </a:p>
@@ -22071,7 +22160,7 @@
                 <a:ea typeface="Calibri" pitchFamily="34" charset="-122"/>
                 <a:cs typeface="Calibri" pitchFamily="34" charset="-120"/>
               </a:rPr>
-              <a:t>This is the LBG stage (mean of the 8 images). The total speedup is shown separately for gray and color on the next slide.</a:t>
+              <a:t>This is the LBG stage. The total speedup is shown separately for gray and color two slides later.</a:t>
             </a:r>
             <a:endParaRPr lang="en-US" sz="1600" dirty="0"/>
           </a:p>
@@ -22208,7 +22297,7 @@
                 <a:ea typeface="Cambria" pitchFamily="34" charset="-122"/>
                 <a:cs typeface="Cambria" pitchFamily="34" charset="-120"/>
               </a:rPr>
-              <a:t>Total Speedup: Grayscale and Color</a:t>
+              <a:t>Parallel Efficiency of LBG Training</a:t>
             </a:r>
             <a:endParaRPr lang="en-US" sz="2800" dirty="0"/>
           </a:p>
@@ -22299,7 +22388,7 @@
                 <a:ea typeface="Cambria" pitchFamily="34" charset="-122"/>
                 <a:cs typeface="Cambria" pitchFamily="34" charset="-120"/>
               </a:rPr>
-              <a:t>S = T_seq / T_P          E = S / P</a:t>
+              <a:t>E = S / P</a:t>
             </a:r>
             <a:endParaRPr lang="en-US" sz="2000" dirty="0"/>
           </a:p>
@@ -22334,7 +22423,7 @@
       </p:sp>
       <p:pic>
         <p:nvPicPr>
-          <p:cNvPr id="9" name="Image 0" descr="assets/total_speedup_chart.png">    </p:cNvPr>
+          <p:cNvPr id="9" name="Image 0" descr="assets/efficiency_chart.png">    </p:cNvPr>
           <p:cNvPicPr>
             <a:picLocks noChangeAspect="1"/>
           </p:cNvPicPr>
@@ -22406,13 +22495,13 @@
           <a:p>
             <a:pPr marL="342900" indent="-342900">
               <a:spcAft>
-                <a:spcPts val="1000"/>
+                <a:spcPts val="900"/>
               </a:spcAft>
               <a:buSzPct val="100000"/>
               <a:buChar char="■"/>
             </a:pPr>
             <a:r>
-              <a:rPr lang="en-US" sz="1500" dirty="0">
+              <a:rPr lang="en-US" sz="1600" dirty="0">
                 <a:solidFill>
                   <a:srgbClr val="1F1A33"/>
                 </a:solidFill>
@@ -22420,20 +22509,20 @@
                 <a:ea typeface="Calibri" pitchFamily="34" charset="-122"/>
                 <a:cs typeface="Calibri" pitchFamily="34" charset="-120"/>
               </a:rPr>
-              <a:t>Total speedup at P = 14: 5.00× (grayscale) and 6.84× (color); efficiency 35.7% and 48.9%.</a:t>
-            </a:r>
-            <a:endParaRPr lang="en-US" sz="1500" dirty="0"/>
+              <a:t>Efficiency is 97% at P = 2 and stays at 90% or more up to P = 6 (P-cores only).</a:t>
+            </a:r>
+            <a:endParaRPr lang="en-US" sz="1600" dirty="0"/>
           </a:p>
           <a:p>
             <a:pPr marL="342900" indent="-342900">
               <a:spcAft>
-                <a:spcPts val="1000"/>
+                <a:spcPts val="900"/>
               </a:spcAft>
               <a:buSzPct val="100000"/>
               <a:buChar char="■"/>
             </a:pPr>
             <a:r>
-              <a:rPr lang="en-US" sz="1500" dirty="0">
+              <a:rPr lang="en-US" sz="1600" dirty="0">
                 <a:solidFill>
                   <a:srgbClr val="1F1A33"/>
                 </a:solidFill>
@@ -22441,20 +22530,20 @@
                 <a:ea typeface="Calibri" pitchFamily="34" charset="-122"/>
                 <a:cs typeface="Calibri" pitchFamily="34" charset="-120"/>
               </a:rPr>
-              <a:t>It is lower than the LBG speedup (9.19×) because the other stages (image reading, delta and Huffman coding, reconstruction) remain sequential.</a:t>
-            </a:r>
-            <a:endParaRPr lang="en-US" sz="1500" dirty="0"/>
+              <a:t>It drops to 79% at P = 8, where the E-cores start to be used, and reaches 66% at P = 14.</a:t>
+            </a:r>
+            <a:endParaRPr lang="en-US" sz="1600" dirty="0"/>
           </a:p>
           <a:p>
             <a:pPr marL="342900" indent="-342900">
               <a:spcAft>
-                <a:spcPts val="1000"/>
+                <a:spcPts val="900"/>
               </a:spcAft>
               <a:buSzPct val="100000"/>
               <a:buChar char="■"/>
             </a:pPr>
             <a:r>
-              <a:rPr lang="en-US" sz="1500" dirty="0">
+              <a:rPr lang="en-US" sz="1600" dirty="0">
                 <a:solidFill>
                   <a:srgbClr val="1F1A33"/>
                 </a:solidFill>
@@ -22462,20 +22551,20 @@
                 <a:ea typeface="Calibri" pitchFamily="34" charset="-122"/>
                 <a:cs typeface="Calibri" pitchFamily="34" charset="-120"/>
               </a:rPr>
-              <a:t>Color images gain more: LBG is 81% of their sequential time, against 77% for grayscale.</a:t>
-            </a:r>
-            <a:endParaRPr lang="en-US" sz="1500" dirty="0"/>
+              <a:t>The E-cores are slower than the P-cores, so each added process contributes less than a full core.</a:t>
+            </a:r>
+            <a:endParaRPr lang="en-US" sz="1600" dirty="0"/>
           </a:p>
           <a:p>
             <a:pPr marL="342900" indent="-342900">
               <a:spcAft>
-                <a:spcPts val="1000"/>
+                <a:spcPts val="900"/>
               </a:spcAft>
               <a:buSzPct val="100000"/>
               <a:buChar char="■"/>
             </a:pPr>
             <a:r>
-              <a:rPr lang="en-US" sz="1500" dirty="0">
+              <a:rPr lang="en-US" sz="1600" dirty="0">
                 <a:solidFill>
                   <a:srgbClr val="1F1A33"/>
                 </a:solidFill>
@@ -22483,9 +22572,30 @@
                 <a:ea typeface="Calibri" pitchFamily="34" charset="-122"/>
                 <a:cs typeface="Calibri" pitchFamily="34" charset="-120"/>
               </a:rPr>
-              <a:t>Total time is the whole program execution; the shaded bands show the minimum to maximum over the images of each type.</a:t>
-            </a:r>
-            <a:endParaRPr lang="en-US" sz="1500" dirty="0"/>
+              <a:t>Karp–Flatt stays near 0.04 for P ≥ 8: the serial fraction of LBG remains small.</a:t>
+            </a:r>
+            <a:endParaRPr lang="en-US" sz="1600" dirty="0"/>
+          </a:p>
+          <a:p>
+            <a:pPr marL="342900" indent="-342900">
+              <a:spcAft>
+                <a:spcPts val="900"/>
+              </a:spcAft>
+              <a:buSzPct val="100000"/>
+              <a:buChar char="■"/>
+            </a:pPr>
+            <a:r>
+              <a:rPr lang="en-US" sz="1600" dirty="0">
+                <a:solidFill>
+                  <a:srgbClr val="1F1A33"/>
+                </a:solidFill>
+                <a:latin typeface="Calibri" pitchFamily="34" charset="0"/>
+                <a:ea typeface="Calibri" pitchFamily="34" charset="-122"/>
+                <a:cs typeface="Calibri" pitchFamily="34" charset="-120"/>
+              </a:rPr>
+              <a:t>Mean of the 8 images.</a:t>
+            </a:r>
+            <a:endParaRPr lang="en-US" sz="1600" dirty="0"/>
           </a:p>
         </p:txBody>
       </p:sp>
@@ -22620,7 +22730,7 @@
                 <a:ea typeface="Cambria" pitchFamily="34" charset="-122"/>
                 <a:cs typeface="Cambria" pitchFamily="34" charset="-120"/>
               </a:rPr>
-              <a:t>Equal vs Adaptive Workload Distribution</a:t>
+              <a:t>Total Speedup: Grayscale and Color</a:t>
             </a:r>
             <a:endParaRPr lang="en-US" sz="2800" dirty="0"/>
           </a:p>
@@ -22659,12 +22769,78 @@
         </p:nvSpPr>
         <p:spPr>
           <a:xfrm>
-            <a:off x="457200" y="1234440"/>
-            <a:ext cx="7498080" cy="5029200"/>
+            <a:off x="457200" y="1097280"/>
+            <a:ext cx="7498080" cy="457200"/>
           </a:xfrm>
           <a:prstGeom prst="roundRect">
             <a:avLst>
-              <a:gd name="adj" fmla="val 1455"/>
+              <a:gd name="adj" fmla="val 16000"/>
+            </a:avLst>
+          </a:prstGeom>
+          <a:solidFill>
+            <a:srgbClr val="FDF1E6"/>
+          </a:solidFill>
+          <a:ln w="15875">
+            <a:solidFill>
+              <a:srgbClr val="E07B22"/>
+            </a:solidFill>
+            <a:prstDash val="solid"/>
+          </a:ln>
+        </p:spPr>
+      </p:sp>
+      <p:sp>
+        <p:nvSpPr>
+          <p:cNvPr id="7" name="Text 5"/>
+          <p:cNvSpPr/>
+          <p:nvPr/>
+        </p:nvSpPr>
+        <p:spPr>
+          <a:xfrm>
+            <a:off x="457200" y="1097280"/>
+            <a:ext cx="7498080" cy="457200"/>
+          </a:xfrm>
+          <a:prstGeom prst="rect">
+            <a:avLst/>
+          </a:prstGeom>
+          <a:noFill/>
+          <a:ln/>
+        </p:spPr>
+        <p:txBody>
+          <a:bodyPr wrap="square" lIns="508" tIns="508" rIns="508" bIns="508" rtlCol="0" anchor="ctr"/>
+          <a:lstStyle/>
+          <a:p>
+            <a:pPr algn="ctr" indent="0" marL="0">
+              <a:buNone/>
+            </a:pPr>
+            <a:r>
+              <a:rPr lang="en-US" sz="2000" b="1" dirty="0">
+                <a:solidFill>
+                  <a:srgbClr val="2E2055"/>
+                </a:solidFill>
+                <a:latin typeface="Cambria" pitchFamily="34" charset="0"/>
+                <a:ea typeface="Cambria" pitchFamily="34" charset="-122"/>
+                <a:cs typeface="Cambria" pitchFamily="34" charset="-120"/>
+              </a:rPr>
+              <a:t>S = T_seq / T_P</a:t>
+            </a:r>
+            <a:endParaRPr lang="en-US" sz="2000" dirty="0"/>
+          </a:p>
+        </p:txBody>
+      </p:sp>
+      <p:sp>
+        <p:nvSpPr>
+          <p:cNvPr id="8" name="Shape 6"/>
+          <p:cNvSpPr/>
+          <p:nvPr/>
+        </p:nvSpPr>
+        <p:spPr>
+          <a:xfrm>
+            <a:off x="457200" y="1645920"/>
+            <a:ext cx="7498080" cy="4617720"/>
+          </a:xfrm>
+          <a:prstGeom prst="roundRect">
+            <a:avLst>
+              <a:gd name="adj" fmla="val 1584"/>
             </a:avLst>
           </a:prstGeom>
           <a:solidFill>
@@ -22680,7 +22856,7 @@
       </p:sp>
       <p:pic>
         <p:nvPicPr>
-          <p:cNvPr id="7" name="Image 0" descr="assets/eqad_chart.png">    </p:cNvPr>
+          <p:cNvPr id="9" name="Image 0" descr="assets/total_speedup_chart.png">    </p:cNvPr>
           <p:cNvPicPr>
             <a:picLocks noChangeAspect="1"/>
           </p:cNvPicPr>
@@ -22694,7 +22870,7 @@
         </p:blipFill>
         <p:spPr>
           <a:xfrm>
-            <a:off x="457200" y="1467016"/>
+            <a:off x="457200" y="1672756"/>
             <a:ext cx="7498080" cy="4564049"/>
           </a:xfrm>
           <a:prstGeom prst="rect">
@@ -22704,7 +22880,7 @@
       </p:pic>
       <p:sp>
         <p:nvSpPr>
-          <p:cNvPr id="8" name="Shape 5"/>
+          <p:cNvPr id="10" name="Shape 7"/>
           <p:cNvSpPr/>
           <p:nvPr/>
         </p:nvSpPr>
@@ -22731,7 +22907,7 @@
       </p:sp>
       <p:sp>
         <p:nvSpPr>
-          <p:cNvPr id="9" name="Text 6"/>
+          <p:cNvPr id="11" name="Text 8"/>
           <p:cNvSpPr/>
           <p:nvPr/>
         </p:nvSpPr>
@@ -22752,7 +22928,7 @@
           <a:p>
             <a:pPr marL="342900" indent="-342900">
               <a:spcAft>
-                <a:spcPts val="800"/>
+                <a:spcPts val="1000"/>
               </a:spcAft>
               <a:buSzPct val="100000"/>
               <a:buChar char="■"/>
@@ -22766,14 +22942,14 @@
                 <a:ea typeface="Calibri" pitchFamily="34" charset="-122"/>
                 <a:cs typeface="Calibri" pitchFamily="34" charset="-120"/>
               </a:rPr>
-              <a:t>With Equal distribution, the faster P-cores finish early and wait for the E-cores: 7.61× at P = 14.</a:t>
+              <a:t>Total speedup at P = 14: 5.00× (grayscale) and 6.84× (color); efficiency 35.7% and 48.9%.</a:t>
             </a:r>
             <a:endParaRPr lang="en-US" sz="1500" dirty="0"/>
           </a:p>
           <a:p>
             <a:pPr marL="342900" indent="-342900">
               <a:spcAft>
-                <a:spcPts val="800"/>
+                <a:spcPts val="1000"/>
               </a:spcAft>
               <a:buSzPct val="100000"/>
               <a:buChar char="■"/>
@@ -22787,14 +22963,14 @@
                 <a:ea typeface="Calibri" pitchFamily="34" charset="-122"/>
                 <a:cs typeface="Calibri" pitchFamily="34" charset="-120"/>
               </a:rPr>
-              <a:t>Adaptive distribution reaches 9.19× at P = 14.</a:t>
+              <a:t>It is lower than the LBG speedup (9.19×) because the other stages (image reading, delta and Huffman coding, reconstruction) remain sequential.</a:t>
             </a:r>
             <a:endParaRPr lang="en-US" sz="1500" dirty="0"/>
           </a:p>
           <a:p>
             <a:pPr marL="342900" indent="-342900">
               <a:spcAft>
-                <a:spcPts val="800"/>
+                <a:spcPts val="1000"/>
               </a:spcAft>
               <a:buSzPct val="100000"/>
               <a:buChar char="■"/>
@@ -22808,14 +22984,14 @@
                 <a:ea typeface="Calibri" pitchFamily="34" charset="-122"/>
                 <a:cs typeface="Calibri" pitchFamily="34" charset="-120"/>
               </a:rPr>
-              <a:t>LBG time is reduced by 28.3%, 23.6%, 19.8% and 17.2% at P = 8, 10, 12 and 14.</a:t>
+              <a:t>Color images gain more: LBG is 81% of their sequential time, against 77% for grayscale.</a:t>
             </a:r>
             <a:endParaRPr lang="en-US" sz="1500" dirty="0"/>
           </a:p>
           <a:p>
             <a:pPr marL="342900" indent="-342900">
               <a:spcAft>
-                <a:spcPts val="800"/>
+                <a:spcPts val="1000"/>
               </a:spcAft>
               <a:buSzPct val="100000"/>
               <a:buChar char="■"/>
@@ -22829,70 +23005,7 @@
                 <a:ea typeface="Calibri" pitchFamily="34" charset="-122"/>
                 <a:cs typeface="Calibri" pitchFamily="34" charset="-120"/>
               </a:rPr>
-              <a:t>Total time is reduced by 17.9% to 8.8%.</a:t>
-            </a:r>
-            <a:endParaRPr lang="en-US" sz="1500" dirty="0"/>
-          </a:p>
-          <a:p>
-            <a:pPr marL="342900" indent="-342900">
-              <a:spcAft>
-                <a:spcPts val="800"/>
-              </a:spcAft>
-              <a:buSzPct val="100000"/>
-              <a:buChar char="■"/>
-            </a:pPr>
-            <a:r>
-              <a:rPr lang="en-US" sz="1500" dirty="0">
-                <a:solidFill>
-                  <a:srgbClr val="1F1A33"/>
-                </a:solidFill>
-                <a:latin typeface="Calibri" pitchFamily="34" charset="0"/>
-                <a:ea typeface="Calibri" pitchFamily="34" charset="-122"/>
-                <a:cs typeface="Calibri" pitchFamily="34" charset="-120"/>
-              </a:rPr>
-              <a:t>No adaptive-distribution benefit was observed when only P-cores were used (P ≤ 6).</a:t>
-            </a:r>
-            <a:endParaRPr lang="en-US" sz="1500" dirty="0"/>
-          </a:p>
-          <a:p>
-            <a:pPr marL="342900" indent="-342900">
-              <a:spcAft>
-                <a:spcPts val="800"/>
-              </a:spcAft>
-              <a:buSzPct val="100000"/>
-              <a:buChar char="■"/>
-            </a:pPr>
-            <a:r>
-              <a:rPr lang="en-US" sz="1500" dirty="0">
-                <a:solidFill>
-                  <a:srgbClr val="1F1A33"/>
-                </a:solidFill>
-                <a:latin typeface="Calibri" pitchFamily="34" charset="0"/>
-                <a:ea typeface="Calibri" pitchFamily="34" charset="-122"/>
-                <a:cs typeface="Calibri" pitchFamily="34" charset="-120"/>
-              </a:rPr>
-              <a:t>The reconstructed images are identical in both cases.</a:t>
-            </a:r>
-            <a:endParaRPr lang="en-US" sz="1500" dirty="0"/>
-          </a:p>
-          <a:p>
-            <a:pPr marL="342900" indent="-342900">
-              <a:spcAft>
-                <a:spcPts val="800"/>
-              </a:spcAft>
-              <a:buSzPct val="100000"/>
-              <a:buChar char="■"/>
-            </a:pPr>
-            <a:r>
-              <a:rPr lang="en-US" sz="1500" dirty="0">
-                <a:solidFill>
-                  <a:srgbClr val="1F1A33"/>
-                </a:solidFill>
-                <a:latin typeface="Calibri" pitchFamily="34" charset="0"/>
-                <a:ea typeface="Calibri" pitchFamily="34" charset="-122"/>
-                <a:cs typeface="Calibri" pitchFamily="34" charset="-120"/>
-              </a:rPr>
-              <a:t>Adaptive values here come from the Equal-vs-Adaptive runs, so they can differ by up to 0.02× from the main speedup runs.</a:t>
+              <a:t>Total time is the whole program execution; the shaded bands show the minimum to maximum over the images of each type.</a:t>
             </a:r>
             <a:endParaRPr lang="en-US" sz="1500" dirty="0"/>
           </a:p>
@@ -23029,7 +23142,7 @@
                 <a:ea typeface="Cambria" pitchFamily="34" charset="-122"/>
                 <a:cs typeface="Cambria" pitchFamily="34" charset="-120"/>
               </a:rPr>
-              <a:t>Throughput</a:t>
+              <a:t>Equal vs Adaptive Workload Distribution</a:t>
             </a:r>
             <a:endParaRPr lang="en-US" sz="2800" dirty="0"/>
           </a:p>
@@ -23068,78 +23181,12 @@
         </p:nvSpPr>
         <p:spPr>
           <a:xfrm>
-            <a:off x="457200" y="1097280"/>
-            <a:ext cx="7498080" cy="457200"/>
+            <a:off x="457200" y="1234440"/>
+            <a:ext cx="7498080" cy="5029200"/>
           </a:xfrm>
           <a:prstGeom prst="roundRect">
             <a:avLst>
-              <a:gd name="adj" fmla="val 16000"/>
-            </a:avLst>
-          </a:prstGeom>
-          <a:solidFill>
-            <a:srgbClr val="FDF1E6"/>
-          </a:solidFill>
-          <a:ln w="15875">
-            <a:solidFill>
-              <a:srgbClr val="E07B22"/>
-            </a:solidFill>
-            <a:prstDash val="solid"/>
-          </a:ln>
-        </p:spPr>
-      </p:sp>
-      <p:sp>
-        <p:nvSpPr>
-          <p:cNvPr id="7" name="Text 5"/>
-          <p:cNvSpPr/>
-          <p:nvPr/>
-        </p:nvSpPr>
-        <p:spPr>
-          <a:xfrm>
-            <a:off x="457200" y="1097280"/>
-            <a:ext cx="7498080" cy="457200"/>
-          </a:xfrm>
-          <a:prstGeom prst="rect">
-            <a:avLst/>
-          </a:prstGeom>
-          <a:noFill/>
-          <a:ln/>
-        </p:spPr>
-        <p:txBody>
-          <a:bodyPr wrap="square" lIns="508" tIns="508" rIns="508" bIns="508" rtlCol="0" anchor="ctr"/>
-          <a:lstStyle/>
-          <a:p>
-            <a:pPr algn="ctr" indent="0" marL="0">
-              <a:buNone/>
-            </a:pPr>
-            <a:r>
-              <a:rPr lang="en-US" sz="1900" b="1" dirty="0">
-                <a:solidFill>
-                  <a:srgbClr val="2E2055"/>
-                </a:solidFill>
-                <a:latin typeface="Cambria" pitchFamily="34" charset="0"/>
-                <a:ea typeface="Cambria" pitchFamily="34" charset="-122"/>
-                <a:cs typeface="Cambria" pitchFamily="34" charset="-120"/>
-              </a:rPr>
-              <a:t>Throughput = I_size / T_total   (MiB/s)</a:t>
-            </a:r>
-            <a:endParaRPr lang="en-US" sz="1900" dirty="0"/>
-          </a:p>
-        </p:txBody>
-      </p:sp>
-      <p:sp>
-        <p:nvSpPr>
-          <p:cNvPr id="8" name="Shape 6"/>
-          <p:cNvSpPr/>
-          <p:nvPr/>
-        </p:nvSpPr>
-        <p:spPr>
-          <a:xfrm>
-            <a:off x="457200" y="1645920"/>
-            <a:ext cx="7498080" cy="4617720"/>
-          </a:xfrm>
-          <a:prstGeom prst="roundRect">
-            <a:avLst>
-              <a:gd name="adj" fmla="val 1584"/>
+              <a:gd name="adj" fmla="val 1455"/>
             </a:avLst>
           </a:prstGeom>
           <a:solidFill>
@@ -23155,7 +23202,7 @@
       </p:sp>
       <p:pic>
         <p:nvPicPr>
-          <p:cNvPr id="9" name="Image 0" descr="assets/throughput_ch4.png">    </p:cNvPr>
+          <p:cNvPr id="7" name="Image 0" descr="assets/eqad_chart.png">    </p:cNvPr>
           <p:cNvPicPr>
             <a:picLocks noChangeAspect="1"/>
           </p:cNvPicPr>
@@ -23169,8 +23216,8 @@
         </p:blipFill>
         <p:spPr>
           <a:xfrm>
-            <a:off x="714695" y="1645920"/>
-            <a:ext cx="6983091" cy="4617720"/>
+            <a:off x="457200" y="1467016"/>
+            <a:ext cx="7498080" cy="4564049"/>
           </a:xfrm>
           <a:prstGeom prst="rect">
             <a:avLst/>
@@ -23179,7 +23226,7 @@
       </p:pic>
       <p:sp>
         <p:nvSpPr>
-          <p:cNvPr id="10" name="Shape 7"/>
+          <p:cNvPr id="8" name="Shape 5"/>
           <p:cNvSpPr/>
           <p:nvPr/>
         </p:nvSpPr>
@@ -23206,7 +23253,7 @@
       </p:sp>
       <p:sp>
         <p:nvSpPr>
-          <p:cNvPr id="11" name="Text 8"/>
+          <p:cNvPr id="9" name="Text 6"/>
           <p:cNvSpPr/>
           <p:nvPr/>
         </p:nvSpPr>
@@ -23227,7 +23274,7 @@
           <a:p>
             <a:pPr marL="342900" indent="-342900">
               <a:spcAft>
-                <a:spcPts val="900"/>
+                <a:spcPts val="800"/>
               </a:spcAft>
               <a:buSzPct val="100000"/>
               <a:buChar char="■"/>
@@ -23241,14 +23288,14 @@
                 <a:ea typeface="Calibri" pitchFamily="34" charset="-122"/>
                 <a:cs typeface="Calibri" pitchFamily="34" charset="-120"/>
               </a:rPr>
-              <a:t>Throughput = original image size / total execution time (MiB/s).</a:t>
+              <a:t>With Equal distribution, the faster P-cores finish early and wait for the E-cores: 7.61× at P = 14.</a:t>
             </a:r>
             <a:endParaRPr lang="en-US" sz="1500" dirty="0"/>
           </a:p>
           <a:p>
             <a:pPr marL="342900" indent="-342900">
               <a:spcAft>
-                <a:spcPts val="900"/>
+                <a:spcPts val="800"/>
               </a:spcAft>
               <a:buSzPct val="100000"/>
               <a:buChar char="■"/>
@@ -23262,14 +23309,14 @@
                 <a:ea typeface="Calibri" pitchFamily="34" charset="-122"/>
                 <a:cs typeface="Calibri" pitchFamily="34" charset="-120"/>
               </a:rPr>
-              <a:t>Grayscale: 1.30 → 3.35 MiB/s from P = 2 to P = 14.</a:t>
+              <a:t>Adaptive distribution reaches 9.19× at P = 14.</a:t>
             </a:r>
             <a:endParaRPr lang="en-US" sz="1500" dirty="0"/>
           </a:p>
           <a:p>
             <a:pPr marL="342900" indent="-342900">
               <a:spcAft>
-                <a:spcPts val="900"/>
+                <a:spcPts val="800"/>
               </a:spcAft>
               <a:buSzPct val="100000"/>
               <a:buChar char="■"/>
@@ -23283,14 +23330,14 @@
                 <a:ea typeface="Calibri" pitchFamily="34" charset="-122"/>
                 <a:cs typeface="Calibri" pitchFamily="34" charset="-120"/>
               </a:rPr>
-              <a:t>Color: 1.42 → 4.54 MiB/s.</a:t>
+              <a:t>LBG time is reduced by 28.3%, 23.6%, 19.8% and 17.2% at P = 8, 10, 12 and 14.</a:t>
             </a:r>
             <a:endParaRPr lang="en-US" sz="1500" dirty="0"/>
           </a:p>
           <a:p>
             <a:pPr marL="342900" indent="-342900">
               <a:spcAft>
-                <a:spcPts val="900"/>
+                <a:spcPts val="800"/>
               </a:spcAft>
               <a:buSzPct val="100000"/>
               <a:buChar char="■"/>
@@ -23304,14 +23351,14 @@
                 <a:ea typeface="Calibri" pitchFamily="34" charset="-122"/>
                 <a:cs typeface="Calibri" pitchFamily="34" charset="-120"/>
               </a:rPr>
-              <a:t>Color images hold three times more data, but their total time grows by only about 2.2× at P = 14, so their throughput is higher.</a:t>
+              <a:t>Total time is reduced by 17.9% to 8.8%.</a:t>
             </a:r>
             <a:endParaRPr lang="en-US" sz="1500" dirty="0"/>
           </a:p>
           <a:p>
             <a:pPr marL="342900" indent="-342900">
               <a:spcAft>
-                <a:spcPts val="900"/>
+                <a:spcPts val="800"/>
               </a:spcAft>
               <a:buSzPct val="100000"/>
               <a:buChar char="■"/>
@@ -23325,7 +23372,49 @@
                 <a:ea typeface="Calibri" pitchFamily="34" charset="-122"/>
                 <a:cs typeface="Calibri" pitchFamily="34" charset="-120"/>
               </a:rPr>
-              <a:t>Shaded bands: minimum to maximum over the images.</a:t>
+              <a:t>No adaptive-distribution benefit was observed when only P-cores were used (P ≤ 6).</a:t>
+            </a:r>
+            <a:endParaRPr lang="en-US" sz="1500" dirty="0"/>
+          </a:p>
+          <a:p>
+            <a:pPr marL="342900" indent="-342900">
+              <a:spcAft>
+                <a:spcPts val="800"/>
+              </a:spcAft>
+              <a:buSzPct val="100000"/>
+              <a:buChar char="■"/>
+            </a:pPr>
+            <a:r>
+              <a:rPr lang="en-US" sz="1500" dirty="0">
+                <a:solidFill>
+                  <a:srgbClr val="1F1A33"/>
+                </a:solidFill>
+                <a:latin typeface="Calibri" pitchFamily="34" charset="0"/>
+                <a:ea typeface="Calibri" pitchFamily="34" charset="-122"/>
+                <a:cs typeface="Calibri" pitchFamily="34" charset="-120"/>
+              </a:rPr>
+              <a:t>The reconstructed images are identical in both cases.</a:t>
+            </a:r>
+            <a:endParaRPr lang="en-US" sz="1500" dirty="0"/>
+          </a:p>
+          <a:p>
+            <a:pPr marL="342900" indent="-342900">
+              <a:spcAft>
+                <a:spcPts val="800"/>
+              </a:spcAft>
+              <a:buSzPct val="100000"/>
+              <a:buChar char="■"/>
+            </a:pPr>
+            <a:r>
+              <a:rPr lang="en-US" sz="1500" dirty="0">
+                <a:solidFill>
+                  <a:srgbClr val="1F1A33"/>
+                </a:solidFill>
+                <a:latin typeface="Calibri" pitchFamily="34" charset="0"/>
+                <a:ea typeface="Calibri" pitchFamily="34" charset="-122"/>
+                <a:cs typeface="Calibri" pitchFamily="34" charset="-120"/>
+              </a:rPr>
+              <a:t>Adaptive values here come from the Equal-vs-Adaptive runs, so they can differ by up to 0.02× from the main speedup runs.</a:t>
             </a:r>
             <a:endParaRPr lang="en-US" sz="1500" dirty="0"/>
           </a:p>
@@ -23462,7 +23551,7 @@
                 <a:ea typeface="Cambria" pitchFamily="34" charset="-122"/>
                 <a:cs typeface="Cambria" pitchFamily="34" charset="-120"/>
               </a:rPr>
-              <a:t>Karp–Flatt Metric</a:t>
+              <a:t>Throughput</a:t>
             </a:r>
             <a:endParaRPr lang="en-US" sz="2800" dirty="0"/>
           </a:p>
@@ -23501,8 +23590,8 @@
         </p:nvSpPr>
         <p:spPr>
           <a:xfrm>
-            <a:off x="457200" y="1143000"/>
-            <a:ext cx="7772400" cy="457200"/>
+            <a:off x="457200" y="1097280"/>
+            <a:ext cx="7498080" cy="457200"/>
           </a:xfrm>
           <a:prstGeom prst="roundRect">
             <a:avLst>
@@ -23528,6 +23617,982 @@
         </p:nvSpPr>
         <p:spPr>
           <a:xfrm>
+            <a:off x="457200" y="1097280"/>
+            <a:ext cx="7498080" cy="457200"/>
+          </a:xfrm>
+          <a:prstGeom prst="rect">
+            <a:avLst/>
+          </a:prstGeom>
+          <a:noFill/>
+          <a:ln/>
+        </p:spPr>
+        <p:txBody>
+          <a:bodyPr wrap="square" lIns="508" tIns="508" rIns="508" bIns="508" rtlCol="0" anchor="ctr"/>
+          <a:lstStyle/>
+          <a:p>
+            <a:pPr algn="ctr" indent="0" marL="0">
+              <a:buNone/>
+            </a:pPr>
+            <a:r>
+              <a:rPr lang="en-US" sz="1900" b="1" dirty="0">
+                <a:solidFill>
+                  <a:srgbClr val="2E2055"/>
+                </a:solidFill>
+                <a:latin typeface="Cambria" pitchFamily="34" charset="0"/>
+                <a:ea typeface="Cambria" pitchFamily="34" charset="-122"/>
+                <a:cs typeface="Cambria" pitchFamily="34" charset="-120"/>
+              </a:rPr>
+              <a:t>Throughput = I_size / T_total   (MiB/s)</a:t>
+            </a:r>
+            <a:endParaRPr lang="en-US" sz="1900" dirty="0"/>
+          </a:p>
+        </p:txBody>
+      </p:sp>
+      <p:sp>
+        <p:nvSpPr>
+          <p:cNvPr id="8" name="Shape 6"/>
+          <p:cNvSpPr/>
+          <p:nvPr/>
+        </p:nvSpPr>
+        <p:spPr>
+          <a:xfrm>
+            <a:off x="457200" y="1645920"/>
+            <a:ext cx="7498080" cy="4617720"/>
+          </a:xfrm>
+          <a:prstGeom prst="roundRect">
+            <a:avLst>
+              <a:gd name="adj" fmla="val 1584"/>
+            </a:avLst>
+          </a:prstGeom>
+          <a:solidFill>
+            <a:srgbClr val="FFFFFF"/>
+          </a:solidFill>
+          <a:ln w="15875">
+            <a:solidFill>
+              <a:srgbClr val="2A9D8F"/>
+            </a:solidFill>
+            <a:prstDash val="solid"/>
+          </a:ln>
+        </p:spPr>
+      </p:sp>
+      <p:pic>
+        <p:nvPicPr>
+          <p:cNvPr id="9" name="Image 0" descr="assets/throughput_ch4.png">    </p:cNvPr>
+          <p:cNvPicPr>
+            <a:picLocks noChangeAspect="1"/>
+          </p:cNvPicPr>
+          <p:nvPr/>
+        </p:nvPicPr>
+        <p:blipFill>
+          <a:blip r:embed="rId1"/>
+          <a:stretch>
+            <a:fillRect/>
+          </a:stretch>
+        </p:blipFill>
+        <p:spPr>
+          <a:xfrm>
+            <a:off x="714695" y="1645920"/>
+            <a:ext cx="6983091" cy="4617720"/>
+          </a:xfrm>
+          <a:prstGeom prst="rect">
+            <a:avLst/>
+          </a:prstGeom>
+        </p:spPr>
+      </p:pic>
+      <p:sp>
+        <p:nvSpPr>
+          <p:cNvPr id="10" name="Shape 7"/>
+          <p:cNvSpPr/>
+          <p:nvPr/>
+        </p:nvSpPr>
+        <p:spPr>
+          <a:xfrm>
+            <a:off x="8183880" y="1234440"/>
+            <a:ext cx="3566160" cy="5029200"/>
+          </a:xfrm>
+          <a:prstGeom prst="roundRect">
+            <a:avLst>
+              <a:gd name="adj" fmla="val 2051"/>
+            </a:avLst>
+          </a:prstGeom>
+          <a:solidFill>
+            <a:srgbClr val="F5F1FB"/>
+          </a:solidFill>
+          <a:ln w="12700">
+            <a:solidFill>
+              <a:srgbClr val="F5F1FB"/>
+            </a:solidFill>
+            <a:prstDash val="solid"/>
+          </a:ln>
+        </p:spPr>
+      </p:sp>
+      <p:sp>
+        <p:nvSpPr>
+          <p:cNvPr id="11" name="Text 8"/>
+          <p:cNvSpPr/>
+          <p:nvPr/>
+        </p:nvSpPr>
+        <p:spPr>
+          <a:xfrm>
+            <a:off x="8275320" y="1325880"/>
+            <a:ext cx="3383280" cy="4846320"/>
+          </a:xfrm>
+          <a:prstGeom prst="rect">
+            <a:avLst/>
+          </a:prstGeom>
+          <a:noFill/>
+          <a:ln/>
+        </p:spPr>
+        <p:txBody>
+          <a:bodyPr wrap="square" lIns="1016" tIns="1016" rIns="1016" bIns="1016" rtlCol="0" anchor="t"/>
+          <a:lstStyle/>
+          <a:p>
+            <a:pPr marL="342900" indent="-342900">
+              <a:spcAft>
+                <a:spcPts val="900"/>
+              </a:spcAft>
+              <a:buSzPct val="100000"/>
+              <a:buChar char="■"/>
+            </a:pPr>
+            <a:r>
+              <a:rPr lang="en-US" sz="1500" dirty="0">
+                <a:solidFill>
+                  <a:srgbClr val="1F1A33"/>
+                </a:solidFill>
+                <a:latin typeface="Calibri" pitchFamily="34" charset="0"/>
+                <a:ea typeface="Calibri" pitchFamily="34" charset="-122"/>
+                <a:cs typeface="Calibri" pitchFamily="34" charset="-120"/>
+              </a:rPr>
+              <a:t>Throughput = original image size / total execution time (MiB/s).</a:t>
+            </a:r>
+            <a:endParaRPr lang="en-US" sz="1500" dirty="0"/>
+          </a:p>
+          <a:p>
+            <a:pPr marL="342900" indent="-342900">
+              <a:spcAft>
+                <a:spcPts val="900"/>
+              </a:spcAft>
+              <a:buSzPct val="100000"/>
+              <a:buChar char="■"/>
+            </a:pPr>
+            <a:r>
+              <a:rPr lang="en-US" sz="1500" dirty="0">
+                <a:solidFill>
+                  <a:srgbClr val="1F1A33"/>
+                </a:solidFill>
+                <a:latin typeface="Calibri" pitchFamily="34" charset="0"/>
+                <a:ea typeface="Calibri" pitchFamily="34" charset="-122"/>
+                <a:cs typeface="Calibri" pitchFamily="34" charset="-120"/>
+              </a:rPr>
+              <a:t>Grayscale: 1.30 → 3.35 MiB/s from P = 2 to P = 14.</a:t>
+            </a:r>
+            <a:endParaRPr lang="en-US" sz="1500" dirty="0"/>
+          </a:p>
+          <a:p>
+            <a:pPr marL="342900" indent="-342900">
+              <a:spcAft>
+                <a:spcPts val="900"/>
+              </a:spcAft>
+              <a:buSzPct val="100000"/>
+              <a:buChar char="■"/>
+            </a:pPr>
+            <a:r>
+              <a:rPr lang="en-US" sz="1500" dirty="0">
+                <a:solidFill>
+                  <a:srgbClr val="1F1A33"/>
+                </a:solidFill>
+                <a:latin typeface="Calibri" pitchFamily="34" charset="0"/>
+                <a:ea typeface="Calibri" pitchFamily="34" charset="-122"/>
+                <a:cs typeface="Calibri" pitchFamily="34" charset="-120"/>
+              </a:rPr>
+              <a:t>Color: 1.42 → 4.54 MiB/s.</a:t>
+            </a:r>
+            <a:endParaRPr lang="en-US" sz="1500" dirty="0"/>
+          </a:p>
+          <a:p>
+            <a:pPr marL="342900" indent="-342900">
+              <a:spcAft>
+                <a:spcPts val="900"/>
+              </a:spcAft>
+              <a:buSzPct val="100000"/>
+              <a:buChar char="■"/>
+            </a:pPr>
+            <a:r>
+              <a:rPr lang="en-US" sz="1500" dirty="0">
+                <a:solidFill>
+                  <a:srgbClr val="1F1A33"/>
+                </a:solidFill>
+                <a:latin typeface="Calibri" pitchFamily="34" charset="0"/>
+                <a:ea typeface="Calibri" pitchFamily="34" charset="-122"/>
+                <a:cs typeface="Calibri" pitchFamily="34" charset="-120"/>
+              </a:rPr>
+              <a:t>Color images hold three times more data, but their total time grows by only about 2.2× at P = 14, so their throughput is higher.</a:t>
+            </a:r>
+            <a:endParaRPr lang="en-US" sz="1500" dirty="0"/>
+          </a:p>
+          <a:p>
+            <a:pPr marL="342900" indent="-342900">
+              <a:spcAft>
+                <a:spcPts val="900"/>
+              </a:spcAft>
+              <a:buSzPct val="100000"/>
+              <a:buChar char="■"/>
+            </a:pPr>
+            <a:r>
+              <a:rPr lang="en-US" sz="1500" dirty="0">
+                <a:solidFill>
+                  <a:srgbClr val="1F1A33"/>
+                </a:solidFill>
+                <a:latin typeface="Calibri" pitchFamily="34" charset="0"/>
+                <a:ea typeface="Calibri" pitchFamily="34" charset="-122"/>
+                <a:cs typeface="Calibri" pitchFamily="34" charset="-120"/>
+              </a:rPr>
+              <a:t>Shaded bands: minimum to maximum over the images.</a:t>
+            </a:r>
+            <a:endParaRPr lang="en-US" sz="1500" dirty="0"/>
+          </a:p>
+        </p:txBody>
+      </p:sp>
+    </p:spTree>
+  </p:cSld>
+  <p:clrMapOvr>
+    <a:masterClrMapping/>
+  </p:clrMapOvr>
+</p:sld>
+</file>
+
+<file path=ppt/slides/slide3.xml><?xml version="1.0" encoding="utf-8"?>
+<p:sld xmlns:a="http://schemas.openxmlformats.org/drawingml/2006/main" xmlns:r="http://schemas.openxmlformats.org/officeDocument/2006/relationships" xmlns:p="http://schemas.openxmlformats.org/presentationml/2006/main">
+  <p:cSld name="Slide 3">
+    <p:bg>
+      <p:bgPr>
+        <a:solidFill>
+          <a:srgbClr val="FFFFFF"/>
+        </a:solidFill>
+      </p:bgPr>
+    </p:bg>
+    <p:spTree>
+      <p:nvGrpSpPr>
+        <p:cNvPr id="1" name=""/>
+        <p:cNvGrpSpPr/>
+        <p:nvPr/>
+      </p:nvGrpSpPr>
+      <p:grpSpPr>
+        <a:xfrm>
+          <a:off x="0" y="0"/>
+          <a:ext cx="0" cy="0"/>
+          <a:chOff x="0" y="0"/>
+          <a:chExt cx="0" cy="0"/>
+        </a:xfrm>
+      </p:grpSpPr>
+      <p:sp>
+        <p:nvSpPr>
+          <p:cNvPr id="2" name="Shape 0"/>
+          <p:cNvSpPr/>
+          <p:nvPr/>
+        </p:nvSpPr>
+        <p:spPr>
+          <a:xfrm>
+            <a:off x="457200" y="320040"/>
+            <a:ext cx="1920240" cy="502920"/>
+          </a:xfrm>
+          <a:prstGeom prst="roundRect">
+            <a:avLst>
+              <a:gd name="adj" fmla="val 18182"/>
+            </a:avLst>
+          </a:prstGeom>
+          <a:solidFill>
+            <a:srgbClr val="6B4FA3"/>
+          </a:solidFill>
+          <a:ln w="12700">
+            <a:solidFill>
+              <a:srgbClr val="6B4FA3"/>
+            </a:solidFill>
+            <a:prstDash val="solid"/>
+          </a:ln>
+        </p:spPr>
+      </p:sp>
+      <p:sp>
+        <p:nvSpPr>
+          <p:cNvPr id="3" name="Text 1"/>
+          <p:cNvSpPr/>
+          <p:nvPr/>
+        </p:nvSpPr>
+        <p:spPr>
+          <a:xfrm>
+            <a:off x="457200" y="320040"/>
+            <a:ext cx="1920240" cy="502920"/>
+          </a:xfrm>
+          <a:prstGeom prst="rect">
+            <a:avLst/>
+          </a:prstGeom>
+          <a:noFill/>
+          <a:ln/>
+        </p:spPr>
+        <p:txBody>
+          <a:bodyPr wrap="square" lIns="0" tIns="0" rIns="0" bIns="0" rtlCol="0" anchor="ctr"/>
+          <a:lstStyle/>
+          <a:p>
+            <a:pPr algn="ctr" indent="0" marL="0">
+              <a:buNone/>
+            </a:pPr>
+            <a:r>
+              <a:rPr lang="en-US" sz="1600" b="1" dirty="0">
+                <a:solidFill>
+                  <a:srgbClr val="FFFFFF"/>
+                </a:solidFill>
+                <a:latin typeface="Calibri" pitchFamily="34" charset="0"/>
+                <a:ea typeface="Calibri" pitchFamily="34" charset="-122"/>
+                <a:cs typeface="Calibri" pitchFamily="34" charset="-120"/>
+              </a:rPr>
+              <a:t>Introduction</a:t>
+            </a:r>
+            <a:endParaRPr lang="en-US" sz="1600" dirty="0"/>
+          </a:p>
+        </p:txBody>
+      </p:sp>
+      <p:sp>
+        <p:nvSpPr>
+          <p:cNvPr id="4" name="Text 2"/>
+          <p:cNvSpPr/>
+          <p:nvPr/>
+        </p:nvSpPr>
+        <p:spPr>
+          <a:xfrm>
+            <a:off x="2560320" y="274320"/>
+            <a:ext cx="9601200" cy="594360"/>
+          </a:xfrm>
+          <a:prstGeom prst="rect">
+            <a:avLst/>
+          </a:prstGeom>
+          <a:noFill/>
+          <a:ln/>
+        </p:spPr>
+        <p:txBody>
+          <a:bodyPr wrap="square" lIns="0" tIns="0" rIns="0" bIns="0" rtlCol="0" anchor="ctr"/>
+          <a:lstStyle/>
+          <a:p>
+            <a:pPr indent="0" marL="0">
+              <a:buNone/>
+            </a:pPr>
+            <a:r>
+              <a:rPr lang="en-US" sz="2800" b="1" dirty="0">
+                <a:solidFill>
+                  <a:srgbClr val="2E2055"/>
+                </a:solidFill>
+                <a:latin typeface="Cambria" pitchFamily="34" charset="0"/>
+                <a:ea typeface="Cambria" pitchFamily="34" charset="-122"/>
+                <a:cs typeface="Cambria" pitchFamily="34" charset="-120"/>
+              </a:rPr>
+              <a:t>Why Image Compression?</a:t>
+            </a:r>
+            <a:endParaRPr lang="en-US" sz="2800" dirty="0"/>
+          </a:p>
+        </p:txBody>
+      </p:sp>
+      <p:sp>
+        <p:nvSpPr>
+          <p:cNvPr id="5" name="Shape 3"/>
+          <p:cNvSpPr/>
+          <p:nvPr/>
+        </p:nvSpPr>
+        <p:spPr>
+          <a:xfrm>
+            <a:off x="457200" y="960120"/>
+            <a:ext cx="11274552" cy="36576"/>
+          </a:xfrm>
+          <a:prstGeom prst="rect">
+            <a:avLst/>
+          </a:prstGeom>
+          <a:solidFill>
+            <a:srgbClr val="6B4FA3"/>
+          </a:solidFill>
+          <a:ln w="12700">
+            <a:solidFill>
+              <a:srgbClr val="6B4FA3"/>
+            </a:solidFill>
+            <a:prstDash val="solid"/>
+          </a:ln>
+        </p:spPr>
+      </p:sp>
+      <p:sp>
+        <p:nvSpPr>
+          <p:cNvPr id="6" name="Shape 4"/>
+          <p:cNvSpPr/>
+          <p:nvPr/>
+        </p:nvSpPr>
+        <p:spPr>
+          <a:xfrm>
+            <a:off x="640080" y="1371600"/>
+            <a:ext cx="3520440" cy="3291840"/>
+          </a:xfrm>
+          <a:prstGeom prst="roundRect">
+            <a:avLst>
+              <a:gd name="adj" fmla="val 2778"/>
+            </a:avLst>
+          </a:prstGeom>
+          <a:solidFill>
+            <a:srgbClr val="FFFFFF"/>
+          </a:solidFill>
+          <a:ln w="22225">
+            <a:solidFill>
+              <a:srgbClr val="6B4FA3"/>
+            </a:solidFill>
+            <a:prstDash val="solid"/>
+          </a:ln>
+        </p:spPr>
+      </p:sp>
+      <p:sp>
+        <p:nvSpPr>
+          <p:cNvPr id="7" name="Shape 5"/>
+          <p:cNvSpPr/>
+          <p:nvPr/>
+        </p:nvSpPr>
+        <p:spPr>
+          <a:xfrm>
+            <a:off x="658368" y="1389888"/>
+            <a:ext cx="109728" cy="3255264"/>
+          </a:xfrm>
+          <a:prstGeom prst="rect">
+            <a:avLst/>
+          </a:prstGeom>
+          <a:solidFill>
+            <a:srgbClr val="6B4FA3"/>
+          </a:solidFill>
+          <a:ln w="12700">
+            <a:solidFill>
+              <a:srgbClr val="6B4FA3"/>
+            </a:solidFill>
+            <a:prstDash val="solid"/>
+          </a:ln>
+        </p:spPr>
+      </p:sp>
+      <p:sp>
+        <p:nvSpPr>
+          <p:cNvPr id="8" name="Text 6"/>
+          <p:cNvSpPr/>
+          <p:nvPr/>
+        </p:nvSpPr>
+        <p:spPr>
+          <a:xfrm>
+            <a:off x="914400" y="1417320"/>
+            <a:ext cx="3108960" cy="3200400"/>
+          </a:xfrm>
+          <a:prstGeom prst="rect">
+            <a:avLst/>
+          </a:prstGeom>
+          <a:noFill/>
+          <a:ln/>
+        </p:spPr>
+        <p:txBody>
+          <a:bodyPr wrap="square" lIns="635" tIns="635" rIns="635" bIns="635" rtlCol="0" anchor="ctr"/>
+          <a:lstStyle/>
+          <a:p>
+            <a:pPr indent="0" marL="0">
+              <a:spcAft>
+                <a:spcPts val="600"/>
+              </a:spcAft>
+              <a:buNone/>
+            </a:pPr>
+            <a:r>
+              <a:rPr lang="en-US" sz="2400" b="1" dirty="0">
+                <a:solidFill>
+                  <a:srgbClr val="6B4FA3"/>
+                </a:solidFill>
+                <a:latin typeface="Calibri" pitchFamily="34" charset="0"/>
+                <a:ea typeface="Calibri" pitchFamily="34" charset="-122"/>
+                <a:cs typeface="Calibri" pitchFamily="34" charset="-120"/>
+              </a:rPr>
+              <a:t>Storage</a:t>
+            </a:r>
+            <a:endParaRPr lang="en-US" sz="2400" dirty="0"/>
+          </a:p>
+          <a:p>
+            <a:pPr indent="0" marL="0">
+              <a:spcAft>
+                <a:spcPts val="600"/>
+              </a:spcAft>
+              <a:buNone/>
+            </a:pPr>
+            <a:r>
+              <a:rPr lang="en-US" sz="1800" dirty="0">
+                <a:solidFill>
+                  <a:srgbClr val="1F1A33"/>
+                </a:solidFill>
+                <a:latin typeface="Calibri" pitchFamily="34" charset="0"/>
+                <a:ea typeface="Calibri" pitchFamily="34" charset="-122"/>
+                <a:cs typeface="Calibri" pitchFamily="34" charset="-120"/>
+              </a:rPr>
+              <a:t>Large image collections require a large amount of storage space.</a:t>
+            </a:r>
+            <a:endParaRPr lang="en-US" sz="2400" dirty="0"/>
+          </a:p>
+        </p:txBody>
+      </p:sp>
+      <p:sp>
+        <p:nvSpPr>
+          <p:cNvPr id="9" name="Shape 7"/>
+          <p:cNvSpPr/>
+          <p:nvPr/>
+        </p:nvSpPr>
+        <p:spPr>
+          <a:xfrm>
+            <a:off x="4343400" y="1371600"/>
+            <a:ext cx="3520440" cy="3291840"/>
+          </a:xfrm>
+          <a:prstGeom prst="roundRect">
+            <a:avLst>
+              <a:gd name="adj" fmla="val 2778"/>
+            </a:avLst>
+          </a:prstGeom>
+          <a:solidFill>
+            <a:srgbClr val="FFFFFF"/>
+          </a:solidFill>
+          <a:ln w="22225">
+            <a:solidFill>
+              <a:srgbClr val="E0457B"/>
+            </a:solidFill>
+            <a:prstDash val="solid"/>
+          </a:ln>
+        </p:spPr>
+      </p:sp>
+      <p:sp>
+        <p:nvSpPr>
+          <p:cNvPr id="10" name="Shape 8"/>
+          <p:cNvSpPr/>
+          <p:nvPr/>
+        </p:nvSpPr>
+        <p:spPr>
+          <a:xfrm>
+            <a:off x="4361688" y="1389888"/>
+            <a:ext cx="109728" cy="3255264"/>
+          </a:xfrm>
+          <a:prstGeom prst="rect">
+            <a:avLst/>
+          </a:prstGeom>
+          <a:solidFill>
+            <a:srgbClr val="E0457B"/>
+          </a:solidFill>
+          <a:ln w="12700">
+            <a:solidFill>
+              <a:srgbClr val="E0457B"/>
+            </a:solidFill>
+            <a:prstDash val="solid"/>
+          </a:ln>
+        </p:spPr>
+      </p:sp>
+      <p:sp>
+        <p:nvSpPr>
+          <p:cNvPr id="11" name="Text 9"/>
+          <p:cNvSpPr/>
+          <p:nvPr/>
+        </p:nvSpPr>
+        <p:spPr>
+          <a:xfrm>
+            <a:off x="4617720" y="1417320"/>
+            <a:ext cx="3108960" cy="3200400"/>
+          </a:xfrm>
+          <a:prstGeom prst="rect">
+            <a:avLst/>
+          </a:prstGeom>
+          <a:noFill/>
+          <a:ln/>
+        </p:spPr>
+        <p:txBody>
+          <a:bodyPr wrap="square" lIns="635" tIns="635" rIns="635" bIns="635" rtlCol="0" anchor="ctr"/>
+          <a:lstStyle/>
+          <a:p>
+            <a:pPr indent="0" marL="0">
+              <a:spcAft>
+                <a:spcPts val="600"/>
+              </a:spcAft>
+              <a:buNone/>
+            </a:pPr>
+            <a:r>
+              <a:rPr lang="en-US" sz="2400" b="1" dirty="0">
+                <a:solidFill>
+                  <a:srgbClr val="E0457B"/>
+                </a:solidFill>
+                <a:latin typeface="Calibri" pitchFamily="34" charset="0"/>
+                <a:ea typeface="Calibri" pitchFamily="34" charset="-122"/>
+                <a:cs typeface="Calibri" pitchFamily="34" charset="-120"/>
+              </a:rPr>
+              <a:t>Transmission</a:t>
+            </a:r>
+            <a:endParaRPr lang="en-US" sz="2400" dirty="0"/>
+          </a:p>
+          <a:p>
+            <a:pPr indent="0" marL="0">
+              <a:spcAft>
+                <a:spcPts val="600"/>
+              </a:spcAft>
+              <a:buNone/>
+            </a:pPr>
+            <a:r>
+              <a:rPr lang="en-US" sz="1800" dirty="0">
+                <a:solidFill>
+                  <a:srgbClr val="1F1A33"/>
+                </a:solidFill>
+                <a:latin typeface="Calibri" pitchFamily="34" charset="0"/>
+                <a:ea typeface="Calibri" pitchFamily="34" charset="-122"/>
+                <a:cs typeface="Calibri" pitchFamily="34" charset="-120"/>
+              </a:rPr>
+              <a:t>Smaller images reach the receiver sooner and use less network bandwidth.</a:t>
+            </a:r>
+            <a:endParaRPr lang="en-US" sz="2400" dirty="0"/>
+          </a:p>
+        </p:txBody>
+      </p:sp>
+      <p:sp>
+        <p:nvSpPr>
+          <p:cNvPr id="12" name="Shape 10"/>
+          <p:cNvSpPr/>
+          <p:nvPr/>
+        </p:nvSpPr>
+        <p:spPr>
+          <a:xfrm>
+            <a:off x="8046720" y="1371600"/>
+            <a:ext cx="3520440" cy="3291840"/>
+          </a:xfrm>
+          <a:prstGeom prst="roundRect">
+            <a:avLst>
+              <a:gd name="adj" fmla="val 2778"/>
+            </a:avLst>
+          </a:prstGeom>
+          <a:solidFill>
+            <a:srgbClr val="FFFFFF"/>
+          </a:solidFill>
+          <a:ln w="22225">
+            <a:solidFill>
+              <a:srgbClr val="2A9D8F"/>
+            </a:solidFill>
+            <a:prstDash val="solid"/>
+          </a:ln>
+        </p:spPr>
+      </p:sp>
+      <p:sp>
+        <p:nvSpPr>
+          <p:cNvPr id="13" name="Shape 11"/>
+          <p:cNvSpPr/>
+          <p:nvPr/>
+        </p:nvSpPr>
+        <p:spPr>
+          <a:xfrm>
+            <a:off x="8065008" y="1389888"/>
+            <a:ext cx="109728" cy="3255264"/>
+          </a:xfrm>
+          <a:prstGeom prst="rect">
+            <a:avLst/>
+          </a:prstGeom>
+          <a:solidFill>
+            <a:srgbClr val="2A9D8F"/>
+          </a:solidFill>
+          <a:ln w="12700">
+            <a:solidFill>
+              <a:srgbClr val="2A9D8F"/>
+            </a:solidFill>
+            <a:prstDash val="solid"/>
+          </a:ln>
+        </p:spPr>
+      </p:sp>
+      <p:sp>
+        <p:nvSpPr>
+          <p:cNvPr id="14" name="Text 12"/>
+          <p:cNvSpPr/>
+          <p:nvPr/>
+        </p:nvSpPr>
+        <p:spPr>
+          <a:xfrm>
+            <a:off x="8321040" y="1417320"/>
+            <a:ext cx="3108960" cy="3200400"/>
+          </a:xfrm>
+          <a:prstGeom prst="rect">
+            <a:avLst/>
+          </a:prstGeom>
+          <a:noFill/>
+          <a:ln/>
+        </p:spPr>
+        <p:txBody>
+          <a:bodyPr wrap="square" lIns="635" tIns="635" rIns="635" bIns="635" rtlCol="0" anchor="ctr"/>
+          <a:lstStyle/>
+          <a:p>
+            <a:pPr indent="0" marL="0">
+              <a:spcAft>
+                <a:spcPts val="600"/>
+              </a:spcAft>
+              <a:buNone/>
+            </a:pPr>
+            <a:r>
+              <a:rPr lang="en-US" sz="2400" b="1" dirty="0">
+                <a:solidFill>
+                  <a:srgbClr val="2A9D8F"/>
+                </a:solidFill>
+                <a:latin typeface="Calibri" pitchFamily="34" charset="0"/>
+                <a:ea typeface="Calibri" pitchFamily="34" charset="-122"/>
+                <a:cs typeface="Calibri" pitchFamily="34" charset="-120"/>
+              </a:rPr>
+              <a:t>Computation</a:t>
+            </a:r>
+            <a:endParaRPr lang="en-US" sz="2400" dirty="0"/>
+          </a:p>
+          <a:p>
+            <a:pPr indent="0" marL="0">
+              <a:spcAft>
+                <a:spcPts val="600"/>
+              </a:spcAft>
+              <a:buNone/>
+            </a:pPr>
+            <a:r>
+              <a:rPr lang="en-US" sz="1800" dirty="0">
+                <a:solidFill>
+                  <a:srgbClr val="1F1A33"/>
+                </a:solidFill>
+                <a:latin typeface="Calibri" pitchFamily="34" charset="0"/>
+                <a:ea typeface="Calibri" pitchFamily="34" charset="-122"/>
+                <a:cs typeface="Calibri" pitchFamily="34" charset="-120"/>
+              </a:rPr>
+              <a:t>A good compression ratio needs complex methods, so the compression itself must stay fast.</a:t>
+            </a:r>
+            <a:endParaRPr lang="en-US" sz="2400" dirty="0"/>
+          </a:p>
+        </p:txBody>
+      </p:sp>
+      <p:sp>
+        <p:nvSpPr>
+          <p:cNvPr id="15" name="Text 13"/>
+          <p:cNvSpPr/>
+          <p:nvPr/>
+        </p:nvSpPr>
+        <p:spPr>
+          <a:xfrm>
+            <a:off x="640080" y="5074920"/>
+            <a:ext cx="10881360" cy="640080"/>
+          </a:xfrm>
+          <a:prstGeom prst="rect">
+            <a:avLst/>
+          </a:prstGeom>
+          <a:noFill/>
+          <a:ln/>
+        </p:spPr>
+        <p:txBody>
+          <a:bodyPr wrap="square" lIns="0" tIns="0" rIns="0" bIns="0" rtlCol="0" anchor="ctr"/>
+          <a:lstStyle/>
+          <a:p>
+            <a:pPr algn="ctr" indent="0" marL="0">
+              <a:buNone/>
+            </a:pPr>
+            <a:r>
+              <a:rPr lang="en-US" sz="2200" i="1" dirty="0">
+                <a:solidFill>
+                  <a:srgbClr val="2E2055"/>
+                </a:solidFill>
+                <a:latin typeface="Cambria" pitchFamily="34" charset="0"/>
+                <a:ea typeface="Cambria" pitchFamily="34" charset="-122"/>
+                <a:cs typeface="Cambria" pitchFamily="34" charset="-120"/>
+              </a:rPr>
+              <a:t>Image compression reduces the amount of data needed to represent an image.</a:t>
+            </a:r>
+            <a:endParaRPr lang="en-US" sz="2200" dirty="0"/>
+          </a:p>
+        </p:txBody>
+      </p:sp>
+    </p:spTree>
+  </p:cSld>
+  <p:clrMapOvr>
+    <a:masterClrMapping/>
+  </p:clrMapOvr>
+</p:sld>
+</file>
+
+<file path=ppt/slides/slide30.xml><?xml version="1.0" encoding="utf-8"?>
+<p:sld xmlns:a="http://schemas.openxmlformats.org/drawingml/2006/main" xmlns:r="http://schemas.openxmlformats.org/officeDocument/2006/relationships" xmlns:p="http://schemas.openxmlformats.org/presentationml/2006/main">
+  <p:cSld name="Slide 30">
+    <p:bg>
+      <p:bgPr>
+        <a:solidFill>
+          <a:srgbClr val="FFFFFF"/>
+        </a:solidFill>
+      </p:bgPr>
+    </p:bg>
+    <p:spTree>
+      <p:nvGrpSpPr>
+        <p:cNvPr id="1" name=""/>
+        <p:cNvGrpSpPr/>
+        <p:nvPr/>
+      </p:nvGrpSpPr>
+      <p:grpSpPr>
+        <a:xfrm>
+          <a:off x="0" y="0"/>
+          <a:ext cx="0" cy="0"/>
+          <a:chOff x="0" y="0"/>
+          <a:chExt cx="0" cy="0"/>
+        </a:xfrm>
+      </p:grpSpPr>
+      <p:sp>
+        <p:nvSpPr>
+          <p:cNvPr id="2" name="Shape 0"/>
+          <p:cNvSpPr/>
+          <p:nvPr/>
+        </p:nvSpPr>
+        <p:spPr>
+          <a:xfrm>
+            <a:off x="457200" y="320040"/>
+            <a:ext cx="1737360" cy="502920"/>
+          </a:xfrm>
+          <a:prstGeom prst="roundRect">
+            <a:avLst>
+              <a:gd name="adj" fmla="val 18182"/>
+            </a:avLst>
+          </a:prstGeom>
+          <a:solidFill>
+            <a:srgbClr val="2A9D8F"/>
+          </a:solidFill>
+          <a:ln w="12700">
+            <a:solidFill>
+              <a:srgbClr val="2A9D8F"/>
+            </a:solidFill>
+            <a:prstDash val="solid"/>
+          </a:ln>
+        </p:spPr>
+      </p:sp>
+      <p:sp>
+        <p:nvSpPr>
+          <p:cNvPr id="3" name="Text 1"/>
+          <p:cNvSpPr/>
+          <p:nvPr/>
+        </p:nvSpPr>
+        <p:spPr>
+          <a:xfrm>
+            <a:off x="457200" y="320040"/>
+            <a:ext cx="1737360" cy="502920"/>
+          </a:xfrm>
+          <a:prstGeom prst="rect">
+            <a:avLst/>
+          </a:prstGeom>
+          <a:noFill/>
+          <a:ln/>
+        </p:spPr>
+        <p:txBody>
+          <a:bodyPr wrap="square" lIns="0" tIns="0" rIns="0" bIns="0" rtlCol="0" anchor="ctr"/>
+          <a:lstStyle/>
+          <a:p>
+            <a:pPr algn="ctr" indent="0" marL="0">
+              <a:buNone/>
+            </a:pPr>
+            <a:r>
+              <a:rPr lang="en-US" sz="1800" b="1" dirty="0">
+                <a:solidFill>
+                  <a:srgbClr val="FFFFFF"/>
+                </a:solidFill>
+                <a:latin typeface="Calibri" pitchFamily="34" charset="0"/>
+                <a:ea typeface="Calibri" pitchFamily="34" charset="-122"/>
+                <a:cs typeface="Calibri" pitchFamily="34" charset="-120"/>
+              </a:rPr>
+              <a:t>Results</a:t>
+            </a:r>
+            <a:endParaRPr lang="en-US" sz="1800" dirty="0"/>
+          </a:p>
+        </p:txBody>
+      </p:sp>
+      <p:sp>
+        <p:nvSpPr>
+          <p:cNvPr id="4" name="Text 2"/>
+          <p:cNvSpPr/>
+          <p:nvPr/>
+        </p:nvSpPr>
+        <p:spPr>
+          <a:xfrm>
+            <a:off x="2377440" y="274320"/>
+            <a:ext cx="9326880" cy="594360"/>
+          </a:xfrm>
+          <a:prstGeom prst="rect">
+            <a:avLst/>
+          </a:prstGeom>
+          <a:noFill/>
+          <a:ln/>
+        </p:spPr>
+        <p:txBody>
+          <a:bodyPr wrap="square" lIns="0" tIns="0" rIns="0" bIns="0" rtlCol="0" anchor="ctr"/>
+          <a:lstStyle/>
+          <a:p>
+            <a:pPr indent="0" marL="0">
+              <a:buNone/>
+            </a:pPr>
+            <a:r>
+              <a:rPr lang="en-US" sz="2800" b="1" dirty="0">
+                <a:solidFill>
+                  <a:srgbClr val="2E2055"/>
+                </a:solidFill>
+                <a:latin typeface="Cambria" pitchFamily="34" charset="0"/>
+                <a:ea typeface="Cambria" pitchFamily="34" charset="-122"/>
+                <a:cs typeface="Cambria" pitchFamily="34" charset="-120"/>
+              </a:rPr>
+              <a:t>Karp–Flatt Metric</a:t>
+            </a:r>
+            <a:endParaRPr lang="en-US" sz="2800" dirty="0"/>
+          </a:p>
+        </p:txBody>
+      </p:sp>
+      <p:sp>
+        <p:nvSpPr>
+          <p:cNvPr id="5" name="Shape 3"/>
+          <p:cNvSpPr/>
+          <p:nvPr/>
+        </p:nvSpPr>
+        <p:spPr>
+          <a:xfrm>
+            <a:off x="457200" y="960120"/>
+            <a:ext cx="11274552" cy="36576"/>
+          </a:xfrm>
+          <a:prstGeom prst="rect">
+            <a:avLst/>
+          </a:prstGeom>
+          <a:solidFill>
+            <a:srgbClr val="2A9D8F"/>
+          </a:solidFill>
+          <a:ln w="12700">
+            <a:solidFill>
+              <a:srgbClr val="2A9D8F"/>
+            </a:solidFill>
+            <a:prstDash val="solid"/>
+          </a:ln>
+        </p:spPr>
+      </p:sp>
+      <p:sp>
+        <p:nvSpPr>
+          <p:cNvPr id="6" name="Shape 4"/>
+          <p:cNvSpPr/>
+          <p:nvPr/>
+        </p:nvSpPr>
+        <p:spPr>
+          <a:xfrm>
+            <a:off x="457200" y="1143000"/>
+            <a:ext cx="7772400" cy="457200"/>
+          </a:xfrm>
+          <a:prstGeom prst="roundRect">
+            <a:avLst>
+              <a:gd name="adj" fmla="val 16000"/>
+            </a:avLst>
+          </a:prstGeom>
+          <a:solidFill>
+            <a:srgbClr val="FDF1E6"/>
+          </a:solidFill>
+          <a:ln w="15875">
+            <a:solidFill>
+              <a:srgbClr val="E07B22"/>
+            </a:solidFill>
+            <a:prstDash val="solid"/>
+          </a:ln>
+        </p:spPr>
+      </p:sp>
+      <p:sp>
+        <p:nvSpPr>
+          <p:cNvPr id="7" name="Text 5"/>
+          <p:cNvSpPr/>
+          <p:nvPr/>
+        </p:nvSpPr>
+        <p:spPr>
+          <a:xfrm>
             <a:off x="457200" y="1143000"/>
             <a:ext cx="7772400" cy="457200"/>
           </a:xfrm>
@@ -23561,7 +24626,7 @@
       </p:sp>
       <p:graphicFrame>
         <p:nvGraphicFramePr>
-          <p:cNvPr id="30" name="Table 0"/>
+          <p:cNvPr id="31" name="Table 0"/>
           <p:cNvGraphicFramePr>
             <a:graphicFrameLocks noGrp="1"/>
           </p:cNvGraphicFramePr>
@@ -27598,886 +28663,6 @@
 </p:sld>
 </file>
 
-<file path=ppt/slides/slide3.xml><?xml version="1.0" encoding="utf-8"?>
-<p:sld xmlns:a="http://schemas.openxmlformats.org/drawingml/2006/main" xmlns:r="http://schemas.openxmlformats.org/officeDocument/2006/relationships" xmlns:p="http://schemas.openxmlformats.org/presentationml/2006/main">
-  <p:cSld name="Slide 3">
-    <p:bg>
-      <p:bgPr>
-        <a:solidFill>
-          <a:srgbClr val="FFFFFF"/>
-        </a:solidFill>
-      </p:bgPr>
-    </p:bg>
-    <p:spTree>
-      <p:nvGrpSpPr>
-        <p:cNvPr id="1" name=""/>
-        <p:cNvGrpSpPr/>
-        <p:nvPr/>
-      </p:nvGrpSpPr>
-      <p:grpSpPr>
-        <a:xfrm>
-          <a:off x="0" y="0"/>
-          <a:ext cx="0" cy="0"/>
-          <a:chOff x="0" y="0"/>
-          <a:chExt cx="0" cy="0"/>
-        </a:xfrm>
-      </p:grpSpPr>
-      <p:sp>
-        <p:nvSpPr>
-          <p:cNvPr id="2" name="Shape 0"/>
-          <p:cNvSpPr/>
-          <p:nvPr/>
-        </p:nvSpPr>
-        <p:spPr>
-          <a:xfrm>
-            <a:off x="457200" y="320040"/>
-            <a:ext cx="1920240" cy="502920"/>
-          </a:xfrm>
-          <a:prstGeom prst="roundRect">
-            <a:avLst>
-              <a:gd name="adj" fmla="val 18182"/>
-            </a:avLst>
-          </a:prstGeom>
-          <a:solidFill>
-            <a:srgbClr val="6B4FA3"/>
-          </a:solidFill>
-          <a:ln w="12700">
-            <a:solidFill>
-              <a:srgbClr val="6B4FA3"/>
-            </a:solidFill>
-            <a:prstDash val="solid"/>
-          </a:ln>
-        </p:spPr>
-      </p:sp>
-      <p:sp>
-        <p:nvSpPr>
-          <p:cNvPr id="3" name="Text 1"/>
-          <p:cNvSpPr/>
-          <p:nvPr/>
-        </p:nvSpPr>
-        <p:spPr>
-          <a:xfrm>
-            <a:off x="457200" y="320040"/>
-            <a:ext cx="1920240" cy="502920"/>
-          </a:xfrm>
-          <a:prstGeom prst="rect">
-            <a:avLst/>
-          </a:prstGeom>
-          <a:noFill/>
-          <a:ln/>
-        </p:spPr>
-        <p:txBody>
-          <a:bodyPr wrap="square" lIns="0" tIns="0" rIns="0" bIns="0" rtlCol="0" anchor="ctr"/>
-          <a:lstStyle/>
-          <a:p>
-            <a:pPr algn="ctr" indent="0" marL="0">
-              <a:buNone/>
-            </a:pPr>
-            <a:r>
-              <a:rPr lang="en-US" sz="1600" b="1" dirty="0">
-                <a:solidFill>
-                  <a:srgbClr val="FFFFFF"/>
-                </a:solidFill>
-                <a:latin typeface="Calibri" pitchFamily="34" charset="0"/>
-                <a:ea typeface="Calibri" pitchFamily="34" charset="-122"/>
-                <a:cs typeface="Calibri" pitchFamily="34" charset="-120"/>
-              </a:rPr>
-              <a:t>Introduction</a:t>
-            </a:r>
-            <a:endParaRPr lang="en-US" sz="1600" dirty="0"/>
-          </a:p>
-        </p:txBody>
-      </p:sp>
-      <p:sp>
-        <p:nvSpPr>
-          <p:cNvPr id="4" name="Text 2"/>
-          <p:cNvSpPr/>
-          <p:nvPr/>
-        </p:nvSpPr>
-        <p:spPr>
-          <a:xfrm>
-            <a:off x="2560320" y="274320"/>
-            <a:ext cx="9601200" cy="594360"/>
-          </a:xfrm>
-          <a:prstGeom prst="rect">
-            <a:avLst/>
-          </a:prstGeom>
-          <a:noFill/>
-          <a:ln/>
-        </p:spPr>
-        <p:txBody>
-          <a:bodyPr wrap="square" lIns="0" tIns="0" rIns="0" bIns="0" rtlCol="0" anchor="ctr"/>
-          <a:lstStyle/>
-          <a:p>
-            <a:pPr indent="0" marL="0">
-              <a:buNone/>
-            </a:pPr>
-            <a:r>
-              <a:rPr lang="en-US" sz="2800" b="1" dirty="0">
-                <a:solidFill>
-                  <a:srgbClr val="2E2055"/>
-                </a:solidFill>
-                <a:latin typeface="Cambria" pitchFamily="34" charset="0"/>
-                <a:ea typeface="Cambria" pitchFamily="34" charset="-122"/>
-                <a:cs typeface="Cambria" pitchFamily="34" charset="-120"/>
-              </a:rPr>
-              <a:t>Why Image Compression?</a:t>
-            </a:r>
-            <a:endParaRPr lang="en-US" sz="2800" dirty="0"/>
-          </a:p>
-        </p:txBody>
-      </p:sp>
-      <p:sp>
-        <p:nvSpPr>
-          <p:cNvPr id="5" name="Shape 3"/>
-          <p:cNvSpPr/>
-          <p:nvPr/>
-        </p:nvSpPr>
-        <p:spPr>
-          <a:xfrm>
-            <a:off x="457200" y="960120"/>
-            <a:ext cx="11274552" cy="36576"/>
-          </a:xfrm>
-          <a:prstGeom prst="rect">
-            <a:avLst/>
-          </a:prstGeom>
-          <a:solidFill>
-            <a:srgbClr val="6B4FA3"/>
-          </a:solidFill>
-          <a:ln w="12700">
-            <a:solidFill>
-              <a:srgbClr val="6B4FA3"/>
-            </a:solidFill>
-            <a:prstDash val="solid"/>
-          </a:ln>
-        </p:spPr>
-      </p:sp>
-      <p:sp>
-        <p:nvSpPr>
-          <p:cNvPr id="6" name="Shape 4"/>
-          <p:cNvSpPr/>
-          <p:nvPr/>
-        </p:nvSpPr>
-        <p:spPr>
-          <a:xfrm>
-            <a:off x="640080" y="1371600"/>
-            <a:ext cx="3520440" cy="3291840"/>
-          </a:xfrm>
-          <a:prstGeom prst="roundRect">
-            <a:avLst>
-              <a:gd name="adj" fmla="val 2778"/>
-            </a:avLst>
-          </a:prstGeom>
-          <a:solidFill>
-            <a:srgbClr val="FFFFFF"/>
-          </a:solidFill>
-          <a:ln w="22225">
-            <a:solidFill>
-              <a:srgbClr val="6B4FA3"/>
-            </a:solidFill>
-            <a:prstDash val="solid"/>
-          </a:ln>
-        </p:spPr>
-      </p:sp>
-      <p:sp>
-        <p:nvSpPr>
-          <p:cNvPr id="7" name="Shape 5"/>
-          <p:cNvSpPr/>
-          <p:nvPr/>
-        </p:nvSpPr>
-        <p:spPr>
-          <a:xfrm>
-            <a:off x="658368" y="1389888"/>
-            <a:ext cx="109728" cy="3255264"/>
-          </a:xfrm>
-          <a:prstGeom prst="rect">
-            <a:avLst/>
-          </a:prstGeom>
-          <a:solidFill>
-            <a:srgbClr val="6B4FA3"/>
-          </a:solidFill>
-          <a:ln w="12700">
-            <a:solidFill>
-              <a:srgbClr val="6B4FA3"/>
-            </a:solidFill>
-            <a:prstDash val="solid"/>
-          </a:ln>
-        </p:spPr>
-      </p:sp>
-      <p:sp>
-        <p:nvSpPr>
-          <p:cNvPr id="8" name="Text 6"/>
-          <p:cNvSpPr/>
-          <p:nvPr/>
-        </p:nvSpPr>
-        <p:spPr>
-          <a:xfrm>
-            <a:off x="914400" y="1417320"/>
-            <a:ext cx="3108960" cy="3200400"/>
-          </a:xfrm>
-          <a:prstGeom prst="rect">
-            <a:avLst/>
-          </a:prstGeom>
-          <a:noFill/>
-          <a:ln/>
-        </p:spPr>
-        <p:txBody>
-          <a:bodyPr wrap="square" lIns="635" tIns="635" rIns="635" bIns="635" rtlCol="0" anchor="ctr"/>
-          <a:lstStyle/>
-          <a:p>
-            <a:pPr indent="0" marL="0">
-              <a:spcAft>
-                <a:spcPts val="600"/>
-              </a:spcAft>
-              <a:buNone/>
-            </a:pPr>
-            <a:r>
-              <a:rPr lang="en-US" sz="2400" b="1" dirty="0">
-                <a:solidFill>
-                  <a:srgbClr val="6B4FA3"/>
-                </a:solidFill>
-                <a:latin typeface="Calibri" pitchFamily="34" charset="0"/>
-                <a:ea typeface="Calibri" pitchFamily="34" charset="-122"/>
-                <a:cs typeface="Calibri" pitchFamily="34" charset="-120"/>
-              </a:rPr>
-              <a:t>Storage</a:t>
-            </a:r>
-            <a:endParaRPr lang="en-US" sz="2400" dirty="0"/>
-          </a:p>
-          <a:p>
-            <a:pPr indent="0" marL="0">
-              <a:spcAft>
-                <a:spcPts val="600"/>
-              </a:spcAft>
-              <a:buNone/>
-            </a:pPr>
-            <a:r>
-              <a:rPr lang="en-US" sz="1800" dirty="0">
-                <a:solidFill>
-                  <a:srgbClr val="1F1A33"/>
-                </a:solidFill>
-                <a:latin typeface="Calibri" pitchFamily="34" charset="0"/>
-                <a:ea typeface="Calibri" pitchFamily="34" charset="-122"/>
-                <a:cs typeface="Calibri" pitchFamily="34" charset="-120"/>
-              </a:rPr>
-              <a:t>Large image collections require a large amount of storage space.</a:t>
-            </a:r>
-            <a:endParaRPr lang="en-US" sz="2400" dirty="0"/>
-          </a:p>
-        </p:txBody>
-      </p:sp>
-      <p:sp>
-        <p:nvSpPr>
-          <p:cNvPr id="9" name="Shape 7"/>
-          <p:cNvSpPr/>
-          <p:nvPr/>
-        </p:nvSpPr>
-        <p:spPr>
-          <a:xfrm>
-            <a:off x="4343400" y="1371600"/>
-            <a:ext cx="3520440" cy="3291840"/>
-          </a:xfrm>
-          <a:prstGeom prst="roundRect">
-            <a:avLst>
-              <a:gd name="adj" fmla="val 2778"/>
-            </a:avLst>
-          </a:prstGeom>
-          <a:solidFill>
-            <a:srgbClr val="FFFFFF"/>
-          </a:solidFill>
-          <a:ln w="22225">
-            <a:solidFill>
-              <a:srgbClr val="E0457B"/>
-            </a:solidFill>
-            <a:prstDash val="solid"/>
-          </a:ln>
-        </p:spPr>
-      </p:sp>
-      <p:sp>
-        <p:nvSpPr>
-          <p:cNvPr id="10" name="Shape 8"/>
-          <p:cNvSpPr/>
-          <p:nvPr/>
-        </p:nvSpPr>
-        <p:spPr>
-          <a:xfrm>
-            <a:off x="4361688" y="1389888"/>
-            <a:ext cx="109728" cy="3255264"/>
-          </a:xfrm>
-          <a:prstGeom prst="rect">
-            <a:avLst/>
-          </a:prstGeom>
-          <a:solidFill>
-            <a:srgbClr val="E0457B"/>
-          </a:solidFill>
-          <a:ln w="12700">
-            <a:solidFill>
-              <a:srgbClr val="E0457B"/>
-            </a:solidFill>
-            <a:prstDash val="solid"/>
-          </a:ln>
-        </p:spPr>
-      </p:sp>
-      <p:sp>
-        <p:nvSpPr>
-          <p:cNvPr id="11" name="Text 9"/>
-          <p:cNvSpPr/>
-          <p:nvPr/>
-        </p:nvSpPr>
-        <p:spPr>
-          <a:xfrm>
-            <a:off x="4617720" y="1417320"/>
-            <a:ext cx="3108960" cy="3200400"/>
-          </a:xfrm>
-          <a:prstGeom prst="rect">
-            <a:avLst/>
-          </a:prstGeom>
-          <a:noFill/>
-          <a:ln/>
-        </p:spPr>
-        <p:txBody>
-          <a:bodyPr wrap="square" lIns="635" tIns="635" rIns="635" bIns="635" rtlCol="0" anchor="ctr"/>
-          <a:lstStyle/>
-          <a:p>
-            <a:pPr indent="0" marL="0">
-              <a:spcAft>
-                <a:spcPts val="600"/>
-              </a:spcAft>
-              <a:buNone/>
-            </a:pPr>
-            <a:r>
-              <a:rPr lang="en-US" sz="2400" b="1" dirty="0">
-                <a:solidFill>
-                  <a:srgbClr val="E0457B"/>
-                </a:solidFill>
-                <a:latin typeface="Calibri" pitchFamily="34" charset="0"/>
-                <a:ea typeface="Calibri" pitchFamily="34" charset="-122"/>
-                <a:cs typeface="Calibri" pitchFamily="34" charset="-120"/>
-              </a:rPr>
-              <a:t>Transmission</a:t>
-            </a:r>
-            <a:endParaRPr lang="en-US" sz="2400" dirty="0"/>
-          </a:p>
-          <a:p>
-            <a:pPr indent="0" marL="0">
-              <a:spcAft>
-                <a:spcPts val="600"/>
-              </a:spcAft>
-              <a:buNone/>
-            </a:pPr>
-            <a:r>
-              <a:rPr lang="en-US" sz="1800" dirty="0">
-                <a:solidFill>
-                  <a:srgbClr val="1F1A33"/>
-                </a:solidFill>
-                <a:latin typeface="Calibri" pitchFamily="34" charset="0"/>
-                <a:ea typeface="Calibri" pitchFamily="34" charset="-122"/>
-                <a:cs typeface="Calibri" pitchFamily="34" charset="-120"/>
-              </a:rPr>
-              <a:t>Smaller images reach the receiver sooner and use less network bandwidth.</a:t>
-            </a:r>
-            <a:endParaRPr lang="en-US" sz="2400" dirty="0"/>
-          </a:p>
-        </p:txBody>
-      </p:sp>
-      <p:sp>
-        <p:nvSpPr>
-          <p:cNvPr id="12" name="Shape 10"/>
-          <p:cNvSpPr/>
-          <p:nvPr/>
-        </p:nvSpPr>
-        <p:spPr>
-          <a:xfrm>
-            <a:off x="8046720" y="1371600"/>
-            <a:ext cx="3520440" cy="3291840"/>
-          </a:xfrm>
-          <a:prstGeom prst="roundRect">
-            <a:avLst>
-              <a:gd name="adj" fmla="val 2778"/>
-            </a:avLst>
-          </a:prstGeom>
-          <a:solidFill>
-            <a:srgbClr val="FFFFFF"/>
-          </a:solidFill>
-          <a:ln w="22225">
-            <a:solidFill>
-              <a:srgbClr val="2A9D8F"/>
-            </a:solidFill>
-            <a:prstDash val="solid"/>
-          </a:ln>
-        </p:spPr>
-      </p:sp>
-      <p:sp>
-        <p:nvSpPr>
-          <p:cNvPr id="13" name="Shape 11"/>
-          <p:cNvSpPr/>
-          <p:nvPr/>
-        </p:nvSpPr>
-        <p:spPr>
-          <a:xfrm>
-            <a:off x="8065008" y="1389888"/>
-            <a:ext cx="109728" cy="3255264"/>
-          </a:xfrm>
-          <a:prstGeom prst="rect">
-            <a:avLst/>
-          </a:prstGeom>
-          <a:solidFill>
-            <a:srgbClr val="2A9D8F"/>
-          </a:solidFill>
-          <a:ln w="12700">
-            <a:solidFill>
-              <a:srgbClr val="2A9D8F"/>
-            </a:solidFill>
-            <a:prstDash val="solid"/>
-          </a:ln>
-        </p:spPr>
-      </p:sp>
-      <p:sp>
-        <p:nvSpPr>
-          <p:cNvPr id="14" name="Text 12"/>
-          <p:cNvSpPr/>
-          <p:nvPr/>
-        </p:nvSpPr>
-        <p:spPr>
-          <a:xfrm>
-            <a:off x="8321040" y="1417320"/>
-            <a:ext cx="3108960" cy="3200400"/>
-          </a:xfrm>
-          <a:prstGeom prst="rect">
-            <a:avLst/>
-          </a:prstGeom>
-          <a:noFill/>
-          <a:ln/>
-        </p:spPr>
-        <p:txBody>
-          <a:bodyPr wrap="square" lIns="635" tIns="635" rIns="635" bIns="635" rtlCol="0" anchor="ctr"/>
-          <a:lstStyle/>
-          <a:p>
-            <a:pPr indent="0" marL="0">
-              <a:spcAft>
-                <a:spcPts val="600"/>
-              </a:spcAft>
-              <a:buNone/>
-            </a:pPr>
-            <a:r>
-              <a:rPr lang="en-US" sz="2400" b="1" dirty="0">
-                <a:solidFill>
-                  <a:srgbClr val="2A9D8F"/>
-                </a:solidFill>
-                <a:latin typeface="Calibri" pitchFamily="34" charset="0"/>
-                <a:ea typeface="Calibri" pitchFamily="34" charset="-122"/>
-                <a:cs typeface="Calibri" pitchFamily="34" charset="-120"/>
-              </a:rPr>
-              <a:t>Computation</a:t>
-            </a:r>
-            <a:endParaRPr lang="en-US" sz="2400" dirty="0"/>
-          </a:p>
-          <a:p>
-            <a:pPr indent="0" marL="0">
-              <a:spcAft>
-                <a:spcPts val="600"/>
-              </a:spcAft>
-              <a:buNone/>
-            </a:pPr>
-            <a:r>
-              <a:rPr lang="en-US" sz="1800" dirty="0">
-                <a:solidFill>
-                  <a:srgbClr val="1F1A33"/>
-                </a:solidFill>
-                <a:latin typeface="Calibri" pitchFamily="34" charset="0"/>
-                <a:ea typeface="Calibri" pitchFamily="34" charset="-122"/>
-                <a:cs typeface="Calibri" pitchFamily="34" charset="-120"/>
-              </a:rPr>
-              <a:t>A good compression ratio needs complex methods, so the compression itself must stay fast.</a:t>
-            </a:r>
-            <a:endParaRPr lang="en-US" sz="2400" dirty="0"/>
-          </a:p>
-        </p:txBody>
-      </p:sp>
-      <p:sp>
-        <p:nvSpPr>
-          <p:cNvPr id="15" name="Text 13"/>
-          <p:cNvSpPr/>
-          <p:nvPr/>
-        </p:nvSpPr>
-        <p:spPr>
-          <a:xfrm>
-            <a:off x="640080" y="5074920"/>
-            <a:ext cx="10881360" cy="640080"/>
-          </a:xfrm>
-          <a:prstGeom prst="rect">
-            <a:avLst/>
-          </a:prstGeom>
-          <a:noFill/>
-          <a:ln/>
-        </p:spPr>
-        <p:txBody>
-          <a:bodyPr wrap="square" lIns="0" tIns="0" rIns="0" bIns="0" rtlCol="0" anchor="ctr"/>
-          <a:lstStyle/>
-          <a:p>
-            <a:pPr algn="ctr" indent="0" marL="0">
-              <a:buNone/>
-            </a:pPr>
-            <a:r>
-              <a:rPr lang="en-US" sz="2200" i="1" dirty="0">
-                <a:solidFill>
-                  <a:srgbClr val="2E2055"/>
-                </a:solidFill>
-                <a:latin typeface="Cambria" pitchFamily="34" charset="0"/>
-                <a:ea typeface="Cambria" pitchFamily="34" charset="-122"/>
-                <a:cs typeface="Cambria" pitchFamily="34" charset="-120"/>
-              </a:rPr>
-              <a:t>Image compression reduces the amount of data needed to represent an image.</a:t>
-            </a:r>
-            <a:endParaRPr lang="en-US" sz="2200" dirty="0"/>
-          </a:p>
-        </p:txBody>
-      </p:sp>
-    </p:spTree>
-  </p:cSld>
-  <p:clrMapOvr>
-    <a:masterClrMapping/>
-  </p:clrMapOvr>
-</p:sld>
-</file>
-
-<file path=ppt/slides/slide30.xml><?xml version="1.0" encoding="utf-8"?>
-<p:sld xmlns:a="http://schemas.openxmlformats.org/drawingml/2006/main" xmlns:r="http://schemas.openxmlformats.org/officeDocument/2006/relationships" xmlns:p="http://schemas.openxmlformats.org/presentationml/2006/main">
-  <p:cSld name="Slide 30">
-    <p:bg>
-      <p:bgPr>
-        <a:solidFill>
-          <a:srgbClr val="FFFFFF"/>
-        </a:solidFill>
-      </p:bgPr>
-    </p:bg>
-    <p:spTree>
-      <p:nvGrpSpPr>
-        <p:cNvPr id="1" name=""/>
-        <p:cNvGrpSpPr/>
-        <p:nvPr/>
-      </p:nvGrpSpPr>
-      <p:grpSpPr>
-        <a:xfrm>
-          <a:off x="0" y="0"/>
-          <a:ext cx="0" cy="0"/>
-          <a:chOff x="0" y="0"/>
-          <a:chExt cx="0" cy="0"/>
-        </a:xfrm>
-      </p:grpSpPr>
-      <p:sp>
-        <p:nvSpPr>
-          <p:cNvPr id="2" name="Shape 0"/>
-          <p:cNvSpPr/>
-          <p:nvPr/>
-        </p:nvSpPr>
-        <p:spPr>
-          <a:xfrm>
-            <a:off x="457200" y="320040"/>
-            <a:ext cx="2103120" cy="502920"/>
-          </a:xfrm>
-          <a:prstGeom prst="roundRect">
-            <a:avLst>
-              <a:gd name="adj" fmla="val 18182"/>
-            </a:avLst>
-          </a:prstGeom>
-          <a:solidFill>
-            <a:srgbClr val="2E2055"/>
-          </a:solidFill>
-          <a:ln w="12700">
-            <a:solidFill>
-              <a:srgbClr val="2E2055"/>
-            </a:solidFill>
-            <a:prstDash val="solid"/>
-          </a:ln>
-        </p:spPr>
-      </p:sp>
-      <p:sp>
-        <p:nvSpPr>
-          <p:cNvPr id="3" name="Text 1"/>
-          <p:cNvSpPr/>
-          <p:nvPr/>
-        </p:nvSpPr>
-        <p:spPr>
-          <a:xfrm>
-            <a:off x="457200" y="320040"/>
-            <a:ext cx="2103120" cy="502920"/>
-          </a:xfrm>
-          <a:prstGeom prst="rect">
-            <a:avLst/>
-          </a:prstGeom>
-          <a:noFill/>
-          <a:ln/>
-        </p:spPr>
-        <p:txBody>
-          <a:bodyPr wrap="square" lIns="0" tIns="0" rIns="0" bIns="0" rtlCol="0" anchor="ctr"/>
-          <a:lstStyle/>
-          <a:p>
-            <a:pPr algn="ctr" indent="0" marL="0">
-              <a:buNone/>
-            </a:pPr>
-            <a:r>
-              <a:rPr lang="en-US" sz="1600" b="1" dirty="0">
-                <a:solidFill>
-                  <a:srgbClr val="FFFFFF"/>
-                </a:solidFill>
-                <a:latin typeface="Calibri" pitchFamily="34" charset="0"/>
-                <a:ea typeface="Calibri" pitchFamily="34" charset="-122"/>
-                <a:cs typeface="Calibri" pitchFamily="34" charset="-120"/>
-              </a:rPr>
-              <a:t>Conclusion</a:t>
-            </a:r>
-            <a:endParaRPr lang="en-US" sz="1600" dirty="0"/>
-          </a:p>
-        </p:txBody>
-      </p:sp>
-      <p:sp>
-        <p:nvSpPr>
-          <p:cNvPr id="4" name="Text 2"/>
-          <p:cNvSpPr/>
-          <p:nvPr/>
-        </p:nvSpPr>
-        <p:spPr>
-          <a:xfrm>
-            <a:off x="2743200" y="274320"/>
-            <a:ext cx="9418320" cy="594360"/>
-          </a:xfrm>
-          <a:prstGeom prst="rect">
-            <a:avLst/>
-          </a:prstGeom>
-          <a:noFill/>
-          <a:ln/>
-        </p:spPr>
-        <p:txBody>
-          <a:bodyPr wrap="square" lIns="0" tIns="0" rIns="0" bIns="0" rtlCol="0" anchor="ctr"/>
-          <a:lstStyle/>
-          <a:p>
-            <a:pPr indent="0" marL="0">
-              <a:buNone/>
-            </a:pPr>
-            <a:r>
-              <a:rPr lang="en-US" sz="2800" b="1" dirty="0">
-                <a:solidFill>
-                  <a:srgbClr val="2E2055"/>
-                </a:solidFill>
-                <a:latin typeface="Cambria" pitchFamily="34" charset="0"/>
-                <a:ea typeface="Cambria" pitchFamily="34" charset="-122"/>
-                <a:cs typeface="Cambria" pitchFamily="34" charset="-120"/>
-              </a:rPr>
-              <a:t>Conclusion</a:t>
-            </a:r>
-            <a:endParaRPr lang="en-US" sz="2800" dirty="0"/>
-          </a:p>
-        </p:txBody>
-      </p:sp>
-      <p:sp>
-        <p:nvSpPr>
-          <p:cNvPr id="5" name="Shape 3"/>
-          <p:cNvSpPr/>
-          <p:nvPr/>
-        </p:nvSpPr>
-        <p:spPr>
-          <a:xfrm>
-            <a:off x="457200" y="960120"/>
-            <a:ext cx="11274552" cy="36576"/>
-          </a:xfrm>
-          <a:prstGeom prst="rect">
-            <a:avLst/>
-          </a:prstGeom>
-          <a:solidFill>
-            <a:srgbClr val="2E2055"/>
-          </a:solidFill>
-          <a:ln w="12700">
-            <a:solidFill>
-              <a:srgbClr val="2E2055"/>
-            </a:solidFill>
-            <a:prstDash val="solid"/>
-          </a:ln>
-        </p:spPr>
-      </p:sp>
-      <p:sp>
-        <p:nvSpPr>
-          <p:cNvPr id="6" name="Shape 4"/>
-          <p:cNvSpPr/>
-          <p:nvPr/>
-        </p:nvSpPr>
-        <p:spPr>
-          <a:xfrm>
-            <a:off x="640080" y="1280160"/>
-            <a:ext cx="10927080" cy="5029200"/>
-          </a:xfrm>
-          <a:prstGeom prst="roundRect">
-            <a:avLst>
-              <a:gd name="adj" fmla="val 1455"/>
-            </a:avLst>
-          </a:prstGeom>
-          <a:solidFill>
-            <a:srgbClr val="F5F1FB"/>
-          </a:solidFill>
-          <a:ln w="12700">
-            <a:solidFill>
-              <a:srgbClr val="F5F1FB"/>
-            </a:solidFill>
-            <a:prstDash val="solid"/>
-          </a:ln>
-        </p:spPr>
-      </p:sp>
-      <p:sp>
-        <p:nvSpPr>
-          <p:cNvPr id="7" name="Text 5"/>
-          <p:cNvSpPr/>
-          <p:nvPr/>
-        </p:nvSpPr>
-        <p:spPr>
-          <a:xfrm>
-            <a:off x="777240" y="1371600"/>
-            <a:ext cx="10652760" cy="4846320"/>
-          </a:xfrm>
-          <a:prstGeom prst="rect">
-            <a:avLst/>
-          </a:prstGeom>
-          <a:noFill/>
-          <a:ln/>
-        </p:spPr>
-        <p:txBody>
-          <a:bodyPr wrap="square" lIns="1016" tIns="1016" rIns="1016" bIns="1016" rtlCol="0" anchor="t"/>
-          <a:lstStyle/>
-          <a:p>
-            <a:pPr marL="342900" indent="-342900">
-              <a:spcAft>
-                <a:spcPts val="1000"/>
-              </a:spcAft>
-              <a:buSzPct val="100000"/>
-              <a:buChar char="■"/>
-            </a:pPr>
-            <a:r>
-              <a:rPr lang="en-US" sz="1900" dirty="0">
-                <a:solidFill>
-                  <a:srgbClr val="1F1A33"/>
-                </a:solidFill>
-                <a:latin typeface="Calibri" pitchFamily="34" charset="0"/>
-                <a:ea typeface="Calibri" pitchFamily="34" charset="-122"/>
-                <a:cs typeface="Calibri" pitchFamily="34" charset="-120"/>
-              </a:rPr>
-              <a:t>A hybrid image compression framework was implemented: LBG vector quantization, delta coding and Huffman coding.</a:t>
-            </a:r>
-            <a:endParaRPr lang="en-US" sz="1900" dirty="0"/>
-          </a:p>
-          <a:p>
-            <a:pPr marL="342900" indent="-342900">
-              <a:spcAft>
-                <a:spcPts val="1000"/>
-              </a:spcAft>
-              <a:buSzPct val="100000"/>
-              <a:buChar char="■"/>
-            </a:pPr>
-            <a:r>
-              <a:rPr lang="en-US" sz="1900" dirty="0">
-                <a:solidFill>
-                  <a:srgbClr val="1F1A33"/>
-                </a:solidFill>
-                <a:latin typeface="Calibri" pitchFamily="34" charset="0"/>
-                <a:ea typeface="Calibri" pitchFamily="34" charset="-122"/>
-                <a:cs typeface="Calibri" pitchFamily="34" charset="-120"/>
-              </a:rPr>
-              <a:t>LBG training was parallelized with MPI: 9.19× speedup on 14 processes (efficiency ≈ 66%); total speedup 5.00× (gray) and 6.84× (color).</a:t>
-            </a:r>
-            <a:endParaRPr lang="en-US" sz="1900" dirty="0"/>
-          </a:p>
-          <a:p>
-            <a:pPr marL="342900" indent="-342900">
-              <a:spcAft>
-                <a:spcPts val="1000"/>
-              </a:spcAft>
-              <a:buSzPct val="100000"/>
-              <a:buChar char="■"/>
-            </a:pPr>
-            <a:r>
-              <a:rPr lang="en-US" sz="1900" dirty="0">
-                <a:solidFill>
-                  <a:srgbClr val="1F1A33"/>
-                </a:solidFill>
-                <a:latin typeface="Calibri" pitchFamily="34" charset="0"/>
-                <a:ea typeface="Calibri" pitchFamily="34" charset="-122"/>
-                <a:cs typeface="Calibri" pitchFamily="34" charset="-120"/>
-              </a:rPr>
-              <a:t>The speed-aware (Adaptive) distribution reduced LBG time by 17.2–28.3% compared with Equal distribution (P = 8 to 14).</a:t>
-            </a:r>
-            <a:endParaRPr lang="en-US" sz="1900" dirty="0"/>
-          </a:p>
-          <a:p>
-            <a:pPr marL="342900" indent="-342900">
-              <a:spcAft>
-                <a:spcPts val="1000"/>
-              </a:spcAft>
-              <a:buSzPct val="100000"/>
-              <a:buChar char="■"/>
-            </a:pPr>
-            <a:r>
-              <a:rPr lang="en-US" sz="1900" dirty="0">
-                <a:solidFill>
-                  <a:srgbClr val="1F1A33"/>
-                </a:solidFill>
-                <a:latin typeface="Calibri" pitchFamily="34" charset="0"/>
-                <a:ea typeface="Calibri" pitchFamily="34" charset="-122"/>
-                <a:cs typeface="Calibri" pitchFamily="34" charset="-120"/>
-              </a:rPr>
-              <a:t>The parallel results were identical to the sequential ones: same reconstructed images and quality metrics.</a:t>
-            </a:r>
-            <a:endParaRPr lang="en-US" sz="1900" dirty="0"/>
-          </a:p>
-          <a:p>
-            <a:pPr marL="342900" indent="-342900">
-              <a:spcAft>
-                <a:spcPts val="1000"/>
-              </a:spcAft>
-              <a:buSzPct val="100000"/>
-              <a:buChar char="■"/>
-            </a:pPr>
-            <a:r>
-              <a:rPr lang="en-US" sz="1900" dirty="0">
-                <a:solidFill>
-                  <a:srgbClr val="1F1A33"/>
-                </a:solidFill>
-                <a:latin typeface="Calibri" pitchFamily="34" charset="0"/>
-                <a:ea typeface="Calibri" pitchFamily="34" charset="-122"/>
-                <a:cs typeface="Calibri" pitchFamily="34" charset="-120"/>
-              </a:rPr>
-              <a:t>Quality: mean PSNR 29.49 dB and SSIM 0.8266 (gray); 28.80 dB and 0.7654 (color), at a compression ratio of ___ (gray) and ___ (color).</a:t>
-            </a:r>
-            <a:endParaRPr lang="en-US" sz="1900" dirty="0"/>
-          </a:p>
-          <a:p>
-            <a:pPr marL="342900" indent="-342900">
-              <a:spcAft>
-                <a:spcPts val="1000"/>
-              </a:spcAft>
-              <a:buSzPct val="100000"/>
-              <a:buChar char="■"/>
-            </a:pPr>
-            <a:r>
-              <a:rPr lang="en-US" sz="1900" dirty="0">
-                <a:solidFill>
-                  <a:srgbClr val="1F1A33"/>
-                </a:solidFill>
-                <a:latin typeface="Calibri" pitchFamily="34" charset="0"/>
-                <a:ea typeface="Calibri" pitchFamily="34" charset="-122"/>
-                <a:cs typeface="Calibri" pitchFamily="34" charset="-120"/>
-              </a:rPr>
-              <a:t>The total speedup is limited by the sequential coding and reconstruction stages.</a:t>
-            </a:r>
-            <a:endParaRPr lang="en-US" sz="1900" dirty="0"/>
-          </a:p>
-        </p:txBody>
-      </p:sp>
-    </p:spTree>
-  </p:cSld>
-  <p:clrMapOvr>
-    <a:masterClrMapping/>
-  </p:clrMapOvr>
-</p:sld>
-</file>
-
 <file path=ppt/slides/slide31.xml><?xml version="1.0" encoding="utf-8"?>
 <p:sld xmlns:a="http://schemas.openxmlformats.org/drawingml/2006/main" xmlns:r="http://schemas.openxmlformats.org/officeDocument/2006/relationships" xmlns:p="http://schemas.openxmlformats.org/presentationml/2006/main">
   <p:cSld name="Slide 31">
@@ -28562,7 +28747,7 @@
                 <a:ea typeface="Calibri" pitchFamily="34" charset="-122"/>
                 <a:cs typeface="Calibri" pitchFamily="34" charset="-120"/>
               </a:rPr>
-              <a:t>Future Work</a:t>
+              <a:t>Conclusion</a:t>
             </a:r>
             <a:endParaRPr lang="en-US" sz="1600" dirty="0"/>
           </a:p>
@@ -28601,7 +28786,7 @@
                 <a:ea typeface="Cambria" pitchFamily="34" charset="-122"/>
                 <a:cs typeface="Cambria" pitchFamily="34" charset="-120"/>
               </a:rPr>
-              <a:t>Future Work</a:t>
+              <a:t>Conclusion</a:t>
             </a:r>
             <a:endParaRPr lang="en-US" sz="2800" dirty="0"/>
           </a:p>
@@ -28688,7 +28873,7 @@
               <a:buChar char="■"/>
             </a:pPr>
             <a:r>
-              <a:rPr lang="en-US" sz="2100" dirty="0">
+              <a:rPr lang="en-US" sz="1900" dirty="0">
                 <a:solidFill>
                   <a:srgbClr val="1F1A33"/>
                 </a:solidFill>
@@ -28696,9 +28881,9 @@
                 <a:ea typeface="Calibri" pitchFamily="34" charset="-122"/>
                 <a:cs typeface="Calibri" pitchFamily="34" charset="-120"/>
               </a:rPr>
-              <a:t>Parallelize the delta coding, Huffman coding and reconstruction stages.</a:t>
-            </a:r>
-            <a:endParaRPr lang="en-US" sz="2100" dirty="0"/>
+              <a:t>A hybrid image compression framework was implemented: LBG vector quantization, delta coding and Huffman coding.</a:t>
+            </a:r>
+            <a:endParaRPr lang="en-US" sz="1900" dirty="0"/>
           </a:p>
           <a:p>
             <a:pPr marL="342900" indent="-342900">
@@ -28709,7 +28894,7 @@
               <a:buChar char="■"/>
             </a:pPr>
             <a:r>
-              <a:rPr lang="en-US" sz="2100" dirty="0">
+              <a:rPr lang="en-US" sz="1900" dirty="0">
                 <a:solidFill>
                   <a:srgbClr val="1F1A33"/>
                 </a:solidFill>
@@ -28717,9 +28902,9 @@
                 <a:ea typeface="Calibri" pitchFamily="34" charset="-122"/>
                 <a:cs typeface="Calibri" pitchFamily="34" charset="-120"/>
               </a:rPr>
-              <a:t>Evaluate other block sizes, codebook sizes and larger images.</a:t>
-            </a:r>
-            <a:endParaRPr lang="en-US" sz="2100" dirty="0"/>
+              <a:t>LBG training was parallelized with MPI: 9.19× speedup on 14 processes (efficiency ≈ 66%); total speedup 5.00× (gray) and 6.84× (color).</a:t>
+            </a:r>
+            <a:endParaRPr lang="en-US" sz="1900" dirty="0"/>
           </a:p>
           <a:p>
             <a:pPr marL="342900" indent="-342900">
@@ -28730,7 +28915,7 @@
               <a:buChar char="■"/>
             </a:pPr>
             <a:r>
-              <a:rPr lang="en-US" sz="2100" dirty="0">
+              <a:rPr lang="en-US" sz="1900" dirty="0">
                 <a:solidFill>
                   <a:srgbClr val="1F1A33"/>
                 </a:solidFill>
@@ -28738,9 +28923,9 @@
                 <a:ea typeface="Calibri" pitchFamily="34" charset="-122"/>
                 <a:cs typeface="Calibri" pitchFamily="34" charset="-120"/>
               </a:rPr>
-              <a:t>Define an efficiency measure that accounts for the different speeds of P-cores and E-cores.</a:t>
-            </a:r>
-            <a:endParaRPr lang="en-US" sz="2100" dirty="0"/>
+              <a:t>The speed-aware (Adaptive) distribution reduced LBG time by 17.2–28.3% compared with Equal distribution (P = 8 to 14).</a:t>
+            </a:r>
+            <a:endParaRPr lang="en-US" sz="1900" dirty="0"/>
           </a:p>
           <a:p>
             <a:pPr marL="342900" indent="-342900">
@@ -28751,7 +28936,7 @@
               <a:buChar char="■"/>
             </a:pPr>
             <a:r>
-              <a:rPr lang="en-US" sz="2100" dirty="0">
+              <a:rPr lang="en-US" sz="1900" dirty="0">
                 <a:solidFill>
                   <a:srgbClr val="1F1A33"/>
                 </a:solidFill>
@@ -28759,9 +28944,9 @@
                 <a:ea typeface="Calibri" pitchFamily="34" charset="-122"/>
                 <a:cs typeface="Calibri" pitchFamily="34" charset="-120"/>
               </a:rPr>
-              <a:t>Implement a complete container file format (stored Huffman table and header) with a stand-alone decoder; the current program only accounts the compressed size.</a:t>
-            </a:r>
-            <a:endParaRPr lang="en-US" sz="2100" dirty="0"/>
+              <a:t>The parallel results were identical to the sequential ones: same reconstructed images and quality metrics.</a:t>
+            </a:r>
+            <a:endParaRPr lang="en-US" sz="1900" dirty="0"/>
           </a:p>
           <a:p>
             <a:pPr marL="342900" indent="-342900">
@@ -28772,7 +28957,7 @@
               <a:buChar char="■"/>
             </a:pPr>
             <a:r>
-              <a:rPr lang="en-US" sz="2100" dirty="0">
+              <a:rPr lang="en-US" sz="1900" dirty="0">
                 <a:solidFill>
                   <a:srgbClr val="1F1A33"/>
                 </a:solidFill>
@@ -28780,9 +28965,30 @@
                 <a:ea typeface="Calibri" pitchFamily="34" charset="-122"/>
                 <a:cs typeface="Calibri" pitchFamily="34" charset="-120"/>
               </a:rPr>
-              <a:t>Extend the study to other hybrid CPUs and to hybrid MPI + OpenMP implementations.</a:t>
-            </a:r>
-            <a:endParaRPr lang="en-US" sz="2100" dirty="0"/>
+              <a:t>Quality: mean PSNR 29.49 dB and SSIM 0.8266 (gray); 28.80 dB and 0.7654 (color), at a compression ratio of ___ (gray) and ___ (color).</a:t>
+            </a:r>
+            <a:endParaRPr lang="en-US" sz="1900" dirty="0"/>
+          </a:p>
+          <a:p>
+            <a:pPr marL="342900" indent="-342900">
+              <a:spcAft>
+                <a:spcPts val="1000"/>
+              </a:spcAft>
+              <a:buSzPct val="100000"/>
+              <a:buChar char="■"/>
+            </a:pPr>
+            <a:r>
+              <a:rPr lang="en-US" sz="1900" dirty="0">
+                <a:solidFill>
+                  <a:srgbClr val="1F1A33"/>
+                </a:solidFill>
+                <a:latin typeface="Calibri" pitchFamily="34" charset="0"/>
+                <a:ea typeface="Calibri" pitchFamily="34" charset="-122"/>
+                <a:cs typeface="Calibri" pitchFamily="34" charset="-120"/>
+              </a:rPr>
+              <a:t>The total speedup is limited by the sequential coding and reconstruction stages.</a:t>
+            </a:r>
+            <a:endParaRPr lang="en-US" sz="1900" dirty="0"/>
           </a:p>
         </p:txBody>
       </p:sp>
@@ -28797,6 +29003,322 @@
 <file path=ppt/slides/slide32.xml><?xml version="1.0" encoding="utf-8"?>
 <p:sld xmlns:a="http://schemas.openxmlformats.org/drawingml/2006/main" xmlns:r="http://schemas.openxmlformats.org/officeDocument/2006/relationships" xmlns:p="http://schemas.openxmlformats.org/presentationml/2006/main">
   <p:cSld name="Slide 32">
+    <p:bg>
+      <p:bgPr>
+        <a:solidFill>
+          <a:srgbClr val="FFFFFF"/>
+        </a:solidFill>
+      </p:bgPr>
+    </p:bg>
+    <p:spTree>
+      <p:nvGrpSpPr>
+        <p:cNvPr id="1" name=""/>
+        <p:cNvGrpSpPr/>
+        <p:nvPr/>
+      </p:nvGrpSpPr>
+      <p:grpSpPr>
+        <a:xfrm>
+          <a:off x="0" y="0"/>
+          <a:ext cx="0" cy="0"/>
+          <a:chOff x="0" y="0"/>
+          <a:chExt cx="0" cy="0"/>
+        </a:xfrm>
+      </p:grpSpPr>
+      <p:sp>
+        <p:nvSpPr>
+          <p:cNvPr id="2" name="Shape 0"/>
+          <p:cNvSpPr/>
+          <p:nvPr/>
+        </p:nvSpPr>
+        <p:spPr>
+          <a:xfrm>
+            <a:off x="457200" y="320040"/>
+            <a:ext cx="2103120" cy="502920"/>
+          </a:xfrm>
+          <a:prstGeom prst="roundRect">
+            <a:avLst>
+              <a:gd name="adj" fmla="val 18182"/>
+            </a:avLst>
+          </a:prstGeom>
+          <a:solidFill>
+            <a:srgbClr val="2E2055"/>
+          </a:solidFill>
+          <a:ln w="12700">
+            <a:solidFill>
+              <a:srgbClr val="2E2055"/>
+            </a:solidFill>
+            <a:prstDash val="solid"/>
+          </a:ln>
+        </p:spPr>
+      </p:sp>
+      <p:sp>
+        <p:nvSpPr>
+          <p:cNvPr id="3" name="Text 1"/>
+          <p:cNvSpPr/>
+          <p:nvPr/>
+        </p:nvSpPr>
+        <p:spPr>
+          <a:xfrm>
+            <a:off x="457200" y="320040"/>
+            <a:ext cx="2103120" cy="502920"/>
+          </a:xfrm>
+          <a:prstGeom prst="rect">
+            <a:avLst/>
+          </a:prstGeom>
+          <a:noFill/>
+          <a:ln/>
+        </p:spPr>
+        <p:txBody>
+          <a:bodyPr wrap="square" lIns="0" tIns="0" rIns="0" bIns="0" rtlCol="0" anchor="ctr"/>
+          <a:lstStyle/>
+          <a:p>
+            <a:pPr algn="ctr" indent="0" marL="0">
+              <a:buNone/>
+            </a:pPr>
+            <a:r>
+              <a:rPr lang="en-US" sz="1600" b="1" dirty="0">
+                <a:solidFill>
+                  <a:srgbClr val="FFFFFF"/>
+                </a:solidFill>
+                <a:latin typeface="Calibri" pitchFamily="34" charset="0"/>
+                <a:ea typeface="Calibri" pitchFamily="34" charset="-122"/>
+                <a:cs typeface="Calibri" pitchFamily="34" charset="-120"/>
+              </a:rPr>
+              <a:t>Future Work</a:t>
+            </a:r>
+            <a:endParaRPr lang="en-US" sz="1600" dirty="0"/>
+          </a:p>
+        </p:txBody>
+      </p:sp>
+      <p:sp>
+        <p:nvSpPr>
+          <p:cNvPr id="4" name="Text 2"/>
+          <p:cNvSpPr/>
+          <p:nvPr/>
+        </p:nvSpPr>
+        <p:spPr>
+          <a:xfrm>
+            <a:off x="2743200" y="274320"/>
+            <a:ext cx="9418320" cy="594360"/>
+          </a:xfrm>
+          <a:prstGeom prst="rect">
+            <a:avLst/>
+          </a:prstGeom>
+          <a:noFill/>
+          <a:ln/>
+        </p:spPr>
+        <p:txBody>
+          <a:bodyPr wrap="square" lIns="0" tIns="0" rIns="0" bIns="0" rtlCol="0" anchor="ctr"/>
+          <a:lstStyle/>
+          <a:p>
+            <a:pPr indent="0" marL="0">
+              <a:buNone/>
+            </a:pPr>
+            <a:r>
+              <a:rPr lang="en-US" sz="2800" b="1" dirty="0">
+                <a:solidFill>
+                  <a:srgbClr val="2E2055"/>
+                </a:solidFill>
+                <a:latin typeface="Cambria" pitchFamily="34" charset="0"/>
+                <a:ea typeface="Cambria" pitchFamily="34" charset="-122"/>
+                <a:cs typeface="Cambria" pitchFamily="34" charset="-120"/>
+              </a:rPr>
+              <a:t>Future Work</a:t>
+            </a:r>
+            <a:endParaRPr lang="en-US" sz="2800" dirty="0"/>
+          </a:p>
+        </p:txBody>
+      </p:sp>
+      <p:sp>
+        <p:nvSpPr>
+          <p:cNvPr id="5" name="Shape 3"/>
+          <p:cNvSpPr/>
+          <p:nvPr/>
+        </p:nvSpPr>
+        <p:spPr>
+          <a:xfrm>
+            <a:off x="457200" y="960120"/>
+            <a:ext cx="11274552" cy="36576"/>
+          </a:xfrm>
+          <a:prstGeom prst="rect">
+            <a:avLst/>
+          </a:prstGeom>
+          <a:solidFill>
+            <a:srgbClr val="2E2055"/>
+          </a:solidFill>
+          <a:ln w="12700">
+            <a:solidFill>
+              <a:srgbClr val="2E2055"/>
+            </a:solidFill>
+            <a:prstDash val="solid"/>
+          </a:ln>
+        </p:spPr>
+      </p:sp>
+      <p:sp>
+        <p:nvSpPr>
+          <p:cNvPr id="6" name="Shape 4"/>
+          <p:cNvSpPr/>
+          <p:nvPr/>
+        </p:nvSpPr>
+        <p:spPr>
+          <a:xfrm>
+            <a:off x="640080" y="1280160"/>
+            <a:ext cx="10927080" cy="5029200"/>
+          </a:xfrm>
+          <a:prstGeom prst="roundRect">
+            <a:avLst>
+              <a:gd name="adj" fmla="val 1455"/>
+            </a:avLst>
+          </a:prstGeom>
+          <a:solidFill>
+            <a:srgbClr val="F5F1FB"/>
+          </a:solidFill>
+          <a:ln w="12700">
+            <a:solidFill>
+              <a:srgbClr val="F5F1FB"/>
+            </a:solidFill>
+            <a:prstDash val="solid"/>
+          </a:ln>
+        </p:spPr>
+      </p:sp>
+      <p:sp>
+        <p:nvSpPr>
+          <p:cNvPr id="7" name="Text 5"/>
+          <p:cNvSpPr/>
+          <p:nvPr/>
+        </p:nvSpPr>
+        <p:spPr>
+          <a:xfrm>
+            <a:off x="777240" y="1371600"/>
+            <a:ext cx="10652760" cy="4846320"/>
+          </a:xfrm>
+          <a:prstGeom prst="rect">
+            <a:avLst/>
+          </a:prstGeom>
+          <a:noFill/>
+          <a:ln/>
+        </p:spPr>
+        <p:txBody>
+          <a:bodyPr wrap="square" lIns="1016" tIns="1016" rIns="1016" bIns="1016" rtlCol="0" anchor="t"/>
+          <a:lstStyle/>
+          <a:p>
+            <a:pPr marL="342900" indent="-342900">
+              <a:spcAft>
+                <a:spcPts val="1000"/>
+              </a:spcAft>
+              <a:buSzPct val="100000"/>
+              <a:buChar char="■"/>
+            </a:pPr>
+            <a:r>
+              <a:rPr lang="en-US" sz="2100" dirty="0">
+                <a:solidFill>
+                  <a:srgbClr val="1F1A33"/>
+                </a:solidFill>
+                <a:latin typeface="Calibri" pitchFamily="34" charset="0"/>
+                <a:ea typeface="Calibri" pitchFamily="34" charset="-122"/>
+                <a:cs typeface="Calibri" pitchFamily="34" charset="-120"/>
+              </a:rPr>
+              <a:t>Parallelize the delta coding, Huffman coding and reconstruction stages.</a:t>
+            </a:r>
+            <a:endParaRPr lang="en-US" sz="2100" dirty="0"/>
+          </a:p>
+          <a:p>
+            <a:pPr marL="342900" indent="-342900">
+              <a:spcAft>
+                <a:spcPts val="1000"/>
+              </a:spcAft>
+              <a:buSzPct val="100000"/>
+              <a:buChar char="■"/>
+            </a:pPr>
+            <a:r>
+              <a:rPr lang="en-US" sz="2100" dirty="0">
+                <a:solidFill>
+                  <a:srgbClr val="1F1A33"/>
+                </a:solidFill>
+                <a:latin typeface="Calibri" pitchFamily="34" charset="0"/>
+                <a:ea typeface="Calibri" pitchFamily="34" charset="-122"/>
+                <a:cs typeface="Calibri" pitchFamily="34" charset="-120"/>
+              </a:rPr>
+              <a:t>Evaluate other block sizes, codebook sizes and larger images.</a:t>
+            </a:r>
+            <a:endParaRPr lang="en-US" sz="2100" dirty="0"/>
+          </a:p>
+          <a:p>
+            <a:pPr marL="342900" indent="-342900">
+              <a:spcAft>
+                <a:spcPts val="1000"/>
+              </a:spcAft>
+              <a:buSzPct val="100000"/>
+              <a:buChar char="■"/>
+            </a:pPr>
+            <a:r>
+              <a:rPr lang="en-US" sz="2100" dirty="0">
+                <a:solidFill>
+                  <a:srgbClr val="1F1A33"/>
+                </a:solidFill>
+                <a:latin typeface="Calibri" pitchFamily="34" charset="0"/>
+                <a:ea typeface="Calibri" pitchFamily="34" charset="-122"/>
+                <a:cs typeface="Calibri" pitchFamily="34" charset="-120"/>
+              </a:rPr>
+              <a:t>Define an efficiency measure that accounts for the different speeds of P-cores and E-cores.</a:t>
+            </a:r>
+            <a:endParaRPr lang="en-US" sz="2100" dirty="0"/>
+          </a:p>
+          <a:p>
+            <a:pPr marL="342900" indent="-342900">
+              <a:spcAft>
+                <a:spcPts val="1000"/>
+              </a:spcAft>
+              <a:buSzPct val="100000"/>
+              <a:buChar char="■"/>
+            </a:pPr>
+            <a:r>
+              <a:rPr lang="en-US" sz="2100" dirty="0">
+                <a:solidFill>
+                  <a:srgbClr val="1F1A33"/>
+                </a:solidFill>
+                <a:latin typeface="Calibri" pitchFamily="34" charset="0"/>
+                <a:ea typeface="Calibri" pitchFamily="34" charset="-122"/>
+                <a:cs typeface="Calibri" pitchFamily="34" charset="-120"/>
+              </a:rPr>
+              <a:t>Implement a complete container file format (stored Huffman table and header) with a stand-alone decoder; the current program only accounts the compressed size.</a:t>
+            </a:r>
+            <a:endParaRPr lang="en-US" sz="2100" dirty="0"/>
+          </a:p>
+          <a:p>
+            <a:pPr marL="342900" indent="-342900">
+              <a:spcAft>
+                <a:spcPts val="1000"/>
+              </a:spcAft>
+              <a:buSzPct val="100000"/>
+              <a:buChar char="■"/>
+            </a:pPr>
+            <a:r>
+              <a:rPr lang="en-US" sz="2100" dirty="0">
+                <a:solidFill>
+                  <a:srgbClr val="1F1A33"/>
+                </a:solidFill>
+                <a:latin typeface="Calibri" pitchFamily="34" charset="0"/>
+                <a:ea typeface="Calibri" pitchFamily="34" charset="-122"/>
+                <a:cs typeface="Calibri" pitchFamily="34" charset="-120"/>
+              </a:rPr>
+              <a:t>Extend the study to other hybrid CPUs and to hybrid MPI + OpenMP implementations.</a:t>
+            </a:r>
+            <a:endParaRPr lang="en-US" sz="2100" dirty="0"/>
+          </a:p>
+        </p:txBody>
+      </p:sp>
+    </p:spTree>
+  </p:cSld>
+  <p:clrMapOvr>
+    <a:masterClrMapping/>
+  </p:clrMapOvr>
+</p:sld>
+</file>
+
+<file path=ppt/slides/slide33.xml><?xml version="1.0" encoding="utf-8"?>
+<p:sld xmlns:a="http://schemas.openxmlformats.org/drawingml/2006/main" xmlns:r="http://schemas.openxmlformats.org/officeDocument/2006/relationships" xmlns:p="http://schemas.openxmlformats.org/presentationml/2006/main">
+  <p:cSld name="Slide 33">
     <p:bg>
       <p:bgPr>
         <a:solidFill>

</xml_diff>

<commit_message>
Seminar: correct what limits the total speedup (I/O on Rank 0), fix Future Work bullet
Co-Authored-By: Claude Sonnet 5.5 <noreply@anthropic.com>
Claude-Session: https://claude.ai/code/session_01T6gEewJ8YaCdmnsfS34RJd
</commit_message>
<xml_diff>
--- a/results/seminar/figs/Seminar_Ibtihal_FINAL.pptx
+++ b/results/seminar/figs/Seminar_Ibtihal_FINAL.pptx
@@ -22963,7 +22963,7 @@
                 <a:ea typeface="Calibri" pitchFamily="34" charset="-122"/>
                 <a:cs typeface="Calibri" pitchFamily="34" charset="-120"/>
               </a:rPr>
-              <a:t>It is lower than the LBG speedup (9.19×) because the other stages (image reading, delta and Huffman coding, reconstruction) remain sequential.</a:t>
+              <a:t>It is lower than the LBG speedup (9.19×) because the work outside LBG (mainly image reading and file output) runs on Rank 0.</a:t>
             </a:r>
             <a:endParaRPr lang="en-US" sz="1500" dirty="0"/>
           </a:p>
@@ -28628,7 +28628,7 @@
                 <a:ea typeface="Calibri" pitchFamily="34" charset="-122"/>
                 <a:cs typeface="Calibri" pitchFamily="34" charset="-120"/>
               </a:rPr>
-              <a:t>Total: about 0.14 (gray) and 0.08 (color); the sequential coding and reconstruction stages dominate.</a:t>
+              <a:t>Total: about 0.14 (gray) and 0.08 (color); the work on Rank 0 (mainly image reading and file output) limits the speedup.</a:t>
             </a:r>
             <a:endParaRPr lang="en-US" sz="1400" dirty="0"/>
           </a:p>
@@ -28986,7 +28986,7 @@
                 <a:ea typeface="Calibri" pitchFamily="34" charset="-122"/>
                 <a:cs typeface="Calibri" pitchFamily="34" charset="-120"/>
               </a:rPr>
-              <a:t>The total speedup is limited by the sequential coding and reconstruction stages.</a:t>
+              <a:t>The total speedup is limited by the work that runs on Rank 0, mainly image reading and file output.</a:t>
             </a:r>
             <a:endParaRPr lang="en-US" sz="1900" dirty="0"/>
           </a:p>
@@ -29218,7 +29218,7 @@
                 <a:ea typeface="Calibri" pitchFamily="34" charset="-122"/>
                 <a:cs typeface="Calibri" pitchFamily="34" charset="-120"/>
               </a:rPr>
-              <a:t>Parallelize the delta coding, Huffman coding and reconstruction stages.</a:t>
+              <a:t>Reduce the sequential part on Rank 0: faster image reading and file output (for example, parallel I/O).</a:t>
             </a:r>
             <a:endParaRPr lang="en-US" sz="2100" dirty="0"/>
           </a:p>

</xml_diff>

<commit_message>
Seminar: new Future Work bullets
Co-Authored-By: Claude Sonnet 5.5 <noreply@anthropic.com>
Claude-Session: https://claude.ai/code/session_01T6gEewJ8YaCdmnsfS34RJd
</commit_message>
<xml_diff>
--- a/results/seminar/figs/Seminar_Ibtihal_FINAL.pptx
+++ b/results/seminar/figs/Seminar_Ibtihal_FINAL.pptx
@@ -29210,7 +29210,7 @@
               <a:buChar char="■"/>
             </a:pPr>
             <a:r>
-              <a:rPr lang="en-US" sz="2100" dirty="0">
+              <a:rPr lang="en-US" sz="2200" dirty="0">
                 <a:solidFill>
                   <a:srgbClr val="1F1A33"/>
                 </a:solidFill>
@@ -29218,9 +29218,9 @@
                 <a:ea typeface="Calibri" pitchFamily="34" charset="-122"/>
                 <a:cs typeface="Calibri" pitchFamily="34" charset="-120"/>
               </a:rPr>
-              <a:t>Reduce the sequential part on Rank 0: faster image reading and file output (for example, parallel I/O).</a:t>
-            </a:r>
-            <a:endParaRPr lang="en-US" sz="2100" dirty="0"/>
+              <a:t>Improve the rate–distortion performance: color transform (YCbCr instead of RGB), prediction or context modeling of the VQ indices, and variable block sizes.</a:t>
+            </a:r>
+            <a:endParaRPr lang="en-US" sz="2200" dirty="0"/>
           </a:p>
           <a:p>
             <a:pPr marL="342900" indent="-342900">
@@ -29231,7 +29231,7 @@
               <a:buChar char="■"/>
             </a:pPr>
             <a:r>
-              <a:rPr lang="en-US" sz="2100" dirty="0">
+              <a:rPr lang="en-US" sz="2200" dirty="0">
                 <a:solidFill>
                   <a:srgbClr val="1F1A33"/>
                 </a:solidFill>
@@ -29239,9 +29239,9 @@
                 <a:ea typeface="Calibri" pitchFamily="34" charset="-122"/>
                 <a:cs typeface="Calibri" pitchFamily="34" charset="-120"/>
               </a:rPr>
-              <a:t>Evaluate other block sizes, codebook sizes and larger images.</a:t>
-            </a:r>
-            <a:endParaRPr lang="en-US" sz="2100" dirty="0"/>
+              <a:t>Accelerate the LBG assignment step, which dominates the run time, with GPUs (CUDA or OpenCL) combined with MPI.</a:t>
+            </a:r>
+            <a:endParaRPr lang="en-US" sz="2200" dirty="0"/>
           </a:p>
           <a:p>
             <a:pPr marL="342900" indent="-342900">
@@ -29252,7 +29252,7 @@
               <a:buChar char="■"/>
             </a:pPr>
             <a:r>
-              <a:rPr lang="en-US" sz="2100" dirty="0">
+              <a:rPr lang="en-US" sz="2200" dirty="0">
                 <a:solidFill>
                   <a:srgbClr val="1F1A33"/>
                 </a:solidFill>
@@ -29260,9 +29260,9 @@
                 <a:ea typeface="Calibri" pitchFamily="34" charset="-122"/>
                 <a:cs typeface="Calibri" pitchFamily="34" charset="-120"/>
               </a:rPr>
-              <a:t>Define an efficiency measure that accounts for the different speeds of P-cores and E-cores.</a:t>
-            </a:r>
-            <a:endParaRPr lang="en-US" sz="2100" dirty="0"/>
+              <a:t>Scale to multi-node clusters, larger images and image sequences that share one codebook.</a:t>
+            </a:r>
+            <a:endParaRPr lang="en-US" sz="2200" dirty="0"/>
           </a:p>
           <a:p>
             <a:pPr marL="342900" indent="-342900">
@@ -29273,7 +29273,7 @@
               <a:buChar char="■"/>
             </a:pPr>
             <a:r>
-              <a:rPr lang="en-US" sz="2100" dirty="0">
+              <a:rPr lang="en-US" sz="2200" dirty="0">
                 <a:solidFill>
                   <a:srgbClr val="1F1A33"/>
                 </a:solidFill>
@@ -29281,30 +29281,9 @@
                 <a:ea typeface="Calibri" pitchFamily="34" charset="-122"/>
                 <a:cs typeface="Calibri" pitchFamily="34" charset="-120"/>
               </a:rPr>
-              <a:t>Implement a complete container file format (stored Huffman table and header) with a stand-alone decoder; the current program only accounts the compressed size.</a:t>
-            </a:r>
-            <a:endParaRPr lang="en-US" sz="2100" dirty="0"/>
-          </a:p>
-          <a:p>
-            <a:pPr marL="342900" indent="-342900">
-              <a:spcAft>
-                <a:spcPts val="1000"/>
-              </a:spcAft>
-              <a:buSzPct val="100000"/>
-              <a:buChar char="■"/>
-            </a:pPr>
-            <a:r>
-              <a:rPr lang="en-US" sz="2100" dirty="0">
-                <a:solidFill>
-                  <a:srgbClr val="1F1A33"/>
-                </a:solidFill>
-                <a:latin typeface="Calibri" pitchFamily="34" charset="0"/>
-                <a:ea typeface="Calibri" pitchFamily="34" charset="-122"/>
-                <a:cs typeface="Calibri" pitchFamily="34" charset="-120"/>
-              </a:rPr>
-              <a:t>Extend the study to other hybrid CPUs and to hybrid MPI + OpenMP implementations.</a:t>
-            </a:r>
-            <a:endParaRPr lang="en-US" sz="2100" dirty="0"/>
+              <a:t>Rebalance the workload during the run, using the measured compute time of each rank and a load-imbalance measure.</a:t>
+            </a:r>
+            <a:endParaRPr lang="en-US" sz="2200" dirty="0"/>
           </a:p>
         </p:txBody>
       </p:sp>

</xml_diff>

<commit_message>
Seminar: closing slide (thank you, questions, cameraman result, P/E cores)
Co-Authored-By: Claude Sonnet 5.5 <noreply@anthropic.com>
Claude-Session: https://claude.ai/code/session_01T6gEewJ8YaCdmnsfS34RJd
</commit_message>
<xml_diff>
--- a/results/seminar/figs/Seminar_Ibtihal_FINAL.pptx
+++ b/results/seminar/figs/Seminar_Ibtihal_FINAL.pptx
@@ -38,9 +38,10 @@
     <p:sldId id="286" r:id="rId32"/>
     <p:sldId id="287" r:id="rId33"/>
     <p:sldId id="288" r:id="rId34"/>
+    <p:sldId id="289" r:id="rId35"/>
   </p:sldIdLst>
   <p:notesMasterIdLst>
-    <p:notesMasterId r:id="rId35"/>
+    <p:notesMasterId r:id="rId36"/>
   </p:notesMasterIdLst>
   <p:sldSz cx="12192000" cy="6858000"/>
   <p:notesSz cx="6858000" cy="12192000"/>
@@ -2846,6 +2847,94 @@
             <a:fld id="{F7021451-1387-4CA6-816F-3879F97B5CBC}" type="slidenum">
               <a:rPr lang="en-US"/>
               <a:t>33</a:t>
+            </a:fld>
+            <a:endParaRPr lang="en-US"/>
+          </a:p>
+        </p:txBody>
+      </p:sp>
+    </p:spTree>
+    <p:extLst>
+      <p:ext uri="{BB962C8B-B14F-4D97-AF65-F5344CB8AC3E}">
+        <p14:creationId xmlns:p14="http://schemas.microsoft.com/office/powerpoint/2010/main" val="1024086991"/>
+      </p:ext>
+    </p:extLst>
+  </p:cSld>
+  <p:clrMapOvr>
+    <a:masterClrMapping/>
+  </p:clrMapOvr>
+</p:notes>
+</file>
+
+<file path=ppt/notesSlides/notesSlide34.xml><?xml version="1.0" encoding="utf-8"?>
+<p:notes xmlns:a="http://schemas.openxmlformats.org/drawingml/2006/main" xmlns:r="http://schemas.openxmlformats.org/officeDocument/2006/relationships" xmlns:p="http://schemas.openxmlformats.org/presentationml/2006/main">
+  <p:cSld>
+    <p:spTree>
+      <p:nvGrpSpPr>
+        <p:cNvPr id="1" name=""/>
+        <p:cNvGrpSpPr/>
+        <p:nvPr/>
+      </p:nvGrpSpPr>
+      <p:grpSpPr>
+        <a:xfrm>
+          <a:off x="0" y="0"/>
+          <a:ext cx="0" cy="0"/>
+          <a:chOff x="0" y="0"/>
+          <a:chExt cx="0" cy="0"/>
+        </a:xfrm>
+      </p:grpSpPr>
+      <p:sp>
+        <p:nvSpPr>
+          <p:cNvPr id="2" name="Slide Image Placeholder 1"/>
+          <p:cNvSpPr>
+            <a:spLocks noGrp="1" noRot="1" noChangeAspect="1"/>
+          </p:cNvSpPr>
+          <p:nvPr>
+            <p:ph type="sldImg"/>
+          </p:nvPr>
+        </p:nvSpPr>
+        <p:spPr/>
+      </p:sp>
+      <p:sp>
+        <p:nvSpPr>
+          <p:cNvPr id="3" name="Notes Placeholder 2"/>
+          <p:cNvSpPr>
+            <a:spLocks noGrp="1"/>
+          </p:cNvSpPr>
+          <p:nvPr>
+            <p:ph type="body" idx="1"/>
+          </p:nvPr>
+        </p:nvSpPr>
+        <p:spPr/>
+        <p:txBody>
+          <a:bodyPr/>
+          <a:lstStyle/>
+          <a:p>
+            <a:r>
+              <a:rPr lang="en-US" dirty="0"/>
+              <a:t/>
+            </a:r>
+            <a:endParaRPr lang="en-US" dirty="0"/>
+          </a:p>
+        </p:txBody>
+      </p:sp>
+      <p:sp>
+        <p:nvSpPr>
+          <p:cNvPr id="4" name="Slide Number Placeholder 3"/>
+          <p:cNvSpPr>
+            <a:spLocks noGrp="1"/>
+          </p:cNvSpPr>
+          <p:nvPr>
+            <p:ph type="sldNum" sz="quarter" idx="10"/>
+          </p:nvPr>
+        </p:nvSpPr>
+        <p:spPr/>
+        <p:txBody>
+          <a:bodyPr/>
+          <a:lstStyle/>
+          <a:p>
+            <a:fld id="{F7021451-1387-4CA6-816F-3879F97B5CBC}" type="slidenum">
+              <a:rPr lang="en-US"/>
+              <a:t>34</a:t>
             </a:fld>
             <a:endParaRPr lang="en-US"/>
           </a:p>
@@ -29611,6 +29700,252 @@
 </p:sld>
 </file>
 
+<file path=ppt/slides/slide34.xml><?xml version="1.0" encoding="utf-8"?>
+<p:sld xmlns:a="http://schemas.openxmlformats.org/drawingml/2006/main" xmlns:r="http://schemas.openxmlformats.org/officeDocument/2006/relationships" xmlns:p="http://schemas.openxmlformats.org/presentationml/2006/main">
+  <p:cSld name="Slide 34">
+    <p:bg>
+      <p:bgPr>
+        <a:solidFill>
+          <a:srgbClr val="2E2055"/>
+        </a:solidFill>
+      </p:bgPr>
+    </p:bg>
+    <p:spTree>
+      <p:nvGrpSpPr>
+        <p:cNvPr id="1" name=""/>
+        <p:cNvGrpSpPr/>
+        <p:nvPr/>
+      </p:nvGrpSpPr>
+      <p:grpSpPr>
+        <a:xfrm>
+          <a:off x="0" y="0"/>
+          <a:ext cx="0" cy="0"/>
+          <a:chOff x="0" y="0"/>
+          <a:chExt cx="0" cy="0"/>
+        </a:xfrm>
+      </p:grpSpPr>
+      <p:sp>
+        <p:nvSpPr>
+          <p:cNvPr id="2" name="Shape 0"/>
+          <p:cNvSpPr/>
+          <p:nvPr/>
+        </p:nvSpPr>
+        <p:spPr>
+          <a:xfrm>
+            <a:off x="0" y="0"/>
+            <a:ext cx="12191695" cy="6858000"/>
+          </a:xfrm>
+          <a:prstGeom prst="rect">
+            <a:avLst/>
+          </a:prstGeom>
+          <a:solidFill>
+            <a:srgbClr val="2E2055"/>
+          </a:solidFill>
+          <a:ln w="12700">
+            <a:solidFill>
+              <a:srgbClr val="2E2055"/>
+            </a:solidFill>
+            <a:prstDash val="solid"/>
+          </a:ln>
+        </p:spPr>
+      </p:sp>
+      <p:sp>
+        <p:nvSpPr>
+          <p:cNvPr id="3" name="Shape 1"/>
+          <p:cNvSpPr/>
+          <p:nvPr/>
+        </p:nvSpPr>
+        <p:spPr>
+          <a:xfrm>
+            <a:off x="0" y="0"/>
+            <a:ext cx="320040" cy="6858000"/>
+          </a:xfrm>
+          <a:prstGeom prst="rect">
+            <a:avLst/>
+          </a:prstGeom>
+          <a:solidFill>
+            <a:srgbClr val="E0457B"/>
+          </a:solidFill>
+          <a:ln w="12700">
+            <a:solidFill>
+              <a:srgbClr val="E0457B"/>
+            </a:solidFill>
+            <a:prstDash val="solid"/>
+          </a:ln>
+        </p:spPr>
+      </p:sp>
+      <p:sp>
+        <p:nvSpPr>
+          <p:cNvPr id="4" name="Text 2"/>
+          <p:cNvSpPr/>
+          <p:nvPr/>
+        </p:nvSpPr>
+        <p:spPr>
+          <a:xfrm>
+            <a:off x="822960" y="1554480"/>
+            <a:ext cx="5120640" cy="2011680"/>
+          </a:xfrm>
+          <a:prstGeom prst="rect">
+            <a:avLst/>
+          </a:prstGeom>
+          <a:noFill/>
+          <a:ln/>
+        </p:spPr>
+        <p:txBody>
+          <a:bodyPr wrap="square" lIns="0" tIns="0" rIns="0" bIns="0" rtlCol="0" anchor="ctr"/>
+          <a:lstStyle/>
+          <a:p>
+            <a:pPr indent="0" marL="0">
+              <a:buNone/>
+            </a:pPr>
+            <a:r>
+              <a:rPr lang="en-US" sz="4400" b="1" dirty="0">
+                <a:solidFill>
+                  <a:srgbClr val="FFFFFF"/>
+                </a:solidFill>
+                <a:latin typeface="Cambria" pitchFamily="34" charset="0"/>
+                <a:ea typeface="Cambria" pitchFamily="34" charset="-122"/>
+                <a:cs typeface="Cambria" pitchFamily="34" charset="-120"/>
+              </a:rPr>
+              <a:t>Thank you for your attention</a:t>
+            </a:r>
+            <a:endParaRPr lang="en-US" sz="4400" dirty="0"/>
+          </a:p>
+        </p:txBody>
+      </p:sp>
+      <p:sp>
+        <p:nvSpPr>
+          <p:cNvPr id="5" name="Text 3"/>
+          <p:cNvSpPr/>
+          <p:nvPr/>
+        </p:nvSpPr>
+        <p:spPr>
+          <a:xfrm>
+            <a:off x="822960" y="3657600"/>
+            <a:ext cx="5120640" cy="731520"/>
+          </a:xfrm>
+          <a:prstGeom prst="rect">
+            <a:avLst/>
+          </a:prstGeom>
+          <a:noFill/>
+          <a:ln/>
+        </p:spPr>
+        <p:txBody>
+          <a:bodyPr wrap="square" lIns="0" tIns="0" rIns="0" bIns="0" rtlCol="0" anchor="ctr"/>
+          <a:lstStyle/>
+          <a:p>
+            <a:pPr indent="0" marL="0">
+              <a:buNone/>
+            </a:pPr>
+            <a:r>
+              <a:rPr lang="en-US" sz="3200" b="1" dirty="0">
+                <a:solidFill>
+                  <a:srgbClr val="F2993A"/>
+                </a:solidFill>
+                <a:latin typeface="Calibri" pitchFamily="34" charset="0"/>
+                <a:ea typeface="Calibri" pitchFamily="34" charset="-122"/>
+                <a:cs typeface="Calibri" pitchFamily="34" charset="-120"/>
+              </a:rPr>
+              <a:t>Questions?</a:t>
+            </a:r>
+            <a:endParaRPr lang="en-US" sz="3200" dirty="0"/>
+          </a:p>
+        </p:txBody>
+      </p:sp>
+      <p:sp>
+        <p:nvSpPr>
+          <p:cNvPr id="6" name="Text 4"/>
+          <p:cNvSpPr/>
+          <p:nvPr/>
+        </p:nvSpPr>
+        <p:spPr>
+          <a:xfrm>
+            <a:off x="822960" y="4937760"/>
+            <a:ext cx="5120640" cy="914400"/>
+          </a:xfrm>
+          <a:prstGeom prst="rect">
+            <a:avLst/>
+          </a:prstGeom>
+          <a:noFill/>
+          <a:ln/>
+        </p:spPr>
+        <p:txBody>
+          <a:bodyPr wrap="square" lIns="0" tIns="0" rIns="0" bIns="0" rtlCol="0" anchor="ctr"/>
+          <a:lstStyle/>
+          <a:p>
+            <a:pPr indent="0" marL="0">
+              <a:spcAft>
+                <a:spcPts val="600"/>
+              </a:spcAft>
+              <a:buNone/>
+            </a:pPr>
+            <a:r>
+              <a:rPr lang="en-US" sz="2000" b="1" dirty="0">
+                <a:solidFill>
+                  <a:srgbClr val="FFFFFF"/>
+                </a:solidFill>
+                <a:latin typeface="Calibri" pitchFamily="34" charset="0"/>
+                <a:ea typeface="Calibri" pitchFamily="34" charset="-122"/>
+                <a:cs typeface="Calibri" pitchFamily="34" charset="-120"/>
+              </a:rPr>
+              <a:t>MSc. Student Ibtihal Hussien</a:t>
+            </a:r>
+            <a:endParaRPr lang="en-US" sz="2000" dirty="0"/>
+          </a:p>
+          <a:p>
+            <a:pPr indent="0" marL="0">
+              <a:spcAft>
+                <a:spcPts val="600"/>
+              </a:spcAft>
+              <a:buNone/>
+            </a:pPr>
+            <a:r>
+              <a:rPr lang="en-US" sz="2000" dirty="0">
+                <a:solidFill>
+                  <a:srgbClr val="C9BDE8"/>
+                </a:solidFill>
+                <a:latin typeface="Calibri" pitchFamily="34" charset="0"/>
+                <a:ea typeface="Calibri" pitchFamily="34" charset="-122"/>
+                <a:cs typeface="Calibri" pitchFamily="34" charset="-120"/>
+              </a:rPr>
+              <a:t>University of Babylon</a:t>
+            </a:r>
+            <a:endParaRPr lang="en-US" sz="2000" dirty="0"/>
+          </a:p>
+        </p:txBody>
+      </p:sp>
+      <p:pic>
+        <p:nvPicPr>
+          <p:cNvPr id="7" name="Image 0" descr="assets/closing.png">    </p:cNvPr>
+          <p:cNvPicPr>
+            <a:picLocks noChangeAspect="1"/>
+          </p:cNvPicPr>
+          <p:nvPr/>
+        </p:nvPicPr>
+        <p:blipFill>
+          <a:blip r:embed="rId1"/>
+          <a:stretch>
+            <a:fillRect/>
+          </a:stretch>
+        </p:blipFill>
+        <p:spPr>
+          <a:xfrm>
+            <a:off x="5943600" y="1097280"/>
+            <a:ext cx="5943600" cy="4493941"/>
+          </a:xfrm>
+          <a:prstGeom prst="rect">
+            <a:avLst/>
+          </a:prstGeom>
+        </p:spPr>
+      </p:pic>
+    </p:spTree>
+  </p:cSld>
+  <p:clrMapOvr>
+    <a:masterClrMapping/>
+  </p:clrMapOvr>
+</p:sld>
+</file>
+
 <file path=ppt/slides/slide4.xml><?xml version="1.0" encoding="utf-8"?>
 <p:sld xmlns:a="http://schemas.openxmlformats.org/drawingml/2006/main" xmlns:r="http://schemas.openxmlformats.org/officeDocument/2006/relationships" xmlns:p="http://schemas.openxmlformats.org/presentationml/2006/main">
   <p:cSld name="Slide 4">

</xml_diff>

<commit_message>
Related Work slide 1: values verified against sources, CR filled (previous accounting, noted), clearer footnote and conclusion
Co-Authored-By: Claude Sonnet 5.5 <noreply@anthropic.com>
Claude-Session: https://claude.ai/code/session_01T6gEewJ8YaCdmnsfS34RJd
</commit_message>
<xml_diff>
--- a/results/seminar/figs/Seminar_Ibtihal_FINAL.pptx
+++ b/results/seminar/figs/Seminar_Ibtihal_FINAL.pptx
@@ -3175,7 +3175,7 @@
           <a:p>
             <a:r>
               <a:rPr lang="en-US" dirty="0"/>
-              <a:t/>
+              <a:t>CR values of 'This work' come from the previous Huffman-table accounting. Replace them with the CR column of correctness.csv after the rerun (expected change about -1.2%). Source values checked against the papers: [6] Table 1 and Table 3; [16] Table 1; [17] Table 1 (Cameraman, FLBG).</a:t>
             </a:r>
             <a:endParaRPr lang="en-US" dirty="0"/>
           </a:p>
@@ -31903,6 +31903,17 @@
                       <a:pPr algn="ctr" indent="0" marL="0">
                         <a:buNone/>
                       </a:pPr>
+                      <a:r>
+                        <a:rPr lang="en-US" sz="1300" b="1" dirty="0">
+                          <a:solidFill>
+                            <a:srgbClr val="1F1A33"/>
+                          </a:solidFill>
+                          <a:latin typeface="Calibri" pitchFamily="34" charset="0"/>
+                          <a:ea typeface="Calibri" pitchFamily="34" charset="-122"/>
+                          <a:cs typeface="Calibri" pitchFamily="34" charset="-120"/>
+                        </a:rPr>
+                        <a:t>Lena</a:t>
+                      </a:r>
                       <a:endParaRPr lang="en-US" sz="1300" dirty="0">
                         <a:latin typeface="Calibri" charset="0"/>
                         <a:ea typeface="Calibri" charset="0"/>
@@ -32351,13 +32362,13 @@
                       <a:r>
                         <a:rPr lang="en-US" sz="1300" b="1" dirty="0">
                           <a:solidFill>
-                            <a:srgbClr val="E0457B"/>
+                            <a:srgbClr val="1F1A33"/>
                           </a:solidFill>
                           <a:latin typeface="Calibri" pitchFamily="34" charset="0"/>
                           <a:ea typeface="Calibri" pitchFamily="34" charset="-122"/>
                           <a:cs typeface="Calibri" pitchFamily="34" charset="-120"/>
                         </a:rPr>
-                        <a:t>___</a:t>
+                        <a:t>23.50</a:t>
                       </a:r>
                       <a:endParaRPr lang="en-US" sz="1300" dirty="0">
                         <a:latin typeface="Calibri" charset="0"/>
@@ -32417,7 +32428,7 @@
                         <a:buNone/>
                       </a:pPr>
                       <a:r>
-                        <a:rPr lang="en-US" sz="1300" dirty="0">
+                        <a:rPr lang="en-US" sz="1300" b="1" dirty="0">
                           <a:solidFill>
                             <a:srgbClr val="1F1A33"/>
                           </a:solidFill>
@@ -33013,13 +33024,13 @@
                       <a:r>
                         <a:rPr lang="en-US" sz="1300" b="1" dirty="0">
                           <a:solidFill>
-                            <a:srgbClr val="E0457B"/>
+                            <a:srgbClr val="1F1A33"/>
                           </a:solidFill>
                           <a:latin typeface="Calibri" pitchFamily="34" charset="0"/>
                           <a:ea typeface="Calibri" pitchFamily="34" charset="-122"/>
                           <a:cs typeface="Calibri" pitchFamily="34" charset="-120"/>
                         </a:rPr>
-                        <a:t>___</a:t>
+                        <a:t>26.54</a:t>
                       </a:r>
                       <a:endParaRPr lang="en-US" sz="1300" dirty="0">
                         <a:latin typeface="Calibri" charset="0"/>
@@ -33079,7 +33090,7 @@
                         <a:buNone/>
                       </a:pPr>
                       <a:r>
-                        <a:rPr lang="en-US" sz="1300" dirty="0">
+                        <a:rPr lang="en-US" sz="1300" b="1" dirty="0">
                           <a:solidFill>
                             <a:srgbClr val="1F1A33"/>
                           </a:solidFill>
@@ -33675,13 +33686,13 @@
                       <a:r>
                         <a:rPr lang="en-US" sz="1300" b="1" dirty="0">
                           <a:solidFill>
-                            <a:srgbClr val="E0457B"/>
+                            <a:srgbClr val="1F1A33"/>
                           </a:solidFill>
                           <a:latin typeface="Calibri" pitchFamily="34" charset="0"/>
                           <a:ea typeface="Calibri" pitchFamily="34" charset="-122"/>
                           <a:cs typeface="Calibri" pitchFamily="34" charset="-120"/>
                         </a:rPr>
-                        <a:t>___</a:t>
+                        <a:t>28.88</a:t>
                       </a:r>
                       <a:endParaRPr lang="en-US" sz="1300" dirty="0">
                         <a:latin typeface="Calibri" charset="0"/>
@@ -33741,7 +33752,7 @@
                         <a:buNone/>
                       </a:pPr>
                       <a:r>
-                        <a:rPr lang="en-US" sz="1300" dirty="0">
+                        <a:rPr lang="en-US" sz="1300" b="1" dirty="0">
                           <a:solidFill>
                             <a:srgbClr val="1F1A33"/>
                           </a:solidFill>
@@ -33807,7 +33818,7 @@
       </p:graphicFrame>
       <p:sp>
         <p:nvSpPr>
-          <p:cNvPr id="7" name="Text 4"/>
+          <p:cNvPr id="8" name="Text 4"/>
           <p:cNvSpPr/>
           <p:nvPr/>
         </p:nvSpPr>
@@ -33838,7 +33849,7 @@
                 <a:ea typeface="Calibri" pitchFamily="34" charset="-122"/>
                 <a:cs typeface="Calibri" pitchFamily="34" charset="-120"/>
               </a:rPr>
-              <a:t>* Bilal et al.: PSNR range at bit rates up to 0.625 bpp (CR not reported). Thomas et al. is a near-lossless scheme (CR ≈ 1.5).</a:t>
+              <a:t>[16]: Lena 512 × 512, Table 1 (CR 4.4058, PSNR 34.7809 dB). [6]: near-lossless scheme. * [17]: FLBG PSNR over 0.15–0.625 bpp (CR not reported).</a:t>
             </a:r>
             <a:endParaRPr lang="en-US" sz="1200" dirty="0"/>
           </a:p>
@@ -33846,7 +33857,7 @@
       </p:sp>
       <p:sp>
         <p:nvSpPr>
-          <p:cNvPr id="8" name="Text 5"/>
+          <p:cNvPr id="9" name="Text 5"/>
           <p:cNvSpPr/>
           <p:nvPr/>
         </p:nvSpPr>
@@ -33877,7 +33888,7 @@
                 <a:ea typeface="Cambria" pitchFamily="34" charset="-122"/>
                 <a:cs typeface="Cambria" pitchFamily="34" charset="-120"/>
               </a:rPr>
-              <a:t>The proposed method provides substantially higher compression than the near-lossless method, with lower reconstruction fidelity.</a:t>
+              <a:t>This work reaches a much higher compression ratio than [6] and [16], at a lower PSNR.</a:t>
             </a:r>
             <a:endParaRPr lang="en-US" sz="1800" dirty="0"/>
           </a:p>

</xml_diff>

<commit_message>
Related Work slide 1: add Algorithm column
Co-Authored-By: Claude Sonnet 5.5 <noreply@anthropic.com>
Claude-Session: https://claude.ai/code/session_01T6gEewJ8YaCdmnsfS34RJd
</commit_message>
<xml_diff>
--- a/results/seminar/figs/Seminar_Ibtihal_FINAL.pptx
+++ b/results/seminar/figs/Seminar_Ibtihal_FINAL.pptx
@@ -31136,11 +31136,12 @@
             <a:tbl>
               <a:tblPr/>
               <a:tblGrid>
-                <a:gridCol w="1097280"/>
+                <a:gridCol w="822960"/>
+                <a:gridCol w="1371600"/>
                 <a:gridCol w="2011680"/>
-                <a:gridCol w="3840480"/>
-                <a:gridCol w="1828800"/>
-                <a:gridCol w="2103120"/>
+                <a:gridCol w="3657600"/>
+                <a:gridCol w="1280160"/>
+                <a:gridCol w="1737360"/>
               </a:tblGrid>
               <a:tr h="457200">
                 <a:tc>
@@ -31297,6 +31298,74 @@
                           <a:cs typeface="Calibri" pitchFamily="34" charset="-120"/>
                         </a:rPr>
                         <a:t>Study</a:t>
+                      </a:r>
+                      <a:endParaRPr lang="en-US" sz="1400" dirty="0">
+                        <a:latin typeface="Calibri" charset="0"/>
+                        <a:ea typeface="Calibri" charset="0"/>
+                        <a:cs typeface="Calibri" charset="0"/>
+                      </a:endParaRPr>
+                    </a:p>
+                  </a:txBody>
+                  <a:tcPr marL="91440" marR="91440" marT="45720" marB="45720" anchor="ctr">
+                    <a:lnL w="12700" cap="flat" cmpd="sng" algn="ctr">
+                      <a:solidFill>
+                        <a:srgbClr val="E2D9F3"/>
+                      </a:solidFill>
+                      <a:prstDash val="solid"/>
+                      <a:round/>
+                      <a:headEnd type="none" w="med" len="med"/>
+                      <a:tailEnd type="none" w="med" len="med"/>
+                    </a:lnL>
+                    <a:lnR w="12700" cap="flat" cmpd="sng" algn="ctr">
+                      <a:solidFill>
+                        <a:srgbClr val="E2D9F3"/>
+                      </a:solidFill>
+                      <a:prstDash val="solid"/>
+                      <a:round/>
+                      <a:headEnd type="none" w="med" len="med"/>
+                      <a:tailEnd type="none" w="med" len="med"/>
+                    </a:lnR>
+                    <a:lnT w="12700" cap="flat" cmpd="sng" algn="ctr">
+                      <a:solidFill>
+                        <a:srgbClr val="E2D9F3"/>
+                      </a:solidFill>
+                      <a:prstDash val="solid"/>
+                      <a:round/>
+                      <a:headEnd type="none" w="med" len="med"/>
+                      <a:tailEnd type="none" w="med" len="med"/>
+                    </a:lnT>
+                    <a:lnB w="12700" cap="flat" cmpd="sng" algn="ctr">
+                      <a:solidFill>
+                        <a:srgbClr val="E2D9F3"/>
+                      </a:solidFill>
+                      <a:prstDash val="solid"/>
+                      <a:round/>
+                      <a:headEnd type="none" w="med" len="med"/>
+                      <a:tailEnd type="none" w="med" len="med"/>
+                    </a:lnB>
+                    <a:solidFill>
+                      <a:srgbClr val="6B4FA3"/>
+                    </a:solidFill>
+                  </a:tcPr>
+                </a:tc>
+                <a:tc>
+                  <a:txBody>
+                    <a:bodyPr/>
+                    <a:lstStyle/>
+                    <a:p>
+                      <a:pPr algn="ctr" indent="0" marL="0">
+                        <a:buNone/>
+                      </a:pPr>
+                      <a:r>
+                        <a:rPr lang="en-US" sz="1400" b="1" dirty="0">
+                          <a:solidFill>
+                            <a:srgbClr val="FFFFFF"/>
+                          </a:solidFill>
+                          <a:latin typeface="Calibri" pitchFamily="34" charset="0"/>
+                          <a:ea typeface="Calibri" pitchFamily="34" charset="-122"/>
+                          <a:cs typeface="Calibri" pitchFamily="34" charset="-120"/>
+                        </a:rPr>
+                        <a:t>Algorithm</a:t>
                       </a:r>
                       <a:endParaRPr lang="en-US" sz="1400" dirty="0">
                         <a:latin typeface="Calibri" charset="0"/>
@@ -31694,6 +31763,74 @@
                     <a:bodyPr/>
                     <a:lstStyle/>
                     <a:p>
+                      <a:pPr algn="l" indent="0" marL="0">
+                        <a:buNone/>
+                      </a:pPr>
+                      <a:r>
+                        <a:rPr lang="en-US" sz="1300" dirty="0">
+                          <a:solidFill>
+                            <a:srgbClr val="1F1A33"/>
+                          </a:solidFill>
+                          <a:latin typeface="Calibri" pitchFamily="34" charset="0"/>
+                          <a:ea typeface="Calibri" pitchFamily="34" charset="-122"/>
+                          <a:cs typeface="Calibri" pitchFamily="34" charset="-120"/>
+                        </a:rPr>
+                        <a:t>Wavelet coefficients + Huffman coding</a:t>
+                      </a:r>
+                      <a:endParaRPr lang="en-US" sz="1300" dirty="0">
+                        <a:latin typeface="Calibri" charset="0"/>
+                        <a:ea typeface="Calibri" charset="0"/>
+                        <a:cs typeface="Calibri" charset="0"/>
+                      </a:endParaRPr>
+                    </a:p>
+                  </a:txBody>
+                  <a:tcPr marL="91440" marR="91440" marT="45720" marB="45720" anchor="ctr">
+                    <a:lnL w="12700" cap="flat" cmpd="sng" algn="ctr">
+                      <a:solidFill>
+                        <a:srgbClr val="E2D9F3"/>
+                      </a:solidFill>
+                      <a:prstDash val="solid"/>
+                      <a:round/>
+                      <a:headEnd type="none" w="med" len="med"/>
+                      <a:tailEnd type="none" w="med" len="med"/>
+                    </a:lnL>
+                    <a:lnR w="12700" cap="flat" cmpd="sng" algn="ctr">
+                      <a:solidFill>
+                        <a:srgbClr val="E2D9F3"/>
+                      </a:solidFill>
+                      <a:prstDash val="solid"/>
+                      <a:round/>
+                      <a:headEnd type="none" w="med" len="med"/>
+                      <a:tailEnd type="none" w="med" len="med"/>
+                    </a:lnR>
+                    <a:lnT w="12700" cap="flat" cmpd="sng" algn="ctr">
+                      <a:solidFill>
+                        <a:srgbClr val="E2D9F3"/>
+                      </a:solidFill>
+                      <a:prstDash val="solid"/>
+                      <a:round/>
+                      <a:headEnd type="none" w="med" len="med"/>
+                      <a:tailEnd type="none" w="med" len="med"/>
+                    </a:lnT>
+                    <a:lnB w="12700" cap="flat" cmpd="sng" algn="ctr">
+                      <a:solidFill>
+                        <a:srgbClr val="E2D9F3"/>
+                      </a:solidFill>
+                      <a:prstDash val="solid"/>
+                      <a:round/>
+                      <a:headEnd type="none" w="med" len="med"/>
+                      <a:tailEnd type="none" w="med" len="med"/>
+                    </a:lnB>
+                    <a:solidFill>
+                      <a:srgbClr val="FFFFFF"/>
+                    </a:solidFill>
+                  </a:tcPr>
+                </a:tc>
+                <a:tc>
+                  <a:txBody>
+                    <a:bodyPr/>
+                    <a:lstStyle/>
+                    <a:p>
                       <a:pPr algn="ctr" indent="0" marL="0">
                         <a:buNone/>
                       </a:pPr>
@@ -32036,6 +32173,74 @@
                     <a:bodyPr/>
                     <a:lstStyle/>
                     <a:p>
+                      <a:pPr algn="l" indent="0" marL="0">
+                        <a:buNone/>
+                      </a:pPr>
+                      <a:r>
+                        <a:rPr lang="en-US" sz="1300" dirty="0">
+                          <a:solidFill>
+                            <a:srgbClr val="1F1A33"/>
+                          </a:solidFill>
+                          <a:latin typeface="Calibri" pitchFamily="34" charset="0"/>
+                          <a:ea typeface="Calibri" pitchFamily="34" charset="-122"/>
+                          <a:cs typeface="Calibri" pitchFamily="34" charset="-120"/>
+                        </a:rPr>
+                        <a:t>2D DWT + PCA + canonical Huffman</a:t>
+                      </a:r>
+                      <a:endParaRPr lang="en-US" sz="1300" dirty="0">
+                        <a:latin typeface="Calibri" charset="0"/>
+                        <a:ea typeface="Calibri" charset="0"/>
+                        <a:cs typeface="Calibri" charset="0"/>
+                      </a:endParaRPr>
+                    </a:p>
+                  </a:txBody>
+                  <a:tcPr marL="91440" marR="91440" marT="45720" marB="45720" anchor="ctr">
+                    <a:lnL w="12700" cap="flat" cmpd="sng" algn="ctr">
+                      <a:solidFill>
+                        <a:srgbClr val="E2D9F3"/>
+                      </a:solidFill>
+                      <a:prstDash val="solid"/>
+                      <a:round/>
+                      <a:headEnd type="none" w="med" len="med"/>
+                      <a:tailEnd type="none" w="med" len="med"/>
+                    </a:lnL>
+                    <a:lnR w="12700" cap="flat" cmpd="sng" algn="ctr">
+                      <a:solidFill>
+                        <a:srgbClr val="E2D9F3"/>
+                      </a:solidFill>
+                      <a:prstDash val="solid"/>
+                      <a:round/>
+                      <a:headEnd type="none" w="med" len="med"/>
+                      <a:tailEnd type="none" w="med" len="med"/>
+                    </a:lnR>
+                    <a:lnT w="12700" cap="flat" cmpd="sng" algn="ctr">
+                      <a:solidFill>
+                        <a:srgbClr val="E2D9F3"/>
+                      </a:solidFill>
+                      <a:prstDash val="solid"/>
+                      <a:round/>
+                      <a:headEnd type="none" w="med" len="med"/>
+                      <a:tailEnd type="none" w="med" len="med"/>
+                    </a:lnT>
+                    <a:lnB w="12700" cap="flat" cmpd="sng" algn="ctr">
+                      <a:solidFill>
+                        <a:srgbClr val="E2D9F3"/>
+                      </a:solidFill>
+                      <a:prstDash val="solid"/>
+                      <a:round/>
+                      <a:headEnd type="none" w="med" len="med"/>
+                      <a:tailEnd type="none" w="med" len="med"/>
+                    </a:lnB>
+                    <a:solidFill>
+                      <a:srgbClr val="FFFFFF"/>
+                    </a:solidFill>
+                  </a:tcPr>
+                </a:tc>
+                <a:tc>
+                  <a:txBody>
+                    <a:bodyPr/>
+                    <a:lstStyle/>
+                    <a:p>
                       <a:pPr algn="ctr" indent="0" marL="0">
                         <a:buNone/>
                       </a:pPr>
@@ -32301,6 +32506,74 @@
                           <a:cs typeface="Calibri" pitchFamily="34" charset="-120"/>
                         </a:rPr>
                         <a:t>This work</a:t>
+                      </a:r>
+                      <a:endParaRPr lang="en-US" sz="1300" dirty="0">
+                        <a:latin typeface="Calibri" charset="0"/>
+                        <a:ea typeface="Calibri" charset="0"/>
+                        <a:cs typeface="Calibri" charset="0"/>
+                      </a:endParaRPr>
+                    </a:p>
+                  </a:txBody>
+                  <a:tcPr marL="91440" marR="91440" marT="45720" marB="45720" anchor="ctr">
+                    <a:lnL w="12700" cap="flat" cmpd="sng" algn="ctr">
+                      <a:solidFill>
+                        <a:srgbClr val="E2D9F3"/>
+                      </a:solidFill>
+                      <a:prstDash val="solid"/>
+                      <a:round/>
+                      <a:headEnd type="none" w="med" len="med"/>
+                      <a:tailEnd type="none" w="med" len="med"/>
+                    </a:lnL>
+                    <a:lnR w="12700" cap="flat" cmpd="sng" algn="ctr">
+                      <a:solidFill>
+                        <a:srgbClr val="E2D9F3"/>
+                      </a:solidFill>
+                      <a:prstDash val="solid"/>
+                      <a:round/>
+                      <a:headEnd type="none" w="med" len="med"/>
+                      <a:tailEnd type="none" w="med" len="med"/>
+                    </a:lnR>
+                    <a:lnT w="12700" cap="flat" cmpd="sng" algn="ctr">
+                      <a:solidFill>
+                        <a:srgbClr val="E2D9F3"/>
+                      </a:solidFill>
+                      <a:prstDash val="solid"/>
+                      <a:round/>
+                      <a:headEnd type="none" w="med" len="med"/>
+                      <a:tailEnd type="none" w="med" len="med"/>
+                    </a:lnT>
+                    <a:lnB w="12700" cap="flat" cmpd="sng" algn="ctr">
+                      <a:solidFill>
+                        <a:srgbClr val="E2D9F3"/>
+                      </a:solidFill>
+                      <a:prstDash val="solid"/>
+                      <a:round/>
+                      <a:headEnd type="none" w="med" len="med"/>
+                      <a:tailEnd type="none" w="med" len="med"/>
+                    </a:lnB>
+                    <a:solidFill>
+                      <a:srgbClr val="F1ECF9"/>
+                    </a:solidFill>
+                  </a:tcPr>
+                </a:tc>
+                <a:tc>
+                  <a:txBody>
+                    <a:bodyPr/>
+                    <a:lstStyle/>
+                    <a:p>
+                      <a:pPr algn="l" indent="0" marL="0">
+                        <a:buNone/>
+                      </a:pPr>
+                      <a:r>
+                        <a:rPr lang="en-US" sz="1300" b="1" dirty="0">
+                          <a:solidFill>
+                            <a:srgbClr val="1F1A33"/>
+                          </a:solidFill>
+                          <a:latin typeface="Calibri" pitchFamily="34" charset="0"/>
+                          <a:ea typeface="Calibri" pitchFamily="34" charset="-122"/>
+                          <a:cs typeface="Calibri" pitchFamily="34" charset="-120"/>
+                        </a:rPr>
+                        <a:t>LBG-VQ + delta + Huffman</a:t>
                       </a:r>
                       <a:endParaRPr lang="en-US" sz="1300" dirty="0">
                         <a:latin typeface="Calibri" charset="0"/>
@@ -32698,6 +32971,74 @@
                     <a:bodyPr/>
                     <a:lstStyle/>
                     <a:p>
+                      <a:pPr algn="l" indent="0" marL="0">
+                        <a:buNone/>
+                      </a:pPr>
+                      <a:r>
+                        <a:rPr lang="en-US" sz="1300" dirty="0">
+                          <a:solidFill>
+                            <a:srgbClr val="1F1A33"/>
+                          </a:solidFill>
+                          <a:latin typeface="Calibri" pitchFamily="34" charset="0"/>
+                          <a:ea typeface="Calibri" pitchFamily="34" charset="-122"/>
+                          <a:cs typeface="Calibri" pitchFamily="34" charset="-120"/>
+                        </a:rPr>
+                        <a:t>Wavelet coefficients + Huffman coding</a:t>
+                      </a:r>
+                      <a:endParaRPr lang="en-US" sz="1300" dirty="0">
+                        <a:latin typeface="Calibri" charset="0"/>
+                        <a:ea typeface="Calibri" charset="0"/>
+                        <a:cs typeface="Calibri" charset="0"/>
+                      </a:endParaRPr>
+                    </a:p>
+                  </a:txBody>
+                  <a:tcPr marL="91440" marR="91440" marT="45720" marB="45720" anchor="ctr">
+                    <a:lnL w="12700" cap="flat" cmpd="sng" algn="ctr">
+                      <a:solidFill>
+                        <a:srgbClr val="E2D9F3"/>
+                      </a:solidFill>
+                      <a:prstDash val="solid"/>
+                      <a:round/>
+                      <a:headEnd type="none" w="med" len="med"/>
+                      <a:tailEnd type="none" w="med" len="med"/>
+                    </a:lnL>
+                    <a:lnR w="12700" cap="flat" cmpd="sng" algn="ctr">
+                      <a:solidFill>
+                        <a:srgbClr val="E2D9F3"/>
+                      </a:solidFill>
+                      <a:prstDash val="solid"/>
+                      <a:round/>
+                      <a:headEnd type="none" w="med" len="med"/>
+                      <a:tailEnd type="none" w="med" len="med"/>
+                    </a:lnR>
+                    <a:lnT w="12700" cap="flat" cmpd="sng" algn="ctr">
+                      <a:solidFill>
+                        <a:srgbClr val="E2D9F3"/>
+                      </a:solidFill>
+                      <a:prstDash val="solid"/>
+                      <a:round/>
+                      <a:headEnd type="none" w="med" len="med"/>
+                      <a:tailEnd type="none" w="med" len="med"/>
+                    </a:lnT>
+                    <a:lnB w="12700" cap="flat" cmpd="sng" algn="ctr">
+                      <a:solidFill>
+                        <a:srgbClr val="E2D9F3"/>
+                      </a:solidFill>
+                      <a:prstDash val="solid"/>
+                      <a:round/>
+                      <a:headEnd type="none" w="med" len="med"/>
+                      <a:tailEnd type="none" w="med" len="med"/>
+                    </a:lnB>
+                    <a:solidFill>
+                      <a:srgbClr val="FFFFFF"/>
+                    </a:solidFill>
+                  </a:tcPr>
+                </a:tc>
+                <a:tc>
+                  <a:txBody>
+                    <a:bodyPr/>
+                    <a:lstStyle/>
+                    <a:p>
                       <a:pPr algn="ctr" indent="0" marL="0">
                         <a:buNone/>
                       </a:pPr>
@@ -32963,6 +33304,74 @@
                           <a:cs typeface="Calibri" pitchFamily="34" charset="-120"/>
                         </a:rPr>
                         <a:t>This work</a:t>
+                      </a:r>
+                      <a:endParaRPr lang="en-US" sz="1300" dirty="0">
+                        <a:latin typeface="Calibri" charset="0"/>
+                        <a:ea typeface="Calibri" charset="0"/>
+                        <a:cs typeface="Calibri" charset="0"/>
+                      </a:endParaRPr>
+                    </a:p>
+                  </a:txBody>
+                  <a:tcPr marL="91440" marR="91440" marT="45720" marB="45720" anchor="ctr">
+                    <a:lnL w="12700" cap="flat" cmpd="sng" algn="ctr">
+                      <a:solidFill>
+                        <a:srgbClr val="E2D9F3"/>
+                      </a:solidFill>
+                      <a:prstDash val="solid"/>
+                      <a:round/>
+                      <a:headEnd type="none" w="med" len="med"/>
+                      <a:tailEnd type="none" w="med" len="med"/>
+                    </a:lnL>
+                    <a:lnR w="12700" cap="flat" cmpd="sng" algn="ctr">
+                      <a:solidFill>
+                        <a:srgbClr val="E2D9F3"/>
+                      </a:solidFill>
+                      <a:prstDash val="solid"/>
+                      <a:round/>
+                      <a:headEnd type="none" w="med" len="med"/>
+                      <a:tailEnd type="none" w="med" len="med"/>
+                    </a:lnR>
+                    <a:lnT w="12700" cap="flat" cmpd="sng" algn="ctr">
+                      <a:solidFill>
+                        <a:srgbClr val="E2D9F3"/>
+                      </a:solidFill>
+                      <a:prstDash val="solid"/>
+                      <a:round/>
+                      <a:headEnd type="none" w="med" len="med"/>
+                      <a:tailEnd type="none" w="med" len="med"/>
+                    </a:lnT>
+                    <a:lnB w="12700" cap="flat" cmpd="sng" algn="ctr">
+                      <a:solidFill>
+                        <a:srgbClr val="E2D9F3"/>
+                      </a:solidFill>
+                      <a:prstDash val="solid"/>
+                      <a:round/>
+                      <a:headEnd type="none" w="med" len="med"/>
+                      <a:tailEnd type="none" w="med" len="med"/>
+                    </a:lnB>
+                    <a:solidFill>
+                      <a:srgbClr val="F1ECF9"/>
+                    </a:solidFill>
+                  </a:tcPr>
+                </a:tc>
+                <a:tc>
+                  <a:txBody>
+                    <a:bodyPr/>
+                    <a:lstStyle/>
+                    <a:p>
+                      <a:pPr algn="l" indent="0" marL="0">
+                        <a:buNone/>
+                      </a:pPr>
+                      <a:r>
+                        <a:rPr lang="en-US" sz="1300" b="1" dirty="0">
+                          <a:solidFill>
+                            <a:srgbClr val="1F1A33"/>
+                          </a:solidFill>
+                          <a:latin typeface="Calibri" pitchFamily="34" charset="0"/>
+                          <a:ea typeface="Calibri" pitchFamily="34" charset="-122"/>
+                          <a:cs typeface="Calibri" pitchFamily="34" charset="-120"/>
+                        </a:rPr>
+                        <a:t>LBG-VQ + delta + Huffman</a:t>
                       </a:r>
                       <a:endParaRPr lang="en-US" sz="1300" dirty="0">
                         <a:latin typeface="Calibri" charset="0"/>
@@ -33360,6 +33769,74 @@
                     <a:bodyPr/>
                     <a:lstStyle/>
                     <a:p>
+                      <a:pPr algn="l" indent="0" marL="0">
+                        <a:buNone/>
+                      </a:pPr>
+                      <a:r>
+                        <a:rPr lang="en-US" sz="1300" dirty="0">
+                          <a:solidFill>
+                            <a:srgbClr val="1F1A33"/>
+                          </a:solidFill>
+                          <a:latin typeface="Calibri" pitchFamily="34" charset="0"/>
+                          <a:ea typeface="Calibri" pitchFamily="34" charset="-122"/>
+                          <a:cs typeface="Calibri" pitchFamily="34" charset="-120"/>
+                        </a:rPr>
+                        <a:t>FLBG (LBG with bilinear rescaling)</a:t>
+                      </a:r>
+                      <a:endParaRPr lang="en-US" sz="1300" dirty="0">
+                        <a:latin typeface="Calibri" charset="0"/>
+                        <a:ea typeface="Calibri" charset="0"/>
+                        <a:cs typeface="Calibri" charset="0"/>
+                      </a:endParaRPr>
+                    </a:p>
+                  </a:txBody>
+                  <a:tcPr marL="91440" marR="91440" marT="45720" marB="45720" anchor="ctr">
+                    <a:lnL w="12700" cap="flat" cmpd="sng" algn="ctr">
+                      <a:solidFill>
+                        <a:srgbClr val="E2D9F3"/>
+                      </a:solidFill>
+                      <a:prstDash val="solid"/>
+                      <a:round/>
+                      <a:headEnd type="none" w="med" len="med"/>
+                      <a:tailEnd type="none" w="med" len="med"/>
+                    </a:lnL>
+                    <a:lnR w="12700" cap="flat" cmpd="sng" algn="ctr">
+                      <a:solidFill>
+                        <a:srgbClr val="E2D9F3"/>
+                      </a:solidFill>
+                      <a:prstDash val="solid"/>
+                      <a:round/>
+                      <a:headEnd type="none" w="med" len="med"/>
+                      <a:tailEnd type="none" w="med" len="med"/>
+                    </a:lnR>
+                    <a:lnT w="12700" cap="flat" cmpd="sng" algn="ctr">
+                      <a:solidFill>
+                        <a:srgbClr val="E2D9F3"/>
+                      </a:solidFill>
+                      <a:prstDash val="solid"/>
+                      <a:round/>
+                      <a:headEnd type="none" w="med" len="med"/>
+                      <a:tailEnd type="none" w="med" len="med"/>
+                    </a:lnT>
+                    <a:lnB w="12700" cap="flat" cmpd="sng" algn="ctr">
+                      <a:solidFill>
+                        <a:srgbClr val="E2D9F3"/>
+                      </a:solidFill>
+                      <a:prstDash val="solid"/>
+                      <a:round/>
+                      <a:headEnd type="none" w="med" len="med"/>
+                      <a:tailEnd type="none" w="med" len="med"/>
+                    </a:lnB>
+                    <a:solidFill>
+                      <a:srgbClr val="FFFFFF"/>
+                    </a:solidFill>
+                  </a:tcPr>
+                </a:tc>
+                <a:tc>
+                  <a:txBody>
+                    <a:bodyPr/>
+                    <a:lstStyle/>
+                    <a:p>
                       <a:pPr algn="ctr" indent="0" marL="0">
                         <a:buNone/>
                       </a:pPr>
@@ -33625,6 +34102,74 @@
                           <a:cs typeface="Calibri" pitchFamily="34" charset="-120"/>
                         </a:rPr>
                         <a:t>This work</a:t>
+                      </a:r>
+                      <a:endParaRPr lang="en-US" sz="1300" dirty="0">
+                        <a:latin typeface="Calibri" charset="0"/>
+                        <a:ea typeface="Calibri" charset="0"/>
+                        <a:cs typeface="Calibri" charset="0"/>
+                      </a:endParaRPr>
+                    </a:p>
+                  </a:txBody>
+                  <a:tcPr marL="91440" marR="91440" marT="45720" marB="45720" anchor="ctr">
+                    <a:lnL w="12700" cap="flat" cmpd="sng" algn="ctr">
+                      <a:solidFill>
+                        <a:srgbClr val="E2D9F3"/>
+                      </a:solidFill>
+                      <a:prstDash val="solid"/>
+                      <a:round/>
+                      <a:headEnd type="none" w="med" len="med"/>
+                      <a:tailEnd type="none" w="med" len="med"/>
+                    </a:lnL>
+                    <a:lnR w="12700" cap="flat" cmpd="sng" algn="ctr">
+                      <a:solidFill>
+                        <a:srgbClr val="E2D9F3"/>
+                      </a:solidFill>
+                      <a:prstDash val="solid"/>
+                      <a:round/>
+                      <a:headEnd type="none" w="med" len="med"/>
+                      <a:tailEnd type="none" w="med" len="med"/>
+                    </a:lnR>
+                    <a:lnT w="12700" cap="flat" cmpd="sng" algn="ctr">
+                      <a:solidFill>
+                        <a:srgbClr val="E2D9F3"/>
+                      </a:solidFill>
+                      <a:prstDash val="solid"/>
+                      <a:round/>
+                      <a:headEnd type="none" w="med" len="med"/>
+                      <a:tailEnd type="none" w="med" len="med"/>
+                    </a:lnT>
+                    <a:lnB w="12700" cap="flat" cmpd="sng" algn="ctr">
+                      <a:solidFill>
+                        <a:srgbClr val="E2D9F3"/>
+                      </a:solidFill>
+                      <a:prstDash val="solid"/>
+                      <a:round/>
+                      <a:headEnd type="none" w="med" len="med"/>
+                      <a:tailEnd type="none" w="med" len="med"/>
+                    </a:lnB>
+                    <a:solidFill>
+                      <a:srgbClr val="F1ECF9"/>
+                    </a:solidFill>
+                  </a:tcPr>
+                </a:tc>
+                <a:tc>
+                  <a:txBody>
+                    <a:bodyPr/>
+                    <a:lstStyle/>
+                    <a:p>
+                      <a:pPr algn="l" indent="0" marL="0">
+                        <a:buNone/>
+                      </a:pPr>
+                      <a:r>
+                        <a:rPr lang="en-US" sz="1300" b="1" dirty="0">
+                          <a:solidFill>
+                            <a:srgbClr val="1F1A33"/>
+                          </a:solidFill>
+                          <a:latin typeface="Calibri" pitchFamily="34" charset="0"/>
+                          <a:ea typeface="Calibri" pitchFamily="34" charset="-122"/>
+                          <a:cs typeface="Calibri" pitchFamily="34" charset="-120"/>
+                        </a:rPr>
+                        <a:t>LBG-VQ + delta + Huffman</a:t>
                       </a:r>
                       <a:endParaRPr lang="en-US" sz="1300" dirty="0">
                         <a:latin typeface="Calibri" charset="0"/>

</xml_diff>

<commit_message>
Seminar: cheerful thank-you slide
Co-Authored-By: Claude Sonnet 5.5 <noreply@anthropic.com>
Claude-Session: https://claude.ai/code/session_01T6gEewJ8YaCdmnsfS34RJd
</commit_message>
<xml_diff>
--- a/results/seminar/figs/Seminar_Ibtihal_FINAL.pptx
+++ b/results/seminar/figs/Seminar_Ibtihal_FINAL.pptx
@@ -29706,7 +29706,7 @@
     <p:bg>
       <p:bgPr>
         <a:solidFill>
-          <a:srgbClr val="2E2055"/>
+          <a:srgbClr val="FFF8EE"/>
         </a:solidFill>
       </p:bgPr>
     </p:bg>
@@ -29739,11 +29739,11 @@
             <a:avLst/>
           </a:prstGeom>
           <a:solidFill>
-            <a:srgbClr val="2E2055"/>
+            <a:srgbClr val="FFF8EE"/>
           </a:solidFill>
           <a:ln w="12700">
             <a:solidFill>
-              <a:srgbClr val="2E2055"/>
+              <a:srgbClr val="FFF8EE"/>
             </a:solidFill>
             <a:prstDash val="solid"/>
           </a:ln>
@@ -29756,11 +29756,61 @@
           <p:nvPr/>
         </p:nvSpPr>
         <p:spPr>
-          <a:xfrm>
-            <a:off x="0" y="0"/>
-            <a:ext cx="320040" cy="6858000"/>
-          </a:xfrm>
-          <a:prstGeom prst="rect">
+          <a:xfrm rot="2880000">
+            <a:off x="4626864" y="429768"/>
+            <a:ext cx="438912" cy="438912"/>
+          </a:xfrm>
+          <a:prstGeom prst="triangle">
+            <a:avLst/>
+          </a:prstGeom>
+          <a:solidFill>
+            <a:srgbClr val="FFC93C"/>
+          </a:solidFill>
+          <a:ln w="12700">
+            <a:solidFill>
+              <a:srgbClr val="FFC93C"/>
+            </a:solidFill>
+            <a:prstDash val="solid"/>
+          </a:ln>
+        </p:spPr>
+      </p:sp>
+      <p:sp>
+        <p:nvSpPr>
+          <p:cNvPr id="4" name="Shape 2"/>
+          <p:cNvSpPr/>
+          <p:nvPr/>
+        </p:nvSpPr>
+        <p:spPr>
+          <a:xfrm rot="1800000">
+            <a:off x="978408" y="704088"/>
+            <a:ext cx="292608" cy="292608"/>
+          </a:xfrm>
+          <a:prstGeom prst="ellipse">
+            <a:avLst/>
+          </a:prstGeom>
+          <a:solidFill>
+            <a:srgbClr val="2A9D8F"/>
+          </a:solidFill>
+          <a:ln w="12700">
+            <a:solidFill>
+              <a:srgbClr val="2A9D8F"/>
+            </a:solidFill>
+            <a:prstDash val="solid"/>
+          </a:ln>
+        </p:spPr>
+      </p:sp>
+      <p:sp>
+        <p:nvSpPr>
+          <p:cNvPr id="5" name="Shape 3"/>
+          <p:cNvSpPr/>
+          <p:nvPr/>
+        </p:nvSpPr>
+        <p:spPr>
+          <a:xfrm rot="17100000">
+            <a:off x="4690872" y="6190488"/>
+            <a:ext cx="329184" cy="329184"/>
+          </a:xfrm>
+          <a:prstGeom prst="ellipse">
             <a:avLst/>
           </a:prstGeom>
           <a:solidFill>
@@ -29776,14 +29826,1139 @@
       </p:sp>
       <p:sp>
         <p:nvSpPr>
-          <p:cNvPr id="4" name="Text 2"/>
-          <p:cNvSpPr/>
-          <p:nvPr/>
-        </p:nvSpPr>
-        <p:spPr>
-          <a:xfrm>
-            <a:off x="822960" y="1554480"/>
-            <a:ext cx="5120640" cy="2011680"/>
+          <p:cNvPr id="6" name="Shape 4"/>
+          <p:cNvSpPr/>
+          <p:nvPr/>
+        </p:nvSpPr>
+        <p:spPr>
+          <a:xfrm rot="17160000">
+            <a:off x="1837944" y="877824"/>
+            <a:ext cx="246888" cy="246888"/>
+          </a:xfrm>
+          <a:prstGeom prst="rect">
+            <a:avLst/>
+          </a:prstGeom>
+          <a:solidFill>
+            <a:srgbClr val="F2993A"/>
+          </a:solidFill>
+          <a:ln w="12700">
+            <a:solidFill>
+              <a:srgbClr val="F2993A"/>
+            </a:solidFill>
+            <a:prstDash val="solid"/>
+          </a:ln>
+        </p:spPr>
+      </p:sp>
+      <p:sp>
+        <p:nvSpPr>
+          <p:cNvPr id="7" name="Shape 5"/>
+          <p:cNvSpPr/>
+          <p:nvPr/>
+        </p:nvSpPr>
+        <p:spPr>
+          <a:xfrm rot="16800000">
+            <a:off x="6757416" y="1325880"/>
+            <a:ext cx="192024" cy="192024"/>
+          </a:xfrm>
+          <a:prstGeom prst="rect">
+            <a:avLst/>
+          </a:prstGeom>
+          <a:solidFill>
+            <a:srgbClr val="E0457B"/>
+          </a:solidFill>
+          <a:ln w="12700">
+            <a:solidFill>
+              <a:srgbClr val="E0457B"/>
+            </a:solidFill>
+            <a:prstDash val="solid"/>
+          </a:ln>
+        </p:spPr>
+      </p:sp>
+      <p:sp>
+        <p:nvSpPr>
+          <p:cNvPr id="8" name="Shape 6"/>
+          <p:cNvSpPr/>
+          <p:nvPr/>
+        </p:nvSpPr>
+        <p:spPr>
+          <a:xfrm rot="2460000">
+            <a:off x="9281160" y="4526280"/>
+            <a:ext cx="256032" cy="256032"/>
+          </a:xfrm>
+          <a:prstGeom prst="triangle">
+            <a:avLst/>
+          </a:prstGeom>
+          <a:solidFill>
+            <a:srgbClr val="6B4FA3"/>
+          </a:solidFill>
+          <a:ln w="12700">
+            <a:solidFill>
+              <a:srgbClr val="6B4FA3"/>
+            </a:solidFill>
+            <a:prstDash val="solid"/>
+          </a:ln>
+        </p:spPr>
+      </p:sp>
+      <p:sp>
+        <p:nvSpPr>
+          <p:cNvPr id="9" name="Shape 7"/>
+          <p:cNvSpPr/>
+          <p:nvPr/>
+        </p:nvSpPr>
+        <p:spPr>
+          <a:xfrm rot="18660000">
+            <a:off x="10149840" y="4672584"/>
+            <a:ext cx="320040" cy="320040"/>
+          </a:xfrm>
+          <a:prstGeom prst="triangle">
+            <a:avLst/>
+          </a:prstGeom>
+          <a:solidFill>
+            <a:srgbClr val="F2993A"/>
+          </a:solidFill>
+          <a:ln w="12700">
+            <a:solidFill>
+              <a:srgbClr val="F2993A"/>
+            </a:solidFill>
+            <a:prstDash val="solid"/>
+          </a:ln>
+        </p:spPr>
+      </p:sp>
+      <p:sp>
+        <p:nvSpPr>
+          <p:cNvPr id="10" name="Shape 8"/>
+          <p:cNvSpPr/>
+          <p:nvPr/>
+        </p:nvSpPr>
+        <p:spPr>
+          <a:xfrm rot="12180000">
+            <a:off x="8951976" y="941832"/>
+            <a:ext cx="283464" cy="283464"/>
+          </a:xfrm>
+          <a:prstGeom prst="star5">
+            <a:avLst/>
+          </a:prstGeom>
+          <a:solidFill>
+            <a:srgbClr val="6B4FA3"/>
+          </a:solidFill>
+          <a:ln w="12700">
+            <a:solidFill>
+              <a:srgbClr val="6B4FA3"/>
+            </a:solidFill>
+            <a:prstDash val="solid"/>
+          </a:ln>
+        </p:spPr>
+      </p:sp>
+      <p:sp>
+        <p:nvSpPr>
+          <p:cNvPr id="11" name="Shape 9"/>
+          <p:cNvSpPr/>
+          <p:nvPr/>
+        </p:nvSpPr>
+        <p:spPr>
+          <a:xfrm rot="7080000">
+            <a:off x="11365992" y="4343400"/>
+            <a:ext cx="374904" cy="374904"/>
+          </a:xfrm>
+          <a:prstGeom prst="triangle">
+            <a:avLst/>
+          </a:prstGeom>
+          <a:solidFill>
+            <a:srgbClr val="2A9D8F"/>
+          </a:solidFill>
+          <a:ln w="12700">
+            <a:solidFill>
+              <a:srgbClr val="2A9D8F"/>
+            </a:solidFill>
+            <a:prstDash val="solid"/>
+          </a:ln>
+        </p:spPr>
+      </p:sp>
+      <p:sp>
+        <p:nvSpPr>
+          <p:cNvPr id="12" name="Shape 10"/>
+          <p:cNvSpPr/>
+          <p:nvPr/>
+        </p:nvSpPr>
+        <p:spPr>
+          <a:xfrm rot="780000">
+            <a:off x="6135624" y="1033272"/>
+            <a:ext cx="438912" cy="438912"/>
+          </a:xfrm>
+          <a:prstGeom prst="rect">
+            <a:avLst/>
+          </a:prstGeom>
+          <a:solidFill>
+            <a:srgbClr val="FFC93C"/>
+          </a:solidFill>
+          <a:ln w="12700">
+            <a:solidFill>
+              <a:srgbClr val="FFC93C"/>
+            </a:solidFill>
+            <a:prstDash val="solid"/>
+          </a:ln>
+        </p:spPr>
+      </p:sp>
+      <p:sp>
+        <p:nvSpPr>
+          <p:cNvPr id="13" name="Shape 11"/>
+          <p:cNvSpPr/>
+          <p:nvPr/>
+        </p:nvSpPr>
+        <p:spPr>
+          <a:xfrm rot="5580000">
+            <a:off x="6144768" y="256032"/>
+            <a:ext cx="320040" cy="320040"/>
+          </a:xfrm>
+          <a:prstGeom prst="rect">
+            <a:avLst/>
+          </a:prstGeom>
+          <a:solidFill>
+            <a:srgbClr val="2A9D8F"/>
+          </a:solidFill>
+          <a:ln w="12700">
+            <a:solidFill>
+              <a:srgbClr val="2A9D8F"/>
+            </a:solidFill>
+            <a:prstDash val="solid"/>
+          </a:ln>
+        </p:spPr>
+      </p:sp>
+      <p:sp>
+        <p:nvSpPr>
+          <p:cNvPr id="14" name="Shape 12"/>
+          <p:cNvSpPr/>
+          <p:nvPr/>
+        </p:nvSpPr>
+        <p:spPr>
+          <a:xfrm rot="19740000">
+            <a:off x="10332720" y="1088136"/>
+            <a:ext cx="393192" cy="393192"/>
+          </a:xfrm>
+          <a:prstGeom prst="triangle">
+            <a:avLst/>
+          </a:prstGeom>
+          <a:solidFill>
+            <a:srgbClr val="4DA3FF"/>
+          </a:solidFill>
+          <a:ln w="12700">
+            <a:solidFill>
+              <a:srgbClr val="4DA3FF"/>
+            </a:solidFill>
+            <a:prstDash val="solid"/>
+          </a:ln>
+        </p:spPr>
+      </p:sp>
+      <p:sp>
+        <p:nvSpPr>
+          <p:cNvPr id="15" name="Shape 13"/>
+          <p:cNvSpPr/>
+          <p:nvPr/>
+        </p:nvSpPr>
+        <p:spPr>
+          <a:xfrm rot="14040000">
+            <a:off x="8449056" y="256032"/>
+            <a:ext cx="256032" cy="256032"/>
+          </a:xfrm>
+          <a:prstGeom prst="triangle">
+            <a:avLst/>
+          </a:prstGeom>
+          <a:solidFill>
+            <a:srgbClr val="FFC93C"/>
+          </a:solidFill>
+          <a:ln w="12700">
+            <a:solidFill>
+              <a:srgbClr val="FFC93C"/>
+            </a:solidFill>
+            <a:prstDash val="solid"/>
+          </a:ln>
+        </p:spPr>
+      </p:sp>
+      <p:sp>
+        <p:nvSpPr>
+          <p:cNvPr id="16" name="Shape 14"/>
+          <p:cNvSpPr/>
+          <p:nvPr/>
+        </p:nvSpPr>
+        <p:spPr>
+          <a:xfrm rot="3180000">
+            <a:off x="914400" y="6263640"/>
+            <a:ext cx="310896" cy="310896"/>
+          </a:xfrm>
+          <a:prstGeom prst="triangle">
+            <a:avLst/>
+          </a:prstGeom>
+          <a:solidFill>
+            <a:srgbClr val="6B4FA3"/>
+          </a:solidFill>
+          <a:ln w="12700">
+            <a:solidFill>
+              <a:srgbClr val="6B4FA3"/>
+            </a:solidFill>
+            <a:prstDash val="solid"/>
+          </a:ln>
+        </p:spPr>
+      </p:sp>
+      <p:sp>
+        <p:nvSpPr>
+          <p:cNvPr id="17" name="Shape 15"/>
+          <p:cNvSpPr/>
+          <p:nvPr/>
+        </p:nvSpPr>
+        <p:spPr>
+          <a:xfrm rot="12780000">
+            <a:off x="1581912" y="210312"/>
+            <a:ext cx="237744" cy="237744"/>
+          </a:xfrm>
+          <a:prstGeom prst="ellipse">
+            <a:avLst/>
+          </a:prstGeom>
+          <a:solidFill>
+            <a:srgbClr val="FFC93C"/>
+          </a:solidFill>
+          <a:ln w="12700">
+            <a:solidFill>
+              <a:srgbClr val="FFC93C"/>
+            </a:solidFill>
+            <a:prstDash val="solid"/>
+          </a:ln>
+        </p:spPr>
+      </p:sp>
+      <p:sp>
+        <p:nvSpPr>
+          <p:cNvPr id="18" name="Shape 16"/>
+          <p:cNvSpPr/>
+          <p:nvPr/>
+        </p:nvSpPr>
+        <p:spPr>
+          <a:xfrm rot="1260000">
+            <a:off x="9592056" y="1051560"/>
+            <a:ext cx="192024" cy="192024"/>
+          </a:xfrm>
+          <a:prstGeom prst="ellipse">
+            <a:avLst/>
+          </a:prstGeom>
+          <a:solidFill>
+            <a:srgbClr val="FFC93C"/>
+          </a:solidFill>
+          <a:ln w="12700">
+            <a:solidFill>
+              <a:srgbClr val="FFC93C"/>
+            </a:solidFill>
+            <a:prstDash val="solid"/>
+          </a:ln>
+        </p:spPr>
+      </p:sp>
+      <p:sp>
+        <p:nvSpPr>
+          <p:cNvPr id="19" name="Shape 17"/>
+          <p:cNvSpPr/>
+          <p:nvPr/>
+        </p:nvSpPr>
+        <p:spPr>
+          <a:xfrm rot="15720000">
+            <a:off x="7470648" y="411480"/>
+            <a:ext cx="374904" cy="374904"/>
+          </a:xfrm>
+          <a:prstGeom prst="triangle">
+            <a:avLst/>
+          </a:prstGeom>
+          <a:solidFill>
+            <a:srgbClr val="4DA3FF"/>
+          </a:solidFill>
+          <a:ln w="12700">
+            <a:solidFill>
+              <a:srgbClr val="4DA3FF"/>
+            </a:solidFill>
+            <a:prstDash val="solid"/>
+          </a:ln>
+        </p:spPr>
+      </p:sp>
+      <p:sp>
+        <p:nvSpPr>
+          <p:cNvPr id="20" name="Shape 18"/>
+          <p:cNvSpPr/>
+          <p:nvPr/>
+        </p:nvSpPr>
+        <p:spPr>
+          <a:xfrm rot="19200000">
+            <a:off x="5340096" y="457200"/>
+            <a:ext cx="274320" cy="274320"/>
+          </a:xfrm>
+          <a:prstGeom prst="ellipse">
+            <a:avLst/>
+          </a:prstGeom>
+          <a:solidFill>
+            <a:srgbClr val="E0457B"/>
+          </a:solidFill>
+          <a:ln w="12700">
+            <a:solidFill>
+              <a:srgbClr val="E0457B"/>
+            </a:solidFill>
+            <a:prstDash val="solid"/>
+          </a:ln>
+        </p:spPr>
+      </p:sp>
+      <p:sp>
+        <p:nvSpPr>
+          <p:cNvPr id="21" name="Shape 19"/>
+          <p:cNvSpPr/>
+          <p:nvPr/>
+        </p:nvSpPr>
+        <p:spPr>
+          <a:xfrm rot="15420000">
+            <a:off x="219456" y="5111496"/>
+            <a:ext cx="310896" cy="310896"/>
+          </a:xfrm>
+          <a:prstGeom prst="rect">
+            <a:avLst/>
+          </a:prstGeom>
+          <a:solidFill>
+            <a:srgbClr val="4DA3FF"/>
+          </a:solidFill>
+          <a:ln w="12700">
+            <a:solidFill>
+              <a:srgbClr val="4DA3FF"/>
+            </a:solidFill>
+            <a:prstDash val="solid"/>
+          </a:ln>
+        </p:spPr>
+      </p:sp>
+      <p:sp>
+        <p:nvSpPr>
+          <p:cNvPr id="22" name="Shape 20"/>
+          <p:cNvSpPr/>
+          <p:nvPr/>
+        </p:nvSpPr>
+        <p:spPr>
+          <a:xfrm rot="12180000">
+            <a:off x="9729216" y="146304"/>
+            <a:ext cx="347472" cy="347472"/>
+          </a:xfrm>
+          <a:prstGeom prst="star5">
+            <a:avLst/>
+          </a:prstGeom>
+          <a:solidFill>
+            <a:srgbClr val="F2993A"/>
+          </a:solidFill>
+          <a:ln w="12700">
+            <a:solidFill>
+              <a:srgbClr val="F2993A"/>
+            </a:solidFill>
+            <a:prstDash val="solid"/>
+          </a:ln>
+        </p:spPr>
+      </p:sp>
+      <p:sp>
+        <p:nvSpPr>
+          <p:cNvPr id="23" name="Shape 21"/>
+          <p:cNvSpPr/>
+          <p:nvPr/>
+        </p:nvSpPr>
+        <p:spPr>
+          <a:xfrm rot="8880000">
+            <a:off x="2386584" y="210312"/>
+            <a:ext cx="438912" cy="438912"/>
+          </a:xfrm>
+          <a:prstGeom prst="ellipse">
+            <a:avLst/>
+          </a:prstGeom>
+          <a:solidFill>
+            <a:srgbClr val="4DA3FF"/>
+          </a:solidFill>
+          <a:ln w="12700">
+            <a:solidFill>
+              <a:srgbClr val="4DA3FF"/>
+            </a:solidFill>
+            <a:prstDash val="solid"/>
+          </a:ln>
+        </p:spPr>
+      </p:sp>
+      <p:sp>
+        <p:nvSpPr>
+          <p:cNvPr id="24" name="Shape 22"/>
+          <p:cNvSpPr/>
+          <p:nvPr/>
+        </p:nvSpPr>
+        <p:spPr>
+          <a:xfrm rot="4620000">
+            <a:off x="2971800" y="795528"/>
+            <a:ext cx="493776" cy="493776"/>
+          </a:xfrm>
+          <a:prstGeom prst="star5">
+            <a:avLst/>
+          </a:prstGeom>
+          <a:solidFill>
+            <a:srgbClr val="6B4FA3"/>
+          </a:solidFill>
+          <a:ln w="12700">
+            <a:solidFill>
+              <a:srgbClr val="6B4FA3"/>
+            </a:solidFill>
+            <a:prstDash val="solid"/>
+          </a:ln>
+        </p:spPr>
+      </p:sp>
+      <p:sp>
+        <p:nvSpPr>
+          <p:cNvPr id="25" name="Shape 23"/>
+          <p:cNvSpPr/>
+          <p:nvPr/>
+        </p:nvSpPr>
+        <p:spPr>
+          <a:xfrm rot="7140000">
+            <a:off x="9043416" y="146304"/>
+            <a:ext cx="292608" cy="292608"/>
+          </a:xfrm>
+          <a:prstGeom prst="star5">
+            <a:avLst/>
+          </a:prstGeom>
+          <a:solidFill>
+            <a:srgbClr val="6B4FA3"/>
+          </a:solidFill>
+          <a:ln w="12700">
+            <a:solidFill>
+              <a:srgbClr val="6B4FA3"/>
+            </a:solidFill>
+            <a:prstDash val="solid"/>
+          </a:ln>
+        </p:spPr>
+      </p:sp>
+      <p:sp>
+        <p:nvSpPr>
+          <p:cNvPr id="26" name="Shape 24"/>
+          <p:cNvSpPr/>
+          <p:nvPr/>
+        </p:nvSpPr>
+        <p:spPr>
+          <a:xfrm rot="16200000">
+            <a:off x="3630168" y="932688"/>
+            <a:ext cx="356616" cy="356616"/>
+          </a:xfrm>
+          <a:prstGeom prst="ellipse">
+            <a:avLst/>
+          </a:prstGeom>
+          <a:solidFill>
+            <a:srgbClr val="F2993A"/>
+          </a:solidFill>
+          <a:ln w="12700">
+            <a:solidFill>
+              <a:srgbClr val="F2993A"/>
+            </a:solidFill>
+            <a:prstDash val="solid"/>
+          </a:ln>
+        </p:spPr>
+      </p:sp>
+      <p:sp>
+        <p:nvSpPr>
+          <p:cNvPr id="27" name="Shape 25"/>
+          <p:cNvSpPr/>
+          <p:nvPr/>
+        </p:nvSpPr>
+        <p:spPr>
+          <a:xfrm rot="7560000">
+            <a:off x="10442448" y="329184"/>
+            <a:ext cx="274320" cy="274320"/>
+          </a:xfrm>
+          <a:prstGeom prst="triangle">
+            <a:avLst/>
+          </a:prstGeom>
+          <a:solidFill>
+            <a:srgbClr val="2A9D8F"/>
+          </a:solidFill>
+          <a:ln w="12700">
+            <a:solidFill>
+              <a:srgbClr val="2A9D8F"/>
+            </a:solidFill>
+            <a:prstDash val="solid"/>
+          </a:ln>
+        </p:spPr>
+      </p:sp>
+      <p:sp>
+        <p:nvSpPr>
+          <p:cNvPr id="28" name="Shape 26"/>
+          <p:cNvSpPr/>
+          <p:nvPr/>
+        </p:nvSpPr>
+        <p:spPr>
+          <a:xfrm rot="17220000">
+            <a:off x="3200400" y="210312"/>
+            <a:ext cx="283464" cy="283464"/>
+          </a:xfrm>
+          <a:prstGeom prst="triangle">
+            <a:avLst/>
+          </a:prstGeom>
+          <a:solidFill>
+            <a:srgbClr val="4DA3FF"/>
+          </a:solidFill>
+          <a:ln w="12700">
+            <a:solidFill>
+              <a:srgbClr val="4DA3FF"/>
+            </a:solidFill>
+            <a:prstDash val="solid"/>
+          </a:ln>
+        </p:spPr>
+      </p:sp>
+      <p:sp>
+        <p:nvSpPr>
+          <p:cNvPr id="29" name="Shape 27"/>
+          <p:cNvSpPr/>
+          <p:nvPr/>
+        </p:nvSpPr>
+        <p:spPr>
+          <a:xfrm rot="7980000">
+            <a:off x="7662672" y="1234440"/>
+            <a:ext cx="292608" cy="292608"/>
+          </a:xfrm>
+          <a:prstGeom prst="star5">
+            <a:avLst/>
+          </a:prstGeom>
+          <a:solidFill>
+            <a:srgbClr val="E0457B"/>
+          </a:solidFill>
+          <a:ln w="12700">
+            <a:solidFill>
+              <a:srgbClr val="E0457B"/>
+            </a:solidFill>
+            <a:prstDash val="solid"/>
+          </a:ln>
+        </p:spPr>
+      </p:sp>
+      <p:sp>
+        <p:nvSpPr>
+          <p:cNvPr id="30" name="Shape 28"/>
+          <p:cNvSpPr/>
+          <p:nvPr/>
+        </p:nvSpPr>
+        <p:spPr>
+          <a:xfrm rot="3240000">
+            <a:off x="8714232" y="4489704"/>
+            <a:ext cx="420624" cy="420624"/>
+          </a:xfrm>
+          <a:prstGeom prst="ellipse">
+            <a:avLst/>
+          </a:prstGeom>
+          <a:solidFill>
+            <a:srgbClr val="2A9D8F"/>
+          </a:solidFill>
+          <a:ln w="12700">
+            <a:solidFill>
+              <a:srgbClr val="2A9D8F"/>
+            </a:solidFill>
+            <a:prstDash val="solid"/>
+          </a:ln>
+        </p:spPr>
+      </p:sp>
+      <p:sp>
+        <p:nvSpPr>
+          <p:cNvPr id="31" name="Shape 29"/>
+          <p:cNvSpPr/>
+          <p:nvPr/>
+        </p:nvSpPr>
+        <p:spPr>
+          <a:xfrm rot="12240000">
+            <a:off x="8211312" y="5769864"/>
+            <a:ext cx="237744" cy="237744"/>
+          </a:xfrm>
+          <a:prstGeom prst="triangle">
+            <a:avLst/>
+          </a:prstGeom>
+          <a:solidFill>
+            <a:srgbClr val="6B4FA3"/>
+          </a:solidFill>
+          <a:ln w="12700">
+            <a:solidFill>
+              <a:srgbClr val="6B4FA3"/>
+            </a:solidFill>
+            <a:prstDash val="solid"/>
+          </a:ln>
+        </p:spPr>
+      </p:sp>
+      <p:sp>
+        <p:nvSpPr>
+          <p:cNvPr id="32" name="Shape 30"/>
+          <p:cNvSpPr/>
+          <p:nvPr/>
+        </p:nvSpPr>
+        <p:spPr>
+          <a:xfrm rot="2640000">
+            <a:off x="8375904" y="941832"/>
+            <a:ext cx="219456" cy="219456"/>
+          </a:xfrm>
+          <a:prstGeom prst="triangle">
+            <a:avLst/>
+          </a:prstGeom>
+          <a:solidFill>
+            <a:srgbClr val="4DA3FF"/>
+          </a:solidFill>
+          <a:ln w="12700">
+            <a:solidFill>
+              <a:srgbClr val="4DA3FF"/>
+            </a:solidFill>
+            <a:prstDash val="solid"/>
+          </a:ln>
+        </p:spPr>
+      </p:sp>
+      <p:sp>
+        <p:nvSpPr>
+          <p:cNvPr id="33" name="Shape 31"/>
+          <p:cNvSpPr/>
+          <p:nvPr/>
+        </p:nvSpPr>
+        <p:spPr>
+          <a:xfrm rot="4740000">
+            <a:off x="6922008" y="6272784"/>
+            <a:ext cx="365760" cy="365760"/>
+          </a:xfrm>
+          <a:prstGeom prst="ellipse">
+            <a:avLst/>
+          </a:prstGeom>
+          <a:solidFill>
+            <a:srgbClr val="4DA3FF"/>
+          </a:solidFill>
+          <a:ln w="12700">
+            <a:solidFill>
+              <a:srgbClr val="4DA3FF"/>
+            </a:solidFill>
+            <a:prstDash val="solid"/>
+          </a:ln>
+        </p:spPr>
+      </p:sp>
+      <p:sp>
+        <p:nvSpPr>
+          <p:cNvPr id="34" name="Shape 32"/>
+          <p:cNvSpPr/>
+          <p:nvPr/>
+        </p:nvSpPr>
+        <p:spPr>
+          <a:xfrm rot="6660000">
+            <a:off x="7909560" y="6419088"/>
+            <a:ext cx="164592" cy="164592"/>
+          </a:xfrm>
+          <a:prstGeom prst="ellipse">
+            <a:avLst/>
+          </a:prstGeom>
+          <a:solidFill>
+            <a:srgbClr val="E0457B"/>
+          </a:solidFill>
+          <a:ln w="12700">
+            <a:solidFill>
+              <a:srgbClr val="E0457B"/>
+            </a:solidFill>
+            <a:prstDash val="solid"/>
+          </a:ln>
+        </p:spPr>
+      </p:sp>
+      <p:sp>
+        <p:nvSpPr>
+          <p:cNvPr id="35" name="Shape 33"/>
+          <p:cNvSpPr/>
+          <p:nvPr/>
+        </p:nvSpPr>
+        <p:spPr>
+          <a:xfrm rot="14100000">
+            <a:off x="6793992" y="192024"/>
+            <a:ext cx="438912" cy="438912"/>
+          </a:xfrm>
+          <a:prstGeom prst="rect">
+            <a:avLst/>
+          </a:prstGeom>
+          <a:solidFill>
+            <a:srgbClr val="2A9D8F"/>
+          </a:solidFill>
+          <a:ln w="12700">
+            <a:solidFill>
+              <a:srgbClr val="2A9D8F"/>
+            </a:solidFill>
+            <a:prstDash val="solid"/>
+          </a:ln>
+        </p:spPr>
+      </p:sp>
+      <p:sp>
+        <p:nvSpPr>
+          <p:cNvPr id="36" name="Shape 34"/>
+          <p:cNvSpPr/>
+          <p:nvPr/>
+        </p:nvSpPr>
+        <p:spPr>
+          <a:xfrm rot="2520000">
+            <a:off x="4005072" y="6227064"/>
+            <a:ext cx="411480" cy="411480"/>
+          </a:xfrm>
+          <a:prstGeom prst="triangle">
+            <a:avLst/>
+          </a:prstGeom>
+          <a:solidFill>
+            <a:srgbClr val="2A9D8F"/>
+          </a:solidFill>
+          <a:ln w="12700">
+            <a:solidFill>
+              <a:srgbClr val="2A9D8F"/>
+            </a:solidFill>
+            <a:prstDash val="solid"/>
+          </a:ln>
+        </p:spPr>
+      </p:sp>
+      <p:sp>
+        <p:nvSpPr>
+          <p:cNvPr id="37" name="Shape 35"/>
+          <p:cNvSpPr/>
+          <p:nvPr/>
+        </p:nvSpPr>
+        <p:spPr>
+          <a:xfrm rot="480000">
+            <a:off x="11237976" y="1024128"/>
+            <a:ext cx="411480" cy="411480"/>
+          </a:xfrm>
+          <a:prstGeom prst="ellipse">
+            <a:avLst/>
+          </a:prstGeom>
+          <a:solidFill>
+            <a:srgbClr val="4DA3FF"/>
+          </a:solidFill>
+          <a:ln w="12700">
+            <a:solidFill>
+              <a:srgbClr val="4DA3FF"/>
+            </a:solidFill>
+            <a:prstDash val="solid"/>
+          </a:ln>
+        </p:spPr>
+      </p:sp>
+      <p:sp>
+        <p:nvSpPr>
+          <p:cNvPr id="38" name="Shape 36"/>
+          <p:cNvSpPr/>
+          <p:nvPr/>
+        </p:nvSpPr>
+        <p:spPr>
+          <a:xfrm rot="2100000">
+            <a:off x="310896" y="804672"/>
+            <a:ext cx="429768" cy="429768"/>
+          </a:xfrm>
+          <a:prstGeom prst="star5">
+            <a:avLst/>
+          </a:prstGeom>
+          <a:solidFill>
+            <a:srgbClr val="6B4FA3"/>
+          </a:solidFill>
+          <a:ln w="12700">
+            <a:solidFill>
+              <a:srgbClr val="6B4FA3"/>
+            </a:solidFill>
+            <a:prstDash val="solid"/>
+          </a:ln>
+        </p:spPr>
+      </p:sp>
+      <p:sp>
+        <p:nvSpPr>
+          <p:cNvPr id="39" name="Shape 37"/>
+          <p:cNvSpPr/>
+          <p:nvPr/>
+        </p:nvSpPr>
+        <p:spPr>
+          <a:xfrm rot="16980000">
+            <a:off x="301752" y="155448"/>
+            <a:ext cx="365760" cy="365760"/>
+          </a:xfrm>
+          <a:prstGeom prst="ellipse">
+            <a:avLst/>
+          </a:prstGeom>
+          <a:solidFill>
+            <a:srgbClr val="4DA3FF"/>
+          </a:solidFill>
+          <a:ln w="12700">
+            <a:solidFill>
+              <a:srgbClr val="4DA3FF"/>
+            </a:solidFill>
+            <a:prstDash val="solid"/>
+          </a:ln>
+        </p:spPr>
+      </p:sp>
+      <p:sp>
+        <p:nvSpPr>
+          <p:cNvPr id="40" name="Shape 38"/>
+          <p:cNvSpPr/>
+          <p:nvPr/>
+        </p:nvSpPr>
+        <p:spPr>
+          <a:xfrm rot="2520000">
+            <a:off x="5586984" y="6373368"/>
+            <a:ext cx="173736" cy="173736"/>
+          </a:xfrm>
+          <a:prstGeom prst="ellipse">
+            <a:avLst/>
+          </a:prstGeom>
+          <a:solidFill>
+            <a:srgbClr val="2A9D8F"/>
+          </a:solidFill>
+          <a:ln w="12700">
+            <a:solidFill>
+              <a:srgbClr val="2A9D8F"/>
+            </a:solidFill>
+            <a:prstDash val="solid"/>
+          </a:ln>
+        </p:spPr>
+      </p:sp>
+      <p:sp>
+        <p:nvSpPr>
+          <p:cNvPr id="41" name="Shape 39"/>
+          <p:cNvSpPr/>
+          <p:nvPr/>
+        </p:nvSpPr>
+        <p:spPr>
+          <a:xfrm rot="4500000">
+            <a:off x="210312" y="1527048"/>
+            <a:ext cx="320040" cy="320040"/>
+          </a:xfrm>
+          <a:prstGeom prst="rect">
+            <a:avLst/>
+          </a:prstGeom>
+          <a:solidFill>
+            <a:srgbClr val="FFC93C"/>
+          </a:solidFill>
+          <a:ln w="12700">
+            <a:solidFill>
+              <a:srgbClr val="FFC93C"/>
+            </a:solidFill>
+            <a:prstDash val="solid"/>
+          </a:ln>
+        </p:spPr>
+      </p:sp>
+      <p:sp>
+        <p:nvSpPr>
+          <p:cNvPr id="42" name="Shape 40"/>
+          <p:cNvSpPr/>
+          <p:nvPr/>
+        </p:nvSpPr>
+        <p:spPr>
+          <a:xfrm rot="2220000">
+            <a:off x="2642616" y="6208776"/>
+            <a:ext cx="265176" cy="265176"/>
+          </a:xfrm>
+          <a:prstGeom prst="ellipse">
+            <a:avLst/>
+          </a:prstGeom>
+          <a:solidFill>
+            <a:srgbClr val="6B4FA3"/>
+          </a:solidFill>
+          <a:ln w="12700">
+            <a:solidFill>
+              <a:srgbClr val="6B4FA3"/>
+            </a:solidFill>
+            <a:prstDash val="solid"/>
+          </a:ln>
+        </p:spPr>
+      </p:sp>
+      <p:sp>
+        <p:nvSpPr>
+          <p:cNvPr id="43" name="Shape 41"/>
+          <p:cNvSpPr/>
+          <p:nvPr/>
+        </p:nvSpPr>
+        <p:spPr>
+          <a:xfrm rot="1320000">
+            <a:off x="4800600" y="1115568"/>
+            <a:ext cx="393192" cy="393192"/>
+          </a:xfrm>
+          <a:prstGeom prst="star5">
+            <a:avLst/>
+          </a:prstGeom>
+          <a:solidFill>
+            <a:srgbClr val="F2993A"/>
+          </a:solidFill>
+          <a:ln w="12700">
+            <a:solidFill>
+              <a:srgbClr val="F2993A"/>
+            </a:solidFill>
+            <a:prstDash val="solid"/>
+          </a:ln>
+        </p:spPr>
+      </p:sp>
+      <p:sp>
+        <p:nvSpPr>
+          <p:cNvPr id="44" name="Shape 42"/>
+          <p:cNvSpPr/>
+          <p:nvPr/>
+        </p:nvSpPr>
+        <p:spPr>
+          <a:xfrm rot="16080000">
+            <a:off x="1682496" y="6391656"/>
+            <a:ext cx="283464" cy="283464"/>
+          </a:xfrm>
+          <a:prstGeom prst="star5">
+            <a:avLst/>
+          </a:prstGeom>
+          <a:solidFill>
+            <a:srgbClr val="6B4FA3"/>
+          </a:solidFill>
+          <a:ln w="12700">
+            <a:solidFill>
+              <a:srgbClr val="6B4FA3"/>
+            </a:solidFill>
+            <a:prstDash val="solid"/>
+          </a:ln>
+        </p:spPr>
+      </p:sp>
+      <p:sp>
+        <p:nvSpPr>
+          <p:cNvPr id="45" name="Shape 43"/>
+          <p:cNvSpPr/>
+          <p:nvPr/>
+        </p:nvSpPr>
+        <p:spPr>
+          <a:xfrm rot="1680000">
+            <a:off x="4005072" y="210312"/>
+            <a:ext cx="320040" cy="320040"/>
+          </a:xfrm>
+          <a:prstGeom prst="star5">
+            <a:avLst/>
+          </a:prstGeom>
+          <a:solidFill>
+            <a:srgbClr val="E0457B"/>
+          </a:solidFill>
+          <a:ln w="12700">
+            <a:solidFill>
+              <a:srgbClr val="E0457B"/>
+            </a:solidFill>
+            <a:prstDash val="solid"/>
+          </a:ln>
+        </p:spPr>
+      </p:sp>
+      <p:sp>
+        <p:nvSpPr>
+          <p:cNvPr id="46" name="Shape 44"/>
+          <p:cNvSpPr/>
+          <p:nvPr/>
+        </p:nvSpPr>
+        <p:spPr>
+          <a:xfrm rot="10620000">
+            <a:off x="5541264" y="1143000"/>
+            <a:ext cx="246888" cy="246888"/>
+          </a:xfrm>
+          <a:prstGeom prst="rect">
+            <a:avLst/>
+          </a:prstGeom>
+          <a:solidFill>
+            <a:srgbClr val="2A9D8F"/>
+          </a:solidFill>
+          <a:ln w="12700">
+            <a:solidFill>
+              <a:srgbClr val="2A9D8F"/>
+            </a:solidFill>
+            <a:prstDash val="solid"/>
+          </a:ln>
+        </p:spPr>
+      </p:sp>
+      <p:sp>
+        <p:nvSpPr>
+          <p:cNvPr id="47" name="Shape 45"/>
+          <p:cNvSpPr/>
+          <p:nvPr/>
+        </p:nvSpPr>
+        <p:spPr>
+          <a:xfrm rot="9780000">
+            <a:off x="11338560" y="301752"/>
+            <a:ext cx="374904" cy="374904"/>
+          </a:xfrm>
+          <a:prstGeom prst="rect">
+            <a:avLst/>
+          </a:prstGeom>
+          <a:solidFill>
+            <a:srgbClr val="F2993A"/>
+          </a:solidFill>
+          <a:ln w="12700">
+            <a:solidFill>
+              <a:srgbClr val="F2993A"/>
+            </a:solidFill>
+            <a:prstDash val="solid"/>
+          </a:ln>
+        </p:spPr>
+      </p:sp>
+      <p:sp>
+        <p:nvSpPr>
+          <p:cNvPr id="48" name="Shape 46"/>
+          <p:cNvSpPr/>
+          <p:nvPr/>
+        </p:nvSpPr>
+        <p:spPr>
+          <a:xfrm rot="19500000">
+            <a:off x="3282696" y="6208776"/>
+            <a:ext cx="292608" cy="292608"/>
+          </a:xfrm>
+          <a:prstGeom prst="star5">
+            <a:avLst/>
+          </a:prstGeom>
+          <a:solidFill>
+            <a:srgbClr val="F2993A"/>
+          </a:solidFill>
+          <a:ln w="12700">
+            <a:solidFill>
+              <a:srgbClr val="F2993A"/>
+            </a:solidFill>
+            <a:prstDash val="solid"/>
+          </a:ln>
+        </p:spPr>
+      </p:sp>
+      <p:sp>
+        <p:nvSpPr>
+          <p:cNvPr id="49" name="Shape 47"/>
+          <p:cNvSpPr/>
+          <p:nvPr/>
+        </p:nvSpPr>
+        <p:spPr>
+          <a:xfrm rot="16260000">
+            <a:off x="338328" y="3090672"/>
+            <a:ext cx="173736" cy="173736"/>
+          </a:xfrm>
+          <a:prstGeom prst="rect">
+            <a:avLst/>
+          </a:prstGeom>
+          <a:solidFill>
+            <a:srgbClr val="E0457B"/>
+          </a:solidFill>
+          <a:ln w="12700">
+            <a:solidFill>
+              <a:srgbClr val="E0457B"/>
+            </a:solidFill>
+            <a:prstDash val="solid"/>
+          </a:ln>
+        </p:spPr>
+      </p:sp>
+      <p:sp>
+        <p:nvSpPr>
+          <p:cNvPr id="50" name="Shape 48"/>
+          <p:cNvSpPr/>
+          <p:nvPr/>
+        </p:nvSpPr>
+        <p:spPr>
+          <a:xfrm rot="14640000">
+            <a:off x="10725912" y="4745736"/>
+            <a:ext cx="192024" cy="192024"/>
+          </a:xfrm>
+          <a:prstGeom prst="rect">
+            <a:avLst/>
+          </a:prstGeom>
+          <a:solidFill>
+            <a:srgbClr val="4DA3FF"/>
+          </a:solidFill>
+          <a:ln w="12700">
+            <a:solidFill>
+              <a:srgbClr val="4DA3FF"/>
+            </a:solidFill>
+            <a:prstDash val="solid"/>
+          </a:ln>
+        </p:spPr>
+      </p:sp>
+      <p:sp>
+        <p:nvSpPr>
+          <p:cNvPr id="51" name="Text 49"/>
+          <p:cNvSpPr/>
+          <p:nvPr/>
+        </p:nvSpPr>
+        <p:spPr>
+          <a:xfrm>
+            <a:off x="731520" y="1691640"/>
+            <a:ext cx="10698480" cy="1737360"/>
           </a:xfrm>
           <a:prstGeom prst="rect">
             <a:avLst/>
@@ -29795,34 +30970,48 @@
           <a:bodyPr wrap="square" lIns="0" tIns="0" rIns="0" bIns="0" rtlCol="0" anchor="ctr"/>
           <a:lstStyle/>
           <a:p>
-            <a:pPr indent="0" marL="0">
+            <a:pPr algn="ctr" indent="0" marL="0">
               <a:buNone/>
             </a:pPr>
             <a:r>
-              <a:rPr lang="en-US" sz="4400" b="1" dirty="0">
+              <a:rPr lang="en-US" sz="8800" b="1" dirty="0">
                 <a:solidFill>
-                  <a:srgbClr val="FFFFFF"/>
+                  <a:srgbClr val="6B4FA3"/>
                 </a:solidFill>
                 <a:latin typeface="Cambria" pitchFamily="34" charset="0"/>
                 <a:ea typeface="Cambria" pitchFamily="34" charset="-122"/>
                 <a:cs typeface="Cambria" pitchFamily="34" charset="-120"/>
               </a:rPr>
-              <a:t>Thank you for your attention</a:t>
-            </a:r>
-            <a:endParaRPr lang="en-US" sz="4400" dirty="0"/>
+              <a:t>Thank </a:t>
+            </a:r>
+            <a:pPr algn="ctr" indent="0" marL="0">
+              <a:buNone/>
+            </a:pPr>
+            <a:r>
+              <a:rPr lang="en-US" sz="8800" b="1" dirty="0">
+                <a:solidFill>
+                  <a:srgbClr val="E0457B"/>
+                </a:solidFill>
+                <a:latin typeface="Cambria" pitchFamily="34" charset="0"/>
+                <a:ea typeface="Cambria" pitchFamily="34" charset="-122"/>
+                <a:cs typeface="Cambria" pitchFamily="34" charset="-120"/>
+              </a:rPr>
+              <a:t>You!</a:t>
+            </a:r>
+            <a:endParaRPr lang="en-US" sz="8800" dirty="0"/>
           </a:p>
         </p:txBody>
       </p:sp>
       <p:sp>
         <p:nvSpPr>
-          <p:cNvPr id="5" name="Text 3"/>
-          <p:cNvSpPr/>
-          <p:nvPr/>
-        </p:nvSpPr>
-        <p:spPr>
-          <a:xfrm>
-            <a:off x="822960" y="3657600"/>
-            <a:ext cx="5120640" cy="731520"/>
+          <p:cNvPr id="52" name="Text 50"/>
+          <p:cNvSpPr/>
+          <p:nvPr/>
+        </p:nvSpPr>
+        <p:spPr>
+          <a:xfrm>
+            <a:off x="731520" y="3429000"/>
+            <a:ext cx="10698480" cy="731520"/>
           </a:xfrm>
           <a:prstGeom prst="rect">
             <a:avLst/>
@@ -29834,11 +31023,11 @@
           <a:bodyPr wrap="square" lIns="0" tIns="0" rIns="0" bIns="0" rtlCol="0" anchor="ctr"/>
           <a:lstStyle/>
           <a:p>
-            <a:pPr indent="0" marL="0">
+            <a:pPr algn="ctr" indent="0" marL="0">
               <a:buNone/>
             </a:pPr>
             <a:r>
-              <a:rPr lang="en-US" sz="3200" b="1" dirty="0">
+              <a:rPr lang="en-US" sz="3600" b="1" dirty="0">
                 <a:solidFill>
                   <a:srgbClr val="F2993A"/>
                 </a:solidFill>
@@ -29846,22 +31035,99 @@
                 <a:ea typeface="Calibri" pitchFamily="34" charset="-122"/>
                 <a:cs typeface="Calibri" pitchFamily="34" charset="-120"/>
               </a:rPr>
-              <a:t>Questions?</a:t>
-            </a:r>
-            <a:endParaRPr lang="en-US" sz="3200" dirty="0"/>
+              <a:t>for your attention</a:t>
+            </a:r>
+            <a:endParaRPr lang="en-US" sz="3600" dirty="0"/>
           </a:p>
         </p:txBody>
       </p:sp>
       <p:sp>
         <p:nvSpPr>
-          <p:cNvPr id="6" name="Text 4"/>
-          <p:cNvSpPr/>
-          <p:nvPr/>
-        </p:nvSpPr>
-        <p:spPr>
-          <a:xfrm>
-            <a:off x="822960" y="4937760"/>
-            <a:ext cx="5120640" cy="914400"/>
+          <p:cNvPr id="53" name="Shape 51"/>
+          <p:cNvSpPr/>
+          <p:nvPr/>
+        </p:nvSpPr>
+        <p:spPr>
+          <a:xfrm>
+            <a:off x="1097280" y="4617720"/>
+            <a:ext cx="1463040" cy="1463040"/>
+          </a:xfrm>
+          <a:prstGeom prst="smileyFace">
+            <a:avLst/>
+          </a:prstGeom>
+          <a:solidFill>
+            <a:srgbClr val="FFC93C"/>
+          </a:solidFill>
+          <a:ln w="38100">
+            <a:solidFill>
+              <a:srgbClr val="2E2055"/>
+            </a:solidFill>
+            <a:prstDash val="solid"/>
+          </a:ln>
+        </p:spPr>
+      </p:sp>
+      <p:sp>
+        <p:nvSpPr>
+          <p:cNvPr id="54" name="Shape 52"/>
+          <p:cNvSpPr/>
+          <p:nvPr/>
+        </p:nvSpPr>
+        <p:spPr>
+          <a:xfrm>
+            <a:off x="2926080" y="4800600"/>
+            <a:ext cx="5120640" cy="1097280"/>
+          </a:xfrm>
+          <a:prstGeom prst="roundRect">
+            <a:avLst>
+              <a:gd name="adj" fmla="val 25000"/>
+            </a:avLst>
+          </a:prstGeom>
+          <a:solidFill>
+            <a:srgbClr val="E0457B"/>
+          </a:solidFill>
+          <a:ln w="12700">
+            <a:solidFill>
+              <a:srgbClr val="E0457B"/>
+            </a:solidFill>
+            <a:prstDash val="solid"/>
+          </a:ln>
+        </p:spPr>
+      </p:sp>
+      <p:sp>
+        <p:nvSpPr>
+          <p:cNvPr id="55" name="Shape 53"/>
+          <p:cNvSpPr/>
+          <p:nvPr/>
+        </p:nvSpPr>
+        <p:spPr>
+          <a:xfrm rot="16200000">
+            <a:off x="2606040" y="5166360"/>
+            <a:ext cx="411480" cy="365760"/>
+          </a:xfrm>
+          <a:prstGeom prst="triangle">
+            <a:avLst/>
+          </a:prstGeom>
+          <a:solidFill>
+            <a:srgbClr val="E0457B"/>
+          </a:solidFill>
+          <a:ln w="12700">
+            <a:solidFill>
+              <a:srgbClr val="E0457B"/>
+            </a:solidFill>
+            <a:prstDash val="solid"/>
+          </a:ln>
+        </p:spPr>
+      </p:sp>
+      <p:sp>
+        <p:nvSpPr>
+          <p:cNvPr id="56" name="Text 54"/>
+          <p:cNvSpPr/>
+          <p:nvPr/>
+        </p:nvSpPr>
+        <p:spPr>
+          <a:xfrm>
+            <a:off x="2926080" y="4800600"/>
+            <a:ext cx="5120640" cy="1097280"/>
           </a:xfrm>
           <a:prstGeom prst="rect">
             <a:avLst/>
@@ -29873,14 +31139,11 @@
           <a:bodyPr wrap="square" lIns="0" tIns="0" rIns="0" bIns="0" rtlCol="0" anchor="ctr"/>
           <a:lstStyle/>
           <a:p>
-            <a:pPr indent="0" marL="0">
-              <a:spcAft>
-                <a:spcPts val="600"/>
-              </a:spcAft>
+            <a:pPr algn="ctr" indent="0" marL="0">
               <a:buNone/>
             </a:pPr>
             <a:r>
-              <a:rPr lang="en-US" sz="2000" b="1" dirty="0">
+              <a:rPr lang="en-US" sz="3600" b="1" dirty="0">
                 <a:solidFill>
                   <a:srgbClr val="FFFFFF"/>
                 </a:solidFill>
@@ -29888,21 +31151,63 @@
                 <a:ea typeface="Calibri" pitchFamily="34" charset="-122"/>
                 <a:cs typeface="Calibri" pitchFamily="34" charset="-120"/>
               </a:rPr>
-              <a:t>MSc. Student Ibtihal Hussien</a:t>
-            </a:r>
-            <a:endParaRPr lang="en-US" sz="2000" dirty="0"/>
-          </a:p>
-          <a:p>
-            <a:pPr indent="0" marL="0">
+              <a:t>Any questions?</a:t>
+            </a:r>
+            <a:endParaRPr lang="en-US" sz="3600" dirty="0"/>
+          </a:p>
+        </p:txBody>
+      </p:sp>
+      <p:sp>
+        <p:nvSpPr>
+          <p:cNvPr id="57" name="Text 55"/>
+          <p:cNvSpPr/>
+          <p:nvPr/>
+        </p:nvSpPr>
+        <p:spPr>
+          <a:xfrm>
+            <a:off x="8686800" y="5349240"/>
+            <a:ext cx="3291840" cy="914400"/>
+          </a:xfrm>
+          <a:prstGeom prst="rect">
+            <a:avLst/>
+          </a:prstGeom>
+          <a:noFill/>
+          <a:ln/>
+        </p:spPr>
+        <p:txBody>
+          <a:bodyPr wrap="square" lIns="0" tIns="0" rIns="0" bIns="0" rtlCol="0" anchor="ctr"/>
+          <a:lstStyle/>
+          <a:p>
+            <a:pPr algn="r" indent="0" marL="0">
               <a:spcAft>
-                <a:spcPts val="600"/>
+                <a:spcPts val="400"/>
               </a:spcAft>
               <a:buNone/>
             </a:pPr>
             <a:r>
-              <a:rPr lang="en-US" sz="2000" dirty="0">
+              <a:rPr lang="en-US" sz="1800" b="1" dirty="0">
                 <a:solidFill>
-                  <a:srgbClr val="C9BDE8"/>
+                  <a:srgbClr val="2E2055"/>
+                </a:solidFill>
+                <a:latin typeface="Calibri" pitchFamily="34" charset="0"/>
+                <a:ea typeface="Calibri" pitchFamily="34" charset="-122"/>
+                <a:cs typeface="Calibri" pitchFamily="34" charset="-120"/>
+              </a:rPr>
+              <a:t>Ibtihal Hussien</a:t>
+            </a:r>
+            <a:endParaRPr lang="en-US" sz="1800" dirty="0"/>
+          </a:p>
+          <a:p>
+            <a:pPr algn="r" indent="0" marL="0">
+              <a:spcAft>
+                <a:spcPts val="400"/>
+              </a:spcAft>
+              <a:buNone/>
+            </a:pPr>
+            <a:r>
+              <a:rPr lang="en-US" sz="1800" dirty="0">
+                <a:solidFill>
+                  <a:srgbClr val="6B4FA3"/>
                 </a:solidFill>
                 <a:latin typeface="Calibri" pitchFamily="34" charset="0"/>
                 <a:ea typeface="Calibri" pitchFamily="34" charset="-122"/>
@@ -29910,34 +31215,10 @@
               </a:rPr>
               <a:t>University of Babylon</a:t>
             </a:r>
-            <a:endParaRPr lang="en-US" sz="2000" dirty="0"/>
+            <a:endParaRPr lang="en-US" sz="1800" dirty="0"/>
           </a:p>
         </p:txBody>
       </p:sp>
-      <p:pic>
-        <p:nvPicPr>
-          <p:cNvPr id="7" name="Image 0" descr="assets/closing.png">    </p:cNvPr>
-          <p:cNvPicPr>
-            <a:picLocks noChangeAspect="1"/>
-          </p:cNvPicPr>
-          <p:nvPr/>
-        </p:nvPicPr>
-        <p:blipFill>
-          <a:blip r:embed="rId1"/>
-          <a:stretch>
-            <a:fillRect/>
-          </a:stretch>
-        </p:blipFill>
-        <p:spPr>
-          <a:xfrm>
-            <a:off x="5943600" y="1097280"/>
-            <a:ext cx="5943600" cy="4493941"/>
-          </a:xfrm>
-          <a:prstGeom prst="rect">
-            <a:avLst/>
-          </a:prstGeom>
-        </p:spPr>
-      </p:pic>
     </p:spTree>
   </p:cSld>
   <p:clrMapOvr>

</xml_diff>

<commit_message>
Related Work 2: replace Tanovic (k-means classification) with Zangana (image compression, GPUs); complete references
Co-Authored-By: Claude Sonnet 5.5 <noreply@anthropic.com>
Claude-Session: https://claude.ai/code/session_01T6gEewJ8YaCdmnsfS34RJd
</commit_message>
<xml_diff>
--- a/results/seminar/figs/Seminar_Ibtihal_FINAL.pptx
+++ b/results/seminar/figs/Seminar_Ibtihal_FINAL.pptx
@@ -29686,7 +29686,70 @@
                 <a:ea typeface="Calibri" pitchFamily="34" charset="-122"/>
                 <a:cs typeface="Calibri" pitchFamily="34" charset="-120"/>
               </a:rPr>
-              <a:t>Tanović, A. et al. (2024). ZINC 2024.  Papakyriakou, D. et al. (2025). Int. J. Comput. Appl.  Bystrov, O. et al. (2023). Proc. 7th Int. Conf. on Parallel, Distributed, GPU and Cloud Computing for Engineering.  Paul, R.K. et al. (2024).  Zangana, H.M. (2025).</a:t>
+              <a:t>Zangana, H.M. (2025). Design and implementation of a novel parallel algorithm for efficient image compression in high-performance computing. EAI Endorsed Trans. AI Robot., 4. doi:10.4108/airo.7832</a:t>
+            </a:r>
+            <a:endParaRPr lang="en-US" sz="1600" dirty="0"/>
+          </a:p>
+          <a:p>
+            <a:pPr marL="342900" indent="-342900">
+              <a:spcAft>
+                <a:spcPts val="1000"/>
+              </a:spcAft>
+              <a:buSzPct val="100000"/>
+              <a:buChar char="■"/>
+            </a:pPr>
+            <a:r>
+              <a:rPr lang="en-US" sz="1600" dirty="0">
+                <a:solidFill>
+                  <a:srgbClr val="1F1A33"/>
+                </a:solidFill>
+                <a:latin typeface="Calibri" pitchFamily="34" charset="0"/>
+                <a:ea typeface="Calibri" pitchFamily="34" charset="-122"/>
+                <a:cs typeface="Calibri" pitchFamily="34" charset="-120"/>
+              </a:rPr>
+              <a:t>Bystrov, O., Pacevič, R., Kačeniauskas, A. (2023). Hybrid parallelization of discrete element software for heterogeneous resources. Proc. 7th Int. Conf. on Parallel, Distributed, GPU and Cloud Computing for Engineering, Civil-Comp Press, Paper 4.1. doi:10.4203/ccc.4.4.1</a:t>
+            </a:r>
+            <a:endParaRPr lang="en-US" sz="1600" dirty="0"/>
+          </a:p>
+          <a:p>
+            <a:pPr marL="342900" indent="-342900">
+              <a:spcAft>
+                <a:spcPts val="1000"/>
+              </a:spcAft>
+              <a:buSzPct val="100000"/>
+              <a:buChar char="■"/>
+            </a:pPr>
+            <a:r>
+              <a:rPr lang="en-US" sz="1600" dirty="0">
+                <a:solidFill>
+                  <a:srgbClr val="1F1A33"/>
+                </a:solidFill>
+                <a:latin typeface="Calibri" pitchFamily="34" charset="0"/>
+                <a:ea typeface="Calibri" pitchFamily="34" charset="-122"/>
+                <a:cs typeface="Calibri" pitchFamily="34" charset="-120"/>
+              </a:rPr>
+              <a:t>Papakyriakou, D. et al. (2025). Int. J. Comput. Appl.  [complete the reference from the paper]</a:t>
+            </a:r>
+            <a:endParaRPr lang="en-US" sz="1600" dirty="0"/>
+          </a:p>
+          <a:p>
+            <a:pPr marL="342900" indent="-342900">
+              <a:spcAft>
+                <a:spcPts val="1000"/>
+              </a:spcAft>
+              <a:buSzPct val="100000"/>
+              <a:buChar char="■"/>
+            </a:pPr>
+            <a:r>
+              <a:rPr lang="en-US" sz="1600" dirty="0">
+                <a:solidFill>
+                  <a:srgbClr val="1F1A33"/>
+                </a:solidFill>
+                <a:latin typeface="Calibri" pitchFamily="34" charset="0"/>
+                <a:ea typeface="Calibri" pitchFamily="34" charset="-122"/>
+                <a:cs typeface="Calibri" pitchFamily="34" charset="-120"/>
+              </a:rPr>
+              <a:t>Paul, R.K., Jena, S., Chandran, S., Bandyopadhyay, A., Swain, S. (2024). Image compression scheme based on optimized K-means clustering and higher-level decomposed DWT. Procedia Comput. Sci., 235: 642-655.</a:t>
             </a:r>
             <a:endParaRPr lang="en-US" sz="1600" dirty="0"/>
           </a:p>
@@ -36271,7 +36334,7 @@
                           <a:ea typeface="Calibri" pitchFamily="34" charset="-122"/>
                           <a:cs typeface="Calibri" pitchFamily="34" charset="-120"/>
                         </a:rPr>
-                        <a:t>Tanović et al. (2024)</a:t>
+                        <a:t>Zangana (2025)</a:t>
                       </a:r>
                       <a:endParaRPr lang="en-US" sz="1300" dirty="0">
                         <a:latin typeface="Calibri" charset="0"/>
@@ -36339,7 +36402,7 @@
                           <a:ea typeface="Calibri" pitchFamily="34" charset="-122"/>
                           <a:cs typeface="Calibri" pitchFamily="34" charset="-120"/>
                         </a:rPr>
-                        <a:t>k-means, image classification</a:t>
+                        <a:t>Image compression (bitplane, wavelet, predictive coding)</a:t>
                       </a:r>
                       <a:endParaRPr lang="en-US" sz="1300" dirty="0">
                         <a:latin typeface="Calibri" charset="0"/>
@@ -36407,7 +36470,7 @@
                           <a:ea typeface="Calibri" pitchFamily="34" charset="-122"/>
                           <a:cs typeface="Calibri" pitchFamily="34" charset="-120"/>
                         </a:rPr>
-                        <a:t>12 cores (OpenMP + MPI)</a:t>
+                        <a:t>1–16 GPUs</a:t>
                       </a:r>
                       <a:endParaRPr lang="en-US" sz="1300" dirty="0">
                         <a:latin typeface="Calibri" charset="0"/>
@@ -36475,7 +36538,7 @@
                           <a:ea typeface="Calibri" pitchFamily="34" charset="-122"/>
                           <a:cs typeface="Calibri" pitchFamily="34" charset="-120"/>
                         </a:rPr>
-                        <a:t>Not stated</a:t>
+                        <a:t>1 GPU</a:t>
                       </a:r>
                       <a:endParaRPr lang="en-US" sz="1300" dirty="0">
                         <a:latin typeface="Calibri" charset="0"/>
@@ -36543,7 +36606,7 @@
                           <a:ea typeface="Calibri" pitchFamily="34" charset="-122"/>
                           <a:cs typeface="Calibri" pitchFamily="34" charset="-120"/>
                         </a:rPr>
-                        <a:t>Up to 10.2×</a:t>
+                        <a:t>9.09× (16 GPUs)</a:t>
                       </a:r>
                       <a:endParaRPr lang="en-US" sz="1300" dirty="0">
                         <a:latin typeface="Calibri" charset="0"/>
@@ -37702,7 +37765,7 @@
                 <a:ea typeface="Calibri" pitchFamily="34" charset="-122"/>
                 <a:cs typeface="Calibri" pitchFamily="34" charset="-120"/>
               </a:rPr>
-              <a:t>Existing parallel studies target k-means or other applications. To our knowledge, none of the reviewed studies evaluates MPI-parallel LBG for image compression on a hybrid P/E-core CPU.</a:t>
+              <a:t>Existing parallel studies use other compression algorithms on GPUs, or target clustering and simulation workloads. To our knowledge, none of the reviewed studies evaluates MPI-parallel LBG for image compression on a hybrid P/E-core CPU.</a:t>
             </a:r>
             <a:endParaRPr lang="en-US" sz="1800" dirty="0"/>
           </a:p>

</xml_diff>

<commit_message>
Related Work 2: apply revised table wording
Co-Authored-By: Claude Sonnet 5.5 <noreply@anthropic.com>
Claude-Session: https://claude.ai/code/session_01T6gEewJ8YaCdmnsfS34RJd
</commit_message>
<xml_diff>
--- a/results/seminar/figs/Seminar_Ibtihal_FINAL.pptx
+++ b/results/seminar/figs/Seminar_Ibtihal_FINAL.pptx
@@ -36128,7 +36128,7 @@
                           <a:ea typeface="Calibri" pitchFamily="34" charset="-122"/>
                           <a:cs typeface="Calibri" pitchFamily="34" charset="-120"/>
                         </a:rPr>
-                        <a:t>Resources</a:t>
+                        <a:t>Parallel Resources</a:t>
                       </a:r>
                       <a:endParaRPr lang="en-US" sz="1400" dirty="0">
                         <a:latin typeface="Calibri" charset="0"/>
@@ -36264,7 +36264,7 @@
                           <a:ea typeface="Calibri" pitchFamily="34" charset="-122"/>
                           <a:cs typeface="Calibri" pitchFamily="34" charset="-120"/>
                         </a:rPr>
-                        <a:t>Speedup</a:t>
+                        <a:t>Reported Speedup</a:t>
                       </a:r>
                       <a:endParaRPr lang="en-US" sz="1400" dirty="0">
                         <a:latin typeface="Calibri" charset="0"/>
@@ -36402,7 +36402,7 @@
                           <a:ea typeface="Calibri" pitchFamily="34" charset="-122"/>
                           <a:cs typeface="Calibri" pitchFamily="34" charset="-120"/>
                         </a:rPr>
-                        <a:t>Image compression (bitplane, wavelet, predictive coding)</a:t>
+                        <a:t>Image compression</a:t>
                       </a:r>
                       <a:endParaRPr lang="en-US" sz="1300" dirty="0">
                         <a:latin typeface="Calibri" charset="0"/>
@@ -36744,7 +36744,7 @@
                           <a:ea typeface="Calibri" pitchFamily="34" charset="-122"/>
                           <a:cs typeface="Calibri" pitchFamily="34" charset="-120"/>
                         </a:rPr>
-                        <a:t>k-means, 75 M synthetic points</a:t>
+                        <a:t>MPI-based k-means clustering</a:t>
                       </a:r>
                       <a:endParaRPr lang="en-US" sz="1300" dirty="0">
                         <a:latin typeface="Calibri" charset="0"/>
@@ -36948,7 +36948,7 @@
                           <a:ea typeface="Calibri" pitchFamily="34" charset="-122"/>
                           <a:cs typeface="Calibri" pitchFamily="34" charset="-120"/>
                         </a:rPr>
-                        <a:t>≈ 10.05×</a:t>
+                        <a:t>10.05×</a:t>
                       </a:r>
                       <a:endParaRPr lang="en-US" sz="1300" dirty="0">
                         <a:latin typeface="Calibri" charset="0"/>
@@ -37428,7 +37428,7 @@
                           <a:ea typeface="Calibri" pitchFamily="34" charset="-122"/>
                           <a:cs typeface="Calibri" pitchFamily="34" charset="-120"/>
                         </a:rPr>
-                        <a:t>LBG image compression</a:t>
+                        <a:t>MPI-based LBG image compression</a:t>
                       </a:r>
                       <a:endParaRPr lang="en-US" sz="1300" dirty="0">
                         <a:latin typeface="Calibri" charset="0"/>
@@ -37496,7 +37496,7 @@
                           <a:ea typeface="Calibri" pitchFamily="34" charset="-122"/>
                           <a:cs typeface="Calibri" pitchFamily="34" charset="-120"/>
                         </a:rPr>
-                        <a:t>14 MPI processes (6 P + 8 E cores)</a:t>
+                        <a:t>14 MPI processes (6 P + 8 E)</a:t>
                       </a:r>
                       <a:endParaRPr lang="en-US" sz="1300" dirty="0">
                         <a:latin typeface="Calibri" charset="0"/>
@@ -37632,7 +37632,7 @@
                           <a:ea typeface="Calibri" pitchFamily="34" charset="-122"/>
                           <a:cs typeface="Calibri" pitchFamily="34" charset="-120"/>
                         </a:rPr>
-                        <a:t>9.19× (LBG); 5.00× / 6.84× (total, gray / color)</a:t>
+                        <a:t>9.19× (LBG); 5.00× (gray total); 6.84× (color total)</a:t>
                       </a:r>
                       <a:endParaRPr lang="en-US" sz="1300" dirty="0">
                         <a:latin typeface="Calibri" charset="0"/>

</xml_diff>

<commit_message>
Related Work 2: Papakyriakou row and reference verified against the paper
Co-Authored-By: Claude Sonnet 5.5 <noreply@anthropic.com>
Claude-Session: https://claude.ai/code/session_01T6gEewJ8YaCdmnsfS34RJd
</commit_message>
<xml_diff>
--- a/results/seminar/figs/Seminar_Ibtihal_FINAL.pptx
+++ b/results/seminar/figs/Seminar_Ibtihal_FINAL.pptx
@@ -29728,7 +29728,7 @@
                 <a:ea typeface="Calibri" pitchFamily="34" charset="-122"/>
                 <a:cs typeface="Calibri" pitchFamily="34" charset="-120"/>
               </a:rPr>
-              <a:t>Papakyriakou, D. et al. (2025). Int. J. Comput. Appl.  [complete the reference from the paper]</a:t>
+              <a:t>Papakyriakou, D., Barbounakis, I.S. (2025). Parallel k-means benchmarking on a CPU-bound Beowulf cluster of Raspberry Pi nodes: an MPI-based scaling analysis with CPU-centric performance evaluation. Int. J. Comput. Appl., 187(32).</a:t>
             </a:r>
             <a:endParaRPr lang="en-US" sz="1600" dirty="0"/>
           </a:p>
@@ -36812,7 +36812,7 @@
                           <a:ea typeface="Calibri" pitchFamily="34" charset="-122"/>
                           <a:cs typeface="Calibri" pitchFamily="34" charset="-120"/>
                         </a:rPr>
-                        <a:t>2–48 MPI processes</a:t>
+                        <a:t>2–48 MPI processes (24 Raspberry Pi nodes)</a:t>
                       </a:r>
                       <a:endParaRPr lang="en-US" sz="1300" dirty="0">
                         <a:latin typeface="Calibri" charset="0"/>
@@ -36948,7 +36948,7 @@
                           <a:ea typeface="Calibri" pitchFamily="34" charset="-122"/>
                           <a:cs typeface="Calibri" pitchFamily="34" charset="-120"/>
                         </a:rPr>
-                        <a:t>10.05×</a:t>
+                        <a:t>≈ 10× (181.8 s to 18.1 s)</a:t>
                       </a:r>
                       <a:endParaRPr lang="en-US" sz="1300" dirty="0">
                         <a:latin typeface="Calibri" charset="0"/>

</xml_diff>

<commit_message>
Seminar: Rank -> Process wording; remove Metrics box from overview figure
Co-Authored-By: Claude Sonnet 5.5 <noreply@anthropic.com>
Claude-Session: https://claude.ai/code/session_01T6gEewJ8YaCdmnsfS34RJd
</commit_message>
<xml_diff>
--- a/results/seminar/figs/Seminar_Ibtihal_FINAL.pptx
+++ b/results/seminar/figs/Seminar_Ibtihal_FINAL.pptx
@@ -4472,7 +4472,7 @@
                 <a:ea typeface="Calibri" pitchFamily="34" charset="-122"/>
                 <a:cs typeface="Calibri" pitchFamily="34" charset="-120"/>
               </a:rPr>
-              <a:t>SEQUENTIAL: Rank 0</a:t>
+              <a:t>SEQUENTIAL: Process 0</a:t>
             </a:r>
             <a:endParaRPr lang="en-US" sz="1200" dirty="0"/>
           </a:p>
@@ -5062,7 +5062,7 @@
                 <a:ea typeface="Calibri" pitchFamily="34" charset="-122"/>
                 <a:cs typeface="Calibri" pitchFamily="34" charset="-120"/>
               </a:rPr>
-              <a:t>PARALLEL: all ranks</a:t>
+              <a:t>PARALLEL: all processes</a:t>
             </a:r>
             <a:endParaRPr lang="en-US" sz="1200" dirty="0"/>
           </a:p>
@@ -5287,7 +5287,7 @@
                 <a:ea typeface="Calibri" pitchFamily="34" charset="-122"/>
                 <a:cs typeface="Calibri" pitchFamily="34" charset="-120"/>
               </a:rPr>
-              <a:t>on each rank</a:t>
+              <a:t>on each process</a:t>
             </a:r>
             <a:endParaRPr lang="en-US" sz="1600" dirty="0"/>
           </a:p>
@@ -5576,7 +5576,7 @@
                 <a:ea typeface="Calibri" pitchFamily="34" charset="-122"/>
                 <a:cs typeface="Calibri" pitchFamily="34" charset="-120"/>
               </a:rPr>
-              <a:t>codebook C + index array L (gathered on Rank 0)</a:t>
+              <a:t>codebook C + index array L (gathered on Process 0)</a:t>
             </a:r>
             <a:endParaRPr lang="en-US" sz="1300" dirty="0"/>
           </a:p>
@@ -5794,7 +5794,7 @@
                 <a:ea typeface="Calibri" pitchFamily="34" charset="-122"/>
                 <a:cs typeface="Calibri" pitchFamily="34" charset="-120"/>
               </a:rPr>
-              <a:t>SEQUENTIAL: Rank 0</a:t>
+              <a:t>SEQUENTIAL: Process 0</a:t>
             </a:r>
             <a:endParaRPr lang="en-US" sz="1200" dirty="0"/>
           </a:p>
@@ -6393,7 +6393,7 @@
               <a:buNone/>
             </a:pPr>
             <a:r>
-              <a:rPr lang="en-US" sz="1100" b="1" dirty="0">
+              <a:rPr lang="en-US" sz="1200" b="1" dirty="0">
                 <a:solidFill>
                   <a:srgbClr val="5B6770"/>
                 </a:solidFill>
@@ -6401,9 +6401,9 @@
                 <a:ea typeface="Calibri" pitchFamily="34" charset="-122"/>
                 <a:cs typeface="Calibri" pitchFamily="34" charset="-120"/>
               </a:rPr>
-              <a:t>Rank 0 | Parallel: SSIM</a:t>
+              <a:t>SEQUENTIAL: Process 0</a:t>
             </a:r>
-            <a:endParaRPr lang="en-US" sz="1100" dirty="0"/>
+            <a:endParaRPr lang="en-US" sz="1200" dirty="0"/>
           </a:p>
         </p:txBody>
       </p:sp>
@@ -6765,148 +6765,6 @@
         </p:nvSpPr>
         <p:spPr>
           <a:xfrm>
-            <a:off x="9400032" y="5655564"/>
-            <a:ext cx="219456" cy="237744"/>
-          </a:xfrm>
-          <a:prstGeom prst="rightArrow">
-            <a:avLst/>
-          </a:prstGeom>
-          <a:solidFill>
-            <a:srgbClr val="1F1A33"/>
-          </a:solidFill>
-          <a:ln w="12700">
-            <a:solidFill>
-              <a:srgbClr val="1F1A33"/>
-            </a:solidFill>
-            <a:prstDash val="solid"/>
-          </a:ln>
-        </p:spPr>
-      </p:sp>
-      <p:sp>
-        <p:nvSpPr>
-          <p:cNvPr id="64" name="Shape 62"/>
-          <p:cNvSpPr/>
-          <p:nvPr/>
-        </p:nvSpPr>
-        <p:spPr>
-          <a:xfrm>
-            <a:off x="9646920" y="5202936"/>
-            <a:ext cx="2011680" cy="1143000"/>
-          </a:xfrm>
-          <a:prstGeom prst="roundRect">
-            <a:avLst>
-              <a:gd name="adj" fmla="val 6400"/>
-            </a:avLst>
-          </a:prstGeom>
-          <a:solidFill>
-            <a:srgbClr val="FDEBD9"/>
-          </a:solidFill>
-          <a:ln w="31750">
-            <a:solidFill>
-              <a:srgbClr val="E07B22"/>
-            </a:solidFill>
-            <a:prstDash val="dash"/>
-          </a:ln>
-        </p:spPr>
-      </p:sp>
-      <p:sp>
-        <p:nvSpPr>
-          <p:cNvPr id="65" name="Text 63"/>
-          <p:cNvSpPr/>
-          <p:nvPr/>
-        </p:nvSpPr>
-        <p:spPr>
-          <a:xfrm>
-            <a:off x="9646920" y="5202936"/>
-            <a:ext cx="2011680" cy="1143000"/>
-          </a:xfrm>
-          <a:prstGeom prst="rect">
-            <a:avLst/>
-          </a:prstGeom>
-          <a:noFill/>
-          <a:ln/>
-        </p:spPr>
-        <p:txBody>
-          <a:bodyPr wrap="square" lIns="635" tIns="635" rIns="635" bIns="635" rtlCol="0" anchor="ctr"/>
-          <a:lstStyle/>
-          <a:p>
-            <a:pPr algn="ctr" indent="0" marL="0">
-              <a:buNone/>
-            </a:pPr>
-            <a:r>
-              <a:rPr lang="en-US" sz="1600" b="1" dirty="0">
-                <a:solidFill>
-                  <a:srgbClr val="6B4FA3"/>
-                </a:solidFill>
-                <a:latin typeface="Calibri" pitchFamily="34" charset="0"/>
-                <a:ea typeface="Calibri" pitchFamily="34" charset="-122"/>
-                <a:cs typeface="Calibri" pitchFamily="34" charset="-120"/>
-              </a:rPr>
-              <a:t>4. Metrics</a:t>
-            </a:r>
-            <a:endParaRPr lang="en-US" sz="1600" dirty="0"/>
-          </a:p>
-          <a:p>
-            <a:pPr algn="ctr" indent="0" marL="0">
-              <a:buNone/>
-            </a:pPr>
-            <a:r>
-              <a:rPr lang="en-US" sz="1300" dirty="0">
-                <a:solidFill>
-                  <a:srgbClr val="1F1A33"/>
-                </a:solidFill>
-                <a:latin typeface="Calibri" pitchFamily="34" charset="0"/>
-                <a:ea typeface="Calibri" pitchFamily="34" charset="-122"/>
-                <a:cs typeface="Calibri" pitchFamily="34" charset="-120"/>
-              </a:rPr>
-              <a:t>CR, BPP, MSE, PSNR</a:t>
-            </a:r>
-            <a:endParaRPr lang="en-US" sz="1600" dirty="0"/>
-          </a:p>
-          <a:p>
-            <a:pPr algn="ctr" indent="0" marL="0">
-              <a:buNone/>
-            </a:pPr>
-            <a:r>
-              <a:rPr lang="en-US" sz="1300" dirty="0">
-                <a:solidFill>
-                  <a:srgbClr val="1F1A33"/>
-                </a:solidFill>
-                <a:latin typeface="Calibri" pitchFamily="34" charset="0"/>
-                <a:ea typeface="Calibri" pitchFamily="34" charset="-122"/>
-                <a:cs typeface="Calibri" pitchFamily="34" charset="-120"/>
-              </a:rPr>
-              <a:t>(Rank 0)</a:t>
-            </a:r>
-            <a:endParaRPr lang="en-US" sz="1600" dirty="0"/>
-          </a:p>
-          <a:p>
-            <a:pPr algn="ctr" indent="0" marL="0">
-              <a:buNone/>
-            </a:pPr>
-            <a:r>
-              <a:rPr lang="en-US" sz="1300" dirty="0">
-                <a:solidFill>
-                  <a:srgbClr val="1F1A33"/>
-                </a:solidFill>
-                <a:latin typeface="Calibri" pitchFamily="34" charset="0"/>
-                <a:ea typeface="Calibri" pitchFamily="34" charset="-122"/>
-                <a:cs typeface="Calibri" pitchFamily="34" charset="-120"/>
-              </a:rPr>
-              <a:t>SSIM (parallel)</a:t>
-            </a:r>
-            <a:endParaRPr lang="en-US" sz="1600" dirty="0"/>
-          </a:p>
-        </p:txBody>
-      </p:sp>
-      <p:sp>
-        <p:nvSpPr>
-          <p:cNvPr id="66" name="Shape 64"/>
-          <p:cNvSpPr/>
-          <p:nvPr/>
-        </p:nvSpPr>
-        <p:spPr>
-          <a:xfrm>
             <a:off x="2377440" y="6473952"/>
             <a:ext cx="457200" cy="219456"/>
           </a:xfrm>
@@ -6928,7 +6786,7 @@
       </p:sp>
       <p:sp>
         <p:nvSpPr>
-          <p:cNvPr id="67" name="Text 65"/>
+          <p:cNvPr id="64" name="Text 62"/>
           <p:cNvSpPr/>
           <p:nvPr/>
         </p:nvSpPr>
@@ -6959,7 +6817,7 @@
                 <a:ea typeface="Calibri" pitchFamily="34" charset="-122"/>
                 <a:cs typeface="Calibri" pitchFamily="34" charset="-120"/>
               </a:rPr>
-              <a:t>Parallel: all MPI ranks work together</a:t>
+              <a:t>Parallel: all MPI processes work together</a:t>
             </a:r>
             <a:endParaRPr lang="en-US" sz="1300" dirty="0"/>
           </a:p>
@@ -6967,7 +6825,7 @@
       </p:sp>
       <p:sp>
         <p:nvSpPr>
-          <p:cNvPr id="68" name="Shape 66"/>
+          <p:cNvPr id="65" name="Shape 63"/>
           <p:cNvSpPr/>
           <p:nvPr/>
         </p:nvSpPr>
@@ -6994,7 +6852,7 @@
       </p:sp>
       <p:sp>
         <p:nvSpPr>
-          <p:cNvPr id="69" name="Text 67"/>
+          <p:cNvPr id="66" name="Text 64"/>
           <p:cNvSpPr/>
           <p:nvPr/>
         </p:nvSpPr>
@@ -7025,7 +6883,7 @@
                 <a:ea typeface="Calibri" pitchFamily="34" charset="-122"/>
                 <a:cs typeface="Calibri" pitchFamily="34" charset="-120"/>
               </a:rPr>
-              <a:t>Sequential: executed on Rank 0 only</a:t>
+              <a:t>Sequential: executed on Process 0 only</a:t>
             </a:r>
             <a:endParaRPr lang="en-US" sz="1300" dirty="0"/>
           </a:p>
@@ -8039,7 +7897,7 @@
                 <a:ea typeface="Calibri" pitchFamily="34" charset="-122"/>
                 <a:cs typeface="Calibri" pitchFamily="34" charset="-120"/>
               </a:rPr>
-              <a:t>SPMD: every rank runs the same program on its own chunk of vectors.</a:t>
+              <a:t>SPMD: every process runs the same program on its own chunk of vectors.</a:t>
             </a:r>
             <a:endParaRPr lang="en-US" sz="1400" dirty="0"/>
           </a:p>
@@ -8130,7 +7988,7 @@
                 <a:ea typeface="Calibri" pitchFamily="34" charset="-122"/>
                 <a:cs typeface="Calibri" pitchFamily="34" charset="-120"/>
               </a:rPr>
-              <a:t>Allreduce combines sums, counts and distortion; every rank updates the same codebook.</a:t>
+              <a:t>Allreduce combines sums, counts and distortion; every process updates the same codebook.</a:t>
             </a:r>
             <a:endParaRPr lang="en-US" sz="1400" dirty="0"/>
           </a:p>
@@ -8151,7 +8009,7 @@
                 <a:ea typeface="Calibri" pitchFamily="34" charset="-122"/>
                 <a:cs typeface="Calibri" pitchFamily="34" charset="-120"/>
               </a:rPr>
-              <a:t>Gatherv collects the final indices on Rank 0.</a:t>
+              <a:t>Gatherv collects the final indices on Process 0.</a:t>
             </a:r>
             <a:endParaRPr lang="en-US" sz="1400" dirty="0"/>
           </a:p>
@@ -8434,7 +8292,7 @@
                 <a:ea typeface="Calibri" pitchFamily="34" charset="-122"/>
                 <a:cs typeface="Calibri" pitchFamily="34" charset="-120"/>
               </a:rPr>
-              <a:t>Equal (default, P ≤ 4): each rank gets N/P vectors (rounded down or up).</a:t>
+              <a:t>Equal (default, P ≤ 4): each process gets N/P vectors (rounded down or up).</a:t>
             </a:r>
             <a:endParaRPr lang="en-US" sz="1600" dirty="0"/>
           </a:p>
@@ -9904,7 +9762,7 @@
                 <a:ea typeface="Calibri" pitchFamily="34" charset="-122"/>
                 <a:cs typeface="Calibri" pitchFamily="34" charset="-120"/>
               </a:rPr>
-              <a:t>Decoding and reconstruction run on Rank 0.</a:t>
+              <a:t>Decoding and reconstruction run on Process 0.</a:t>
             </a:r>
             <a:endParaRPr lang="en-US" sz="1600" dirty="0"/>
           </a:p>
@@ -27768,7 +27626,7 @@
                 <a:ea typeface="Calibri" pitchFamily="34" charset="-122"/>
                 <a:cs typeface="Calibri" pitchFamily="34" charset="-120"/>
               </a:rPr>
-              <a:t>It is lower than the LBG speedup (9.19×) because the work outside LBG (mainly image reading and file output) runs on Rank 0.</a:t>
+              <a:t>It is lower than the LBG speedup (9.19×) because the work outside LBG (mainly image reading and file output) runs on Process 0.</a:t>
             </a:r>
             <a:endParaRPr lang="en-US" sz="1500" dirty="0"/>
           </a:p>
@@ -33779,7 +33637,7 @@
                 <a:ea typeface="Calibri" pitchFamily="34" charset="-122"/>
                 <a:cs typeface="Calibri" pitchFamily="34" charset="-120"/>
               </a:rPr>
-              <a:t>Total: about 0.14 (gray) and 0.08 (color); the work on Rank 0 (mainly image reading and file output) limits the speedup.</a:t>
+              <a:t>Total: about 0.14 (gray) and 0.08 (color); the work on Process 0 (mainly image reading and file output) limits the speedup.</a:t>
             </a:r>
             <a:endParaRPr lang="en-US" sz="1400" dirty="0"/>
           </a:p>
@@ -34137,7 +33995,7 @@
                 <a:ea typeface="Calibri" pitchFamily="34" charset="-122"/>
                 <a:cs typeface="Calibri" pitchFamily="34" charset="-120"/>
               </a:rPr>
-              <a:t>The total speedup is limited by the work that runs on Rank 0, mainly image reading and file output.</a:t>
+              <a:t>The total speedup is limited by the work that runs on Process 0, mainly image reading and file output.</a:t>
             </a:r>
             <a:endParaRPr lang="en-US" sz="1900" dirty="0"/>
           </a:p>
@@ -34432,7 +34290,7 @@
                 <a:ea typeface="Calibri" pitchFamily="34" charset="-122"/>
                 <a:cs typeface="Calibri" pitchFamily="34" charset="-120"/>
               </a:rPr>
-              <a:t>Rebalance the workload during the run, using the measured compute time of each rank and a load-imbalance measure.</a:t>
+              <a:t>Rebalance the workload during the run, using the measured compute time of each process and a load-imbalance measure.</a:t>
             </a:r>
             <a:endParaRPr lang="en-US" sz="2200" dirty="0"/>
           </a:p>

</xml_diff>

<commit_message>
Seminar: remove result numbers from intro, problem and method slides
Co-Authored-By: Claude Sonnet 5.5 <noreply@anthropic.com>
Claude-Session: https://claude.ai/code/session_01T6gEewJ8YaCdmnsfS34RJd
</commit_message>
<xml_diff>
--- a/results/seminar/figs/Seminar_Ibtihal_FINAL.pptx
+++ b/results/seminar/figs/Seminar_Ibtihal_FINAL.pptx
@@ -7918,7 +7918,7 @@
                 <a:ea typeface="Calibri" pitchFamily="34" charset="-122"/>
                 <a:cs typeface="Calibri" pitchFamily="34" charset="-120"/>
               </a:rPr>
-              <a:t>Nearest-codeword assignment is local and is the main cost of LBG, which takes about 77% of the sequential time (gray).</a:t>
+              <a:t>Nearest-codeword assignment is local and is the main cost of LBG.</a:t>
             </a:r>
             <a:endParaRPr lang="en-US" sz="1400" dirty="0"/>
           </a:p>
@@ -36981,7 +36981,7 @@
                 <a:ea typeface="Calibri" pitchFamily="34" charset="-122"/>
                 <a:cs typeface="Calibri" pitchFamily="34" charset="-120"/>
               </a:rPr>
-              <a:t>In the sequential program it takes about 77% (gray) and 81% (color) of the total time.</a:t>
+              <a:t>It is the most time-consuming stage of the sequential program, so it is the stage worth parallelizing.</a:t>
             </a:r>
             <a:endParaRPr lang="en-US" sz="2200" dirty="0"/>
           </a:p>
@@ -43053,7 +43053,7 @@
                 <a:ea typeface="Calibri" pitchFamily="34" charset="-122"/>
                 <a:cs typeface="Calibri" pitchFamily="34" charset="-120"/>
               </a:rPr>
-              <a:t>LBG vector quantization gives a compact representation, but codebook training is computationally expensive: it repeatedly computes distances between training vectors and codewords (about 77% of the sequential time, gray images).</a:t>
+              <a:t>LBG vector quantization gives a compact representation, but codebook training is computationally expensive: it repeatedly computes distances between training vectors and codewords.</a:t>
             </a:r>
             <a:endParaRPr lang="en-US" sz="1800" dirty="0"/>
           </a:p>

</xml_diff>

<commit_message>
Seminar: redraw workload distribution figure (Balanced / Unbalanced) per supervisor sketch
Co-Authored-By: Claude Sonnet 5.5 <noreply@anthropic.com>
Claude-Session: https://claude.ai/code/session_01T6gEewJ8YaCdmnsfS34RJd
</commit_message>
<xml_diff>
--- a/results/seminar/figs/Seminar_Ibtihal_FINAL.pptx
+++ b/results/seminar/figs/Seminar_Ibtihal_FINAL.pptx
@@ -8146,7 +8146,7 @@
                 <a:ea typeface="Cambria" pitchFamily="34" charset="-122"/>
                 <a:cs typeface="Cambria" pitchFamily="34" charset="-120"/>
               </a:rPr>
-              <a:t>Equal and Adaptive Workload Distribution</a:t>
+              <a:t>Balanced and Unbalanced Workload Distribution</a:t>
             </a:r>
             <a:endParaRPr lang="en-US" sz="2800" dirty="0"/>
           </a:p>
@@ -8206,7 +8206,7 @@
       </p:sp>
       <p:pic>
         <p:nvPicPr>
-          <p:cNvPr id="7" name="Image 0" descr="assets/ch3_fig38.png">    </p:cNvPr>
+          <p:cNvPr id="7" name="Image 0" descr="figs/Workload_distribution.png">    </p:cNvPr>
           <p:cNvPicPr>
             <a:picLocks noChangeAspect="1"/>
           </p:cNvPicPr>
@@ -8220,8 +8220,8 @@
         </p:blipFill>
         <p:spPr>
           <a:xfrm>
-            <a:off x="548640" y="1618744"/>
-            <a:ext cx="7132320" cy="4214872"/>
+            <a:off x="590130" y="1325880"/>
+            <a:ext cx="7049339" cy="4800600"/>
           </a:xfrm>
           <a:prstGeom prst="rect">
             <a:avLst/>
@@ -8292,7 +8292,7 @@
                 <a:ea typeface="Calibri" pitchFamily="34" charset="-122"/>
                 <a:cs typeface="Calibri" pitchFamily="34" charset="-120"/>
               </a:rPr>
-              <a:t>Equal (default, P ≤ 4): each process gets N/P vectors (rounded down or up).</a:t>
+              <a:t>Balanced = Equal split (default, P ≤ 4): each process gets N/P vectors.</a:t>
             </a:r>
             <a:endParaRPr lang="en-US" sz="1600" dirty="0"/>
           </a:p>
@@ -8313,7 +8313,7 @@
                 <a:ea typeface="Calibri" pitchFamily="34" charset="-122"/>
                 <a:cs typeface="Calibri" pitchFamily="34" charset="-120"/>
               </a:rPr>
-              <a:t>Adaptive (P &gt; 4): speed measured by calibration (3 trials, the first is a warm-up).</a:t>
+              <a:t>Unbalanced = Adaptive split (P &gt; 4): chunk sizes follow the core speed measured by calibration (3 trials, the first is a warm-up).</a:t>
             </a:r>
             <a:endParaRPr lang="en-US" sz="1600" dirty="0"/>
           </a:p>

</xml_diff>

<commit_message>
Seminar: reword workload distribution bullets
Co-Authored-By: Claude Sonnet 5.5 <noreply@anthropic.com>
Claude-Session: https://claude.ai/code/session_01T6gEewJ8YaCdmnsfS34RJd
</commit_message>
<xml_diff>
--- a/results/seminar/figs/Seminar_Ibtihal_FINAL.pptx
+++ b/results/seminar/figs/Seminar_Ibtihal_FINAL.pptx
@@ -8292,7 +8292,7 @@
                 <a:ea typeface="Calibri" pitchFamily="34" charset="-122"/>
                 <a:cs typeface="Calibri" pitchFamily="34" charset="-120"/>
               </a:rPr>
-              <a:t>Balanced = Equal split (default, P ≤ 4): each process gets N/P vectors.</a:t>
+              <a:t>Balanced (Equal), P ≤ 4: each process gets N/P training vectors.</a:t>
             </a:r>
             <a:endParaRPr lang="en-US" sz="1600" dirty="0"/>
           </a:p>
@@ -8313,7 +8313,7 @@
                 <a:ea typeface="Calibri" pitchFamily="34" charset="-122"/>
                 <a:cs typeface="Calibri" pitchFamily="34" charset="-120"/>
               </a:rPr>
-              <a:t>Unbalanced = Adaptive split (P &gt; 4): chunk sizes follow the core speed measured by calibration (3 trials, the first is a warm-up).</a:t>
+              <a:t>Unbalanced (Adaptive), P &gt; 4: each process gets a share proportional to its measured speed.</a:t>
             </a:r>
             <a:endParaRPr lang="en-US" sz="1600" dirty="0"/>
           </a:p>
@@ -8334,7 +8334,7 @@
                 <a:ea typeface="Calibri" pitchFamily="34" charset="-122"/>
                 <a:cs typeface="Calibri" pitchFamily="34" charset="-120"/>
               </a:rPr>
-              <a:t>q_r = N · s_r / Σ s_j: faster cores receive more vectors.</a:t>
+              <a:t>Share of process r: q_r = N · s_r / Σ s_j, where s_r is the speed of process r.</a:t>
             </a:r>
             <a:endParaRPr lang="en-US" sz="1600" dirty="0"/>
           </a:p>
@@ -8355,7 +8355,7 @@
                 <a:ea typeface="Calibri" pitchFamily="34" charset="-122"/>
                 <a:cs typeface="Calibri" pitchFamily="34" charset="-120"/>
               </a:rPr>
-              <a:t>Adaptive reduces LBG time by 17–28% compared with Equal (P = 8 to 14).</a:t>
+              <a:t>Speed s_r is measured once by a short calibration run (3 trials, the first is a warm-up).</a:t>
             </a:r>
             <a:endParaRPr lang="en-US" sz="1600" dirty="0"/>
           </a:p>

</xml_diff>

<commit_message>
Seminar: colored decoding flow on Stage 4 slide
Co-Authored-By: Claude Sonnet 5.5 <noreply@anthropic.com>
Claude-Session: https://claude.ai/code/session_01T6gEewJ8YaCdmnsfS34RJd
</commit_message>
<xml_diff>
--- a/results/seminar/figs/Seminar_Ibtihal_FINAL.pptx
+++ b/results/seminar/figs/Seminar_Ibtihal_FINAL.pptx
@@ -9202,20 +9202,20 @@
         </p:nvSpPr>
         <p:spPr>
           <a:xfrm>
-            <a:off x="457200" y="1234440"/>
-            <a:ext cx="2468880" cy="731520"/>
+            <a:off x="457200" y="1143000"/>
+            <a:ext cx="2560320" cy="960120"/>
           </a:xfrm>
           <a:prstGeom prst="roundRect">
             <a:avLst>
-              <a:gd name="adj" fmla="val 10000"/>
+              <a:gd name="adj" fmla="val 9524"/>
             </a:avLst>
           </a:prstGeom>
           <a:solidFill>
-            <a:srgbClr val="ECE6F6"/>
+            <a:srgbClr val="2A9D8F"/>
           </a:solidFill>
-          <a:ln w="19050">
+          <a:ln w="12700">
             <a:solidFill>
-              <a:srgbClr val="6B4FA3"/>
+              <a:srgbClr val="2A9D8F"/>
             </a:solidFill>
             <a:prstDash val="solid"/>
           </a:ln>
@@ -9229,8 +9229,8 @@
         </p:nvSpPr>
         <p:spPr>
           <a:xfrm>
-            <a:off x="457200" y="1234440"/>
-            <a:ext cx="2468880" cy="731520"/>
+            <a:off x="457200" y="1143000"/>
+            <a:ext cx="2560320" cy="960120"/>
           </a:xfrm>
           <a:prstGeom prst="rect">
             <a:avLst/>
@@ -9239,7 +9239,7 @@
           <a:ln/>
         </p:spPr>
         <p:txBody>
-          <a:bodyPr wrap="square" lIns="0" tIns="0" rIns="0" bIns="0" rtlCol="0" anchor="ctr"/>
+          <a:bodyPr wrap="square" lIns="635" tIns="635" rIns="635" bIns="635" rtlCol="0" anchor="ctr"/>
           <a:lstStyle/>
           <a:p>
             <a:pPr algn="ctr" indent="0" marL="0">
@@ -9248,16 +9248,33 @@
             <a:r>
               <a:rPr lang="en-US" sz="1600" b="1" dirty="0">
                 <a:solidFill>
-                  <a:srgbClr val="6B4FA3"/>
+                  <a:srgbClr val="FFFFFF"/>
                 </a:solidFill>
                 <a:latin typeface="Calibri" pitchFamily="34" charset="0"/>
                 <a:ea typeface="Calibri" pitchFamily="34" charset="-122"/>
                 <a:cs typeface="Calibri" pitchFamily="34" charset="-120"/>
               </a:rPr>
-              <a:t>Huffman decoding</a:t>
+              <a:t>1. Huffman decoding</a:t>
             </a:r>
             <a:endParaRPr lang="en-US" sz="1600" dirty="0"/>
           </a:p>
+          <a:p>
+            <a:pPr algn="ctr" indent="0" marL="0">
+              <a:buNone/>
+            </a:pPr>
+            <a:r>
+              <a:rPr lang="en-US" sz="1250" dirty="0">
+                <a:solidFill>
+                  <a:srgbClr val="FFFFFF"/>
+                </a:solidFill>
+                <a:latin typeface="Calibri" pitchFamily="34" charset="0"/>
+                <a:ea typeface="Calibri" pitchFamily="34" charset="-122"/>
+                <a:cs typeface="Calibri" pitchFamily="34" charset="-120"/>
+              </a:rPr>
+              <a:t>bit stream → delta values</a:t>
+            </a:r>
+            <a:endParaRPr lang="en-US" sz="1600" dirty="0"/>
+          </a:p>
         </p:txBody>
       </p:sp>
       <p:sp>
@@ -9268,7 +9285,7 @@
         </p:nvSpPr>
         <p:spPr>
           <a:xfrm>
-            <a:off x="2953512" y="1481328"/>
+            <a:off x="3044952" y="1508760"/>
             <a:ext cx="310896" cy="237744"/>
           </a:xfrm>
           <a:prstGeom prst="rightArrow">
@@ -9293,20 +9310,20 @@
         </p:nvSpPr>
         <p:spPr>
           <a:xfrm>
-            <a:off x="3291840" y="1234440"/>
-            <a:ext cx="2468880" cy="731520"/>
+            <a:off x="3383280" y="1143000"/>
+            <a:ext cx="2560320" cy="960120"/>
           </a:xfrm>
           <a:prstGeom prst="roundRect">
             <a:avLst>
-              <a:gd name="adj" fmla="val 10000"/>
+              <a:gd name="adj" fmla="val 9524"/>
             </a:avLst>
           </a:prstGeom>
           <a:solidFill>
-            <a:srgbClr val="ECE6F6"/>
+            <a:srgbClr val="2F6DB5"/>
           </a:solidFill>
-          <a:ln w="19050">
+          <a:ln w="12700">
             <a:solidFill>
-              <a:srgbClr val="6B4FA3"/>
+              <a:srgbClr val="2F6DB5"/>
             </a:solidFill>
             <a:prstDash val="solid"/>
           </a:ln>
@@ -9320,8 +9337,8 @@
         </p:nvSpPr>
         <p:spPr>
           <a:xfrm>
-            <a:off x="3291840" y="1234440"/>
-            <a:ext cx="2468880" cy="731520"/>
+            <a:off x="3383280" y="1143000"/>
+            <a:ext cx="2560320" cy="960120"/>
           </a:xfrm>
           <a:prstGeom prst="rect">
             <a:avLst/>
@@ -9330,7 +9347,7 @@
           <a:ln/>
         </p:spPr>
         <p:txBody>
-          <a:bodyPr wrap="square" lIns="0" tIns="0" rIns="0" bIns="0" rtlCol="0" anchor="ctr"/>
+          <a:bodyPr wrap="square" lIns="635" tIns="635" rIns="635" bIns="635" rtlCol="0" anchor="ctr"/>
           <a:lstStyle/>
           <a:p>
             <a:pPr algn="ctr" indent="0" marL="0">
@@ -9339,16 +9356,33 @@
             <a:r>
               <a:rPr lang="en-US" sz="1600" b="1" dirty="0">
                 <a:solidFill>
-                  <a:srgbClr val="6B4FA3"/>
+                  <a:srgbClr val="FFFFFF"/>
                 </a:solidFill>
                 <a:latin typeface="Calibri" pitchFamily="34" charset="0"/>
                 <a:ea typeface="Calibri" pitchFamily="34" charset="-122"/>
                 <a:cs typeface="Calibri" pitchFamily="34" charset="-120"/>
               </a:rPr>
-              <a:t>Inverse delta</a:t>
+              <a:t>2. Inverse delta</a:t>
             </a:r>
             <a:endParaRPr lang="en-US" sz="1600" dirty="0"/>
           </a:p>
+          <a:p>
+            <a:pPr algn="ctr" indent="0" marL="0">
+              <a:buNone/>
+            </a:pPr>
+            <a:r>
+              <a:rPr lang="en-US" sz="1250" dirty="0">
+                <a:solidFill>
+                  <a:srgbClr val="FFFFFF"/>
+                </a:solidFill>
+                <a:latin typeface="Calibri" pitchFamily="34" charset="0"/>
+                <a:ea typeface="Calibri" pitchFamily="34" charset="-122"/>
+                <a:cs typeface="Calibri" pitchFamily="34" charset="-120"/>
+              </a:rPr>
+              <a:t>deltas → VQ indices</a:t>
+            </a:r>
+            <a:endParaRPr lang="en-US" sz="1600" dirty="0"/>
+          </a:p>
         </p:txBody>
       </p:sp>
       <p:sp>
@@ -9359,7 +9393,7 @@
         </p:nvSpPr>
         <p:spPr>
           <a:xfrm>
-            <a:off x="5788152" y="1481328"/>
+            <a:off x="5971032" y="1508760"/>
             <a:ext cx="310896" cy="237744"/>
           </a:xfrm>
           <a:prstGeom prst="rightArrow">
@@ -9384,20 +9418,20 @@
         </p:nvSpPr>
         <p:spPr>
           <a:xfrm>
-            <a:off x="6126480" y="1234440"/>
-            <a:ext cx="2468880" cy="731520"/>
+            <a:off x="6309360" y="1143000"/>
+            <a:ext cx="2560320" cy="960120"/>
           </a:xfrm>
           <a:prstGeom prst="roundRect">
             <a:avLst>
-              <a:gd name="adj" fmla="val 10000"/>
+              <a:gd name="adj" fmla="val 9524"/>
             </a:avLst>
           </a:prstGeom>
           <a:solidFill>
-            <a:srgbClr val="ECE6F6"/>
+            <a:srgbClr val="E07B22"/>
           </a:solidFill>
-          <a:ln w="19050">
+          <a:ln w="12700">
             <a:solidFill>
-              <a:srgbClr val="6B4FA3"/>
+              <a:srgbClr val="E07B22"/>
             </a:solidFill>
             <a:prstDash val="solid"/>
           </a:ln>
@@ -9411,8 +9445,8 @@
         </p:nvSpPr>
         <p:spPr>
           <a:xfrm>
-            <a:off x="6126480" y="1234440"/>
-            <a:ext cx="2468880" cy="731520"/>
+            <a:off x="6309360" y="1143000"/>
+            <a:ext cx="2560320" cy="960120"/>
           </a:xfrm>
           <a:prstGeom prst="rect">
             <a:avLst/>
@@ -9421,7 +9455,7 @@
           <a:ln/>
         </p:spPr>
         <p:txBody>
-          <a:bodyPr wrap="square" lIns="0" tIns="0" rIns="0" bIns="0" rtlCol="0" anchor="ctr"/>
+          <a:bodyPr wrap="square" lIns="635" tIns="635" rIns="635" bIns="635" rtlCol="0" anchor="ctr"/>
           <a:lstStyle/>
           <a:p>
             <a:pPr algn="ctr" indent="0" marL="0">
@@ -9430,16 +9464,33 @@
             <a:r>
               <a:rPr lang="en-US" sz="1600" b="1" dirty="0">
                 <a:solidFill>
-                  <a:srgbClr val="6B4FA3"/>
+                  <a:srgbClr val="FFFFFF"/>
                 </a:solidFill>
                 <a:latin typeface="Calibri" pitchFamily="34" charset="0"/>
                 <a:ea typeface="Calibri" pitchFamily="34" charset="-122"/>
                 <a:cs typeface="Calibri" pitchFamily="34" charset="-120"/>
               </a:rPr>
-              <a:t>Codebook lookup</a:t>
+              <a:t>3. Codebook lookup</a:t>
             </a:r>
             <a:endParaRPr lang="en-US" sz="1600" dirty="0"/>
           </a:p>
+          <a:p>
+            <a:pPr algn="ctr" indent="0" marL="0">
+              <a:buNone/>
+            </a:pPr>
+            <a:r>
+              <a:rPr lang="en-US" sz="1250" dirty="0">
+                <a:solidFill>
+                  <a:srgbClr val="FFFFFF"/>
+                </a:solidFill>
+                <a:latin typeface="Calibri" pitchFamily="34" charset="0"/>
+                <a:ea typeface="Calibri" pitchFamily="34" charset="-122"/>
+                <a:cs typeface="Calibri" pitchFamily="34" charset="-120"/>
+              </a:rPr>
+              <a:t>index → 4×4 block</a:t>
+            </a:r>
+            <a:endParaRPr lang="en-US" sz="1600" dirty="0"/>
+          </a:p>
         </p:txBody>
       </p:sp>
       <p:sp>
@@ -9450,7 +9501,7 @@
         </p:nvSpPr>
         <p:spPr>
           <a:xfrm>
-            <a:off x="8622792" y="1481328"/>
+            <a:off x="8897112" y="1508760"/>
             <a:ext cx="310896" cy="237744"/>
           </a:xfrm>
           <a:prstGeom prst="rightArrow">
@@ -9475,18 +9526,18 @@
         </p:nvSpPr>
         <p:spPr>
           <a:xfrm>
-            <a:off x="8961120" y="1234440"/>
-            <a:ext cx="2468880" cy="731520"/>
+            <a:off x="9235440" y="1143000"/>
+            <a:ext cx="2560320" cy="960120"/>
           </a:xfrm>
           <a:prstGeom prst="roundRect">
             <a:avLst>
-              <a:gd name="adj" fmla="val 10000"/>
+              <a:gd name="adj" fmla="val 9524"/>
             </a:avLst>
           </a:prstGeom>
           <a:solidFill>
-            <a:srgbClr val="ECE6F6"/>
+            <a:srgbClr val="6B4FA3"/>
           </a:solidFill>
-          <a:ln w="19050">
+          <a:ln w="12700">
             <a:solidFill>
               <a:srgbClr val="6B4FA3"/>
             </a:solidFill>
@@ -9502,8 +9553,8 @@
         </p:nvSpPr>
         <p:spPr>
           <a:xfrm>
-            <a:off x="8961120" y="1234440"/>
-            <a:ext cx="2468880" cy="731520"/>
+            <a:off x="9235440" y="1143000"/>
+            <a:ext cx="2560320" cy="960120"/>
           </a:xfrm>
           <a:prstGeom prst="rect">
             <a:avLst/>
@@ -9512,7 +9563,7 @@
           <a:ln/>
         </p:spPr>
         <p:txBody>
-          <a:bodyPr wrap="square" lIns="0" tIns="0" rIns="0" bIns="0" rtlCol="0" anchor="ctr"/>
+          <a:bodyPr wrap="square" lIns="635" tIns="635" rIns="635" bIns="635" rtlCol="0" anchor="ctr"/>
           <a:lstStyle/>
           <a:p>
             <a:pPr algn="ctr" indent="0" marL="0">
@@ -9521,13 +9572,30 @@
             <a:r>
               <a:rPr lang="en-US" sz="1600" b="1" dirty="0">
                 <a:solidFill>
-                  <a:srgbClr val="6B4FA3"/>
+                  <a:srgbClr val="FFFFFF"/>
                 </a:solidFill>
                 <a:latin typeface="Calibri" pitchFamily="34" charset="0"/>
                 <a:ea typeface="Calibri" pitchFamily="34" charset="-122"/>
                 <a:cs typeface="Calibri" pitchFamily="34" charset="-120"/>
               </a:rPr>
-              <a:t>Reconstructed image</a:t>
+              <a:t>4. Reconstructed image</a:t>
+            </a:r>
+            <a:endParaRPr lang="en-US" sz="1600" dirty="0"/>
+          </a:p>
+          <a:p>
+            <a:pPr algn="ctr" indent="0" marL="0">
+              <a:buNone/>
+            </a:pPr>
+            <a:r>
+              <a:rPr lang="en-US" sz="1250" dirty="0">
+                <a:solidFill>
+                  <a:srgbClr val="FFFFFF"/>
+                </a:solidFill>
+                <a:latin typeface="Calibri" pitchFamily="34" charset="0"/>
+                <a:ea typeface="Calibri" pitchFamily="34" charset="-122"/>
+                <a:cs typeface="Calibri" pitchFamily="34" charset="-120"/>
+              </a:rPr>
+              <a:t>blocks → 512×512 image</a:t>
             </a:r>
             <a:endParaRPr lang="en-US" sz="1600" dirty="0"/>
           </a:p>

</xml_diff>

<commit_message>
Seminar: Stage 4 slide uses Lena color original/reconstructed
Co-Authored-By: Claude Sonnet 5.5 <noreply@anthropic.com>
Claude-Session: https://claude.ai/code/session_01T6gEewJ8YaCdmnsfS34RJd
</commit_message>
<xml_diff>
--- a/results/seminar/figs/Seminar_Ibtihal_FINAL.pptx
+++ b/results/seminar/figs/Seminar_Ibtihal_FINAL.pptx
@@ -9203,7 +9203,7 @@
         <p:spPr>
           <a:xfrm>
             <a:off x="457200" y="1143000"/>
-            <a:ext cx="2560320" cy="960120"/>
+            <a:ext cx="2514600" cy="960120"/>
           </a:xfrm>
           <a:prstGeom prst="roundRect">
             <a:avLst>
@@ -9230,7 +9230,7 @@
         <p:spPr>
           <a:xfrm>
             <a:off x="457200" y="1143000"/>
-            <a:ext cx="2560320" cy="960120"/>
+            <a:ext cx="2514600" cy="960120"/>
           </a:xfrm>
           <a:prstGeom prst="rect">
             <a:avLst/>
@@ -9285,7 +9285,7 @@
         </p:nvSpPr>
         <p:spPr>
           <a:xfrm>
-            <a:off x="3044952" y="1508760"/>
+            <a:off x="2999232" y="1508760"/>
             <a:ext cx="310896" cy="237744"/>
           </a:xfrm>
           <a:prstGeom prst="rightArrow">
@@ -9310,8 +9310,8 @@
         </p:nvSpPr>
         <p:spPr>
           <a:xfrm>
-            <a:off x="3383280" y="1143000"/>
-            <a:ext cx="2560320" cy="960120"/>
+            <a:off x="3337560" y="1143000"/>
+            <a:ext cx="2514600" cy="960120"/>
           </a:xfrm>
           <a:prstGeom prst="roundRect">
             <a:avLst>
@@ -9337,8 +9337,8 @@
         </p:nvSpPr>
         <p:spPr>
           <a:xfrm>
-            <a:off x="3383280" y="1143000"/>
-            <a:ext cx="2560320" cy="960120"/>
+            <a:off x="3337560" y="1143000"/>
+            <a:ext cx="2514600" cy="960120"/>
           </a:xfrm>
           <a:prstGeom prst="rect">
             <a:avLst/>
@@ -9393,7 +9393,7 @@
         </p:nvSpPr>
         <p:spPr>
           <a:xfrm>
-            <a:off x="5971032" y="1508760"/>
+            <a:off x="5879592" y="1508760"/>
             <a:ext cx="310896" cy="237744"/>
           </a:xfrm>
           <a:prstGeom prst="rightArrow">
@@ -9418,8 +9418,8 @@
         </p:nvSpPr>
         <p:spPr>
           <a:xfrm>
-            <a:off x="6309360" y="1143000"/>
-            <a:ext cx="2560320" cy="960120"/>
+            <a:off x="6217920" y="1143000"/>
+            <a:ext cx="2514600" cy="960120"/>
           </a:xfrm>
           <a:prstGeom prst="roundRect">
             <a:avLst>
@@ -9445,8 +9445,8 @@
         </p:nvSpPr>
         <p:spPr>
           <a:xfrm>
-            <a:off x="6309360" y="1143000"/>
-            <a:ext cx="2560320" cy="960120"/>
+            <a:off x="6217920" y="1143000"/>
+            <a:ext cx="2514600" cy="960120"/>
           </a:xfrm>
           <a:prstGeom prst="rect">
             <a:avLst/>
@@ -9501,7 +9501,7 @@
         </p:nvSpPr>
         <p:spPr>
           <a:xfrm>
-            <a:off x="8897112" y="1508760"/>
+            <a:off x="8759952" y="1508760"/>
             <a:ext cx="310896" cy="237744"/>
           </a:xfrm>
           <a:prstGeom prst="rightArrow">
@@ -9526,8 +9526,8 @@
         </p:nvSpPr>
         <p:spPr>
           <a:xfrm>
-            <a:off x="9235440" y="1143000"/>
-            <a:ext cx="2560320" cy="960120"/>
+            <a:off x="9098280" y="1143000"/>
+            <a:ext cx="2514600" cy="960120"/>
           </a:xfrm>
           <a:prstGeom prst="roundRect">
             <a:avLst>
@@ -9553,8 +9553,8 @@
         </p:nvSpPr>
         <p:spPr>
           <a:xfrm>
-            <a:off x="9235440" y="1143000"/>
-            <a:ext cx="2560320" cy="960120"/>
+            <a:off x="9098280" y="1143000"/>
+            <a:ext cx="2514600" cy="960120"/>
           </a:xfrm>
           <a:prstGeom prst="rect">
             <a:avLst/>
@@ -9603,7 +9603,7 @@
       </p:sp>
       <p:pic>
         <p:nvPicPr>
-          <p:cNvPr id="17" name="Image 0" descr="assets/cam_orig.png">    </p:cNvPr>
+          <p:cNvPr id="17" name="Image 0" descr="assets/lena_color_orig.png">    </p:cNvPr>
           <p:cNvPicPr>
             <a:picLocks noChangeAspect="1"/>
           </p:cNvPicPr>
@@ -9627,7 +9627,7 @@
       </p:pic>
       <p:pic>
         <p:nvPicPr>
-          <p:cNvPr id="18" name="Image 1" descr="assets/cam_rec.png">    </p:cNvPr>
+          <p:cNvPr id="18" name="Image 1" descr="assets/lena_color_rec.png">    </p:cNvPr>
           <p:cNvPicPr>
             <a:picLocks noChangeAspect="1"/>
           </p:cNvPicPr>
@@ -9760,7 +9760,7 @@
                 <a:ea typeface="Calibri" pitchFamily="34" charset="-122"/>
                 <a:cs typeface="Calibri" pitchFamily="34" charset="-120"/>
               </a:rPr>
-              <a:t>Cameraman: PSNR 29.75 dB, SSIM 0.8855</a:t>
+              <a:t>Lena (color): PSNR 28.91 dB, SSIM 0.7594</a:t>
             </a:r>
             <a:endParaRPr lang="en-US" sz="1300" dirty="0"/>
           </a:p>

</xml_diff>

<commit_message>
Seminar: note Equal/Adaptive policy under speedup, efficiency, total charts
Co-Authored-By: Claude Sonnet 5.5 <noreply@anthropic.com>
Claude-Session: https://claude.ai/code/session_01T6gEewJ8YaCdmnsfS34RJd
</commit_message>
<xml_diff>
--- a/results/seminar/figs/Seminar_Ibtihal_FINAL.pptx
+++ b/results/seminar/figs/Seminar_Ibtihal_FINAL.pptx
@@ -26745,7 +26745,46 @@
       </p:pic>
       <p:sp>
         <p:nvSpPr>
-          <p:cNvPr id="10" name="Shape 7"/>
+          <p:cNvPr id="10" name="Text 7"/>
+          <p:cNvSpPr/>
+          <p:nvPr/>
+        </p:nvSpPr>
+        <p:spPr>
+          <a:xfrm>
+            <a:off x="457200" y="6309360"/>
+            <a:ext cx="7498080" cy="274320"/>
+          </a:xfrm>
+          <a:prstGeom prst="rect">
+            <a:avLst/>
+          </a:prstGeom>
+          <a:noFill/>
+          <a:ln/>
+        </p:spPr>
+        <p:txBody>
+          <a:bodyPr wrap="square" lIns="0" tIns="0" rIns="0" bIns="0" rtlCol="0" anchor="ctr"/>
+          <a:lstStyle/>
+          <a:p>
+            <a:pPr algn="ctr" indent="0" marL="0">
+              <a:buNone/>
+            </a:pPr>
+            <a:r>
+              <a:rPr lang="en-US" sz="1300" i="1" dirty="0">
+                <a:solidFill>
+                  <a:srgbClr val="6B4FA3"/>
+                </a:solidFill>
+                <a:latin typeface="Calibri" pitchFamily="34" charset="0"/>
+                <a:ea typeface="Calibri" pitchFamily="34" charset="-122"/>
+                <a:cs typeface="Calibri" pitchFamily="34" charset="-120"/>
+              </a:rPr>
+              <a:t>Workload distribution: Equal for P ≤ 4, Adaptive for P &gt; 4.</a:t>
+            </a:r>
+            <a:endParaRPr lang="en-US" sz="1300" dirty="0"/>
+          </a:p>
+        </p:txBody>
+      </p:sp>
+      <p:sp>
+        <p:nvSpPr>
+          <p:cNvPr id="11" name="Shape 8"/>
           <p:cNvSpPr/>
           <p:nvPr/>
         </p:nvSpPr>
@@ -26772,7 +26811,7 @@
       </p:sp>
       <p:sp>
         <p:nvSpPr>
-          <p:cNvPr id="11" name="Text 8"/>
+          <p:cNvPr id="12" name="Text 9"/>
           <p:cNvSpPr/>
           <p:nvPr/>
         </p:nvSpPr>
@@ -27178,7 +27217,46 @@
       </p:pic>
       <p:sp>
         <p:nvSpPr>
-          <p:cNvPr id="10" name="Shape 7"/>
+          <p:cNvPr id="10" name="Text 7"/>
+          <p:cNvSpPr/>
+          <p:nvPr/>
+        </p:nvSpPr>
+        <p:spPr>
+          <a:xfrm>
+            <a:off x="457200" y="6309360"/>
+            <a:ext cx="7498080" cy="274320"/>
+          </a:xfrm>
+          <a:prstGeom prst="rect">
+            <a:avLst/>
+          </a:prstGeom>
+          <a:noFill/>
+          <a:ln/>
+        </p:spPr>
+        <p:txBody>
+          <a:bodyPr wrap="square" lIns="0" tIns="0" rIns="0" bIns="0" rtlCol="0" anchor="ctr"/>
+          <a:lstStyle/>
+          <a:p>
+            <a:pPr algn="ctr" indent="0" marL="0">
+              <a:buNone/>
+            </a:pPr>
+            <a:r>
+              <a:rPr lang="en-US" sz="1300" i="1" dirty="0">
+                <a:solidFill>
+                  <a:srgbClr val="6B4FA3"/>
+                </a:solidFill>
+                <a:latin typeface="Calibri" pitchFamily="34" charset="0"/>
+                <a:ea typeface="Calibri" pitchFamily="34" charset="-122"/>
+                <a:cs typeface="Calibri" pitchFamily="34" charset="-120"/>
+              </a:rPr>
+              <a:t>Workload distribution: Equal for P ≤ 4, Adaptive for P &gt; 4.</a:t>
+            </a:r>
+            <a:endParaRPr lang="en-US" sz="1300" dirty="0"/>
+          </a:p>
+        </p:txBody>
+      </p:sp>
+      <p:sp>
+        <p:nvSpPr>
+          <p:cNvPr id="11" name="Shape 8"/>
           <p:cNvSpPr/>
           <p:nvPr/>
         </p:nvSpPr>
@@ -27205,7 +27283,7 @@
       </p:sp>
       <p:sp>
         <p:nvSpPr>
-          <p:cNvPr id="11" name="Text 8"/>
+          <p:cNvPr id="12" name="Text 9"/>
           <p:cNvSpPr/>
           <p:nvPr/>
         </p:nvSpPr>
@@ -27611,7 +27689,46 @@
       </p:pic>
       <p:sp>
         <p:nvSpPr>
-          <p:cNvPr id="10" name="Shape 7"/>
+          <p:cNvPr id="10" name="Text 7"/>
+          <p:cNvSpPr/>
+          <p:nvPr/>
+        </p:nvSpPr>
+        <p:spPr>
+          <a:xfrm>
+            <a:off x="457200" y="6309360"/>
+            <a:ext cx="7498080" cy="274320"/>
+          </a:xfrm>
+          <a:prstGeom prst="rect">
+            <a:avLst/>
+          </a:prstGeom>
+          <a:noFill/>
+          <a:ln/>
+        </p:spPr>
+        <p:txBody>
+          <a:bodyPr wrap="square" lIns="0" tIns="0" rIns="0" bIns="0" rtlCol="0" anchor="ctr"/>
+          <a:lstStyle/>
+          <a:p>
+            <a:pPr algn="ctr" indent="0" marL="0">
+              <a:buNone/>
+            </a:pPr>
+            <a:r>
+              <a:rPr lang="en-US" sz="1300" i="1" dirty="0">
+                <a:solidFill>
+                  <a:srgbClr val="6B4FA3"/>
+                </a:solidFill>
+                <a:latin typeface="Calibri" pitchFamily="34" charset="0"/>
+                <a:ea typeface="Calibri" pitchFamily="34" charset="-122"/>
+                <a:cs typeface="Calibri" pitchFamily="34" charset="-120"/>
+              </a:rPr>
+              <a:t>Workload distribution: Equal for P ≤ 4, Adaptive for P &gt; 4.</a:t>
+            </a:r>
+            <a:endParaRPr lang="en-US" sz="1300" dirty="0"/>
+          </a:p>
+        </p:txBody>
+      </p:sp>
+      <p:sp>
+        <p:nvSpPr>
+          <p:cNvPr id="11" name="Shape 8"/>
           <p:cNvSpPr/>
           <p:nvPr/>
         </p:nvSpPr>
@@ -27638,7 +27755,7 @@
       </p:sp>
       <p:sp>
         <p:nvSpPr>
-          <p:cNvPr id="11" name="Text 8"/>
+          <p:cNvPr id="12" name="Text 9"/>
           <p:cNvSpPr/>
           <p:nvPr/>
         </p:nvSpPr>

</xml_diff>

<commit_message>
Seminar: fill CR and BPP for all 8 images (original implementation, thesis Tables 4.5/4.6)
Co-Authored-By: Claude Sonnet 5.5 <noreply@anthropic.com>
Claude-Session: https://claude.ai/code/session_01T6gEewJ8YaCdmnsfS34RJd
</commit_message>
<xml_diff>
--- a/results/seminar/figs/Seminar_Ibtihal_FINAL.pptx
+++ b/results/seminar/figs/Seminar_Ibtihal_FINAL.pptx
@@ -3353,7 +3353,7 @@
           <a:p>
             <a:r>
               <a:rPr lang="en-US" dirty="0"/>
-              <a:t>CR values of 'This work' come from the previous Huffman-table accounting. Replace them with the CR column of correctness.csv after the rerun (expected change about -1.2%). Source values checked against the papers: [6] Table 1 and Table 3; [16] Table 1; [17] Table 1 (Cameraman, FLBG).</a:t>
+              <a:t>CR values of 'This work' are those of the original (approved) implementation, thesis Tables 4.5 and 4.6. Source values checked against the papers: [6] Table 1 and Table 3; [16] Table 1; [17] Table 1 (Cameraman, FLBG).</a:t>
             </a:r>
             <a:endParaRPr lang="en-US" dirty="0"/>
           </a:p>
@@ -14092,7 +14092,7 @@
                 <a:ea typeface="Calibri" pitchFamily="34" charset="-122"/>
                 <a:cs typeface="Calibri" pitchFamily="34" charset="-120"/>
               </a:rPr>
-              <a:t>CR = ___</a:t>
+              <a:t>CR 23.50   BPP 0.340</a:t>
             </a:r>
             <a:endParaRPr lang="en-US" sz="1300" dirty="0"/>
           </a:p>
@@ -14315,7 +14315,7 @@
                 <a:ea typeface="Calibri" pitchFamily="34" charset="-122"/>
                 <a:cs typeface="Calibri" pitchFamily="34" charset="-120"/>
               </a:rPr>
-              <a:t>CR = ___</a:t>
+              <a:t>CR 26.54   BPP 0.301</a:t>
             </a:r>
             <a:endParaRPr lang="en-US" sz="1300" dirty="0"/>
           </a:p>
@@ -14538,7 +14538,7 @@
                 <a:ea typeface="Calibri" pitchFamily="34" charset="-122"/>
                 <a:cs typeface="Calibri" pitchFamily="34" charset="-120"/>
               </a:rPr>
-              <a:t>CR = ___</a:t>
+              <a:t>CR 28.88   BPP 0.277</a:t>
             </a:r>
             <a:endParaRPr lang="en-US" sz="1300" dirty="0"/>
           </a:p>
@@ -14761,7 +14761,7 @@
                 <a:ea typeface="Calibri" pitchFamily="34" charset="-122"/>
                 <a:cs typeface="Calibri" pitchFamily="34" charset="-120"/>
               </a:rPr>
-              <a:t>CR = ___</a:t>
+              <a:t>CR 24.75   BPP 0.323</a:t>
             </a:r>
             <a:endParaRPr lang="en-US" sz="1300" dirty="0"/>
           </a:p>
@@ -15224,7 +15224,7 @@
                 <a:ea typeface="Calibri" pitchFamily="34" charset="-122"/>
                 <a:cs typeface="Calibri" pitchFamily="34" charset="-120"/>
               </a:rPr>
-              <a:t>CR = ___</a:t>
+              <a:t>CR 24.00   BPP 1.000</a:t>
             </a:r>
             <a:endParaRPr lang="en-US" sz="1300" dirty="0"/>
           </a:p>
@@ -15447,7 +15447,7 @@
                 <a:ea typeface="Calibri" pitchFamily="34" charset="-122"/>
                 <a:cs typeface="Calibri" pitchFamily="34" charset="-120"/>
               </a:rPr>
-              <a:t>CR = ___</a:t>
+              <a:t>CR 23.89   BPP 1.005</a:t>
             </a:r>
             <a:endParaRPr lang="en-US" sz="1300" dirty="0"/>
           </a:p>
@@ -15670,7 +15670,7 @@
                 <a:ea typeface="Calibri" pitchFamily="34" charset="-122"/>
                 <a:cs typeface="Calibri" pitchFamily="34" charset="-120"/>
               </a:rPr>
-              <a:t>CR = ___</a:t>
+              <a:t>CR 26.44   BPP 0.908</a:t>
             </a:r>
             <a:endParaRPr lang="en-US" sz="1300" dirty="0"/>
           </a:p>
@@ -15893,7 +15893,7 @@
                 <a:ea typeface="Calibri" pitchFamily="34" charset="-122"/>
                 <a:cs typeface="Calibri" pitchFamily="34" charset="-120"/>
               </a:rPr>
-              <a:t>CR = ___</a:t>
+              <a:t>CR 23.54   BPP 1.020</a:t>
             </a:r>
             <a:endParaRPr lang="en-US" sz="1300" dirty="0"/>
           </a:p>
@@ -16824,7 +16824,7 @@
                           <a:ea typeface="Calibri" pitchFamily="34" charset="-122"/>
                           <a:cs typeface="Calibri" pitchFamily="34" charset="-120"/>
                         </a:rPr>
-                        <a:t>___</a:t>
+                        <a:t>23.50</a:t>
                       </a:r>
                       <a:endParaRPr lang="en-US" sz="1400" dirty="0">
                         <a:latin typeface="Calibri" charset="0"/>
@@ -16892,7 +16892,7 @@
                           <a:ea typeface="Calibri" pitchFamily="34" charset="-122"/>
                           <a:cs typeface="Calibri" pitchFamily="34" charset="-120"/>
                         </a:rPr>
-                        <a:t>___</a:t>
+                        <a:t>0.340</a:t>
                       </a:r>
                       <a:endParaRPr lang="en-US" sz="1400" dirty="0">
                         <a:latin typeface="Calibri" charset="0"/>
@@ -17302,7 +17302,7 @@
                           <a:ea typeface="Calibri" pitchFamily="34" charset="-122"/>
                           <a:cs typeface="Calibri" pitchFamily="34" charset="-120"/>
                         </a:rPr>
-                        <a:t>___</a:t>
+                        <a:t>26.54</a:t>
                       </a:r>
                       <a:endParaRPr lang="en-US" sz="1400" dirty="0">
                         <a:latin typeface="Calibri" charset="0"/>
@@ -17370,7 +17370,7 @@
                           <a:ea typeface="Calibri" pitchFamily="34" charset="-122"/>
                           <a:cs typeface="Calibri" pitchFamily="34" charset="-120"/>
                         </a:rPr>
-                        <a:t>___</a:t>
+                        <a:t>0.301</a:t>
                       </a:r>
                       <a:endParaRPr lang="en-US" sz="1400" dirty="0">
                         <a:latin typeface="Calibri" charset="0"/>
@@ -17780,7 +17780,7 @@
                           <a:ea typeface="Calibri" pitchFamily="34" charset="-122"/>
                           <a:cs typeface="Calibri" pitchFamily="34" charset="-120"/>
                         </a:rPr>
-                        <a:t>___</a:t>
+                        <a:t>28.88</a:t>
                       </a:r>
                       <a:endParaRPr lang="en-US" sz="1400" dirty="0">
                         <a:latin typeface="Calibri" charset="0"/>
@@ -17848,7 +17848,7 @@
                           <a:ea typeface="Calibri" pitchFamily="34" charset="-122"/>
                           <a:cs typeface="Calibri" pitchFamily="34" charset="-120"/>
                         </a:rPr>
-                        <a:t>___</a:t>
+                        <a:t>0.277</a:t>
                       </a:r>
                       <a:endParaRPr lang="en-US" sz="1400" dirty="0">
                         <a:latin typeface="Calibri" charset="0"/>
@@ -18258,7 +18258,7 @@
                           <a:ea typeface="Calibri" pitchFamily="34" charset="-122"/>
                           <a:cs typeface="Calibri" pitchFamily="34" charset="-120"/>
                         </a:rPr>
-                        <a:t>___</a:t>
+                        <a:t>24.75</a:t>
                       </a:r>
                       <a:endParaRPr lang="en-US" sz="1400" dirty="0">
                         <a:latin typeface="Calibri" charset="0"/>
@@ -18326,7 +18326,7 @@
                           <a:ea typeface="Calibri" pitchFamily="34" charset="-122"/>
                           <a:cs typeface="Calibri" pitchFamily="34" charset="-120"/>
                         </a:rPr>
-                        <a:t>___</a:t>
+                        <a:t>0.323</a:t>
                       </a:r>
                       <a:endParaRPr lang="en-US" sz="1400" dirty="0">
                         <a:latin typeface="Calibri" charset="0"/>
@@ -18736,7 +18736,7 @@
                           <a:ea typeface="Calibri" pitchFamily="34" charset="-122"/>
                           <a:cs typeface="Calibri" pitchFamily="34" charset="-120"/>
                         </a:rPr>
-                        <a:t>___</a:t>
+                        <a:t>25.92</a:t>
                       </a:r>
                       <a:endParaRPr lang="en-US" sz="1400" dirty="0">
                         <a:latin typeface="Calibri" charset="0"/>
@@ -18804,7 +18804,7 @@
                           <a:ea typeface="Calibri" pitchFamily="34" charset="-122"/>
                           <a:cs typeface="Calibri" pitchFamily="34" charset="-120"/>
                         </a:rPr>
-                        <a:t>___</a:t>
+                        <a:t>0.311</a:t>
                       </a:r>
                       <a:endParaRPr lang="en-US" sz="1400" dirty="0">
                         <a:latin typeface="Calibri" charset="0"/>
@@ -19214,7 +19214,7 @@
                           <a:ea typeface="Calibri" pitchFamily="34" charset="-122"/>
                           <a:cs typeface="Calibri" pitchFamily="34" charset="-120"/>
                         </a:rPr>
-                        <a:t>___</a:t>
+                        <a:t>24.00</a:t>
                       </a:r>
                       <a:endParaRPr lang="en-US" sz="1400" dirty="0">
                         <a:latin typeface="Calibri" charset="0"/>
@@ -19282,7 +19282,7 @@
                           <a:ea typeface="Calibri" pitchFamily="34" charset="-122"/>
                           <a:cs typeface="Calibri" pitchFamily="34" charset="-120"/>
                         </a:rPr>
-                        <a:t>___</a:t>
+                        <a:t>1.000</a:t>
                       </a:r>
                       <a:endParaRPr lang="en-US" sz="1400" dirty="0">
                         <a:latin typeface="Calibri" charset="0"/>
@@ -19692,7 +19692,7 @@
                           <a:ea typeface="Calibri" pitchFamily="34" charset="-122"/>
                           <a:cs typeface="Calibri" pitchFamily="34" charset="-120"/>
                         </a:rPr>
-                        <a:t>___</a:t>
+                        <a:t>23.89</a:t>
                       </a:r>
                       <a:endParaRPr lang="en-US" sz="1400" dirty="0">
                         <a:latin typeface="Calibri" charset="0"/>
@@ -19760,7 +19760,7 @@
                           <a:ea typeface="Calibri" pitchFamily="34" charset="-122"/>
                           <a:cs typeface="Calibri" pitchFamily="34" charset="-120"/>
                         </a:rPr>
-                        <a:t>___</a:t>
+                        <a:t>1.005</a:t>
                       </a:r>
                       <a:endParaRPr lang="en-US" sz="1400" dirty="0">
                         <a:latin typeface="Calibri" charset="0"/>
@@ -20170,7 +20170,7 @@
                           <a:ea typeface="Calibri" pitchFamily="34" charset="-122"/>
                           <a:cs typeface="Calibri" pitchFamily="34" charset="-120"/>
                         </a:rPr>
-                        <a:t>___</a:t>
+                        <a:t>26.44</a:t>
                       </a:r>
                       <a:endParaRPr lang="en-US" sz="1400" dirty="0">
                         <a:latin typeface="Calibri" charset="0"/>
@@ -20238,7 +20238,7 @@
                           <a:ea typeface="Calibri" pitchFamily="34" charset="-122"/>
                           <a:cs typeface="Calibri" pitchFamily="34" charset="-120"/>
                         </a:rPr>
-                        <a:t>___</a:t>
+                        <a:t>0.908</a:t>
                       </a:r>
                       <a:endParaRPr lang="en-US" sz="1400" dirty="0">
                         <a:latin typeface="Calibri" charset="0"/>
@@ -20648,7 +20648,7 @@
                           <a:ea typeface="Calibri" pitchFamily="34" charset="-122"/>
                           <a:cs typeface="Calibri" pitchFamily="34" charset="-120"/>
                         </a:rPr>
-                        <a:t>___</a:t>
+                        <a:t>23.54</a:t>
                       </a:r>
                       <a:endParaRPr lang="en-US" sz="1400" dirty="0">
                         <a:latin typeface="Calibri" charset="0"/>
@@ -20716,7 +20716,7 @@
                           <a:ea typeface="Calibri" pitchFamily="34" charset="-122"/>
                           <a:cs typeface="Calibri" pitchFamily="34" charset="-120"/>
                         </a:rPr>
-                        <a:t>___</a:t>
+                        <a:t>1.020</a:t>
                       </a:r>
                       <a:endParaRPr lang="en-US" sz="1400" dirty="0">
                         <a:latin typeface="Calibri" charset="0"/>
@@ -21126,7 +21126,7 @@
                           <a:ea typeface="Calibri" pitchFamily="34" charset="-122"/>
                           <a:cs typeface="Calibri" pitchFamily="34" charset="-120"/>
                         </a:rPr>
-                        <a:t>___</a:t>
+                        <a:t>24.47</a:t>
                       </a:r>
                       <a:endParaRPr lang="en-US" sz="1400" dirty="0">
                         <a:latin typeface="Calibri" charset="0"/>
@@ -21194,7 +21194,7 @@
                           <a:ea typeface="Calibri" pitchFamily="34" charset="-122"/>
                           <a:cs typeface="Calibri" pitchFamily="34" charset="-120"/>
                         </a:rPr>
-                        <a:t>___</a:t>
+                        <a:t>0.983</a:t>
                       </a:r>
                       <a:endParaRPr lang="en-US" sz="1400" dirty="0">
                         <a:latin typeface="Calibri" charset="0"/>
@@ -34159,7 +34159,7 @@
                 <a:ea typeface="Calibri" pitchFamily="34" charset="-122"/>
                 <a:cs typeface="Calibri" pitchFamily="34" charset="-120"/>
               </a:rPr>
-              <a:t>Quality: mean PSNR 29.49 dB and SSIM 0.8266 (gray); 28.80 dB and 0.7654 (color), at a compression ratio of ___ (gray) and ___ (color).</a:t>
+              <a:t>Quality: mean PSNR 29.49 dB and SSIM 0.8266 (gray); 28.80 dB and 0.7654 (color), at a mean compression ratio of 25.92 (gray) and 24.47 (color).</a:t>
             </a:r>
             <a:endParaRPr lang="en-US" sz="1900" dirty="0"/>
           </a:p>

</xml_diff>

<commit_message>
Seminar: MSE formula matches thesis (I, K, 1/MN)
Co-Authored-By: Claude Sonnet 5.5 <noreply@anthropic.com>
Claude-Session: https://claude.ai/code/session_01T6gEewJ8YaCdmnsfS34RJd
</commit_message>
<xml_diff>
--- a/results/seminar/figs/Seminar_Ibtihal_FINAL.pptx
+++ b/results/seminar/figs/Seminar_Ibtihal_FINAL.pptx
@@ -16130,7 +16130,7 @@
               <a:buNone/>
             </a:pPr>
             <a:r>
-              <a:rPr lang="en-US" sz="1700" b="1" dirty="0">
+              <a:rPr lang="en-US" sz="1600" b="1" dirty="0">
                 <a:solidFill>
                   <a:srgbClr val="2E2055"/>
                 </a:solidFill>
@@ -16140,14 +16140,14 @@
               </a:rPr>
               <a:t>CR = S_orig / S_comp        BPP = 8 · S_comp / pixels</a:t>
             </a:r>
-            <a:endParaRPr lang="en-US" sz="1700" dirty="0"/>
+            <a:endParaRPr lang="en-US" sz="1600" dirty="0"/>
           </a:p>
           <a:p>
             <a:pPr algn="ctr" indent="0" marL="0">
               <a:buNone/>
             </a:pPr>
             <a:r>
-              <a:rPr lang="en-US" sz="1700" b="1" dirty="0">
+              <a:rPr lang="en-US" sz="1600" b="1" dirty="0">
                 <a:solidFill>
                   <a:srgbClr val="2E2055"/>
                 </a:solidFill>
@@ -16155,9 +16155,9 @@
                 <a:ea typeface="Cambria" pitchFamily="34" charset="-122"/>
                 <a:cs typeface="Cambria" pitchFamily="34" charset="-120"/>
               </a:rPr>
-              <a:t>MSE = mean (I − Î)²        PSNR = 10·log₁₀(255² / MSE)  dB        SSIM: 11 × 11 Gaussian window, σ = 1.5</a:t>
+              <a:t>MSE = (1/MN) Σ [I(i,j) − K(i,j)]²      PSNR = 10·log₁₀(255² / MSE) dB      SSIM: 11 × 11 Gaussian, σ = 1.5</a:t>
             </a:r>
-            <a:endParaRPr lang="en-US" sz="1700" dirty="0"/>
+            <a:endParaRPr lang="en-US" sz="1600" dirty="0"/>
           </a:p>
         </p:txBody>
       </p:sp>

</xml_diff>

<commit_message>
Seminar: tighten Equal vs Adaptive bullets (verified numbers)
Co-Authored-By: Claude Sonnet 5.5 <noreply@anthropic.com>
Claude-Session: https://claude.ai/code/session_01T6gEewJ8YaCdmnsfS34RJd
</commit_message>
<xml_diff>
--- a/results/seminar/figs/Seminar_Ibtihal_FINAL.pptx
+++ b/results/seminar/figs/Seminar_Ibtihal_FINAL.pptx
@@ -28963,7 +28963,46 @@
       </p:pic>
       <p:sp>
         <p:nvSpPr>
-          <p:cNvPr id="8" name="Shape 5"/>
+          <p:cNvPr id="8" name="Text 5"/>
+          <p:cNvSpPr/>
+          <p:nvPr/>
+        </p:nvSpPr>
+        <p:spPr>
+          <a:xfrm>
+            <a:off x="457200" y="6327648"/>
+            <a:ext cx="7498080" cy="274320"/>
+          </a:xfrm>
+          <a:prstGeom prst="rect">
+            <a:avLst/>
+          </a:prstGeom>
+          <a:noFill/>
+          <a:ln/>
+        </p:spPr>
+        <p:txBody>
+          <a:bodyPr wrap="square" lIns="0" tIns="0" rIns="0" bIns="0" rtlCol="0" anchor="ctr"/>
+          <a:lstStyle/>
+          <a:p>
+            <a:pPr algn="ctr" indent="0" marL="0">
+              <a:buNone/>
+            </a:pPr>
+            <a:r>
+              <a:rPr lang="en-US" sz="1200" i="1" dirty="0">
+                <a:solidFill>
+                  <a:srgbClr val="6B4FA3"/>
+                </a:solidFill>
+                <a:latin typeface="Calibri" pitchFamily="34" charset="0"/>
+                <a:ea typeface="Calibri" pitchFamily="34" charset="-122"/>
+                <a:cs typeface="Calibri" pitchFamily="34" charset="-120"/>
+              </a:rPr>
+              <a:t>Adaptive values come from the Equal-vs-Adaptive runs and differ by up to 0.02× from the main speedup runs.</a:t>
+            </a:r>
+            <a:endParaRPr lang="en-US" sz="1200" dirty="0"/>
+          </a:p>
+        </p:txBody>
+      </p:sp>
+      <p:sp>
+        <p:nvSpPr>
+          <p:cNvPr id="9" name="Shape 6"/>
           <p:cNvSpPr/>
           <p:nvPr/>
         </p:nvSpPr>
@@ -28990,7 +29029,7 @@
       </p:sp>
       <p:sp>
         <p:nvSpPr>
-          <p:cNvPr id="9" name="Text 6"/>
+          <p:cNvPr id="10" name="Text 7"/>
           <p:cNvSpPr/>
           <p:nvPr/>
         </p:nvSpPr>
@@ -29025,7 +29064,7 @@
                 <a:ea typeface="Calibri" pitchFamily="34" charset="-122"/>
                 <a:cs typeface="Calibri" pitchFamily="34" charset="-120"/>
               </a:rPr>
-              <a:t>With Equal distribution, the faster P-cores finish early and wait for the E-cores: 7.61× at P = 14.</a:t>
+              <a:t>Equal: the faster P-cores finish early and wait for the E-cores (LBG speedup 7.61× at P = 14).</a:t>
             </a:r>
             <a:endParaRPr lang="en-US" sz="1500" dirty="0"/>
           </a:p>
@@ -29046,7 +29085,7 @@
                 <a:ea typeface="Calibri" pitchFamily="34" charset="-122"/>
                 <a:cs typeface="Calibri" pitchFamily="34" charset="-120"/>
               </a:rPr>
-              <a:t>Adaptive distribution reaches 9.19× at P = 14.</a:t>
+              <a:t>Adaptive: faster cores receive more vectors (9.19× at P = 14).</a:t>
             </a:r>
             <a:endParaRPr lang="en-US" sz="1500" dirty="0"/>
           </a:p>
@@ -29088,7 +29127,7 @@
                 <a:ea typeface="Calibri" pitchFamily="34" charset="-122"/>
                 <a:cs typeface="Calibri" pitchFamily="34" charset="-120"/>
               </a:rPr>
-              <a:t>Total time is reduced by 17.9% to 8.8%.</a:t>
+              <a:t>Total time is reduced by 17.9% at P = 8 and 8.8% at P = 14, since the stages outside LBG are not affected.</a:t>
             </a:r>
             <a:endParaRPr lang="en-US" sz="1500" dirty="0"/>
           </a:p>
@@ -29109,7 +29148,7 @@
                 <a:ea typeface="Calibri" pitchFamily="34" charset="-122"/>
                 <a:cs typeface="Calibri" pitchFamily="34" charset="-120"/>
               </a:rPr>
-              <a:t>No adaptive-distribution benefit was observed when only P-cores were used (P ≤ 6).</a:t>
+              <a:t>No benefit for P ≤ 6, where only P-cores are used.</a:t>
             </a:r>
             <a:endParaRPr lang="en-US" sz="1500" dirty="0"/>
           </a:p>
@@ -29131,27 +29170,6 @@
                 <a:cs typeface="Calibri" pitchFamily="34" charset="-120"/>
               </a:rPr>
               <a:t>The reconstructed images are identical in both cases.</a:t>
-            </a:r>
-            <a:endParaRPr lang="en-US" sz="1500" dirty="0"/>
-          </a:p>
-          <a:p>
-            <a:pPr marL="342900" indent="-342900">
-              <a:spcAft>
-                <a:spcPts val="800"/>
-              </a:spcAft>
-              <a:buSzPct val="100000"/>
-              <a:buChar char="■"/>
-            </a:pPr>
-            <a:r>
-              <a:rPr lang="en-US" sz="1500" dirty="0">
-                <a:solidFill>
-                  <a:srgbClr val="1F1A33"/>
-                </a:solidFill>
-                <a:latin typeface="Calibri" pitchFamily="34" charset="0"/>
-                <a:ea typeface="Calibri" pitchFamily="34" charset="-122"/>
-                <a:cs typeface="Calibri" pitchFamily="34" charset="-120"/>
-              </a:rPr>
-              <a:t>Adaptive values here come from the Equal-vs-Adaptive runs, so they can differ by up to 0.02× from the main speedup runs.</a:t>
             </a:r>
             <a:endParaRPr lang="en-US" sz="1500" dirty="0"/>
           </a:p>

</xml_diff>